<commit_message>
updating version number in release notes
</commit_message>
<xml_diff>
--- a/Documentation/User Manual Source/Release Notes Vecto3.x.pptx
+++ b/Documentation/User Manual Source/Release Notes Vecto3.x.pptx
@@ -6705,7 +6705,7 @@
             </a:r>
             <a:r>
               <a:rPr lang="en-US" dirty="0" smtClean="0"/>
-              <a:t>3.1.0.xx5</a:t>
+              <a:t>3.1.0.652</a:t>
             </a:r>
             <a:endParaRPr lang="en-US" dirty="0"/>
           </a:p>
@@ -6902,7 +6902,7 @@
             </a:r>
             <a:r>
               <a:rPr lang="en-US" dirty="0" smtClean="0"/>
-              <a:t>3.1.0.xx5</a:t>
+              <a:t>3.1.0.652</a:t>
             </a:r>
             <a:endParaRPr lang="en-US" dirty="0"/>
           </a:p>
@@ -7045,7 +7045,6 @@
               <a:rPr lang="en-US" dirty="0" smtClean="0"/>
               <a:t>Fixes in AAUX module: open correct file-browser, save selected files</a:t>
             </a:r>
-            <a:endParaRPr lang="en-US" dirty="0" smtClean="0"/>
           </a:p>
           <a:p>
             <a:pPr lvl="1"/>
@@ -7106,11 +7105,7 @@
             <a:pPr algn="l"/>
             <a:r>
               <a:rPr lang="en-US" dirty="0" smtClean="0"/>
-              <a:t>Status quo VECTO software and open </a:t>
-            </a:r>
-            <a:r>
-              <a:rPr lang="en-US" dirty="0" smtClean="0"/>
-              <a:t>issues (Oct. 2016)</a:t>
+              <a:t>Status quo VECTO software and open issues (Oct. 2016)</a:t>
             </a:r>
             <a:endParaRPr lang="en-US" dirty="0"/>
           </a:p>
@@ -7202,14 +7197,14 @@
               <a:buChar char="•"/>
             </a:pPr>
             <a:r>
-              <a:rPr lang="en-GB" sz="1400" smtClean="0"/>
+              <a:rPr lang="en-GB" sz="1400" dirty="0" smtClean="0"/>
               <a:t>Further development of the AT model</a:t>
             </a:r>
             <a:br>
-              <a:rPr lang="en-GB" sz="1400" smtClean="0"/>
+              <a:rPr lang="en-GB" sz="1400" dirty="0" smtClean="0"/>
             </a:br>
             <a:r>
-              <a:rPr lang="en-GB" sz="1400" b="0" smtClean="0"/>
+              <a:rPr lang="en-GB" sz="1400" b="0" dirty="0" smtClean="0"/>
               <a:t>Consideration of losses during power shifts, update of gear shift logics</a:t>
             </a:r>
           </a:p>
@@ -7219,11 +7214,11 @@
               <a:buChar char="•"/>
             </a:pPr>
             <a:r>
-              <a:rPr lang="en-GB" sz="1400" smtClean="0"/>
+              <a:rPr lang="en-GB" sz="1400" dirty="0" smtClean="0"/>
               <a:t>Reimplementation </a:t>
             </a:r>
             <a:r>
-              <a:rPr lang="en-GB" sz="1400"/>
+              <a:rPr lang="en-GB" sz="1400" dirty="0"/>
               <a:t>of engine stop/start</a:t>
             </a:r>
           </a:p>
@@ -7233,7 +7228,7 @@
               <a:buChar char="•"/>
             </a:pPr>
             <a:r>
-              <a:rPr lang="en-GB" sz="1400" smtClean="0"/>
+              <a:rPr lang="en-GB" sz="1400" dirty="0" smtClean="0"/>
               <a:t>Declaration mode: implementation of EMS vehicle configurations</a:t>
             </a:r>
           </a:p>
@@ -7242,12 +7237,12 @@
               <a:buFont typeface="Arial" panose="020B0604020202020204" pitchFamily="34" charset="0"/>
               <a:buChar char="•"/>
             </a:pPr>
-            <a:endParaRPr lang="en-GB" sz="1400"/>
+            <a:endParaRPr lang="en-GB" sz="1400" dirty="0"/>
           </a:p>
           <a:p>
             <a:pPr algn="l"/>
             <a:r>
-              <a:rPr lang="en-GB" sz="1400" u="sng" smtClean="0"/>
+              <a:rPr lang="en-GB" sz="1400" u="sng" dirty="0" smtClean="0"/>
               <a:t>Items waiting for decision on methods and resources:</a:t>
             </a:r>
           </a:p>
@@ -7257,15 +7252,23 @@
               <a:buChar char="•"/>
             </a:pPr>
             <a:r>
-              <a:rPr lang="en-GB" sz="1400" smtClean="0"/>
+              <a:rPr lang="en-GB" sz="1400" dirty="0" smtClean="0"/>
               <a:t>Update engine data (according to update of Annex II)</a:t>
             </a:r>
             <a:br>
-              <a:rPr lang="en-GB" sz="1400" smtClean="0"/>
+              <a:rPr lang="en-GB" sz="1400" dirty="0" smtClean="0"/>
             </a:br>
             <a:r>
-              <a:rPr lang="en-GB" sz="1400" b="0" smtClean="0"/>
-              <a:t>Other fuels than diesel, “top torque” feature, correction factor for periodic regerating DPFs</a:t>
+              <a:rPr lang="en-GB" sz="1400" b="0" dirty="0" smtClean="0"/>
+              <a:t>Other fuels than diesel, “top torque” feature, correction factor for periodic </a:t>
+            </a:r>
+            <a:r>
+              <a:rPr lang="en-GB" sz="1400" b="0" dirty="0" err="1" smtClean="0"/>
+              <a:t>regerating</a:t>
+            </a:r>
+            <a:r>
+              <a:rPr lang="en-GB" sz="1400" b="0" dirty="0" smtClean="0"/>
+              <a:t> DPFs</a:t>
             </a:r>
           </a:p>
           <a:p>
@@ -7274,7 +7277,7 @@
               <a:buChar char="•"/>
             </a:pPr>
             <a:r>
-              <a:rPr lang="en-GB" sz="1400" smtClean="0"/>
+              <a:rPr lang="en-GB" sz="1400" dirty="0" smtClean="0"/>
               <a:t>Declaration mode: </a:t>
             </a:r>
           </a:p>
@@ -7287,11 +7290,11 @@
               <a:buChar char="•"/>
             </a:pPr>
             <a:r>
-              <a:rPr lang="en-GB" sz="1400"/>
+              <a:rPr lang="en-GB" sz="1400" dirty="0"/>
               <a:t>Revision of calculated vehicle </a:t>
             </a:r>
             <a:r>
-              <a:rPr lang="en-GB" sz="1400" smtClean="0"/>
+              <a:rPr lang="en-GB" sz="1400" dirty="0" smtClean="0"/>
               <a:t>loads</a:t>
             </a:r>
           </a:p>
@@ -7304,21 +7307,21 @@
               <a:buChar char="•"/>
             </a:pPr>
             <a:r>
-              <a:rPr lang="en-GB" sz="1400" smtClean="0"/>
+              <a:rPr lang="en-GB" sz="1400" dirty="0" smtClean="0"/>
               <a:t>implementation of refuse cycle (instead “municipal”)</a:t>
             </a:r>
             <a:br>
-              <a:rPr lang="en-GB" sz="1400" smtClean="0"/>
+              <a:rPr lang="en-GB" sz="1400" dirty="0" smtClean="0"/>
             </a:br>
             <a:r>
-              <a:rPr lang="en-GB" sz="1400" b="0" smtClean="0"/>
+              <a:rPr lang="en-GB" sz="1400" b="0" dirty="0" smtClean="0"/>
               <a:t>Update of driving cycle, consideration of generic PTO loads during collection part,</a:t>
             </a:r>
             <a:br>
-              <a:rPr lang="en-GB" sz="1400" b="0" smtClean="0"/>
+              <a:rPr lang="en-GB" sz="1400" b="0" dirty="0" smtClean="0"/>
             </a:br>
             <a:r>
-              <a:rPr lang="en-GB" sz="1400" b="0" smtClean="0"/>
+              <a:rPr lang="en-GB" sz="1400" b="0" dirty="0" smtClean="0"/>
               <a:t>generic body weight and payload</a:t>
             </a:r>
           </a:p>
@@ -7331,11 +7334,19 @@
               <a:buChar char="•"/>
             </a:pPr>
             <a:r>
-              <a:rPr lang="en-GB" sz="1400"/>
-              <a:t>VECTO output (approval autorities, customer info, monitoring</a:t>
-            </a:r>
-            <a:r>
-              <a:rPr lang="en-GB" sz="1400" smtClean="0"/>
+              <a:rPr lang="en-GB" sz="1400" dirty="0"/>
+              <a:t>VECTO output (approval </a:t>
+            </a:r>
+            <a:r>
+              <a:rPr lang="en-GB" sz="1400" dirty="0" smtClean="0"/>
+              <a:t>authorities</a:t>
+            </a:r>
+            <a:r>
+              <a:rPr lang="en-GB" sz="1400" dirty="0"/>
+              <a:t>, customer info, monitoring</a:t>
+            </a:r>
+            <a:r>
+              <a:rPr lang="en-GB" sz="1400" dirty="0" smtClean="0"/>
               <a:t>)</a:t>
             </a:r>
           </a:p>
@@ -7348,10 +7359,10 @@
               <a:buChar char="•"/>
             </a:pPr>
             <a:r>
-              <a:rPr lang="en-GB" sz="1400" smtClean="0"/>
+              <a:rPr lang="en-GB" sz="1400" dirty="0" smtClean="0"/>
               <a:t>Buses</a:t>
             </a:r>
-            <a:endParaRPr lang="en-GB" sz="1400" b="0" smtClean="0"/>
+            <a:endParaRPr lang="en-GB" sz="1400" b="0" dirty="0" smtClean="0"/>
           </a:p>
           <a:p>
             <a:pPr marL="285750" indent="-285750" algn="l">
@@ -7359,12 +7370,8 @@
               <a:buChar char="•"/>
             </a:pPr>
             <a:r>
-              <a:rPr lang="en-GB" sz="1400" smtClean="0"/>
-              <a:t>Predictive </a:t>
-            </a:r>
-            <a:r>
               <a:rPr lang="en-GB" sz="1400" dirty="0" smtClean="0"/>
-              <a:t>ADAS</a:t>
+              <a:t>Predictive ADAS</a:t>
             </a:r>
           </a:p>
           <a:p>
@@ -7372,10 +7379,6 @@
               <a:buFont typeface="Arial" panose="020B0604020202020204" pitchFamily="34" charset="0"/>
               <a:buChar char="•"/>
             </a:pPr>
-            <a:r>
-              <a:rPr lang="en-GB" sz="1400" smtClean="0"/>
-              <a:t>API</a:t>
-            </a:r>
             <a:endParaRPr lang="en-GB" sz="1400" dirty="0" smtClean="0"/>
           </a:p>
           <a:p>

</xml_diff>

<commit_message>
chagelog: use current date
</commit_message>
<xml_diff>
--- a/Documentation/User Manual Source/Release Notes Vecto3.x.pptx
+++ b/Documentation/User Manual Source/Release Notes Vecto3.x.pptx
@@ -4476,8 +4476,13 @@
                   <a:srgbClr val="990000"/>
                 </a:solidFill>
               </a:rPr>
-              <a:t>19.07.2016</a:t>
-            </a:r>
+              <a:t>14.10.2016</a:t>
+            </a:r>
+            <a:endParaRPr lang="en-US" sz="2000" dirty="0" smtClean="0">
+              <a:solidFill>
+                <a:srgbClr val="990000"/>
+              </a:solidFill>
+            </a:endParaRPr>
           </a:p>
           <a:p>
             <a:pPr eaLnBrk="1" hangingPunct="1"/>

</xml_diff>

<commit_message>
updated user manual, added checklist for release 3.1.0.662
</commit_message>
<xml_diff>
--- a/Documentation/User Manual Source/Release Notes Vecto3.x.pptx
+++ b/Documentation/User Manual Source/Release Notes Vecto3.x.pptx
@@ -5,29 +5,30 @@
     <p:sldMasterId id="2147483648" r:id="rId1"/>
   </p:sldMasterIdLst>
   <p:notesMasterIdLst>
-    <p:notesMasterId r:id="rId19"/>
+    <p:notesMasterId r:id="rId20"/>
   </p:notesMasterIdLst>
   <p:handoutMasterIdLst>
-    <p:handoutMasterId r:id="rId20"/>
+    <p:handoutMasterId r:id="rId21"/>
   </p:handoutMasterIdLst>
   <p:sldIdLst>
     <p:sldId id="575" r:id="rId2"/>
     <p:sldId id="652" r:id="rId3"/>
-    <p:sldId id="655" r:id="rId4"/>
-    <p:sldId id="654" r:id="rId5"/>
-    <p:sldId id="653" r:id="rId6"/>
-    <p:sldId id="651" r:id="rId7"/>
-    <p:sldId id="648" r:id="rId8"/>
-    <p:sldId id="649" r:id="rId9"/>
-    <p:sldId id="650" r:id="rId10"/>
-    <p:sldId id="645" r:id="rId11"/>
-    <p:sldId id="647" r:id="rId12"/>
-    <p:sldId id="646" r:id="rId13"/>
-    <p:sldId id="640" r:id="rId14"/>
-    <p:sldId id="641" r:id="rId15"/>
-    <p:sldId id="642" r:id="rId16"/>
-    <p:sldId id="643" r:id="rId17"/>
-    <p:sldId id="644" r:id="rId18"/>
+    <p:sldId id="656" r:id="rId4"/>
+    <p:sldId id="655" r:id="rId5"/>
+    <p:sldId id="654" r:id="rId6"/>
+    <p:sldId id="653" r:id="rId7"/>
+    <p:sldId id="651" r:id="rId8"/>
+    <p:sldId id="648" r:id="rId9"/>
+    <p:sldId id="649" r:id="rId10"/>
+    <p:sldId id="650" r:id="rId11"/>
+    <p:sldId id="645" r:id="rId12"/>
+    <p:sldId id="647" r:id="rId13"/>
+    <p:sldId id="646" r:id="rId14"/>
+    <p:sldId id="640" r:id="rId15"/>
+    <p:sldId id="641" r:id="rId16"/>
+    <p:sldId id="642" r:id="rId17"/>
+    <p:sldId id="643" r:id="rId18"/>
+    <p:sldId id="644" r:id="rId19"/>
   </p:sldIdLst>
   <p:sldSz cx="9144000" cy="6858000" type="screen4x3"/>
   <p:notesSz cx="6805613" cy="9944100"/>
@@ -156,6 +157,36 @@
       </a:defRPr>
     </a:lvl9pPr>
   </p:defaultTextStyle>
+  <p:extLst>
+    <p:ext uri="{EFAFB233-063F-42B5-8137-9DF3F51BA10A}">
+      <p15:sldGuideLst xmlns:p15="http://schemas.microsoft.com/office/powerpoint/2012/main">
+        <p15:guide id="1" orient="horz" pos="2160">
+          <p15:clr>
+            <a:srgbClr val="A4A3A4"/>
+          </p15:clr>
+        </p15:guide>
+        <p15:guide id="2" pos="2880">
+          <p15:clr>
+            <a:srgbClr val="A4A3A4"/>
+          </p15:clr>
+        </p15:guide>
+      </p15:sldGuideLst>
+    </p:ext>
+    <p:ext uri="{2D200454-40CA-4A62-9FC3-DE9A4176ACB9}">
+      <p15:notesGuideLst xmlns:p15="http://schemas.microsoft.com/office/powerpoint/2012/main">
+        <p15:guide id="1" orient="horz" pos="3132">
+          <p15:clr>
+            <a:srgbClr val="A4A3A4"/>
+          </p15:clr>
+        </p15:guide>
+        <p15:guide id="2" pos="2143">
+          <p15:clr>
+            <a:srgbClr val="A4A3A4"/>
+          </p15:clr>
+        </p15:guide>
+      </p15:notesGuideLst>
+    </p:ext>
+  </p:extLst>
 </p:presentation>
 </file>
 
@@ -4471,18 +4502,21 @@
               </a:rPr>
             </a:br>
             <a:r>
+              <a:rPr lang="en-US" sz="2000" dirty="0">
+                <a:solidFill>
+                  <a:srgbClr val="990000"/>
+                </a:solidFill>
+              </a:rPr>
+              <a:t>2</a:t>
+            </a:r>
+            <a:r>
               <a:rPr lang="en-US" sz="2000" dirty="0" smtClean="0">
                 <a:solidFill>
                   <a:srgbClr val="990000"/>
                 </a:solidFill>
               </a:rPr>
-              <a:t>14.10.2016</a:t>
-            </a:r>
-            <a:endParaRPr lang="en-US" sz="2000" dirty="0" smtClean="0">
-              <a:solidFill>
-                <a:srgbClr val="990000"/>
-              </a:solidFill>
-            </a:endParaRPr>
+              <a:t>4.10.2016</a:t>
+            </a:r>
           </a:p>
           <a:p>
             <a:pPr eaLnBrk="1" hangingPunct="1"/>
@@ -4655,8 +4689,8 @@
         </p:nvSpPr>
         <p:spPr>
           <a:xfrm>
-            <a:off x="468315" y="570359"/>
-            <a:ext cx="8218487" cy="482377"/>
+            <a:off x="467544" y="548680"/>
+            <a:ext cx="8218487" cy="504056"/>
           </a:xfrm>
         </p:spPr>
         <p:txBody>
@@ -4664,12 +4698,16 @@
           <a:lstStyle/>
           <a:p>
             <a:r>
+              <a:rPr lang="en-US" dirty="0" smtClean="0"/>
+              <a:t>Notes for using </a:t>
+            </a:r>
+            <a:r>
               <a:rPr lang="en-US" dirty="0" err="1" smtClean="0"/>
               <a:t>Vecto</a:t>
             </a:r>
             <a:r>
               <a:rPr lang="en-US" dirty="0" smtClean="0"/>
-              <a:t> 3.0.3.537</a:t>
+              <a:t> 3.x with AAUX (3)</a:t>
             </a:r>
             <a:endParaRPr lang="en-US" dirty="0"/>
           </a:p>
@@ -4687,8 +4725,8 @@
         </p:nvSpPr>
         <p:spPr>
           <a:xfrm>
-            <a:off x="179512" y="1124744"/>
-            <a:ext cx="8784975" cy="4857403"/>
+            <a:off x="251521" y="1628800"/>
+            <a:ext cx="8640959" cy="4608512"/>
           </a:xfrm>
         </p:spPr>
         <p:txBody>
@@ -4697,171 +4735,99 @@
           <a:p>
             <a:r>
               <a:rPr lang="en-US" dirty="0" smtClean="0"/>
-              <a:t>Main Updates</a:t>
-            </a:r>
-          </a:p>
-          <a:p>
-            <a:pPr lvl="1"/>
-            <a:r>
-              <a:rPr lang="en-US" dirty="0" smtClean="0"/>
-              <a:t>Plot shift lines as computed according to WB 2016 declaration mode in GUI</a:t>
-            </a:r>
-          </a:p>
-          <a:p>
-            <a:r>
-              <a:rPr lang="en-US" dirty="0" err="1" smtClean="0"/>
-              <a:t>Bugfixes</a:t>
-            </a:r>
-            <a:endParaRPr lang="en-US" dirty="0" smtClean="0"/>
-          </a:p>
-          <a:p>
-            <a:pPr lvl="1"/>
-            <a:r>
-              <a:rPr lang="en-US" dirty="0" smtClean="0"/>
-              <a:t>GUI: Buttons to add/remove auxiliaries are visible again</a:t>
-            </a:r>
-          </a:p>
-          <a:p>
-            <a:pPr lvl="1"/>
-            <a:r>
-              <a:rPr lang="en-US" dirty="0" smtClean="0"/>
-              <a:t>Error in calculation of WHTC correction factor</a:t>
-            </a:r>
-          </a:p>
-          <a:p>
-            <a:pPr lvl="1"/>
-            <a:r>
-              <a:rPr lang="en-US" dirty="0" smtClean="0"/>
-              <a:t>Fix: consider gearbox inertia (engineering mode) for searching operating point</a:t>
-            </a:r>
-          </a:p>
-          <a:p>
-            <a:pPr lvl="1"/>
-            <a:r>
-              <a:rPr lang="en-US" dirty="0" smtClean="0"/>
-              <a:t>Wrong output of road gradient in measured speed mode (correct gradient for simulation)</a:t>
-            </a:r>
-          </a:p>
-          <a:p>
-            <a:pPr lvl="1"/>
-            <a:r>
-              <a:rPr lang="en-US" dirty="0" smtClean="0"/>
-              <a:t>Fuel consumption in .</a:t>
+              <a:t>Output .</a:t>
             </a:r>
             <a:r>
               <a:rPr lang="en-US" dirty="0" err="1" smtClean="0"/>
               <a:t>vsum</a:t>
             </a:r>
-            <a:r>
-              <a:rPr lang="en-US" dirty="0" smtClean="0"/>
-              <a:t> file now accounts for </a:t>
+            <a:endParaRPr lang="en-US" dirty="0" smtClean="0"/>
+          </a:p>
+          <a:p>
+            <a:pPr lvl="1"/>
+            <a:r>
+              <a:rPr lang="en-US" dirty="0" smtClean="0"/>
+              <a:t>Columns in .</a:t>
             </a:r>
             <a:r>
               <a:rPr lang="en-US" dirty="0" err="1" smtClean="0"/>
-              <a:t>AdvancedAuxiliaries</a:t>
-            </a:r>
-            <a:r>
-              <a:rPr lang="en-US" dirty="0" smtClean="0"/>
-              <a:t> model</a:t>
-            </a:r>
-          </a:p>
-          <a:p>
-            <a:pPr lvl="1"/>
+              <a:t>vsum</a:t>
+            </a:r>
+            <a:r>
+              <a:rPr lang="en-US" dirty="0" smtClean="0"/>
+              <a:t> file:</a:t>
+            </a:r>
+          </a:p>
+          <a:p>
+            <a:pPr lvl="2"/>
+            <a:r>
+              <a:rPr lang="en-US" dirty="0" smtClean="0"/>
+              <a:t>FC-Map: total fuel consumption as computed by </a:t>
+            </a:r>
             <a:r>
               <a:rPr lang="en-US" dirty="0" err="1" smtClean="0"/>
-              <a:t>GraphDrawer</a:t>
-            </a:r>
-            <a:r>
-              <a:rPr lang="en-US" dirty="0" smtClean="0"/>
-              <a:t> (</a:t>
+              <a:t>VectoCore</a:t>
+            </a:r>
+            <a:r>
+              <a:rPr lang="en-US" dirty="0" smtClean="0"/>
+              <a:t> interpolating in the FC-Map, using an average base load of auxiliaries</a:t>
+            </a:r>
+          </a:p>
+          <a:p>
+            <a:pPr lvl="2"/>
+            <a:r>
+              <a:rPr lang="en-US" dirty="0" smtClean="0"/>
+              <a:t>FC-</a:t>
             </a:r>
             <a:r>
               <a:rPr lang="en-US" dirty="0" err="1" smtClean="0"/>
-              <a:t>Vecto</a:t>
-            </a:r>
-            <a:r>
-              <a:rPr lang="en-US" dirty="0" smtClean="0"/>
-              <a:t>): handle new .</a:t>
+              <a:t>AUXc</a:t>
+            </a:r>
+            <a:r>
+              <a:rPr lang="en-US" dirty="0" smtClean="0"/>
+              <a:t>: total fuel consumption corrected due to engine stop/start (currently not applicable)</a:t>
+            </a:r>
+          </a:p>
+          <a:p>
+            <a:pPr lvl="2"/>
+            <a:r>
+              <a:rPr lang="en-US" dirty="0" smtClean="0"/>
+              <a:t>FC-</a:t>
             </a:r>
             <a:r>
               <a:rPr lang="en-US" dirty="0" err="1" smtClean="0"/>
-              <a:t>vmod</a:t>
-            </a:r>
-            <a:r>
-              <a:rPr lang="en-US" dirty="0" smtClean="0"/>
-              <a:t> format of </a:t>
+              <a:t>WHTCc</a:t>
+            </a:r>
+            <a:r>
+              <a:rPr lang="en-US" dirty="0" smtClean="0"/>
+              <a:t>: WHTC-corrected fuel consumption (not applicable in engineering mode)</a:t>
+            </a:r>
+          </a:p>
+          <a:p>
+            <a:pPr lvl="2"/>
+            <a:r>
+              <a:rPr lang="en-US" dirty="0" smtClean="0"/>
+              <a:t>FC-AAUX: fuel consumption per simulation interval, derived from </a:t>
             </a:r>
             <a:r>
               <a:rPr lang="en-US" dirty="0" err="1" smtClean="0"/>
-              <a:t>Vecto</a:t>
-            </a:r>
-            <a:r>
-              <a:rPr lang="en-US" dirty="0" smtClean="0"/>
-              <a:t> 3</a:t>
-            </a:r>
-          </a:p>
-          <a:p>
-            <a:pPr lvl="1"/>
-            <a:r>
-              <a:rPr lang="en-US" dirty="0" err="1" smtClean="0"/>
-              <a:t>AdvancedAuxiliaries</a:t>
-            </a:r>
-            <a:r>
-              <a:rPr lang="en-US" dirty="0" smtClean="0"/>
-              <a:t>: language-settings independent input parsing</a:t>
-            </a:r>
-          </a:p>
-          <a:p>
-            <a:pPr lvl="1"/>
-            <a:r>
-              <a:rPr lang="en-US" dirty="0" err="1" smtClean="0"/>
-              <a:t>Paux</a:t>
-            </a:r>
-            <a:r>
-              <a:rPr lang="en-US" dirty="0" smtClean="0"/>
-              <a:t> was ignored when running </a:t>
-            </a:r>
-            <a:r>
-              <a:rPr lang="en-US" dirty="0" err="1" smtClean="0"/>
-              <a:t>Vecto</a:t>
-            </a:r>
-            <a:r>
-              <a:rPr lang="en-US" dirty="0" smtClean="0"/>
-              <a:t> 2.2</a:t>
-            </a:r>
-          </a:p>
-          <a:p>
-            <a:pPr lvl="1"/>
-            <a:r>
-              <a:rPr lang="en-US" dirty="0" smtClean="0"/>
-              <a:t>Error in massive multithreaded execution</a:t>
-            </a:r>
-          </a:p>
-          <a:p>
-            <a:pPr lvl="1"/>
-            <a:r>
-              <a:rPr lang="en-US" dirty="0" smtClean="0"/>
-              <a:t>Fix unhandled response during simulation</a:t>
-            </a:r>
-          </a:p>
-          <a:p>
-            <a:pPr lvl="1"/>
-            <a:r>
-              <a:rPr lang="en-US" dirty="0" smtClean="0"/>
-              <a:t>Fix output columns in .</a:t>
-            </a:r>
-            <a:r>
-              <a:rPr lang="en-US" dirty="0" err="1" smtClean="0"/>
-              <a:t>vmod</a:t>
+              <a:t>AA_TotalCycleFC_Grams</a:t>
             </a:r>
             <a:endParaRPr lang="en-US" dirty="0" smtClean="0"/>
+          </a:p>
+          <a:p>
+            <a:pPr lvl="2"/>
+            <a:r>
+              <a:rPr lang="en-US" dirty="0" smtClean="0"/>
+              <a:t>FC-Final: final fuel consumption value with all (applicable) corrections applied (stop/start, WHTC, smart auxiliaries)</a:t>
+            </a:r>
           </a:p>
         </p:txBody>
       </p:sp>
     </p:spTree>
     <p:extLst>
       <p:ext uri="{BB962C8B-B14F-4D97-AF65-F5344CB8AC3E}">
-        <p14:creationId xmlns:p14="http://schemas.microsoft.com/office/powerpoint/2010/main" val="4096386672"/>
+        <p14:creationId xmlns:p14="http://schemas.microsoft.com/office/powerpoint/2010/main" val="120205155"/>
       </p:ext>
     </p:extLst>
   </p:cSld>
@@ -4905,6 +4871,269 @@
             <p:ph type="title"/>
           </p:nvPr>
         </p:nvSpPr>
+        <p:spPr>
+          <a:xfrm>
+            <a:off x="468315" y="570359"/>
+            <a:ext cx="8218487" cy="482377"/>
+          </a:xfrm>
+        </p:spPr>
+        <p:txBody>
+          <a:bodyPr/>
+          <a:lstStyle/>
+          <a:p>
+            <a:r>
+              <a:rPr lang="en-US" dirty="0" err="1" smtClean="0"/>
+              <a:t>Vecto</a:t>
+            </a:r>
+            <a:r>
+              <a:rPr lang="en-US" dirty="0" smtClean="0"/>
+              <a:t> </a:t>
+            </a:r>
+            <a:r>
+              <a:rPr lang="en-US" dirty="0"/>
+              <a:t>3.0.3.537</a:t>
+            </a:r>
+            <a:br>
+              <a:rPr lang="en-US" dirty="0"/>
+            </a:br>
+            <a:r>
+              <a:rPr lang="en-US" sz="1600" dirty="0"/>
+              <a:t>2016-06-21</a:t>
+            </a:r>
+            <a:endParaRPr lang="en-US" dirty="0"/>
+          </a:p>
+        </p:txBody>
+      </p:sp>
+      <p:sp>
+        <p:nvSpPr>
+          <p:cNvPr id="3" name="Inhaltsplatzhalter 2"/>
+          <p:cNvSpPr>
+            <a:spLocks noGrp="1"/>
+          </p:cNvSpPr>
+          <p:nvPr>
+            <p:ph idx="1"/>
+          </p:nvPr>
+        </p:nvSpPr>
+        <p:spPr>
+          <a:xfrm>
+            <a:off x="179512" y="1124744"/>
+            <a:ext cx="8784975" cy="4857403"/>
+          </a:xfrm>
+        </p:spPr>
+        <p:txBody>
+          <a:bodyPr/>
+          <a:lstStyle/>
+          <a:p>
+            <a:r>
+              <a:rPr lang="en-US" dirty="0" smtClean="0"/>
+              <a:t>Main Updates</a:t>
+            </a:r>
+          </a:p>
+          <a:p>
+            <a:pPr lvl="1"/>
+            <a:r>
+              <a:rPr lang="en-US" dirty="0" smtClean="0"/>
+              <a:t>Plot shift lines as computed according to WB 2016 declaration mode in GUI</a:t>
+            </a:r>
+          </a:p>
+          <a:p>
+            <a:r>
+              <a:rPr lang="en-US" dirty="0" err="1" smtClean="0"/>
+              <a:t>Bugfixes</a:t>
+            </a:r>
+            <a:endParaRPr lang="en-US" dirty="0" smtClean="0"/>
+          </a:p>
+          <a:p>
+            <a:pPr lvl="1"/>
+            <a:r>
+              <a:rPr lang="en-US" dirty="0" smtClean="0"/>
+              <a:t>GUI: Buttons to add/remove auxiliaries are visible again</a:t>
+            </a:r>
+          </a:p>
+          <a:p>
+            <a:pPr lvl="1"/>
+            <a:r>
+              <a:rPr lang="en-US" dirty="0" smtClean="0"/>
+              <a:t>Error in calculation of WHTC correction factor</a:t>
+            </a:r>
+          </a:p>
+          <a:p>
+            <a:pPr lvl="1"/>
+            <a:r>
+              <a:rPr lang="en-US" dirty="0" smtClean="0"/>
+              <a:t>Fix: consider gearbox inertia (engineering mode) for searching operating point</a:t>
+            </a:r>
+          </a:p>
+          <a:p>
+            <a:pPr lvl="1"/>
+            <a:r>
+              <a:rPr lang="en-US" dirty="0" smtClean="0"/>
+              <a:t>Wrong output of road gradient in measured speed mode (correct gradient for simulation)</a:t>
+            </a:r>
+          </a:p>
+          <a:p>
+            <a:pPr lvl="1"/>
+            <a:r>
+              <a:rPr lang="en-US" dirty="0" smtClean="0"/>
+              <a:t>Fuel consumption in .</a:t>
+            </a:r>
+            <a:r>
+              <a:rPr lang="en-US" dirty="0" err="1" smtClean="0"/>
+              <a:t>vsum</a:t>
+            </a:r>
+            <a:r>
+              <a:rPr lang="en-US" dirty="0" smtClean="0"/>
+              <a:t> file now accounts for </a:t>
+            </a:r>
+            <a:r>
+              <a:rPr lang="en-US" dirty="0" err="1" smtClean="0"/>
+              <a:t>AdvancedAuxiliaries</a:t>
+            </a:r>
+            <a:r>
+              <a:rPr lang="en-US" dirty="0" smtClean="0"/>
+              <a:t> model</a:t>
+            </a:r>
+          </a:p>
+          <a:p>
+            <a:pPr lvl="1"/>
+            <a:r>
+              <a:rPr lang="en-US" dirty="0" err="1" smtClean="0"/>
+              <a:t>GraphDrawer</a:t>
+            </a:r>
+            <a:r>
+              <a:rPr lang="en-US" dirty="0" smtClean="0"/>
+              <a:t> (</a:t>
+            </a:r>
+            <a:r>
+              <a:rPr lang="en-US" dirty="0" err="1" smtClean="0"/>
+              <a:t>Vecto</a:t>
+            </a:r>
+            <a:r>
+              <a:rPr lang="en-US" dirty="0" smtClean="0"/>
+              <a:t>): handle new .</a:t>
+            </a:r>
+            <a:r>
+              <a:rPr lang="en-US" dirty="0" err="1" smtClean="0"/>
+              <a:t>vmod</a:t>
+            </a:r>
+            <a:r>
+              <a:rPr lang="en-US" dirty="0" smtClean="0"/>
+              <a:t> format of </a:t>
+            </a:r>
+            <a:r>
+              <a:rPr lang="en-US" dirty="0" err="1" smtClean="0"/>
+              <a:t>Vecto</a:t>
+            </a:r>
+            <a:r>
+              <a:rPr lang="en-US" dirty="0" smtClean="0"/>
+              <a:t> 3</a:t>
+            </a:r>
+          </a:p>
+          <a:p>
+            <a:pPr lvl="1"/>
+            <a:r>
+              <a:rPr lang="en-US" dirty="0" err="1" smtClean="0"/>
+              <a:t>AdvancedAuxiliaries</a:t>
+            </a:r>
+            <a:r>
+              <a:rPr lang="en-US" dirty="0" smtClean="0"/>
+              <a:t>: language-settings independent input parsing</a:t>
+            </a:r>
+          </a:p>
+          <a:p>
+            <a:pPr lvl="1"/>
+            <a:r>
+              <a:rPr lang="en-US" dirty="0" err="1" smtClean="0"/>
+              <a:t>Paux</a:t>
+            </a:r>
+            <a:r>
+              <a:rPr lang="en-US" dirty="0" smtClean="0"/>
+              <a:t> was ignored when running </a:t>
+            </a:r>
+            <a:r>
+              <a:rPr lang="en-US" dirty="0" err="1" smtClean="0"/>
+              <a:t>Vecto</a:t>
+            </a:r>
+            <a:r>
+              <a:rPr lang="en-US" dirty="0" smtClean="0"/>
+              <a:t> 2.2</a:t>
+            </a:r>
+          </a:p>
+          <a:p>
+            <a:pPr lvl="1"/>
+            <a:r>
+              <a:rPr lang="en-US" dirty="0" smtClean="0"/>
+              <a:t>Error in massive multithreaded execution</a:t>
+            </a:r>
+          </a:p>
+          <a:p>
+            <a:pPr lvl="1"/>
+            <a:r>
+              <a:rPr lang="en-US" dirty="0" smtClean="0"/>
+              <a:t>Fix unhandled response during simulation</a:t>
+            </a:r>
+          </a:p>
+          <a:p>
+            <a:pPr lvl="1"/>
+            <a:r>
+              <a:rPr lang="en-US" dirty="0" smtClean="0"/>
+              <a:t>Fix output columns in .</a:t>
+            </a:r>
+            <a:r>
+              <a:rPr lang="en-US" dirty="0" err="1" smtClean="0"/>
+              <a:t>vmod</a:t>
+            </a:r>
+            <a:endParaRPr lang="en-US" dirty="0" smtClean="0"/>
+          </a:p>
+        </p:txBody>
+      </p:sp>
+    </p:spTree>
+    <p:extLst>
+      <p:ext uri="{BB962C8B-B14F-4D97-AF65-F5344CB8AC3E}">
+        <p14:creationId xmlns:p14="http://schemas.microsoft.com/office/powerpoint/2010/main" val="4096386672"/>
+      </p:ext>
+    </p:extLst>
+  </p:cSld>
+  <p:clrMapOvr>
+    <a:masterClrMapping/>
+  </p:clrMapOvr>
+  <p:timing>
+    <p:tnLst>
+      <p:par>
+        <p:cTn id="1" dur="indefinite" restart="never" nodeType="tmRoot"/>
+      </p:par>
+    </p:tnLst>
+  </p:timing>
+</p:sld>
+</file>
+
+<file path=ppt/slides/slide12.xml><?xml version="1.0" encoding="utf-8"?>
+<p:sld xmlns:a="http://schemas.openxmlformats.org/drawingml/2006/main" xmlns:r="http://schemas.openxmlformats.org/officeDocument/2006/relationships" xmlns:p="http://schemas.openxmlformats.org/presentationml/2006/main">
+  <p:cSld>
+    <p:spTree>
+      <p:nvGrpSpPr>
+        <p:cNvPr id="1" name=""/>
+        <p:cNvGrpSpPr/>
+        <p:nvPr/>
+      </p:nvGrpSpPr>
+      <p:grpSpPr>
+        <a:xfrm>
+          <a:off x="0" y="0"/>
+          <a:ext cx="0" cy="0"/>
+          <a:chOff x="0" y="0"/>
+          <a:chExt cx="0" cy="0"/>
+        </a:xfrm>
+      </p:grpSpPr>
+      <p:sp>
+        <p:nvSpPr>
+          <p:cNvPr id="2" name="Titel 1"/>
+          <p:cNvSpPr>
+            <a:spLocks noGrp="1"/>
+          </p:cNvSpPr>
+          <p:nvPr>
+            <p:ph type="title"/>
+          </p:nvPr>
+        </p:nvSpPr>
         <p:spPr/>
         <p:txBody>
           <a:bodyPr/>
@@ -4916,7 +5145,18 @@
             </a:r>
             <a:r>
               <a:rPr lang="en-US" dirty="0" smtClean="0"/>
-              <a:t> 3.0.3</a:t>
+              <a:t> 3.0.3.495</a:t>
+            </a:r>
+            <a:r>
+              <a:rPr lang="en-US" dirty="0"/>
+              <a:t/>
+            </a:r>
+            <a:br>
+              <a:rPr lang="en-US" dirty="0"/>
+            </a:br>
+            <a:r>
+              <a:rPr lang="en-US" sz="1600" dirty="0"/>
+              <a:t>2016-05-10</a:t>
             </a:r>
             <a:endParaRPr lang="en-US" dirty="0"/>
           </a:p>
@@ -5052,7 +5292,7 @@
 </p:sld>
 </file>
 
-<file path=ppt/slides/slide12.xml><?xml version="1.0" encoding="utf-8"?>
+<file path=ppt/slides/slide13.xml><?xml version="1.0" encoding="utf-8"?>
 <p:sld xmlns:a="http://schemas.openxmlformats.org/drawingml/2006/main" xmlns:r="http://schemas.openxmlformats.org/officeDocument/2006/relationships" xmlns:p="http://schemas.openxmlformats.org/presentationml/2006/main">
   <p:cSld>
     <p:spTree>
@@ -5237,7 +5477,7 @@
 </p:sld>
 </file>
 
-<file path=ppt/slides/slide13.xml><?xml version="1.0" encoding="utf-8"?>
+<file path=ppt/slides/slide14.xml><?xml version="1.0" encoding="utf-8"?>
 <p:sld xmlns:a="http://schemas.openxmlformats.org/drawingml/2006/main" xmlns:r="http://schemas.openxmlformats.org/officeDocument/2006/relationships" xmlns:p="http://schemas.openxmlformats.org/presentationml/2006/main">
   <p:cSld>
     <p:spTree>
@@ -5444,7 +5684,18 @@
             <a:pPr eaLnBrk="1" hangingPunct="1"/>
             <a:r>
               <a:rPr lang="en-GB" sz="2800" kern="0" dirty="0" smtClean="0"/>
-              <a:t>VECTO 3.0.2</a:t>
+              <a:t>VECTO </a:t>
+            </a:r>
+            <a:r>
+              <a:rPr lang="en-GB" sz="2800" kern="0" dirty="0"/>
+              <a:t>3.0.2</a:t>
+            </a:r>
+            <a:br>
+              <a:rPr lang="en-GB" sz="2800" kern="0" dirty="0"/>
+            </a:br>
+            <a:r>
+              <a:rPr lang="en-GB" sz="1600" kern="0" dirty="0" smtClean="0"/>
+              <a:t>2016-03-11</a:t>
             </a:r>
             <a:endParaRPr lang="en-GB" sz="2800" kern="0" dirty="0"/>
           </a:p>
@@ -5813,188 +6064,6 @@
       </p:par>
     </p:tnLst>
   </p:timing>
-</p:sld>
-</file>
-
-<file path=ppt/slides/slide14.xml><?xml version="1.0" encoding="utf-8"?>
-<p:sld xmlns:a="http://schemas.openxmlformats.org/drawingml/2006/main" xmlns:r="http://schemas.openxmlformats.org/officeDocument/2006/relationships" xmlns:p="http://schemas.openxmlformats.org/presentationml/2006/main">
-  <p:cSld>
-    <p:spTree>
-      <p:nvGrpSpPr>
-        <p:cNvPr id="1" name=""/>
-        <p:cNvGrpSpPr/>
-        <p:nvPr/>
-      </p:nvGrpSpPr>
-      <p:grpSpPr>
-        <a:xfrm>
-          <a:off x="0" y="0"/>
-          <a:ext cx="0" cy="0"/>
-          <a:chOff x="0" y="0"/>
-          <a:chExt cx="0" cy="0"/>
-        </a:xfrm>
-      </p:grpSpPr>
-      <p:sp>
-        <p:nvSpPr>
-          <p:cNvPr id="2" name="Titel 1"/>
-          <p:cNvSpPr>
-            <a:spLocks noGrp="1"/>
-          </p:cNvSpPr>
-          <p:nvPr>
-            <p:ph type="title"/>
-          </p:nvPr>
-        </p:nvSpPr>
-        <p:spPr/>
-        <p:txBody>
-          <a:bodyPr/>
-          <a:lstStyle/>
-          <a:p>
-            <a:r>
-              <a:rPr lang="en-US" dirty="0" err="1" smtClean="0"/>
-              <a:t>Pwheel</a:t>
-            </a:r>
-            <a:r>
-              <a:rPr lang="en-US" dirty="0" smtClean="0"/>
-              <a:t> (</a:t>
-            </a:r>
-            <a:r>
-              <a:rPr lang="en-US" dirty="0" err="1" smtClean="0"/>
-              <a:t>SiCo</a:t>
-            </a:r>
-            <a:r>
-              <a:rPr lang="en-US" dirty="0" smtClean="0"/>
-              <a:t>) Mode</a:t>
-            </a:r>
-            <a:endParaRPr lang="en-US" dirty="0"/>
-          </a:p>
-        </p:txBody>
-      </p:sp>
-      <p:sp>
-        <p:nvSpPr>
-          <p:cNvPr id="3" name="Inhaltsplatzhalter 2"/>
-          <p:cNvSpPr>
-            <a:spLocks noGrp="1"/>
-          </p:cNvSpPr>
-          <p:nvPr>
-            <p:ph idx="1"/>
-          </p:nvPr>
-        </p:nvSpPr>
-        <p:spPr/>
-        <p:txBody>
-          <a:bodyPr/>
-          <a:lstStyle/>
-          <a:p>
-            <a:r>
-              <a:rPr lang="en-US" dirty="0" smtClean="0"/>
-              <a:t>Function as already available in </a:t>
-            </a:r>
-            <a:r>
-              <a:rPr lang="en-US" dirty="0" err="1" smtClean="0"/>
-              <a:t>Vecto</a:t>
-            </a:r>
-            <a:r>
-              <a:rPr lang="en-US" dirty="0" smtClean="0"/>
-              <a:t> 2.2 also added in </a:t>
-            </a:r>
-            <a:r>
-              <a:rPr lang="en-US" dirty="0" err="1" smtClean="0"/>
-              <a:t>Vecto</a:t>
-            </a:r>
-            <a:r>
-              <a:rPr lang="en-US" dirty="0" smtClean="0"/>
-              <a:t> 3.0.2</a:t>
-            </a:r>
-          </a:p>
-          <a:p>
-            <a:pPr lvl="1"/>
-            <a:r>
-              <a:rPr lang="en-US" dirty="0" smtClean="0"/>
-              <a:t>Driving cycle specifies power at wheel, engine speed, gear, and auxiliary power</a:t>
-            </a:r>
-          </a:p>
-          <a:p>
-            <a:pPr lvl="1"/>
-            <a:r>
-              <a:rPr lang="en-US" dirty="0"/>
-              <a:t>No driver model in the simulation.</a:t>
-            </a:r>
-          </a:p>
-          <a:p>
-            <a:pPr lvl="1"/>
-            <a:r>
-              <a:rPr lang="en-US" dirty="0" smtClean="0"/>
-              <a:t>The </a:t>
-            </a:r>
-            <a:r>
-              <a:rPr lang="en-US" dirty="0" err="1"/>
-              <a:t>Vecto</a:t>
-            </a:r>
-            <a:r>
-              <a:rPr lang="en-US" dirty="0"/>
-              <a:t> gear-shift model is overruled.</a:t>
-            </a:r>
-          </a:p>
-          <a:p>
-            <a:pPr lvl="1"/>
-            <a:r>
-              <a:rPr lang="en-US" dirty="0"/>
-              <a:t>Function used for </a:t>
-            </a:r>
-            <a:r>
-              <a:rPr lang="en-US" dirty="0" smtClean="0"/>
-              <a:t>creating reference results for </a:t>
-            </a:r>
-            <a:r>
-              <a:rPr lang="en-US" dirty="0" err="1" smtClean="0"/>
-              <a:t>SiCo</a:t>
-            </a:r>
-            <a:r>
-              <a:rPr lang="en-US" dirty="0" smtClean="0"/>
-              <a:t> tests</a:t>
-            </a:r>
-          </a:p>
-          <a:p>
-            <a:pPr lvl="1"/>
-            <a:r>
-              <a:rPr lang="en-US" dirty="0" smtClean="0"/>
-              <a:t>For details see user manual: Simulation Models / </a:t>
-            </a:r>
-            <a:r>
-              <a:rPr lang="en-US" dirty="0" err="1" smtClean="0"/>
-              <a:t>Pwheel</a:t>
-            </a:r>
-            <a:r>
-              <a:rPr lang="en-US" dirty="0" smtClean="0"/>
-              <a:t> Input (</a:t>
-            </a:r>
-            <a:r>
-              <a:rPr lang="en-US" dirty="0" err="1" smtClean="0"/>
-              <a:t>SiCo</a:t>
-            </a:r>
-            <a:r>
-              <a:rPr lang="en-US" dirty="0" smtClean="0"/>
-              <a:t>)</a:t>
-            </a:r>
-            <a:endParaRPr lang="en-US" dirty="0"/>
-          </a:p>
-          <a:p>
-            <a:pPr lvl="1"/>
-            <a:endParaRPr lang="en-US" dirty="0" smtClean="0"/>
-          </a:p>
-          <a:p>
-            <a:endParaRPr lang="en-US" dirty="0"/>
-          </a:p>
-        </p:txBody>
-      </p:sp>
-    </p:spTree>
-    <p:extLst>
-      <p:ext uri="{BB962C8B-B14F-4D97-AF65-F5344CB8AC3E}">
-        <p14:creationId xmlns:p14="http://schemas.microsoft.com/office/powerpoint/2010/main" val="3176522223"/>
-      </p:ext>
-    </p:extLst>
-  </p:cSld>
-  <p:clrMapOvr>
-    <a:masterClrMapping/>
-  </p:clrMapOvr>
 </p:sld>
 </file>
 
@@ -6031,8 +6100,20 @@
           <a:lstStyle/>
           <a:p>
             <a:r>
-              <a:rPr lang="en-US" dirty="0" smtClean="0"/>
-              <a:t>Measured Speed Mode</a:t>
+              <a:rPr lang="en-US" dirty="0" err="1" smtClean="0"/>
+              <a:t>Pwheel</a:t>
+            </a:r>
+            <a:r>
+              <a:rPr lang="en-US" dirty="0" smtClean="0"/>
+              <a:t> (</a:t>
+            </a:r>
+            <a:r>
+              <a:rPr lang="en-US" dirty="0" err="1" smtClean="0"/>
+              <a:t>SiCo</a:t>
+            </a:r>
+            <a:r>
+              <a:rPr lang="en-US" dirty="0" smtClean="0"/>
+              <a:t>) Mode</a:t>
             </a:r>
             <a:endParaRPr lang="en-US" dirty="0"/>
           </a:p>
@@ -6055,7 +6136,7 @@
           <a:p>
             <a:r>
               <a:rPr lang="en-US" dirty="0" smtClean="0"/>
-              <a:t>Functionality already available in </a:t>
+              <a:t>Function as already available in </a:t>
             </a:r>
             <a:r>
               <a:rPr lang="en-US" dirty="0" err="1" smtClean="0"/>
@@ -6063,7 +6144,7 @@
             </a:r>
             <a:r>
               <a:rPr lang="en-US" dirty="0" smtClean="0"/>
-              <a:t> 2.2 added in </a:t>
+              <a:t> 2.2 also added in </a:t>
             </a:r>
             <a:r>
               <a:rPr lang="en-US" dirty="0" err="1" smtClean="0"/>
@@ -6078,37 +6159,79 @@
             <a:pPr lvl="1"/>
             <a:r>
               <a:rPr lang="en-US" dirty="0" smtClean="0"/>
-              <a:t>Driving cycle not defined by target speed but by actual speed. No driver model in the simulation.</a:t>
+              <a:t>Driving cycle specifies power at wheel, engine speed, gear, and auxiliary power</a:t>
             </a:r>
           </a:p>
           <a:p>
             <a:pPr lvl="1"/>
             <a:r>
-              <a:rPr lang="en-US" dirty="0" smtClean="0"/>
-              <a:t>Gear and engine speed can be specified in the driving cycle. In this case the </a:t>
+              <a:rPr lang="en-US" dirty="0"/>
+              <a:t>No driver model in the simulation.</a:t>
+            </a:r>
+          </a:p>
+          <a:p>
+            <a:pPr lvl="1"/>
+            <a:r>
+              <a:rPr lang="en-US" dirty="0" smtClean="0"/>
+              <a:t>The </a:t>
+            </a:r>
+            <a:r>
+              <a:rPr lang="en-US" dirty="0" err="1"/>
+              <a:t>Vecto</a:t>
+            </a:r>
+            <a:r>
+              <a:rPr lang="en-US" dirty="0"/>
+              <a:t> gear-shift model is overruled.</a:t>
+            </a:r>
+          </a:p>
+          <a:p>
+            <a:pPr lvl="1"/>
+            <a:r>
+              <a:rPr lang="en-US" dirty="0"/>
+              <a:t>Function used for </a:t>
+            </a:r>
+            <a:r>
+              <a:rPr lang="en-US" dirty="0" smtClean="0"/>
+              <a:t>creating reference results for </a:t>
             </a:r>
             <a:r>
               <a:rPr lang="en-US" dirty="0" err="1" smtClean="0"/>
-              <a:t>Vecto</a:t>
-            </a:r>
-            <a:r>
-              <a:rPr lang="en-US" dirty="0" smtClean="0"/>
-              <a:t> gear-shift model is overruled.</a:t>
+              <a:t>SiCo</a:t>
+            </a:r>
+            <a:r>
+              <a:rPr lang="en-US" dirty="0" smtClean="0"/>
+              <a:t> tests</a:t>
             </a:r>
           </a:p>
           <a:p>
             <a:pPr lvl="1"/>
             <a:r>
               <a:rPr lang="en-US" dirty="0" smtClean="0"/>
-              <a:t>Function used for “proof of concept” purposes</a:t>
-            </a:r>
+              <a:t>For details see user manual: Simulation Models / </a:t>
+            </a:r>
+            <a:r>
+              <a:rPr lang="en-US" dirty="0" err="1" smtClean="0"/>
+              <a:t>Pwheel</a:t>
+            </a:r>
+            <a:r>
+              <a:rPr lang="en-US" dirty="0" smtClean="0"/>
+              <a:t> Input (</a:t>
+            </a:r>
+            <a:r>
+              <a:rPr lang="en-US" dirty="0" err="1" smtClean="0"/>
+              <a:t>SiCo</a:t>
+            </a:r>
+            <a:r>
+              <a:rPr lang="en-US" dirty="0" smtClean="0"/>
+              <a:t>)</a:t>
+            </a:r>
+            <a:endParaRPr lang="en-US" dirty="0"/>
           </a:p>
           <a:p>
             <a:pPr lvl="1"/>
-            <a:r>
-              <a:rPr lang="en-US" dirty="0" smtClean="0"/>
-              <a:t>For details see user manual: Calculation Modes / Engineering Mode / Measured Speed</a:t>
-            </a:r>
+            <a:endParaRPr lang="en-US" dirty="0" smtClean="0"/>
+          </a:p>
+          <a:p>
             <a:endParaRPr lang="en-US" dirty="0"/>
           </a:p>
         </p:txBody>
@@ -6116,7 +6239,7 @@
     </p:spTree>
     <p:extLst>
       <p:ext uri="{BB962C8B-B14F-4D97-AF65-F5344CB8AC3E}">
-        <p14:creationId xmlns:p14="http://schemas.microsoft.com/office/powerpoint/2010/main" val="3735808897"/>
+        <p14:creationId xmlns:p14="http://schemas.microsoft.com/office/powerpoint/2010/main" val="3176522223"/>
       </p:ext>
     </p:extLst>
   </p:cSld>
@@ -6160,15 +6283,7 @@
           <a:p>
             <a:r>
               <a:rPr lang="en-US" dirty="0" smtClean="0"/>
-              <a:t>.</a:t>
-            </a:r>
-            <a:r>
-              <a:rPr lang="en-US" dirty="0" err="1" smtClean="0"/>
-              <a:t>vmod</a:t>
-            </a:r>
-            <a:r>
-              <a:rPr lang="en-US" dirty="0" smtClean="0"/>
-              <a:t> File Update</a:t>
+              <a:t>Measured Speed Mode</a:t>
             </a:r>
             <a:endParaRPr lang="en-US" dirty="0"/>
           </a:p>
@@ -6190,6 +6305,142 @@
           <a:lstStyle/>
           <a:p>
             <a:r>
+              <a:rPr lang="en-US" dirty="0" smtClean="0"/>
+              <a:t>Functionality already available in </a:t>
+            </a:r>
+            <a:r>
+              <a:rPr lang="en-US" dirty="0" err="1" smtClean="0"/>
+              <a:t>Vecto</a:t>
+            </a:r>
+            <a:r>
+              <a:rPr lang="en-US" dirty="0" smtClean="0"/>
+              <a:t> 2.2 added in </a:t>
+            </a:r>
+            <a:r>
+              <a:rPr lang="en-US" dirty="0" err="1" smtClean="0"/>
+              <a:t>Vecto</a:t>
+            </a:r>
+            <a:r>
+              <a:rPr lang="en-US" dirty="0" smtClean="0"/>
+              <a:t> 3.0.2</a:t>
+            </a:r>
+          </a:p>
+          <a:p>
+            <a:pPr lvl="1"/>
+            <a:r>
+              <a:rPr lang="en-US" dirty="0" smtClean="0"/>
+              <a:t>Driving cycle not defined by target speed but by actual speed. No driver model in the simulation.</a:t>
+            </a:r>
+          </a:p>
+          <a:p>
+            <a:pPr lvl="1"/>
+            <a:r>
+              <a:rPr lang="en-US" dirty="0" smtClean="0"/>
+              <a:t>Gear and engine speed can be specified in the driving cycle. In this case the </a:t>
+            </a:r>
+            <a:r>
+              <a:rPr lang="en-US" dirty="0" err="1" smtClean="0"/>
+              <a:t>Vecto</a:t>
+            </a:r>
+            <a:r>
+              <a:rPr lang="en-US" dirty="0" smtClean="0"/>
+              <a:t> gear-shift model is overruled.</a:t>
+            </a:r>
+          </a:p>
+          <a:p>
+            <a:pPr lvl="1"/>
+            <a:r>
+              <a:rPr lang="en-US" dirty="0" smtClean="0"/>
+              <a:t>Function used for “proof of concept” purposes</a:t>
+            </a:r>
+          </a:p>
+          <a:p>
+            <a:pPr lvl="1"/>
+            <a:r>
+              <a:rPr lang="en-US" dirty="0" smtClean="0"/>
+              <a:t>For details see user manual: Calculation Modes / Engineering Mode / Measured Speed</a:t>
+            </a:r>
+            <a:endParaRPr lang="en-US" dirty="0"/>
+          </a:p>
+        </p:txBody>
+      </p:sp>
+    </p:spTree>
+    <p:extLst>
+      <p:ext uri="{BB962C8B-B14F-4D97-AF65-F5344CB8AC3E}">
+        <p14:creationId xmlns:p14="http://schemas.microsoft.com/office/powerpoint/2010/main" val="3735808897"/>
+      </p:ext>
+    </p:extLst>
+  </p:cSld>
+  <p:clrMapOvr>
+    <a:masterClrMapping/>
+  </p:clrMapOvr>
+</p:sld>
+</file>
+
+<file path=ppt/slides/slide17.xml><?xml version="1.0" encoding="utf-8"?>
+<p:sld xmlns:a="http://schemas.openxmlformats.org/drawingml/2006/main" xmlns:r="http://schemas.openxmlformats.org/officeDocument/2006/relationships" xmlns:p="http://schemas.openxmlformats.org/presentationml/2006/main">
+  <p:cSld>
+    <p:spTree>
+      <p:nvGrpSpPr>
+        <p:cNvPr id="1" name=""/>
+        <p:cNvGrpSpPr/>
+        <p:nvPr/>
+      </p:nvGrpSpPr>
+      <p:grpSpPr>
+        <a:xfrm>
+          <a:off x="0" y="0"/>
+          <a:ext cx="0" cy="0"/>
+          <a:chOff x="0" y="0"/>
+          <a:chExt cx="0" cy="0"/>
+        </a:xfrm>
+      </p:grpSpPr>
+      <p:sp>
+        <p:nvSpPr>
+          <p:cNvPr id="2" name="Titel 1"/>
+          <p:cNvSpPr>
+            <a:spLocks noGrp="1"/>
+          </p:cNvSpPr>
+          <p:nvPr>
+            <p:ph type="title"/>
+          </p:nvPr>
+        </p:nvSpPr>
+        <p:spPr/>
+        <p:txBody>
+          <a:bodyPr/>
+          <a:lstStyle/>
+          <a:p>
+            <a:r>
+              <a:rPr lang="en-US" dirty="0" smtClean="0"/>
+              <a:t>.</a:t>
+            </a:r>
+            <a:r>
+              <a:rPr lang="en-US" dirty="0" err="1" smtClean="0"/>
+              <a:t>vmod</a:t>
+            </a:r>
+            <a:r>
+              <a:rPr lang="en-US" dirty="0" smtClean="0"/>
+              <a:t> File Update</a:t>
+            </a:r>
+            <a:endParaRPr lang="en-US" dirty="0"/>
+          </a:p>
+        </p:txBody>
+      </p:sp>
+      <p:sp>
+        <p:nvSpPr>
+          <p:cNvPr id="3" name="Inhaltsplatzhalter 2"/>
+          <p:cNvSpPr>
+            <a:spLocks noGrp="1"/>
+          </p:cNvSpPr>
+          <p:nvPr>
+            <p:ph idx="1"/>
+          </p:nvPr>
+        </p:nvSpPr>
+        <p:spPr/>
+        <p:txBody>
+          <a:bodyPr/>
+          <a:lstStyle/>
+          <a:p>
+            <a:r>
               <a:rPr lang="en-US" dirty="0"/>
               <a:t>In </a:t>
             </a:r>
@@ -6252,7 +6503,7 @@
 </p:sld>
 </file>
 
-<file path=ppt/slides/slide17.xml><?xml version="1.0" encoding="utf-8"?>
+<file path=ppt/slides/slide18.xml><?xml version="1.0" encoding="utf-8"?>
 <p:sld xmlns:a="http://schemas.openxmlformats.org/drawingml/2006/main" xmlns:r="http://schemas.openxmlformats.org/officeDocument/2006/relationships" xmlns:p="http://schemas.openxmlformats.org/presentationml/2006/main">
   <p:cSld>
     <p:spTree>
@@ -6710,9 +6961,16 @@
             </a:r>
             <a:r>
               <a:rPr lang="en-US" dirty="0" smtClean="0"/>
-              <a:t>3.1.0.652</a:t>
-            </a:r>
-            <a:endParaRPr lang="en-US" dirty="0"/>
+              <a:t>3.1.0.662</a:t>
+            </a:r>
+            <a:br>
+              <a:rPr lang="en-US" dirty="0" smtClean="0"/>
+            </a:br>
+            <a:r>
+              <a:rPr lang="en-US" sz="1600" dirty="0" smtClean="0"/>
+              <a:t>2016-10-24</a:t>
+            </a:r>
+            <a:endParaRPr lang="en-US" sz="1600" dirty="0"/>
           </a:p>
         </p:txBody>
       </p:sp>
@@ -6729,7 +6987,7 @@
         <p:spPr>
           <a:xfrm>
             <a:off x="468315" y="1412776"/>
-            <a:ext cx="8496173" cy="4713387"/>
+            <a:ext cx="8496173" cy="5760640"/>
           </a:xfrm>
         </p:spPr>
         <p:txBody>
@@ -6737,118 +6995,193 @@
           <a:lstStyle/>
           <a:p>
             <a:r>
-              <a:rPr lang="en-US" dirty="0" smtClean="0"/>
-              <a:t>Main Updates</a:t>
+              <a:rPr lang="en-US" sz="1800" b="1" dirty="0" err="1" smtClean="0"/>
+              <a:t>Bugfixes</a:t>
+            </a:r>
+            <a:r>
+              <a:rPr lang="en-US" sz="1800" dirty="0" smtClean="0"/>
+              <a:t>:</a:t>
             </a:r>
           </a:p>
           <a:p>
             <a:pPr lvl="1"/>
             <a:r>
-              <a:rPr lang="en-US" dirty="0" smtClean="0"/>
-              <a:t>Removed VECTO Core 2.2</a:t>
+              <a:rPr lang="en-US" sz="1600" dirty="0" smtClean="0"/>
+              <a:t>[</a:t>
+            </a:r>
+            <a:r>
+              <a:rPr lang="en-US" sz="1600" dirty="0"/>
+              <a:t>VECTO-360] Fixed error during startup of VECTO (loading of DLLs</a:t>
+            </a:r>
+            <a:r>
+              <a:rPr lang="en-US" sz="1600" dirty="0" smtClean="0"/>
+              <a:t>).</a:t>
             </a:r>
           </a:p>
           <a:p>
             <a:pPr lvl="1"/>
             <a:r>
-              <a:rPr lang="en-US" dirty="0" smtClean="0"/>
-              <a:t>Refactoring of the User-Interface Backend: loading, saving files and validating user input uses </a:t>
-            </a:r>
-            <a:r>
-              <a:rPr lang="en-US" dirty="0" err="1" smtClean="0"/>
+              <a:rPr lang="en-US" sz="1600" dirty="0" smtClean="0"/>
+              <a:t>[</a:t>
+            </a:r>
+            <a:r>
+              <a:rPr lang="en-US" sz="1600" dirty="0"/>
+              <a:t>VECTO-358] Fixed errors during simulation where vehicle unintentionally was driving backwards. Fixed 1Hz-Filter for </a:t>
+            </a:r>
+            <a:r>
+              <a:rPr lang="en-US" sz="1600" dirty="0" err="1"/>
+              <a:t>ModFiles</a:t>
+            </a:r>
+            <a:r>
+              <a:rPr lang="en-US" sz="1600" dirty="0"/>
+              <a:t> (distance was wrong under certain circumstances, vehicle seemingly jumping back before halt</a:t>
+            </a:r>
+            <a:r>
+              <a:rPr lang="en-US" sz="1600" dirty="0" smtClean="0"/>
+              <a:t>)</a:t>
+            </a:r>
+          </a:p>
+          <a:p>
+            <a:pPr lvl="1"/>
+            <a:r>
+              <a:rPr lang="en-US" sz="1600" dirty="0" smtClean="0"/>
+              <a:t>[</a:t>
+            </a:r>
+            <a:r>
+              <a:rPr lang="en-US" sz="1600" dirty="0"/>
+              <a:t>VECTO-361] Fixed classification of vehicles with GVM of exactly </a:t>
+            </a:r>
+            <a:r>
+              <a:rPr lang="en-US" sz="1600" dirty="0" smtClean="0"/>
+              <a:t>7500kg</a:t>
+            </a:r>
+          </a:p>
+          <a:p>
+            <a:pPr lvl="1"/>
+            <a:r>
+              <a:rPr lang="en-US" sz="1600" dirty="0" smtClean="0"/>
+              <a:t>[</a:t>
+            </a:r>
+            <a:r>
+              <a:rPr lang="en-US" sz="1600" dirty="0"/>
+              <a:t>VECTO-364] Fixed an error in measured speed mode (run aborts</a:t>
+            </a:r>
+            <a:r>
+              <a:rPr lang="en-US" sz="1600" dirty="0" smtClean="0"/>
+              <a:t>).</a:t>
+            </a:r>
+          </a:p>
+          <a:p>
+            <a:pPr lvl="1"/>
+            <a:r>
+              <a:rPr lang="en-US" sz="1600" dirty="0" smtClean="0"/>
+              <a:t>[</a:t>
+            </a:r>
+            <a:r>
+              <a:rPr lang="en-US" sz="1600" dirty="0"/>
+              <a:t>VECTO-363] Compute shift polygons in declaration mode now uses correct boundary for full load </a:t>
+            </a:r>
+            <a:r>
+              <a:rPr lang="en-US" sz="1600" dirty="0" smtClean="0"/>
+              <a:t>margin.</a:t>
+            </a:r>
+          </a:p>
+          <a:p>
+            <a:pPr lvl="1"/>
+            <a:r>
+              <a:rPr lang="en-US" sz="1600" dirty="0" smtClean="0"/>
+              <a:t>[VECTO-365] </a:t>
+            </a:r>
+            <a:r>
+              <a:rPr lang="en-US" sz="1600" dirty="0" smtClean="0"/>
+              <a:t>Fixed </a:t>
+            </a:r>
+            <a:r>
+              <a:rPr lang="en-US" sz="1600" dirty="0"/>
+              <a:t>editing gears in declaration </a:t>
+            </a:r>
+            <a:r>
+              <a:rPr lang="en-US" sz="1600" dirty="0" smtClean="0"/>
+              <a:t>mode</a:t>
+            </a:r>
+          </a:p>
+          <a:p>
+            <a:r>
+              <a:rPr lang="en-US" sz="1800" b="1" dirty="0" smtClean="0"/>
+              <a:t>Improvements</a:t>
+            </a:r>
+            <a:r>
+              <a:rPr lang="en-US" sz="1800" dirty="0" smtClean="0"/>
+              <a:t>:</a:t>
+            </a:r>
+          </a:p>
+          <a:p>
+            <a:pPr lvl="1"/>
+            <a:r>
+              <a:rPr lang="en-US" sz="1600" dirty="0" smtClean="0"/>
+              <a:t>[</a:t>
+            </a:r>
+            <a:r>
+              <a:rPr lang="en-US" sz="1600" dirty="0"/>
+              <a:t>VECTO-355] User Manual updated (Screenshots, Descriptions, File Formats, </a:t>
+            </a:r>
+            <a:r>
+              <a:rPr lang="en-US" sz="1600" dirty="0" err="1"/>
               <a:t>Vecto</a:t>
             </a:r>
             <a:r>
-              <a:rPr lang="en-US" dirty="0" smtClean="0"/>
-              <a:t> 3 models</a:t>
+              <a:rPr lang="en-US" sz="1600" dirty="0"/>
+              <a:t> V2 Comments removed</a:t>
+            </a:r>
+            <a:r>
+              <a:rPr lang="en-US" sz="1600" dirty="0" smtClean="0"/>
+              <a:t>).</a:t>
             </a:r>
           </a:p>
           <a:p>
             <a:pPr lvl="1"/>
             <a:r>
-              <a:rPr lang="en-US" dirty="0" smtClean="0"/>
-              <a:t>AT-Gearbox Model: differentiate between AT gearbox with serial torque converter and AT gearbox using </a:t>
-            </a:r>
-            <a:r>
-              <a:rPr lang="en-US" dirty="0" err="1" smtClean="0"/>
-              <a:t>powersplit</a:t>
-            </a:r>
-            <a:endParaRPr lang="en-US" dirty="0" smtClean="0"/>
+              <a:rPr lang="en-US" sz="1600" dirty="0" smtClean="0"/>
+              <a:t>[</a:t>
+            </a:r>
+            <a:r>
+              <a:rPr lang="en-US" sz="1600" dirty="0"/>
+              <a:t>VECTO-317] Declaration data for Wheel sizes </a:t>
+            </a:r>
+            <a:r>
+              <a:rPr lang="en-US" sz="1600" dirty="0" smtClean="0"/>
+              <a:t>updated</a:t>
+            </a:r>
           </a:p>
           <a:p>
             <a:pPr lvl="1"/>
             <a:r>
-              <a:rPr lang="en-US" dirty="0" smtClean="0"/>
-              <a:t>Numbering of gears with AT gearbox corresponds to mechanical gears, new column </a:t>
-            </a:r>
-            <a:r>
-              <a:rPr lang="en-US" dirty="0" err="1" smtClean="0"/>
-              <a:t>TC_locked</a:t>
-            </a:r>
-            <a:r>
-              <a:rPr lang="en-US" dirty="0" smtClean="0"/>
-              <a:t> in .</a:t>
-            </a:r>
-            <a:r>
-              <a:rPr lang="en-US" dirty="0" err="1" smtClean="0"/>
-              <a:t>vmod</a:t>
-            </a:r>
-            <a:r>
-              <a:rPr lang="en-US" dirty="0" smtClean="0"/>
-              <a:t> file to indicate if torque converter is active</a:t>
+              <a:rPr lang="en-US" sz="1600" dirty="0" smtClean="0"/>
+              <a:t>[VECTO-359</a:t>
+            </a:r>
+            <a:r>
+              <a:rPr lang="en-US" sz="1600" dirty="0"/>
+              <a:t>] Simplified code regarding PT1 behavior</a:t>
+            </a:r>
+            <a:r>
+              <a:rPr lang="en-US" sz="1600" dirty="0" smtClean="0"/>
+              <a:t>.</a:t>
             </a:r>
           </a:p>
           <a:p>
             <a:pPr lvl="1"/>
             <a:r>
-              <a:rPr lang="en-US" dirty="0" smtClean="0"/>
-              <a:t>Torque converter gear no longer allowed in input (added by </a:t>
-            </a:r>
-            <a:r>
-              <a:rPr lang="en-US" dirty="0" err="1" smtClean="0"/>
-              <a:t>Vecto</a:t>
-            </a:r>
-            <a:r>
-              <a:rPr lang="en-US" dirty="0" smtClean="0"/>
-              <a:t> depending on the AT model)</a:t>
-            </a:r>
-          </a:p>
-          <a:p>
-            <a:pPr lvl="1"/>
-            <a:r>
-              <a:rPr lang="en-US" dirty="0" smtClean="0"/>
-              <a:t>New implementation of torque converter model (analytic solutions)</a:t>
-            </a:r>
-          </a:p>
-          <a:p>
-            <a:pPr lvl="1"/>
-            <a:r>
-              <a:rPr lang="en-US" dirty="0" smtClean="0"/>
-              <a:t>Added PTO option for municipal utility vehicles: PTO idle losses, separate PTO cycle during standstill</a:t>
-            </a:r>
-          </a:p>
-          <a:p>
-            <a:pPr lvl="1"/>
-            <a:r>
-              <a:rPr lang="en-US" dirty="0" smtClean="0"/>
-              <a:t>Added </a:t>
-            </a:r>
-            <a:r>
-              <a:rPr lang="en-US" dirty="0" err="1" smtClean="0"/>
-              <a:t>Angledrive</a:t>
-            </a:r>
-            <a:r>
-              <a:rPr lang="en-US" dirty="0" smtClean="0"/>
-              <a:t> Component</a:t>
-            </a:r>
-          </a:p>
-          <a:p>
-            <a:pPr lvl="1"/>
-            <a:r>
-              <a:rPr lang="en-US" dirty="0" smtClean="0"/>
-              <a:t>Option for constant Auxiliary Power Demand in Job-File</a:t>
-            </a:r>
-            <a:endParaRPr lang="en-US" dirty="0"/>
+              <a:rPr lang="en-US" sz="1600" dirty="0" smtClean="0"/>
+              <a:t>[</a:t>
+            </a:r>
+            <a:r>
+              <a:rPr lang="en-US" sz="1600" dirty="0"/>
+              <a:t>VECTO-323] PTO-Cycle may now be left empty when not used in driving </a:t>
+            </a:r>
+            <a:r>
+              <a:rPr lang="en-US" sz="1600" dirty="0" smtClean="0"/>
+              <a:t>cycle.</a:t>
+            </a:r>
           </a:p>
         </p:txBody>
       </p:sp>
@@ -6909,7 +7242,14 @@
               <a:rPr lang="en-US" dirty="0" smtClean="0"/>
               <a:t>3.1.0.652</a:t>
             </a:r>
-            <a:endParaRPr lang="en-US" dirty="0"/>
+            <a:br>
+              <a:rPr lang="en-US" dirty="0" smtClean="0"/>
+            </a:br>
+            <a:r>
+              <a:rPr lang="en-US" sz="1600" dirty="0" smtClean="0"/>
+              <a:t>2016-10-14</a:t>
+            </a:r>
+            <a:endParaRPr lang="en-US" sz="1600" dirty="0"/>
           </a:p>
         </p:txBody>
       </p:sp>
@@ -6925,8 +7265,8 @@
         </p:nvSpPr>
         <p:spPr>
           <a:xfrm>
-            <a:off x="468315" y="1268760"/>
-            <a:ext cx="8496173" cy="4857403"/>
+            <a:off x="468315" y="1412776"/>
+            <a:ext cx="8496173" cy="4713387"/>
           </a:xfrm>
         </p:spPr>
         <p:txBody>
@@ -6935,132 +7275,124 @@
           <a:p>
             <a:r>
               <a:rPr lang="en-US" dirty="0" smtClean="0"/>
-              <a:t>Main Updates (cont.)</a:t>
+              <a:t>Main Updates</a:t>
             </a:r>
           </a:p>
           <a:p>
             <a:pPr lvl="1"/>
             <a:r>
               <a:rPr lang="en-US" dirty="0" smtClean="0"/>
-              <a:t>Normalize x/y values before triangulating Delaunay map (transmission loss-maps, fuel consumption loss map)</a:t>
+              <a:t>Removed VECTO Core 2.2</a:t>
             </a:r>
           </a:p>
           <a:p>
             <a:pPr lvl="1"/>
             <a:r>
               <a:rPr lang="en-US" dirty="0" smtClean="0"/>
-              <a:t>Additional fuel consumption correction factor in declaration mode: cold/hot balancing factor</a:t>
+              <a:t>Refactoring of the User-Interface Backend: loading, saving files and validating user input uses </a:t>
+            </a:r>
+            <a:r>
+              <a:rPr lang="en-US" dirty="0" err="1" smtClean="0"/>
+              <a:t>Vecto</a:t>
+            </a:r>
+            <a:r>
+              <a:rPr lang="en-US" dirty="0" smtClean="0"/>
+              <a:t> 3 models</a:t>
             </a:r>
           </a:p>
           <a:p>
             <a:pPr lvl="1"/>
             <a:r>
               <a:rPr lang="en-US" dirty="0" smtClean="0"/>
-              <a:t>Added fuel consumption correction factor (WHTC, Cold/Hot balancing, …) in engineering mode</a:t>
-            </a:r>
+              <a:t>AT-Gearbox Model: differentiate between AT gearbox with serial torque converter and AT gearbox using </a:t>
+            </a:r>
+            <a:r>
+              <a:rPr lang="en-US" dirty="0" err="1" smtClean="0"/>
+              <a:t>powersplit</a:t>
+            </a:r>
+            <a:endParaRPr lang="en-US" dirty="0" smtClean="0"/>
           </a:p>
           <a:p>
             <a:pPr lvl="1"/>
             <a:r>
               <a:rPr lang="en-US" dirty="0" smtClean="0"/>
-              <a:t>Update </a:t>
-            </a:r>
-            <a:r>
-              <a:rPr lang="en-US" dirty="0"/>
-              <a:t>auxiliaries power demand according to latest </a:t>
+              <a:t>Numbering of gears with AT gearbox corresponds to mechanical gears, new column </a:t>
             </a:r>
             <a:r>
               <a:rPr lang="en-US" dirty="0" err="1" smtClean="0"/>
-              <a:t>whitebook</a:t>
-            </a:r>
-            <a:endParaRPr lang="en-US" dirty="0" smtClean="0"/>
+              <a:t>TC_locked</a:t>
+            </a:r>
+            <a:r>
+              <a:rPr lang="en-US" dirty="0" smtClean="0"/>
+              <a:t> in .</a:t>
+            </a:r>
+            <a:r>
+              <a:rPr lang="en-US" dirty="0" err="1" smtClean="0"/>
+              <a:t>vmod</a:t>
+            </a:r>
+            <a:r>
+              <a:rPr lang="en-US" dirty="0" smtClean="0"/>
+              <a:t> file to indicate if torque converter is active</a:t>
+            </a:r>
           </a:p>
           <a:p>
             <a:pPr lvl="1"/>
             <a:r>
               <a:rPr lang="en-US" dirty="0" smtClean="0"/>
-              <a:t>Allow multiple steered axles</a:t>
+              <a:t>Torque converter gear no longer allowed in input (added by </a:t>
+            </a:r>
+            <a:r>
+              <a:rPr lang="en-US" dirty="0" err="1" smtClean="0"/>
+              <a:t>Vecto</a:t>
+            </a:r>
+            <a:r>
+              <a:rPr lang="en-US" dirty="0" smtClean="0"/>
+              <a:t> depending on the AT model)</a:t>
             </a:r>
           </a:p>
           <a:p>
             <a:pPr lvl="1"/>
             <a:r>
               <a:rPr lang="en-US" dirty="0" smtClean="0"/>
-              <a:t>Adapted engine idle controller (during declutch) – engine speed decreases faster</a:t>
+              <a:t>New implementation of torque converter model (analytic solutions)</a:t>
             </a:r>
           </a:p>
           <a:p>
             <a:pPr lvl="1"/>
             <a:r>
               <a:rPr lang="en-US" dirty="0" smtClean="0"/>
-              <a:t>SUM-File: split </a:t>
+              <a:t>Added PTO option for municipal utility vehicles: PTO idle losses, separate PTO cycle during standstill</a:t>
+            </a:r>
+          </a:p>
+          <a:p>
+            <a:pPr lvl="1"/>
+            <a:r>
+              <a:rPr lang="en-US" dirty="0" smtClean="0"/>
+              <a:t>Added </a:t>
             </a:r>
             <a:r>
               <a:rPr lang="en-US" dirty="0" err="1" smtClean="0"/>
-              <a:t>E_axl_gbx</a:t>
-            </a:r>
-            <a:r>
-              <a:rPr lang="en-US" dirty="0" smtClean="0"/>
-              <a:t> into two columns, </a:t>
-            </a:r>
-            <a:r>
-              <a:rPr lang="en-US" dirty="0" err="1" smtClean="0"/>
-              <a:t>E_axl</a:t>
-            </a:r>
-            <a:r>
-              <a:rPr lang="en-US" dirty="0" smtClean="0"/>
-              <a:t> and </a:t>
-            </a:r>
-            <a:r>
-              <a:rPr lang="en-US" dirty="0" err="1" smtClean="0"/>
-              <a:t>E_gbx</a:t>
-            </a:r>
-            <a:endParaRPr lang="en-US" dirty="0" smtClean="0"/>
+              <a:t>Angledrive</a:t>
+            </a:r>
+            <a:r>
+              <a:rPr lang="en-US" dirty="0" smtClean="0"/>
+              <a:t> Component</a:t>
+            </a:r>
           </a:p>
           <a:p>
             <a:pPr lvl="1"/>
             <a:r>
               <a:rPr lang="en-US" dirty="0" smtClean="0"/>
-              <a:t>New columns in mod-file: PTO, torque converter</a:t>
+              <a:t>Option for constant Auxiliary Power Demand in Job-File</a:t>
             </a:r>
             <a:endParaRPr lang="en-US" dirty="0"/>
-          </a:p>
-          <a:p>
-            <a:pPr lvl="1"/>
-            <a:r>
-              <a:rPr lang="en-US" dirty="0" smtClean="0"/>
-              <a:t>Removed full-load curve per gear, only single value </a:t>
-            </a:r>
-            <a:r>
-              <a:rPr lang="en-US" dirty="0" err="1" smtClean="0"/>
-              <a:t>MaxTorque</a:t>
-            </a:r>
-            <a:endParaRPr lang="en-US" dirty="0" smtClean="0"/>
-          </a:p>
-          <a:p>
-            <a:pPr lvl="1"/>
-            <a:r>
-              <a:rPr lang="en-US" dirty="0" smtClean="0"/>
-              <a:t>Removed rims (dynamic wheel radius depends on wheel type)</a:t>
-            </a:r>
-          </a:p>
-          <a:p>
-            <a:pPr lvl="1"/>
-            <a:r>
-              <a:rPr lang="en-US" dirty="0" smtClean="0"/>
-              <a:t>Fixes in AAUX module: open correct file-browser, save selected files</a:t>
-            </a:r>
-          </a:p>
-          <a:p>
-            <a:pPr lvl="1"/>
-            <a:endParaRPr lang="en-US" dirty="0" smtClean="0"/>
           </a:p>
         </p:txBody>
       </p:sp>
     </p:spTree>
     <p:extLst>
       <p:ext uri="{BB962C8B-B14F-4D97-AF65-F5344CB8AC3E}">
-        <p14:creationId xmlns:p14="http://schemas.microsoft.com/office/powerpoint/2010/main" val="3003112543"/>
+        <p14:creationId xmlns:p14="http://schemas.microsoft.com/office/powerpoint/2010/main" val="3595445446"/>
       </p:ext>
     </p:extLst>
   </p:cSld>
@@ -7097,321 +7429,187 @@
             <p:ph type="title"/>
           </p:nvPr>
         </p:nvSpPr>
+        <p:spPr/>
+        <p:txBody>
+          <a:bodyPr/>
+          <a:lstStyle/>
+          <a:p>
+            <a:r>
+              <a:rPr lang="en-US" dirty="0" err="1"/>
+              <a:t>Vecto</a:t>
+            </a:r>
+            <a:r>
+              <a:rPr lang="en-US" dirty="0"/>
+              <a:t> </a:t>
+            </a:r>
+            <a:r>
+              <a:rPr lang="en-US" dirty="0" smtClean="0"/>
+              <a:t>3.1.0.652</a:t>
+            </a:r>
+            <a:br>
+              <a:rPr lang="en-US" dirty="0" smtClean="0"/>
+            </a:br>
+            <a:r>
+              <a:rPr lang="en-US" sz="1600" dirty="0"/>
+              <a:t>2016-10-14</a:t>
+            </a:r>
+          </a:p>
+        </p:txBody>
+      </p:sp>
+      <p:sp>
+        <p:nvSpPr>
+          <p:cNvPr id="3" name="Inhaltsplatzhalter 2"/>
+          <p:cNvSpPr>
+            <a:spLocks noGrp="1"/>
+          </p:cNvSpPr>
+          <p:nvPr>
+            <p:ph idx="1"/>
+          </p:nvPr>
+        </p:nvSpPr>
         <p:spPr>
           <a:xfrm>
-            <a:off x="296532" y="476672"/>
-            <a:ext cx="8451932" cy="576064"/>
+            <a:off x="468315" y="1268760"/>
+            <a:ext cx="8496173" cy="4857403"/>
           </a:xfrm>
         </p:spPr>
         <p:txBody>
           <a:bodyPr/>
           <a:lstStyle/>
           <a:p>
-            <a:pPr algn="l"/>
-            <a:r>
-              <a:rPr lang="en-US" dirty="0" smtClean="0"/>
-              <a:t>Status quo VECTO software and open issues (Oct. 2016)</a:t>
+            <a:r>
+              <a:rPr lang="en-US" dirty="0" smtClean="0"/>
+              <a:t>Main Updates (cont.)</a:t>
+            </a:r>
+          </a:p>
+          <a:p>
+            <a:pPr lvl="1"/>
+            <a:r>
+              <a:rPr lang="en-US" dirty="0" smtClean="0"/>
+              <a:t>Normalize x/y values before triangulating Delaunay map (transmission loss-maps, fuel consumption loss map)</a:t>
+            </a:r>
+          </a:p>
+          <a:p>
+            <a:pPr lvl="1"/>
+            <a:r>
+              <a:rPr lang="en-US" dirty="0" smtClean="0"/>
+              <a:t>Additional fuel consumption correction factor in declaration mode: cold/hot balancing factor</a:t>
+            </a:r>
+          </a:p>
+          <a:p>
+            <a:pPr lvl="1"/>
+            <a:r>
+              <a:rPr lang="en-US" dirty="0" smtClean="0"/>
+              <a:t>Added fuel consumption correction factor (WHTC, Cold/Hot balancing, …) in engineering mode</a:t>
+            </a:r>
+          </a:p>
+          <a:p>
+            <a:pPr lvl="1"/>
+            <a:r>
+              <a:rPr lang="en-US" dirty="0" smtClean="0"/>
+              <a:t>Update </a:t>
+            </a:r>
+            <a:r>
+              <a:rPr lang="en-US" dirty="0"/>
+              <a:t>auxiliaries power demand according to latest </a:t>
+            </a:r>
+            <a:r>
+              <a:rPr lang="en-US" dirty="0" err="1" smtClean="0"/>
+              <a:t>whitebook</a:t>
+            </a:r>
+            <a:endParaRPr lang="en-US" dirty="0" smtClean="0"/>
+          </a:p>
+          <a:p>
+            <a:pPr lvl="1"/>
+            <a:r>
+              <a:rPr lang="en-US" dirty="0" smtClean="0"/>
+              <a:t>Allow multiple steered axles</a:t>
+            </a:r>
+          </a:p>
+          <a:p>
+            <a:pPr lvl="1"/>
+            <a:r>
+              <a:rPr lang="en-US" dirty="0" smtClean="0"/>
+              <a:t>Adapted engine idle controller (during declutch) – engine speed decreases faster</a:t>
+            </a:r>
+          </a:p>
+          <a:p>
+            <a:pPr lvl="1"/>
+            <a:r>
+              <a:rPr lang="en-US" dirty="0" smtClean="0"/>
+              <a:t>SUM-File: split </a:t>
+            </a:r>
+            <a:r>
+              <a:rPr lang="en-US" dirty="0" err="1" smtClean="0"/>
+              <a:t>E_axl_gbx</a:t>
+            </a:r>
+            <a:r>
+              <a:rPr lang="en-US" dirty="0" smtClean="0"/>
+              <a:t> into two columns, </a:t>
+            </a:r>
+            <a:r>
+              <a:rPr lang="en-US" dirty="0" err="1" smtClean="0"/>
+              <a:t>E_axl</a:t>
+            </a:r>
+            <a:r>
+              <a:rPr lang="en-US" dirty="0" smtClean="0"/>
+              <a:t> and </a:t>
+            </a:r>
+            <a:r>
+              <a:rPr lang="en-US" dirty="0" err="1" smtClean="0"/>
+              <a:t>E_gbx</a:t>
+            </a:r>
+            <a:endParaRPr lang="en-US" dirty="0" smtClean="0"/>
+          </a:p>
+          <a:p>
+            <a:pPr lvl="1"/>
+            <a:r>
+              <a:rPr lang="en-US" dirty="0" smtClean="0"/>
+              <a:t>New columns in mod-file: PTO, torque converter</a:t>
             </a:r>
             <a:endParaRPr lang="en-US" dirty="0"/>
           </a:p>
-        </p:txBody>
-      </p:sp>
-      <p:sp>
-        <p:nvSpPr>
-          <p:cNvPr id="3" name="Textfeld 2"/>
-          <p:cNvSpPr txBox="1"/>
-          <p:nvPr/>
-        </p:nvSpPr>
-        <p:spPr>
-          <a:xfrm>
-            <a:off x="323528" y="908720"/>
-            <a:ext cx="8496944" cy="400110"/>
-          </a:xfrm>
-          <a:prstGeom prst="rect">
-            <a:avLst/>
-          </a:prstGeom>
-          <a:noFill/>
-        </p:spPr>
-        <p:txBody>
-          <a:bodyPr wrap="square" rtlCol="0">
-            <a:spAutoFit/>
-          </a:bodyPr>
-          <a:lstStyle/>
-          <a:p>
-            <a:pPr algn="l"/>
-            <a:r>
-              <a:rPr lang="de-AT" sz="2000" dirty="0" smtClean="0"/>
-              <a:t>Next </a:t>
-            </a:r>
-            <a:r>
-              <a:rPr lang="de-AT" sz="2000" dirty="0" err="1" smtClean="0"/>
-              <a:t>issues</a:t>
-            </a:r>
-            <a:r>
-              <a:rPr lang="de-AT" sz="2000" dirty="0" smtClean="0"/>
-              <a:t> on </a:t>
-            </a:r>
-            <a:r>
-              <a:rPr lang="de-AT" sz="2000" dirty="0" err="1" smtClean="0"/>
-              <a:t>the</a:t>
-            </a:r>
-            <a:r>
-              <a:rPr lang="de-AT" sz="2000" dirty="0" smtClean="0"/>
-              <a:t> </a:t>
-            </a:r>
-            <a:r>
-              <a:rPr lang="de-AT" sz="2000" dirty="0" err="1" smtClean="0"/>
-              <a:t>to</a:t>
-            </a:r>
-            <a:r>
-              <a:rPr lang="de-AT" sz="2000" dirty="0" smtClean="0"/>
-              <a:t> do </a:t>
-            </a:r>
-            <a:r>
-              <a:rPr lang="de-AT" sz="2000" dirty="0" err="1" smtClean="0"/>
-              <a:t>list</a:t>
-            </a:r>
-            <a:endParaRPr lang="de-AT" sz="2000" dirty="0"/>
-          </a:p>
-        </p:txBody>
-      </p:sp>
-      <p:sp>
-        <p:nvSpPr>
-          <p:cNvPr id="7" name="Textfeld 6"/>
-          <p:cNvSpPr txBox="1"/>
-          <p:nvPr/>
-        </p:nvSpPr>
-        <p:spPr>
-          <a:xfrm>
-            <a:off x="539552" y="1484784"/>
-            <a:ext cx="8352928" cy="5093702"/>
-          </a:xfrm>
-          <a:prstGeom prst="rect">
-            <a:avLst/>
-          </a:prstGeom>
-          <a:noFill/>
-        </p:spPr>
-        <p:txBody>
-          <a:bodyPr wrap="square" rtlCol="0">
-            <a:spAutoFit/>
-          </a:bodyPr>
-          <a:lstStyle/>
-          <a:p>
-            <a:pPr marL="285750" indent="-285750" algn="l">
-              <a:buFont typeface="Arial" panose="020B0604020202020204" pitchFamily="34" charset="0"/>
-              <a:buChar char="•"/>
-            </a:pPr>
-            <a:r>
-              <a:rPr lang="en-GB" sz="1400" dirty="0" smtClean="0"/>
-              <a:t>Further development of the AT model</a:t>
-            </a:r>
-            <a:br>
-              <a:rPr lang="en-GB" sz="1400" dirty="0" smtClean="0"/>
-            </a:br>
-            <a:r>
-              <a:rPr lang="en-GB" sz="1400" b="0" dirty="0" smtClean="0"/>
-              <a:t>Consideration of losses during power shifts, update of gear shift logics</a:t>
-            </a:r>
-          </a:p>
-          <a:p>
-            <a:pPr marL="285750" indent="-285750" algn="l">
-              <a:buFont typeface="Arial" panose="020B0604020202020204" pitchFamily="34" charset="0"/>
-              <a:buChar char="•"/>
-            </a:pPr>
-            <a:r>
-              <a:rPr lang="en-GB" sz="1400" dirty="0" smtClean="0"/>
-              <a:t>Reimplementation </a:t>
-            </a:r>
-            <a:r>
-              <a:rPr lang="en-GB" sz="1400" dirty="0"/>
-              <a:t>of engine stop/start</a:t>
-            </a:r>
-          </a:p>
-          <a:p>
-            <a:pPr marL="285750" indent="-285750" algn="l">
-              <a:buFont typeface="Arial" panose="020B0604020202020204" pitchFamily="34" charset="0"/>
-              <a:buChar char="•"/>
-            </a:pPr>
-            <a:r>
-              <a:rPr lang="en-GB" sz="1400" dirty="0" smtClean="0"/>
-              <a:t>Declaration mode: implementation of EMS vehicle configurations</a:t>
-            </a:r>
-          </a:p>
-          <a:p>
-            <a:pPr marL="285750" indent="-285750" algn="l">
-              <a:buFont typeface="Arial" panose="020B0604020202020204" pitchFamily="34" charset="0"/>
-              <a:buChar char="•"/>
-            </a:pPr>
-            <a:endParaRPr lang="en-GB" sz="1400" dirty="0"/>
-          </a:p>
-          <a:p>
-            <a:pPr algn="l"/>
-            <a:r>
-              <a:rPr lang="en-GB" sz="1400" u="sng" dirty="0" smtClean="0"/>
-              <a:t>Items waiting for decision on methods and resources:</a:t>
-            </a:r>
-          </a:p>
-          <a:p>
-            <a:pPr marL="285750" indent="-285750" algn="l">
-              <a:buFont typeface="Arial" panose="020B0604020202020204" pitchFamily="34" charset="0"/>
-              <a:buChar char="•"/>
-            </a:pPr>
-            <a:r>
-              <a:rPr lang="en-GB" sz="1400" dirty="0" smtClean="0"/>
-              <a:t>Update engine data (according to update of Annex II)</a:t>
-            </a:r>
-            <a:br>
-              <a:rPr lang="en-GB" sz="1400" dirty="0" smtClean="0"/>
-            </a:br>
-            <a:r>
-              <a:rPr lang="en-GB" sz="1400" b="0" dirty="0" smtClean="0"/>
-              <a:t>Other fuels than diesel, “top torque” feature, correction factor for periodic </a:t>
-            </a:r>
-            <a:r>
-              <a:rPr lang="en-GB" sz="1400" b="0" dirty="0" err="1" smtClean="0"/>
-              <a:t>regerating</a:t>
-            </a:r>
-            <a:r>
-              <a:rPr lang="en-GB" sz="1400" b="0" dirty="0" smtClean="0"/>
-              <a:t> DPFs</a:t>
-            </a:r>
-          </a:p>
-          <a:p>
-            <a:pPr marL="285750" indent="-285750" algn="l">
-              <a:buFont typeface="Arial" panose="020B0604020202020204" pitchFamily="34" charset="0"/>
-              <a:buChar char="•"/>
-            </a:pPr>
-            <a:r>
-              <a:rPr lang="en-GB" sz="1400" dirty="0" smtClean="0"/>
-              <a:t>Declaration mode: </a:t>
-            </a:r>
-          </a:p>
-          <a:p>
-            <a:pPr marL="742950" lvl="1" indent="-285750" algn="l">
-              <a:spcBef>
-                <a:spcPts val="300"/>
-              </a:spcBef>
-              <a:buFont typeface="Arial" panose="020B0604020202020204" pitchFamily="34" charset="0"/>
-              <a:buChar char="•"/>
-            </a:pPr>
-            <a:r>
-              <a:rPr lang="en-GB" sz="1400" dirty="0"/>
-              <a:t>Revision of calculated vehicle </a:t>
-            </a:r>
-            <a:r>
-              <a:rPr lang="en-GB" sz="1400" dirty="0" smtClean="0"/>
-              <a:t>loads</a:t>
-            </a:r>
-          </a:p>
-          <a:p>
-            <a:pPr marL="742950" lvl="1" indent="-285750" algn="l">
-              <a:spcBef>
-                <a:spcPts val="300"/>
-              </a:spcBef>
-              <a:buFont typeface="Arial" panose="020B0604020202020204" pitchFamily="34" charset="0"/>
-              <a:buChar char="•"/>
-            </a:pPr>
-            <a:r>
-              <a:rPr lang="en-GB" sz="1400" dirty="0" smtClean="0"/>
-              <a:t>implementation of refuse cycle (instead “municipal”)</a:t>
-            </a:r>
-            <a:br>
-              <a:rPr lang="en-GB" sz="1400" dirty="0" smtClean="0"/>
-            </a:br>
-            <a:r>
-              <a:rPr lang="en-GB" sz="1400" b="0" dirty="0" smtClean="0"/>
-              <a:t>Update of driving cycle, consideration of generic PTO loads during collection part,</a:t>
-            </a:r>
-            <a:br>
-              <a:rPr lang="en-GB" sz="1400" b="0" dirty="0" smtClean="0"/>
-            </a:br>
-            <a:r>
-              <a:rPr lang="en-GB" sz="1400" b="0" dirty="0" smtClean="0"/>
-              <a:t>generic body weight and payload</a:t>
-            </a:r>
-          </a:p>
-          <a:p>
-            <a:pPr marL="742950" lvl="1" indent="-285750" algn="l">
-              <a:spcBef>
-                <a:spcPts val="300"/>
-              </a:spcBef>
-              <a:buFont typeface="Arial" panose="020B0604020202020204" pitchFamily="34" charset="0"/>
-              <a:buChar char="•"/>
-            </a:pPr>
-            <a:r>
-              <a:rPr lang="en-GB" sz="1400" dirty="0"/>
-              <a:t>VECTO output (approval </a:t>
-            </a:r>
-            <a:r>
-              <a:rPr lang="en-GB" sz="1400" dirty="0" smtClean="0"/>
-              <a:t>authorities</a:t>
-            </a:r>
-            <a:r>
-              <a:rPr lang="en-GB" sz="1400" dirty="0"/>
-              <a:t>, customer info, monitoring</a:t>
-            </a:r>
-            <a:r>
-              <a:rPr lang="en-GB" sz="1400" dirty="0" smtClean="0"/>
-              <a:t>)</a:t>
-            </a:r>
-          </a:p>
-          <a:p>
-            <a:pPr marL="742950" lvl="1" indent="-285750" algn="l">
-              <a:spcBef>
-                <a:spcPts val="300"/>
-              </a:spcBef>
-              <a:buFont typeface="Arial" panose="020B0604020202020204" pitchFamily="34" charset="0"/>
-              <a:buChar char="•"/>
-            </a:pPr>
-            <a:r>
-              <a:rPr lang="en-GB" sz="1400" dirty="0" smtClean="0"/>
-              <a:t>Buses</a:t>
-            </a:r>
-            <a:endParaRPr lang="en-GB" sz="1400" b="0" dirty="0" smtClean="0"/>
-          </a:p>
-          <a:p>
-            <a:pPr marL="285750" indent="-285750" algn="l">
-              <a:buFont typeface="Arial" panose="020B0604020202020204" pitchFamily="34" charset="0"/>
-              <a:buChar char="•"/>
-            </a:pPr>
-            <a:r>
-              <a:rPr lang="en-GB" sz="1400" dirty="0" smtClean="0"/>
-              <a:t>Predictive ADAS</a:t>
-            </a:r>
-          </a:p>
-          <a:p>
-            <a:pPr marL="285750" indent="-285750" algn="l">
-              <a:buFont typeface="Arial" panose="020B0604020202020204" pitchFamily="34" charset="0"/>
-              <a:buChar char="•"/>
-            </a:pPr>
-            <a:endParaRPr lang="en-GB" sz="1400" dirty="0" smtClean="0"/>
-          </a:p>
-          <a:p>
-            <a:pPr marL="285750" indent="-285750" algn="l">
-              <a:buFont typeface="Arial" panose="020B0604020202020204" pitchFamily="34" charset="0"/>
-              <a:buChar char="•"/>
-            </a:pPr>
-            <a:endParaRPr lang="en-GB" sz="1400" dirty="0"/>
+          <a:p>
+            <a:pPr lvl="1"/>
+            <a:r>
+              <a:rPr lang="en-US" dirty="0" smtClean="0"/>
+              <a:t>Removed full-load curve per gear, only single value </a:t>
+            </a:r>
+            <a:r>
+              <a:rPr lang="en-US" dirty="0" err="1" smtClean="0"/>
+              <a:t>MaxTorque</a:t>
+            </a:r>
+            <a:endParaRPr lang="en-US" dirty="0" smtClean="0"/>
+          </a:p>
+          <a:p>
+            <a:pPr lvl="1"/>
+            <a:r>
+              <a:rPr lang="en-US" dirty="0" smtClean="0"/>
+              <a:t>Removed rims (dynamic wheel radius depends on wheel type)</a:t>
+            </a:r>
+          </a:p>
+          <a:p>
+            <a:pPr lvl="1"/>
+            <a:r>
+              <a:rPr lang="en-US" dirty="0" smtClean="0"/>
+              <a:t>Fixes in AAUX module: open correct file-browser, save selected files</a:t>
+            </a:r>
+          </a:p>
+          <a:p>
+            <a:pPr lvl="1"/>
+            <a:endParaRPr lang="en-US" dirty="0" smtClean="0"/>
           </a:p>
         </p:txBody>
       </p:sp>
     </p:spTree>
     <p:extLst>
       <p:ext uri="{BB962C8B-B14F-4D97-AF65-F5344CB8AC3E}">
-        <p14:creationId xmlns:p14="http://schemas.microsoft.com/office/powerpoint/2010/main" val="4139329725"/>
+        <p14:creationId xmlns:p14="http://schemas.microsoft.com/office/powerpoint/2010/main" val="3003112543"/>
       </p:ext>
     </p:extLst>
   </p:cSld>
   <p:clrMapOvr>
     <a:masterClrMapping/>
   </p:clrMapOvr>
-  <p:timing>
-    <p:tnLst>
-      <p:par>
-        <p:cTn id="1" dur="indefinite" restart="never" nodeType="tmRoot"/>
-      </p:par>
-    </p:tnLst>
-  </p:timing>
 </p:sld>
 </file>
 
@@ -7442,6 +7640,351 @@
             <p:ph type="title"/>
           </p:nvPr>
         </p:nvSpPr>
+        <p:spPr>
+          <a:xfrm>
+            <a:off x="296532" y="476672"/>
+            <a:ext cx="8451932" cy="576064"/>
+          </a:xfrm>
+        </p:spPr>
+        <p:txBody>
+          <a:bodyPr/>
+          <a:lstStyle/>
+          <a:p>
+            <a:pPr algn="l"/>
+            <a:r>
+              <a:rPr lang="en-US" dirty="0" smtClean="0"/>
+              <a:t>Status quo VECTO software and open issues (Oct. 2016)</a:t>
+            </a:r>
+            <a:endParaRPr lang="en-US" dirty="0"/>
+          </a:p>
+        </p:txBody>
+      </p:sp>
+      <p:sp>
+        <p:nvSpPr>
+          <p:cNvPr id="3" name="Textfeld 2"/>
+          <p:cNvSpPr txBox="1"/>
+          <p:nvPr/>
+        </p:nvSpPr>
+        <p:spPr>
+          <a:xfrm>
+            <a:off x="323528" y="908720"/>
+            <a:ext cx="8496944" cy="400110"/>
+          </a:xfrm>
+          <a:prstGeom prst="rect">
+            <a:avLst/>
+          </a:prstGeom>
+          <a:noFill/>
+        </p:spPr>
+        <p:txBody>
+          <a:bodyPr wrap="square" rtlCol="0">
+            <a:spAutoFit/>
+          </a:bodyPr>
+          <a:lstStyle/>
+          <a:p>
+            <a:pPr algn="l"/>
+            <a:r>
+              <a:rPr lang="de-AT" sz="2000" dirty="0" smtClean="0"/>
+              <a:t>Next </a:t>
+            </a:r>
+            <a:r>
+              <a:rPr lang="de-AT" sz="2000" dirty="0" err="1" smtClean="0"/>
+              <a:t>issues</a:t>
+            </a:r>
+            <a:r>
+              <a:rPr lang="de-AT" sz="2000" dirty="0" smtClean="0"/>
+              <a:t> on </a:t>
+            </a:r>
+            <a:r>
+              <a:rPr lang="de-AT" sz="2000" dirty="0" err="1" smtClean="0"/>
+              <a:t>the</a:t>
+            </a:r>
+            <a:r>
+              <a:rPr lang="de-AT" sz="2000" dirty="0" smtClean="0"/>
+              <a:t> </a:t>
+            </a:r>
+            <a:r>
+              <a:rPr lang="de-AT" sz="2000" dirty="0" err="1" smtClean="0"/>
+              <a:t>to</a:t>
+            </a:r>
+            <a:r>
+              <a:rPr lang="de-AT" sz="2000" dirty="0" smtClean="0"/>
+              <a:t> do </a:t>
+            </a:r>
+            <a:r>
+              <a:rPr lang="de-AT" sz="2000" dirty="0" err="1" smtClean="0"/>
+              <a:t>list</a:t>
+            </a:r>
+            <a:endParaRPr lang="de-AT" sz="2000" dirty="0"/>
+          </a:p>
+        </p:txBody>
+      </p:sp>
+      <p:sp>
+        <p:nvSpPr>
+          <p:cNvPr id="7" name="Textfeld 6"/>
+          <p:cNvSpPr txBox="1"/>
+          <p:nvPr/>
+        </p:nvSpPr>
+        <p:spPr>
+          <a:xfrm>
+            <a:off x="539552" y="1484784"/>
+            <a:ext cx="8352928" cy="5093702"/>
+          </a:xfrm>
+          <a:prstGeom prst="rect">
+            <a:avLst/>
+          </a:prstGeom>
+          <a:noFill/>
+        </p:spPr>
+        <p:txBody>
+          <a:bodyPr wrap="square" rtlCol="0">
+            <a:spAutoFit/>
+          </a:bodyPr>
+          <a:lstStyle/>
+          <a:p>
+            <a:pPr marL="285750" indent="-285750" algn="l">
+              <a:buFont typeface="Arial" panose="020B0604020202020204" pitchFamily="34" charset="0"/>
+              <a:buChar char="•"/>
+            </a:pPr>
+            <a:r>
+              <a:rPr lang="en-GB" sz="1400" dirty="0" smtClean="0"/>
+              <a:t>Further development of the AT model</a:t>
+            </a:r>
+            <a:br>
+              <a:rPr lang="en-GB" sz="1400" dirty="0" smtClean="0"/>
+            </a:br>
+            <a:r>
+              <a:rPr lang="en-GB" sz="1400" b="0" dirty="0" smtClean="0"/>
+              <a:t>Consideration of losses during power shifts, update of gear shift logics</a:t>
+            </a:r>
+          </a:p>
+          <a:p>
+            <a:pPr marL="285750" indent="-285750" algn="l">
+              <a:buFont typeface="Arial" panose="020B0604020202020204" pitchFamily="34" charset="0"/>
+              <a:buChar char="•"/>
+            </a:pPr>
+            <a:r>
+              <a:rPr lang="en-GB" sz="1400" dirty="0" smtClean="0"/>
+              <a:t>Reimplementation </a:t>
+            </a:r>
+            <a:r>
+              <a:rPr lang="en-GB" sz="1400" dirty="0"/>
+              <a:t>of engine stop/start</a:t>
+            </a:r>
+          </a:p>
+          <a:p>
+            <a:pPr marL="285750" indent="-285750" algn="l">
+              <a:buFont typeface="Arial" panose="020B0604020202020204" pitchFamily="34" charset="0"/>
+              <a:buChar char="•"/>
+            </a:pPr>
+            <a:r>
+              <a:rPr lang="en-GB" sz="1400" dirty="0" smtClean="0"/>
+              <a:t>Declaration mode: implementation of EMS vehicle configurations</a:t>
+            </a:r>
+          </a:p>
+          <a:p>
+            <a:pPr marL="285750" indent="-285750" algn="l">
+              <a:buFont typeface="Arial" panose="020B0604020202020204" pitchFamily="34" charset="0"/>
+              <a:buChar char="•"/>
+            </a:pPr>
+            <a:endParaRPr lang="en-GB" sz="1400" dirty="0"/>
+          </a:p>
+          <a:p>
+            <a:pPr algn="l"/>
+            <a:r>
+              <a:rPr lang="en-GB" sz="1400" u="sng" dirty="0" smtClean="0"/>
+              <a:t>Items waiting for decision on methods and resources:</a:t>
+            </a:r>
+          </a:p>
+          <a:p>
+            <a:pPr marL="285750" indent="-285750" algn="l">
+              <a:buFont typeface="Arial" panose="020B0604020202020204" pitchFamily="34" charset="0"/>
+              <a:buChar char="•"/>
+            </a:pPr>
+            <a:r>
+              <a:rPr lang="en-GB" sz="1400" dirty="0" smtClean="0"/>
+              <a:t>Update engine data (according to update of Annex II)</a:t>
+            </a:r>
+            <a:br>
+              <a:rPr lang="en-GB" sz="1400" dirty="0" smtClean="0"/>
+            </a:br>
+            <a:r>
+              <a:rPr lang="en-GB" sz="1400" b="0" dirty="0" smtClean="0"/>
+              <a:t>Other fuels than diesel, “top torque” feature, correction factor for periodic </a:t>
+            </a:r>
+            <a:r>
+              <a:rPr lang="en-GB" sz="1400" b="0" dirty="0" err="1" smtClean="0"/>
+              <a:t>regerating</a:t>
+            </a:r>
+            <a:r>
+              <a:rPr lang="en-GB" sz="1400" b="0" dirty="0" smtClean="0"/>
+              <a:t> DPFs</a:t>
+            </a:r>
+          </a:p>
+          <a:p>
+            <a:pPr marL="285750" indent="-285750" algn="l">
+              <a:buFont typeface="Arial" panose="020B0604020202020204" pitchFamily="34" charset="0"/>
+              <a:buChar char="•"/>
+            </a:pPr>
+            <a:r>
+              <a:rPr lang="en-GB" sz="1400" dirty="0" smtClean="0"/>
+              <a:t>Declaration mode: </a:t>
+            </a:r>
+          </a:p>
+          <a:p>
+            <a:pPr marL="742950" lvl="1" indent="-285750" algn="l">
+              <a:spcBef>
+                <a:spcPts val="300"/>
+              </a:spcBef>
+              <a:buFont typeface="Arial" panose="020B0604020202020204" pitchFamily="34" charset="0"/>
+              <a:buChar char="•"/>
+            </a:pPr>
+            <a:r>
+              <a:rPr lang="en-GB" sz="1400" dirty="0"/>
+              <a:t>Revision of calculated vehicle </a:t>
+            </a:r>
+            <a:r>
+              <a:rPr lang="en-GB" sz="1400" dirty="0" smtClean="0"/>
+              <a:t>loads</a:t>
+            </a:r>
+          </a:p>
+          <a:p>
+            <a:pPr marL="742950" lvl="1" indent="-285750" algn="l">
+              <a:spcBef>
+                <a:spcPts val="300"/>
+              </a:spcBef>
+              <a:buFont typeface="Arial" panose="020B0604020202020204" pitchFamily="34" charset="0"/>
+              <a:buChar char="•"/>
+            </a:pPr>
+            <a:r>
+              <a:rPr lang="en-GB" sz="1400" dirty="0" smtClean="0"/>
+              <a:t>implementation of refuse cycle (instead “municipal”)</a:t>
+            </a:r>
+            <a:br>
+              <a:rPr lang="en-GB" sz="1400" dirty="0" smtClean="0"/>
+            </a:br>
+            <a:r>
+              <a:rPr lang="en-GB" sz="1400" b="0" dirty="0" smtClean="0"/>
+              <a:t>Update of driving cycle, consideration of generic PTO loads during collection part,</a:t>
+            </a:r>
+            <a:br>
+              <a:rPr lang="en-GB" sz="1400" b="0" dirty="0" smtClean="0"/>
+            </a:br>
+            <a:r>
+              <a:rPr lang="en-GB" sz="1400" b="0" dirty="0" smtClean="0"/>
+              <a:t>generic body weight and payload</a:t>
+            </a:r>
+          </a:p>
+          <a:p>
+            <a:pPr marL="742950" lvl="1" indent="-285750" algn="l">
+              <a:spcBef>
+                <a:spcPts val="300"/>
+              </a:spcBef>
+              <a:buFont typeface="Arial" panose="020B0604020202020204" pitchFamily="34" charset="0"/>
+              <a:buChar char="•"/>
+            </a:pPr>
+            <a:r>
+              <a:rPr lang="en-GB" sz="1400" dirty="0"/>
+              <a:t>VECTO output (approval </a:t>
+            </a:r>
+            <a:r>
+              <a:rPr lang="en-GB" sz="1400" dirty="0" smtClean="0"/>
+              <a:t>authorities</a:t>
+            </a:r>
+            <a:r>
+              <a:rPr lang="en-GB" sz="1400" dirty="0"/>
+              <a:t>, customer info, monitoring</a:t>
+            </a:r>
+            <a:r>
+              <a:rPr lang="en-GB" sz="1400" dirty="0" smtClean="0"/>
+              <a:t>)</a:t>
+            </a:r>
+          </a:p>
+          <a:p>
+            <a:pPr marL="742950" lvl="1" indent="-285750" algn="l">
+              <a:spcBef>
+                <a:spcPts val="300"/>
+              </a:spcBef>
+              <a:buFont typeface="Arial" panose="020B0604020202020204" pitchFamily="34" charset="0"/>
+              <a:buChar char="•"/>
+            </a:pPr>
+            <a:r>
+              <a:rPr lang="en-GB" sz="1400" dirty="0" smtClean="0"/>
+              <a:t>Buses</a:t>
+            </a:r>
+            <a:endParaRPr lang="en-GB" sz="1400" b="0" dirty="0" smtClean="0"/>
+          </a:p>
+          <a:p>
+            <a:pPr marL="285750" indent="-285750" algn="l">
+              <a:buFont typeface="Arial" panose="020B0604020202020204" pitchFamily="34" charset="0"/>
+              <a:buChar char="•"/>
+            </a:pPr>
+            <a:r>
+              <a:rPr lang="en-GB" sz="1400" dirty="0" smtClean="0"/>
+              <a:t>Predictive ADAS</a:t>
+            </a:r>
+          </a:p>
+          <a:p>
+            <a:pPr marL="285750" indent="-285750" algn="l">
+              <a:buFont typeface="Arial" panose="020B0604020202020204" pitchFamily="34" charset="0"/>
+              <a:buChar char="•"/>
+            </a:pPr>
+            <a:endParaRPr lang="en-GB" sz="1400" dirty="0" smtClean="0"/>
+          </a:p>
+          <a:p>
+            <a:pPr marL="285750" indent="-285750" algn="l">
+              <a:buFont typeface="Arial" panose="020B0604020202020204" pitchFamily="34" charset="0"/>
+              <a:buChar char="•"/>
+            </a:pPr>
+            <a:endParaRPr lang="en-GB" sz="1400" dirty="0"/>
+          </a:p>
+        </p:txBody>
+      </p:sp>
+    </p:spTree>
+    <p:extLst>
+      <p:ext uri="{BB962C8B-B14F-4D97-AF65-F5344CB8AC3E}">
+        <p14:creationId xmlns:p14="http://schemas.microsoft.com/office/powerpoint/2010/main" val="4139329725"/>
+      </p:ext>
+    </p:extLst>
+  </p:cSld>
+  <p:clrMapOvr>
+    <a:masterClrMapping/>
+  </p:clrMapOvr>
+  <p:timing>
+    <p:tnLst>
+      <p:par>
+        <p:cTn id="1" dur="indefinite" restart="never" nodeType="tmRoot"/>
+      </p:par>
+    </p:tnLst>
+  </p:timing>
+</p:sld>
+</file>
+
+<file path=ppt/slides/slide6.xml><?xml version="1.0" encoding="utf-8"?>
+<p:sld xmlns:a="http://schemas.openxmlformats.org/drawingml/2006/main" xmlns:r="http://schemas.openxmlformats.org/officeDocument/2006/relationships" xmlns:p="http://schemas.openxmlformats.org/presentationml/2006/main">
+  <p:cSld>
+    <p:spTree>
+      <p:nvGrpSpPr>
+        <p:cNvPr id="1" name=""/>
+        <p:cNvGrpSpPr/>
+        <p:nvPr/>
+      </p:nvGrpSpPr>
+      <p:grpSpPr>
+        <a:xfrm>
+          <a:off x="0" y="0"/>
+          <a:ext cx="0" cy="0"/>
+          <a:chOff x="0" y="0"/>
+          <a:chExt cx="0" cy="0"/>
+        </a:xfrm>
+      </p:grpSpPr>
+      <p:sp>
+        <p:nvSpPr>
+          <p:cNvPr id="2" name="Titel 1"/>
+          <p:cNvSpPr>
+            <a:spLocks noGrp="1"/>
+          </p:cNvSpPr>
+          <p:nvPr>
+            <p:ph type="title"/>
+          </p:nvPr>
+        </p:nvSpPr>
         <p:spPr/>
         <p:txBody>
           <a:bodyPr/>
@@ -7453,11 +7996,14 @@
             </a:r>
             <a:r>
               <a:rPr lang="en-US" dirty="0"/>
-              <a:t> </a:t>
-            </a:r>
-            <a:r>
-              <a:rPr lang="en-US" dirty="0" smtClean="0"/>
-              <a:t>3.0.4.565</a:t>
+              <a:t> 3.0.4.565</a:t>
+            </a:r>
+            <a:br>
+              <a:rPr lang="en-US" dirty="0"/>
+            </a:br>
+            <a:r>
+              <a:rPr lang="en-US" sz="1600" dirty="0"/>
+              <a:t>2016-07-19</a:t>
             </a:r>
             <a:endParaRPr lang="en-US" dirty="0"/>
           </a:p>
@@ -7596,7 +8142,7 @@
 </p:sld>
 </file>
 
-<file path=ppt/slides/slide6.xml><?xml version="1.0" encoding="utf-8"?>
+<file path=ppt/slides/slide7.xml><?xml version="1.0" encoding="utf-8"?>
 <p:sld xmlns:a="http://schemas.openxmlformats.org/drawingml/2006/main" xmlns:r="http://schemas.openxmlformats.org/officeDocument/2006/relationships" xmlns:p="http://schemas.openxmlformats.org/presentationml/2006/main">
   <p:cSld>
     <p:spTree>
@@ -7639,7 +8185,18 @@
             </a:r>
             <a:r>
               <a:rPr lang="en-US" dirty="0" smtClean="0"/>
-              <a:t> 3.0.4.544</a:t>
+              <a:t> </a:t>
+            </a:r>
+            <a:r>
+              <a:rPr lang="en-US" dirty="0"/>
+              <a:t>3.0.4.544</a:t>
+            </a:r>
+            <a:br>
+              <a:rPr lang="en-US" dirty="0"/>
+            </a:br>
+            <a:r>
+              <a:rPr lang="en-US" sz="1600" dirty="0"/>
+              <a:t>2016-06-28</a:t>
             </a:r>
             <a:endParaRPr lang="en-US" dirty="0"/>
           </a:p>
@@ -7807,145 +8364,6 @@
     <p:extLst>
       <p:ext uri="{BB962C8B-B14F-4D97-AF65-F5344CB8AC3E}">
         <p14:creationId xmlns:p14="http://schemas.microsoft.com/office/powerpoint/2010/main" val="3997910218"/>
-      </p:ext>
-    </p:extLst>
-  </p:cSld>
-  <p:clrMapOvr>
-    <a:masterClrMapping/>
-  </p:clrMapOvr>
-  <p:timing>
-    <p:tnLst>
-      <p:par>
-        <p:cTn id="1" dur="indefinite" restart="never" nodeType="tmRoot"/>
-      </p:par>
-    </p:tnLst>
-  </p:timing>
-</p:sld>
-</file>
-
-<file path=ppt/slides/slide7.xml><?xml version="1.0" encoding="utf-8"?>
-<p:sld xmlns:a="http://schemas.openxmlformats.org/drawingml/2006/main" xmlns:r="http://schemas.openxmlformats.org/officeDocument/2006/relationships" xmlns:p="http://schemas.openxmlformats.org/presentationml/2006/main">
-  <p:cSld>
-    <p:spTree>
-      <p:nvGrpSpPr>
-        <p:cNvPr id="1" name=""/>
-        <p:cNvGrpSpPr/>
-        <p:nvPr/>
-      </p:nvGrpSpPr>
-      <p:grpSpPr>
-        <a:xfrm>
-          <a:off x="0" y="0"/>
-          <a:ext cx="0" cy="0"/>
-          <a:chOff x="0" y="0"/>
-          <a:chExt cx="0" cy="0"/>
-        </a:xfrm>
-      </p:grpSpPr>
-      <p:sp>
-        <p:nvSpPr>
-          <p:cNvPr id="2" name="Titel 1"/>
-          <p:cNvSpPr>
-            <a:spLocks noGrp="1"/>
-          </p:cNvSpPr>
-          <p:nvPr>
-            <p:ph type="title"/>
-          </p:nvPr>
-        </p:nvSpPr>
-        <p:spPr/>
-        <p:txBody>
-          <a:bodyPr/>
-          <a:lstStyle/>
-          <a:p>
-            <a:r>
-              <a:rPr lang="en-US" dirty="0" smtClean="0"/>
-              <a:t>Notes for using </a:t>
-            </a:r>
-            <a:r>
-              <a:rPr lang="en-US" dirty="0" err="1" smtClean="0"/>
-              <a:t>Vecto</a:t>
-            </a:r>
-            <a:r>
-              <a:rPr lang="en-US" dirty="0" smtClean="0"/>
-              <a:t> 3.x with AAUX (1)</a:t>
-            </a:r>
-            <a:endParaRPr lang="en-US" dirty="0"/>
-          </a:p>
-        </p:txBody>
-      </p:sp>
-      <p:sp>
-        <p:nvSpPr>
-          <p:cNvPr id="3" name="Inhaltsplatzhalter 2"/>
-          <p:cNvSpPr>
-            <a:spLocks noGrp="1"/>
-          </p:cNvSpPr>
-          <p:nvPr>
-            <p:ph idx="1"/>
-          </p:nvPr>
-        </p:nvSpPr>
-        <p:spPr/>
-        <p:txBody>
-          <a:bodyPr/>
-          <a:lstStyle/>
-          <a:p>
-            <a:r>
-              <a:rPr lang="en-US" dirty="0" smtClean="0"/>
-              <a:t>The </a:t>
-            </a:r>
-            <a:r>
-              <a:rPr lang="en-US" dirty="0" err="1" smtClean="0"/>
-              <a:t>AdvancedAuxiliaries</a:t>
-            </a:r>
-            <a:r>
-              <a:rPr lang="en-US" dirty="0" smtClean="0"/>
-              <a:t> module requires the number of activations for pneumatic consumers (brakes, doors, kneeling) and the (estimated) total cycle time. This can be configured in the .APAC-file (actuations file). For standard bus/coach cycles (i.e., the cycle file contains “bus” </a:t>
-            </a:r>
-            <a:r>
-              <a:rPr lang="en-US" b="1" dirty="0" smtClean="0"/>
-              <a:t>and</a:t>
-            </a:r>
-            <a:r>
-              <a:rPr lang="en-US" dirty="0" smtClean="0"/>
-              <a:t> “</a:t>
-            </a:r>
-            <a:r>
-              <a:rPr lang="en-US" dirty="0" err="1" smtClean="0"/>
-              <a:t>heavy_urban</a:t>
-            </a:r>
-            <a:r>
-              <a:rPr lang="en-US" dirty="0" smtClean="0"/>
-              <a:t>” or “suburban” or “interurban” or “urban”; </a:t>
-            </a:r>
-            <a:r>
-              <a:rPr lang="en-US" b="1" dirty="0" smtClean="0"/>
-              <a:t>or</a:t>
-            </a:r>
-            <a:r>
-              <a:rPr lang="en-US" dirty="0" smtClean="0"/>
-              <a:t> the cycle contains “coach” (</a:t>
-            </a:r>
-            <a:r>
-              <a:rPr lang="en-US" i="1" dirty="0" smtClean="0"/>
-              <a:t>case insensitive</a:t>
-            </a:r>
-            <a:r>
-              <a:rPr lang="en-US" dirty="0" smtClean="0"/>
-              <a:t>)) the actuations file already contains the number of activations and the cycle time. For other cycles the filename without extension is used to lookup the activations in the .APAC file (</a:t>
-            </a:r>
-            <a:r>
-              <a:rPr lang="en-US" i="1" dirty="0" smtClean="0"/>
-              <a:t>case sensitive</a:t>
-            </a:r>
-            <a:r>
-              <a:rPr lang="en-US" dirty="0" smtClean="0"/>
-              <a:t>)</a:t>
-            </a:r>
-            <a:endParaRPr lang="en-US" dirty="0"/>
-          </a:p>
-        </p:txBody>
-      </p:sp>
-    </p:spTree>
-    <p:extLst>
-      <p:ext uri="{BB962C8B-B14F-4D97-AF65-F5344CB8AC3E}">
-        <p14:creationId xmlns:p14="http://schemas.microsoft.com/office/powerpoint/2010/main" val="3750013638"/>
       </p:ext>
     </p:extLst>
   </p:cSld>
@@ -7989,12 +8407,7 @@
             <p:ph type="title"/>
           </p:nvPr>
         </p:nvSpPr>
-        <p:spPr>
-          <a:xfrm>
-            <a:off x="467544" y="548680"/>
-            <a:ext cx="8218487" cy="504056"/>
-          </a:xfrm>
-        </p:spPr>
+        <p:spPr/>
         <p:txBody>
           <a:bodyPr/>
           <a:lstStyle/>
@@ -8009,7 +8422,7 @@
             </a:r>
             <a:r>
               <a:rPr lang="en-US" dirty="0" smtClean="0"/>
-              <a:t> 3.x with AAUX (2)</a:t>
+              <a:t> 3.x with AAUX (1)</a:t>
             </a:r>
             <a:endParaRPr lang="en-US" dirty="0"/>
           </a:p>
@@ -8025,218 +8438,71 @@
             <p:ph idx="1"/>
           </p:nvPr>
         </p:nvSpPr>
-        <p:spPr>
-          <a:xfrm>
-            <a:off x="179511" y="1124744"/>
-            <a:ext cx="8856985" cy="5328592"/>
-          </a:xfrm>
-        </p:spPr>
+        <p:spPr/>
         <p:txBody>
           <a:bodyPr/>
           <a:lstStyle/>
           <a:p>
             <a:r>
+              <a:rPr lang="en-US" dirty="0" smtClean="0"/>
+              <a:t>The </a:t>
+            </a:r>
+            <a:r>
               <a:rPr lang="en-US" dirty="0" err="1" smtClean="0"/>
-              <a:t>Vecto</a:t>
-            </a:r>
-            <a:r>
-              <a:rPr lang="en-US" dirty="0" smtClean="0"/>
-              <a:t> 3 uses an average auxiliaries load (determined by the AAUX module depending on the settings)</a:t>
-            </a:r>
-            <a:r>
-              <a:rPr lang="en-US" dirty="0"/>
-              <a:t> for the </a:t>
-            </a:r>
-            <a:r>
-              <a:rPr lang="en-US" dirty="0" smtClean="0"/>
-              <a:t>simulation. The AAUX module computes the fuel consumption in parallel to </a:t>
+              <a:t>AdvancedAuxiliaries</a:t>
+            </a:r>
+            <a:r>
+              <a:rPr lang="en-US" dirty="0" smtClean="0"/>
+              <a:t> module requires the number of activations for pneumatic consumers (brakes, doors, kneeling) and the (estimated) total cycle time. This can be configured in the .APAC-file (actuations file). For standard bus/coach cycles (i.e., the cycle file contains “bus” </a:t>
+            </a:r>
+            <a:r>
+              <a:rPr lang="en-US" b="1" dirty="0" smtClean="0"/>
+              <a:t>and</a:t>
+            </a:r>
+            <a:r>
+              <a:rPr lang="en-US" dirty="0" smtClean="0"/>
+              <a:t> “</a:t>
             </a:r>
             <a:r>
               <a:rPr lang="en-US" dirty="0" err="1" smtClean="0"/>
-              <a:t>VectoCore</a:t>
-            </a:r>
-            <a:r>
-              <a:rPr lang="en-US" dirty="0" smtClean="0"/>
-              <a:t> and accounts for smart consumers (e.g., alternator, pneumatics, …).</a:t>
-            </a:r>
-          </a:p>
-          <a:p>
-            <a:r>
-              <a:rPr lang="en-US" dirty="0" smtClean="0"/>
-              <a:t>Output</a:t>
-            </a:r>
-          </a:p>
-          <a:p>
-            <a:pPr lvl="1"/>
-            <a:r>
-              <a:rPr lang="en-US" dirty="0" smtClean="0"/>
-              <a:t>The .</a:t>
-            </a:r>
-            <a:r>
-              <a:rPr lang="en-US" dirty="0" err="1" smtClean="0"/>
-              <a:t>vmod</a:t>
-            </a:r>
-            <a:r>
-              <a:rPr lang="en-US" dirty="0" smtClean="0"/>
-              <a:t> file contains both, the fuel consumption calculated by </a:t>
-            </a:r>
-            <a:r>
-              <a:rPr lang="en-US" dirty="0" err="1" smtClean="0"/>
-              <a:t>VectoCore</a:t>
-            </a:r>
-            <a:r>
-              <a:rPr lang="en-US" dirty="0" smtClean="0"/>
-              <a:t> (per simulation interval) and AAUX (accumulated and per simulation interval).</a:t>
-            </a:r>
-            <a:br>
-              <a:rPr lang="en-US" dirty="0" smtClean="0"/>
-            </a:br>
-            <a:r>
-              <a:rPr lang="en-US" dirty="0" smtClean="0"/>
-              <a:t>Columns in .</a:t>
-            </a:r>
-            <a:r>
-              <a:rPr lang="en-US" dirty="0" err="1" smtClean="0"/>
-              <a:t>vmod</a:t>
-            </a:r>
-            <a:r>
-              <a:rPr lang="en-US" dirty="0" smtClean="0"/>
-              <a:t> file:</a:t>
-            </a:r>
-          </a:p>
-          <a:p>
-            <a:pPr lvl="2"/>
-            <a:r>
-              <a:rPr lang="en-US" dirty="0" err="1"/>
-              <a:t>AA_TotalCycleFC_Grams</a:t>
-            </a:r>
-            <a:r>
-              <a:rPr lang="en-US" dirty="0"/>
-              <a:t> [g</a:t>
-            </a:r>
-            <a:r>
-              <a:rPr lang="en-US" dirty="0" smtClean="0"/>
-              <a:t>]: accumulated fuel consumption as computed by the AAUX model, considering smart consumers</a:t>
-            </a:r>
-          </a:p>
-          <a:p>
-            <a:pPr lvl="2"/>
-            <a:r>
-              <a:rPr lang="en-US" dirty="0" smtClean="0"/>
-              <a:t>FC-Map </a:t>
-            </a:r>
-            <a:r>
-              <a:rPr lang="en-US" dirty="0"/>
-              <a:t>[</a:t>
-            </a:r>
-            <a:r>
-              <a:rPr lang="en-US" dirty="0" smtClean="0"/>
-              <a:t>g/h]: fuel consumption as computed by </a:t>
-            </a:r>
-            <a:r>
-              <a:rPr lang="en-US" dirty="0" err="1" smtClean="0"/>
-              <a:t>VectoCore</a:t>
-            </a:r>
-            <a:r>
-              <a:rPr lang="en-US" dirty="0" smtClean="0"/>
-              <a:t> interpolating </a:t>
-            </a:r>
-            <a:r>
-              <a:rPr lang="en-US" dirty="0"/>
-              <a:t>in the FC-Map, </a:t>
-            </a:r>
-            <a:r>
-              <a:rPr lang="en-US" dirty="0" smtClean="0"/>
-              <a:t>using an average base load of auxiliaries</a:t>
-            </a:r>
-          </a:p>
-          <a:p>
-            <a:pPr lvl="2"/>
-            <a:r>
-              <a:rPr lang="en-US" dirty="0" smtClean="0"/>
-              <a:t>FC-</a:t>
-            </a:r>
-            <a:r>
-              <a:rPr lang="en-US" dirty="0" err="1" smtClean="0"/>
-              <a:t>AUXc</a:t>
-            </a:r>
-            <a:r>
-              <a:rPr lang="en-US" dirty="0" smtClean="0"/>
-              <a:t> </a:t>
-            </a:r>
-            <a:r>
-              <a:rPr lang="en-US" dirty="0"/>
-              <a:t>[g/h</a:t>
-            </a:r>
-            <a:r>
-              <a:rPr lang="en-US" dirty="0" smtClean="0"/>
-              <a:t>]: fuel consumption corrected due to engine stop/start (currently not applicable)</a:t>
-            </a:r>
-          </a:p>
-          <a:p>
-            <a:pPr lvl="2"/>
-            <a:r>
-              <a:rPr lang="en-US" dirty="0" smtClean="0"/>
-              <a:t>FC-</a:t>
-            </a:r>
-            <a:r>
-              <a:rPr lang="en-US" dirty="0" err="1" smtClean="0"/>
-              <a:t>WHTCc</a:t>
-            </a:r>
-            <a:r>
-              <a:rPr lang="en-US" dirty="0" smtClean="0"/>
-              <a:t> </a:t>
-            </a:r>
-            <a:r>
-              <a:rPr lang="en-US" dirty="0"/>
-              <a:t>[g/h</a:t>
-            </a:r>
-            <a:r>
-              <a:rPr lang="en-US" dirty="0" smtClean="0"/>
-              <a:t>]: WHTC-corrected fuel consumption (not applicable in engineering mode)</a:t>
-            </a:r>
-          </a:p>
-          <a:p>
-            <a:pPr lvl="2"/>
-            <a:r>
-              <a:rPr lang="en-US" dirty="0" smtClean="0"/>
-              <a:t>FC-AAUX </a:t>
-            </a:r>
-            <a:r>
-              <a:rPr lang="en-US" dirty="0"/>
-              <a:t>[</a:t>
-            </a:r>
-            <a:r>
-              <a:rPr lang="en-US" dirty="0" smtClean="0"/>
-              <a:t>g/h]: fuel consumption per simulation interval, derived from </a:t>
-            </a:r>
-            <a:r>
-              <a:rPr lang="en-US" dirty="0" err="1" smtClean="0"/>
-              <a:t>AA_TotalCycleFC_Grams</a:t>
-            </a:r>
-            <a:endParaRPr lang="en-US" dirty="0" smtClean="0"/>
-          </a:p>
-          <a:p>
-            <a:pPr lvl="2"/>
-            <a:r>
-              <a:rPr lang="en-US" dirty="0" smtClean="0"/>
-              <a:t>FC-Final </a:t>
-            </a:r>
-            <a:r>
-              <a:rPr lang="en-US" dirty="0"/>
-              <a:t>[g/h</a:t>
-            </a:r>
-            <a:r>
-              <a:rPr lang="en-US" dirty="0" smtClean="0"/>
-              <a:t>]: final fuel consumption value with all (applicable) corrections applied (stop/start, WHTC, smart auxiliaries)</a:t>
-            </a:r>
+              <a:t>heavy_urban</a:t>
+            </a:r>
+            <a:r>
+              <a:rPr lang="en-US" dirty="0" smtClean="0"/>
+              <a:t>” or “suburban” or “interurban” or “urban”; </a:t>
+            </a:r>
+            <a:r>
+              <a:rPr lang="en-US" b="1" dirty="0" smtClean="0"/>
+              <a:t>or</a:t>
+            </a:r>
+            <a:r>
+              <a:rPr lang="en-US" dirty="0" smtClean="0"/>
+              <a:t> the cycle contains “coach” (</a:t>
+            </a:r>
+            <a:r>
+              <a:rPr lang="en-US" i="1" dirty="0" smtClean="0"/>
+              <a:t>case insensitive</a:t>
+            </a:r>
+            <a:r>
+              <a:rPr lang="en-US" dirty="0" smtClean="0"/>
+              <a:t>)) the actuations file already contains the number of activations and the cycle time. For other cycles the filename without extension is used to lookup the activations in the .APAC file (</a:t>
+            </a:r>
+            <a:r>
+              <a:rPr lang="en-US" i="1" dirty="0" smtClean="0"/>
+              <a:t>case sensitive</a:t>
+            </a:r>
+            <a:r>
+              <a:rPr lang="en-US" dirty="0" smtClean="0"/>
+              <a:t>)</a:t>
+            </a:r>
+            <a:endParaRPr lang="en-US" dirty="0"/>
           </a:p>
         </p:txBody>
       </p:sp>
     </p:spTree>
     <p:extLst>
       <p:ext uri="{BB962C8B-B14F-4D97-AF65-F5344CB8AC3E}">
-        <p14:creationId xmlns:p14="http://schemas.microsoft.com/office/powerpoint/2010/main" val="1949919211"/>
+        <p14:creationId xmlns:p14="http://schemas.microsoft.com/office/powerpoint/2010/main" val="3750013638"/>
       </p:ext>
     </p:extLst>
   </p:cSld>
@@ -8300,7 +8566,7 @@
             </a:r>
             <a:r>
               <a:rPr lang="en-US" dirty="0" smtClean="0"/>
-              <a:t> 3.x with AAUX (3)</a:t>
+              <a:t> 3.x with AAUX (2)</a:t>
             </a:r>
             <a:endParaRPr lang="en-US" dirty="0"/>
           </a:p>
@@ -8318,8 +8584,8 @@
         </p:nvSpPr>
         <p:spPr>
           <a:xfrm>
-            <a:off x="251521" y="1628800"/>
-            <a:ext cx="8640959" cy="4608512"/>
+            <a:off x="179511" y="1124744"/>
+            <a:ext cx="8856985" cy="5328592"/>
           </a:xfrm>
         </p:spPr>
         <p:txBody>
@@ -8327,35 +8593,20 @@
           <a:lstStyle/>
           <a:p>
             <a:r>
-              <a:rPr lang="en-US" dirty="0" smtClean="0"/>
-              <a:t>Output .</a:t>
-            </a:r>
-            <a:r>
               <a:rPr lang="en-US" dirty="0" err="1" smtClean="0"/>
-              <a:t>vsum</a:t>
-            </a:r>
-            <a:endParaRPr lang="en-US" dirty="0" smtClean="0"/>
-          </a:p>
-          <a:p>
-            <a:pPr lvl="1"/>
-            <a:r>
-              <a:rPr lang="en-US" dirty="0" smtClean="0"/>
-              <a:t>Columns in .</a:t>
-            </a:r>
-            <a:r>
-              <a:rPr lang="en-US" dirty="0" err="1" smtClean="0"/>
-              <a:t>vsum</a:t>
-            </a:r>
-            <a:r>
-              <a:rPr lang="en-US" dirty="0" smtClean="0"/>
-              <a:t> file:</a:t>
-            </a:r>
-          </a:p>
-          <a:p>
-            <a:pPr lvl="2"/>
-            <a:r>
-              <a:rPr lang="en-US" dirty="0" smtClean="0"/>
-              <a:t>FC-Map: total fuel consumption as computed by </a:t>
+              <a:t>Vecto</a:t>
+            </a:r>
+            <a:r>
+              <a:rPr lang="en-US" dirty="0" smtClean="0"/>
+              <a:t> 3 uses an average auxiliaries load (determined by the AAUX module depending on the settings)</a:t>
+            </a:r>
+            <a:r>
+              <a:rPr lang="en-US" dirty="0"/>
+              <a:t> for the </a:t>
+            </a:r>
+            <a:r>
+              <a:rPr lang="en-US" dirty="0" smtClean="0"/>
+              <a:t>simulation. The AAUX module computes the fuel consumption in parallel to </a:t>
             </a:r>
             <a:r>
               <a:rPr lang="en-US" dirty="0" err="1" smtClean="0"/>
@@ -8363,7 +8614,97 @@
             </a:r>
             <a:r>
               <a:rPr lang="en-US" dirty="0" smtClean="0"/>
-              <a:t> interpolating in the FC-Map, using an average base load of auxiliaries</a:t>
+              <a:t> and accounts for smart consumers (e.g., alternator, pneumatics, …).</a:t>
+            </a:r>
+          </a:p>
+          <a:p>
+            <a:r>
+              <a:rPr lang="en-US" dirty="0" smtClean="0"/>
+              <a:t>Output</a:t>
+            </a:r>
+          </a:p>
+          <a:p>
+            <a:pPr lvl="1"/>
+            <a:r>
+              <a:rPr lang="en-US" dirty="0" smtClean="0"/>
+              <a:t>The .</a:t>
+            </a:r>
+            <a:r>
+              <a:rPr lang="en-US" dirty="0" err="1" smtClean="0"/>
+              <a:t>vmod</a:t>
+            </a:r>
+            <a:r>
+              <a:rPr lang="en-US" dirty="0" smtClean="0"/>
+              <a:t> file contains both, the fuel consumption calculated by </a:t>
+            </a:r>
+            <a:r>
+              <a:rPr lang="en-US" dirty="0" err="1" smtClean="0"/>
+              <a:t>VectoCore</a:t>
+            </a:r>
+            <a:r>
+              <a:rPr lang="en-US" dirty="0" smtClean="0"/>
+              <a:t> (per simulation interval) and AAUX (accumulated and per simulation interval).</a:t>
+            </a:r>
+            <a:br>
+              <a:rPr lang="en-US" dirty="0" smtClean="0"/>
+            </a:br>
+            <a:r>
+              <a:rPr lang="en-US" dirty="0" smtClean="0"/>
+              <a:t>Columns in .</a:t>
+            </a:r>
+            <a:r>
+              <a:rPr lang="en-US" dirty="0" err="1" smtClean="0"/>
+              <a:t>vmod</a:t>
+            </a:r>
+            <a:r>
+              <a:rPr lang="en-US" dirty="0" smtClean="0"/>
+              <a:t> file:</a:t>
+            </a:r>
+          </a:p>
+          <a:p>
+            <a:pPr lvl="2"/>
+            <a:r>
+              <a:rPr lang="en-US" dirty="0" err="1"/>
+              <a:t>AA_TotalCycleFC_Grams</a:t>
+            </a:r>
+            <a:r>
+              <a:rPr lang="en-US" dirty="0"/>
+              <a:t> [g</a:t>
+            </a:r>
+            <a:r>
+              <a:rPr lang="en-US" dirty="0" smtClean="0"/>
+              <a:t>]: accumulated fuel consumption as computed by the AAUX model, considering smart consumers</a:t>
+            </a:r>
+          </a:p>
+          <a:p>
+            <a:pPr lvl="2"/>
+            <a:r>
+              <a:rPr lang="en-US" dirty="0" smtClean="0"/>
+              <a:t>FC-Map </a:t>
+            </a:r>
+            <a:r>
+              <a:rPr lang="en-US" dirty="0"/>
+              <a:t>[</a:t>
+            </a:r>
+            <a:r>
+              <a:rPr lang="en-US" dirty="0" smtClean="0"/>
+              <a:t>g/h]: fuel consumption as computed by </a:t>
+            </a:r>
+            <a:r>
+              <a:rPr lang="en-US" dirty="0" err="1" smtClean="0"/>
+              <a:t>VectoCore</a:t>
+            </a:r>
+            <a:r>
+              <a:rPr lang="en-US" dirty="0" smtClean="0"/>
+              <a:t> interpolating </a:t>
+            </a:r>
+            <a:r>
+              <a:rPr lang="en-US" dirty="0"/>
+              <a:t>in the FC-Map, </a:t>
+            </a:r>
+            <a:r>
+              <a:rPr lang="en-US" dirty="0" smtClean="0"/>
+              <a:t>using an average base load of auxiliaries</a:t>
             </a:r>
           </a:p>
           <a:p>
@@ -8378,7 +8719,15 @@
             </a:r>
             <a:r>
               <a:rPr lang="en-US" dirty="0" smtClean="0"/>
-              <a:t>: total fuel consumption corrected due to engine stop/start (currently not applicable)</a:t>
+              <a:t> </a:t>
+            </a:r>
+            <a:r>
+              <a:rPr lang="en-US" dirty="0"/>
+              <a:t>[g/h</a:t>
+            </a:r>
+            <a:r>
+              <a:rPr lang="en-US" dirty="0" smtClean="0"/>
+              <a:t>]: fuel consumption corrected due to engine stop/start (currently not applicable)</a:t>
             </a:r>
           </a:p>
           <a:p>
@@ -8393,14 +8742,30 @@
             </a:r>
             <a:r>
               <a:rPr lang="en-US" dirty="0" smtClean="0"/>
-              <a:t>: WHTC-corrected fuel consumption (not applicable in engineering mode)</a:t>
+              <a:t> </a:t>
+            </a:r>
+            <a:r>
+              <a:rPr lang="en-US" dirty="0"/>
+              <a:t>[g/h</a:t>
+            </a:r>
+            <a:r>
+              <a:rPr lang="en-US" dirty="0" smtClean="0"/>
+              <a:t>]: WHTC-corrected fuel consumption (not applicable in engineering mode)</a:t>
             </a:r>
           </a:p>
           <a:p>
             <a:pPr lvl="2"/>
             <a:r>
               <a:rPr lang="en-US" dirty="0" smtClean="0"/>
-              <a:t>FC-AAUX: fuel consumption per simulation interval, derived from </a:t>
+              <a:t>FC-AAUX </a:t>
+            </a:r>
+            <a:r>
+              <a:rPr lang="en-US" dirty="0"/>
+              <a:t>[</a:t>
+            </a:r>
+            <a:r>
+              <a:rPr lang="en-US" dirty="0" smtClean="0"/>
+              <a:t>g/h]: fuel consumption per simulation interval, derived from </a:t>
             </a:r>
             <a:r>
               <a:rPr lang="en-US" dirty="0" err="1" smtClean="0"/>
@@ -8412,7 +8777,15 @@
             <a:pPr lvl="2"/>
             <a:r>
               <a:rPr lang="en-US" dirty="0" smtClean="0"/>
-              <a:t>FC-Final: final fuel consumption value with all (applicable) corrections applied (stop/start, WHTC, smart auxiliaries)</a:t>
+              <a:t>FC-Final </a:t>
+            </a:r>
+            <a:r>
+              <a:rPr lang="en-US" dirty="0"/>
+              <a:t>[g/h</a:t>
+            </a:r>
+            <a:r>
+              <a:rPr lang="en-US" dirty="0" smtClean="0"/>
+              <a:t>]: final fuel consumption value with all (applicable) corrections applied (stop/start, WHTC, smart auxiliaries)</a:t>
             </a:r>
           </a:p>
         </p:txBody>
@@ -8420,7 +8793,7 @@
     </p:spTree>
     <p:extLst>
       <p:ext uri="{BB962C8B-B14F-4D97-AF65-F5344CB8AC3E}">
-        <p14:creationId xmlns:p14="http://schemas.microsoft.com/office/powerpoint/2010/main" val="120205155"/>
+        <p14:creationId xmlns:p14="http://schemas.microsoft.com/office/powerpoint/2010/main" val="1949919211"/>
       </p:ext>
     </p:extLst>
   </p:cSld>

</xml_diff>

<commit_message>
changelog for version 3.1.1
</commit_message>
<xml_diff>
--- a/Documentation/User Manual Source/Release Notes Vecto3.x.pptx
+++ b/Documentation/User Manual Source/Release Notes Vecto3.x.pptx
@@ -5,32 +5,33 @@
     <p:sldMasterId id="2147483648" r:id="rId1"/>
   </p:sldMasterIdLst>
   <p:notesMasterIdLst>
-    <p:notesMasterId r:id="rId22"/>
+    <p:notesMasterId r:id="rId23"/>
   </p:notesMasterIdLst>
   <p:handoutMasterIdLst>
-    <p:handoutMasterId r:id="rId23"/>
+    <p:handoutMasterId r:id="rId24"/>
   </p:handoutMasterIdLst>
   <p:sldIdLst>
     <p:sldId id="575" r:id="rId2"/>
-    <p:sldId id="657" r:id="rId3"/>
-    <p:sldId id="659" r:id="rId4"/>
-    <p:sldId id="660" r:id="rId5"/>
-    <p:sldId id="656" r:id="rId6"/>
-    <p:sldId id="655" r:id="rId7"/>
-    <p:sldId id="654" r:id="rId8"/>
-    <p:sldId id="653" r:id="rId9"/>
-    <p:sldId id="651" r:id="rId10"/>
-    <p:sldId id="648" r:id="rId11"/>
-    <p:sldId id="649" r:id="rId12"/>
-    <p:sldId id="650" r:id="rId13"/>
-    <p:sldId id="645" r:id="rId14"/>
-    <p:sldId id="647" r:id="rId15"/>
-    <p:sldId id="646" r:id="rId16"/>
-    <p:sldId id="640" r:id="rId17"/>
-    <p:sldId id="641" r:id="rId18"/>
-    <p:sldId id="642" r:id="rId19"/>
-    <p:sldId id="643" r:id="rId20"/>
-    <p:sldId id="644" r:id="rId21"/>
+    <p:sldId id="661" r:id="rId3"/>
+    <p:sldId id="657" r:id="rId4"/>
+    <p:sldId id="659" r:id="rId5"/>
+    <p:sldId id="660" r:id="rId6"/>
+    <p:sldId id="656" r:id="rId7"/>
+    <p:sldId id="655" r:id="rId8"/>
+    <p:sldId id="654" r:id="rId9"/>
+    <p:sldId id="653" r:id="rId10"/>
+    <p:sldId id="651" r:id="rId11"/>
+    <p:sldId id="648" r:id="rId12"/>
+    <p:sldId id="649" r:id="rId13"/>
+    <p:sldId id="650" r:id="rId14"/>
+    <p:sldId id="645" r:id="rId15"/>
+    <p:sldId id="647" r:id="rId16"/>
+    <p:sldId id="646" r:id="rId17"/>
+    <p:sldId id="640" r:id="rId18"/>
+    <p:sldId id="641" r:id="rId19"/>
+    <p:sldId id="642" r:id="rId20"/>
+    <p:sldId id="643" r:id="rId21"/>
+    <p:sldId id="644" r:id="rId22"/>
   </p:sldIdLst>
   <p:sldSz cx="9144000" cy="6858000" type="screen4x3"/>
   <p:notesSz cx="6805613" cy="9944100"/>
@@ -161,7 +162,7 @@
   </p:defaultTextStyle>
   <p:extLst>
     <p:ext uri="{EFAFB233-063F-42B5-8137-9DF3F51BA10A}">
-      <p15:sldGuideLst xmlns:p15="http://schemas.microsoft.com/office/powerpoint/2012/main">
+      <p15:sldGuideLst xmlns:p15="http://schemas.microsoft.com/office/powerpoint/2012/main" xmlns="">
         <p15:guide id="1" orient="horz" pos="2160">
           <p15:clr>
             <a:srgbClr val="A4A3A4"/>
@@ -175,7 +176,7 @@
       </p15:sldGuideLst>
     </p:ext>
     <p:ext uri="{2D200454-40CA-4A62-9FC3-DE9A4176ACB9}">
-      <p15:notesGuideLst xmlns:p15="http://schemas.microsoft.com/office/powerpoint/2012/main">
+      <p15:notesGuideLst xmlns:p15="http://schemas.microsoft.com/office/powerpoint/2012/main" xmlns="">
         <p15:guide id="1" orient="horz" pos="3132">
           <p15:clr>
             <a:srgbClr val="A4A3A4"/>
@@ -4510,8 +4511,13 @@
                   <a:srgbClr val="990000"/>
                 </a:solidFill>
               </a:rPr>
-              <a:t>14.11.2016</a:t>
-            </a:r>
+              <a:t>10.01.2017</a:t>
+            </a:r>
+            <a:endParaRPr lang="en-US" sz="2000" dirty="0" smtClean="0">
+              <a:solidFill>
+                <a:srgbClr val="990000"/>
+              </a:solidFill>
+            </a:endParaRPr>
           </a:p>
           <a:p>
             <a:pPr eaLnBrk="1" hangingPunct="1"/>
@@ -4682,22 +4688,34 @@
             <p:ph type="title"/>
           </p:nvPr>
         </p:nvSpPr>
-        <p:spPr/>
+        <p:spPr>
+          <a:xfrm>
+            <a:off x="468315" y="786383"/>
+            <a:ext cx="8218487" cy="482377"/>
+          </a:xfrm>
+        </p:spPr>
         <p:txBody>
           <a:bodyPr/>
           <a:lstStyle/>
           <a:p>
             <a:r>
-              <a:rPr lang="en-US" dirty="0" smtClean="0"/>
-              <a:t>Notes for using </a:t>
-            </a:r>
-            <a:r>
               <a:rPr lang="en-US" dirty="0" err="1" smtClean="0"/>
               <a:t>Vecto</a:t>
             </a:r>
             <a:r>
               <a:rPr lang="en-US" dirty="0" smtClean="0"/>
-              <a:t> 3.x with AAUX (1)</a:t>
+              <a:t> </a:t>
+            </a:r>
+            <a:r>
+              <a:rPr lang="en-US" dirty="0"/>
+              <a:t>3.0.4.544</a:t>
+            </a:r>
+            <a:br>
+              <a:rPr lang="en-US" dirty="0"/>
+            </a:br>
+            <a:r>
+              <a:rPr lang="en-US" sz="1600" dirty="0"/>
+              <a:t>2016-06-28</a:t>
             </a:r>
             <a:endParaRPr lang="en-US" dirty="0"/>
           </a:p>
@@ -4713,71 +4731,158 @@
             <p:ph idx="1"/>
           </p:nvPr>
         </p:nvSpPr>
-        <p:spPr/>
+        <p:spPr>
+          <a:xfrm>
+            <a:off x="539553" y="1628800"/>
+            <a:ext cx="8064896" cy="4353347"/>
+          </a:xfrm>
+        </p:spPr>
         <p:txBody>
           <a:bodyPr/>
           <a:lstStyle/>
           <a:p>
             <a:r>
               <a:rPr lang="en-US" dirty="0" smtClean="0"/>
-              <a:t>The </a:t>
-            </a:r>
+              <a:t>Main </a:t>
+            </a:r>
+            <a:r>
+              <a:rPr lang="en-US" dirty="0"/>
+              <a:t>Updates</a:t>
+            </a:r>
+          </a:p>
+          <a:p>
+            <a:pPr lvl="1"/>
+            <a:r>
+              <a:rPr lang="en-US" dirty="0" smtClean="0"/>
+              <a:t>New </a:t>
+            </a:r>
+            <a:r>
+              <a:rPr lang="en-US" dirty="0"/>
+              <a:t>gear shift strategy according to White Book </a:t>
+            </a:r>
+            <a:r>
+              <a:rPr lang="en-US" dirty="0" smtClean="0"/>
+              <a:t>2016</a:t>
+            </a:r>
+          </a:p>
+          <a:p>
+            <a:pPr lvl="1"/>
+            <a:r>
+              <a:rPr lang="en-US" dirty="0" smtClean="0"/>
+              <a:t>New </a:t>
+            </a:r>
+            <a:r>
+              <a:rPr lang="en-US" dirty="0"/>
+              <a:t>coasting strategy according to White Book 2016</a:t>
+            </a:r>
+          </a:p>
+          <a:p>
+            <a:pPr lvl="1"/>
+            <a:r>
+              <a:rPr lang="en-US" dirty="0" smtClean="0"/>
+              <a:t>New </a:t>
+            </a:r>
+            <a:r>
+              <a:rPr lang="en-US" dirty="0"/>
+              <a:t>input parameters (</a:t>
+            </a:r>
+            <a:r>
+              <a:rPr lang="en-US" dirty="0" err="1"/>
+              <a:t>enineering</a:t>
+            </a:r>
+            <a:r>
+              <a:rPr lang="en-US" dirty="0"/>
+              <a:t> mode) for coasting and gear shift behavior</a:t>
+            </a:r>
+          </a:p>
+          <a:p>
+            <a:pPr lvl="1"/>
+            <a:r>
+              <a:rPr lang="en-US" dirty="0" smtClean="0"/>
+              <a:t>Use </a:t>
+            </a:r>
+            <a:r>
+              <a:rPr lang="en-US" dirty="0"/>
+              <a:t>SI units in Advanced Auxiliaries Module and compile with strict compiler settings (no implicit casts, etc.)</a:t>
+            </a:r>
+          </a:p>
+          <a:p>
+            <a:pPr lvl="1"/>
+            <a:r>
+              <a:rPr lang="en-US" dirty="0" smtClean="0"/>
+              <a:t>Allow </a:t>
+            </a:r>
+            <a:r>
+              <a:rPr lang="en-US" dirty="0"/>
+              <a:t>efficiency for transmission losses (in engineering mode)</a:t>
+            </a:r>
+          </a:p>
+          <a:p>
+            <a:endParaRPr lang="en-US" dirty="0"/>
+          </a:p>
+          <a:p>
             <a:r>
               <a:rPr lang="en-US" dirty="0" err="1" smtClean="0"/>
-              <a:t>AdvancedAuxiliaries</a:t>
-            </a:r>
-            <a:r>
-              <a:rPr lang="en-US" dirty="0" smtClean="0"/>
-              <a:t> module requires the number of activations for pneumatic consumers (brakes, doors, kneeling) and the (estimated) total cycle time. This can be configured in the .APAC-file (actuations file). For standard bus/coach cycles (i.e., the cycle file contains “bus” </a:t>
-            </a:r>
-            <a:r>
-              <a:rPr lang="en-US" b="1" dirty="0" smtClean="0"/>
-              <a:t>and</a:t>
-            </a:r>
-            <a:r>
-              <a:rPr lang="en-US" dirty="0" smtClean="0"/>
-              <a:t> “</a:t>
-            </a:r>
+              <a:t>Bugfixes</a:t>
+            </a:r>
+            <a:endParaRPr lang="en-US" dirty="0"/>
+          </a:p>
+          <a:p>
+            <a:pPr lvl="1"/>
+            <a:r>
+              <a:rPr lang="en-US" dirty="0" smtClean="0"/>
+              <a:t>Auxiliary </a:t>
+            </a:r>
+            <a:r>
+              <a:rPr lang="en-US" dirty="0" err="1"/>
+              <a:t>TechList</a:t>
+            </a:r>
+            <a:r>
+              <a:rPr lang="en-US" dirty="0"/>
+              <a:t> not read from JSON input data</a:t>
+            </a:r>
+          </a:p>
+          <a:p>
+            <a:pPr lvl="1"/>
+            <a:r>
+              <a:rPr lang="en-US" dirty="0" smtClean="0"/>
+              <a:t>Improvements </a:t>
+            </a:r>
+            <a:r>
+              <a:rPr lang="en-US" dirty="0"/>
+              <a:t>in driver strategy</a:t>
+            </a:r>
+          </a:p>
+          <a:p>
+            <a:pPr lvl="1"/>
             <a:r>
               <a:rPr lang="en-US" dirty="0" err="1" smtClean="0"/>
-              <a:t>heavy_urban</a:t>
-            </a:r>
-            <a:r>
-              <a:rPr lang="en-US" dirty="0" smtClean="0"/>
-              <a:t>” or “suburban” or “interurban” or “urban”; </a:t>
-            </a:r>
-            <a:r>
-              <a:rPr lang="en-US" b="1" dirty="0" smtClean="0"/>
-              <a:t>or</a:t>
-            </a:r>
-            <a:r>
-              <a:rPr lang="en-US" dirty="0" smtClean="0"/>
-              <a:t> the cycle contains “coach” (</a:t>
-            </a:r>
-            <a:r>
-              <a:rPr lang="en-US" i="1" dirty="0" smtClean="0"/>
-              <a:t>case insensitive</a:t>
-            </a:r>
-            <a:r>
-              <a:rPr lang="en-US" dirty="0" smtClean="0"/>
-              <a:t>)) the actuations file already contains the number of activations and the cycle time. For other cycles the filename without extension is used to lookup the activations in the .APAC file (</a:t>
-            </a:r>
-            <a:r>
-              <a:rPr lang="en-US" i="1" dirty="0" smtClean="0"/>
-              <a:t>case sensitive</a:t>
-            </a:r>
-            <a:r>
-              <a:rPr lang="en-US" dirty="0" smtClean="0"/>
-              <a:t>)</a:t>
-            </a:r>
-            <a:endParaRPr lang="en-US" dirty="0"/>
+              <a:t>Bugfixes</a:t>
+            </a:r>
+            <a:r>
+              <a:rPr lang="en-US" dirty="0" smtClean="0"/>
+              <a:t> </a:t>
+            </a:r>
+            <a:r>
+              <a:rPr lang="en-US" dirty="0"/>
+              <a:t>in </a:t>
+            </a:r>
+            <a:r>
+              <a:rPr lang="en-US" dirty="0" err="1"/>
+              <a:t>MeasuredSpeed</a:t>
+            </a:r>
+            <a:r>
+              <a:rPr lang="en-US" dirty="0"/>
+              <a:t> mode</a:t>
+            </a:r>
+            <a:endParaRPr lang="en-US" dirty="0" smtClean="0"/>
           </a:p>
         </p:txBody>
       </p:sp>
     </p:spTree>
     <p:extLst>
       <p:ext uri="{BB962C8B-B14F-4D97-AF65-F5344CB8AC3E}">
-        <p14:creationId xmlns:p14="http://schemas.microsoft.com/office/powerpoint/2010/main" val="3750013638"/>
+        <p14:creationId xmlns:p14="http://schemas.microsoft.com/office/powerpoint/2010/main" val="3997910218"/>
       </p:ext>
     </p:extLst>
   </p:cSld>
@@ -4821,12 +4926,7 @@
             <p:ph type="title"/>
           </p:nvPr>
         </p:nvSpPr>
-        <p:spPr>
-          <a:xfrm>
-            <a:off x="467544" y="548680"/>
-            <a:ext cx="8218487" cy="504056"/>
-          </a:xfrm>
-        </p:spPr>
+        <p:spPr/>
         <p:txBody>
           <a:bodyPr/>
           <a:lstStyle/>
@@ -4841,7 +4941,7 @@
             </a:r>
             <a:r>
               <a:rPr lang="en-US" dirty="0" smtClean="0"/>
-              <a:t> 3.x with AAUX (2)</a:t>
+              <a:t> 3.x with AAUX (1)</a:t>
             </a:r>
             <a:endParaRPr lang="en-US" dirty="0"/>
           </a:p>
@@ -4857,218 +4957,71 @@
             <p:ph idx="1"/>
           </p:nvPr>
         </p:nvSpPr>
-        <p:spPr>
-          <a:xfrm>
-            <a:off x="179511" y="1124744"/>
-            <a:ext cx="8856985" cy="5328592"/>
-          </a:xfrm>
-        </p:spPr>
+        <p:spPr/>
         <p:txBody>
           <a:bodyPr/>
           <a:lstStyle/>
           <a:p>
             <a:r>
+              <a:rPr lang="en-US" dirty="0" smtClean="0"/>
+              <a:t>The </a:t>
+            </a:r>
+            <a:r>
               <a:rPr lang="en-US" dirty="0" err="1" smtClean="0"/>
-              <a:t>Vecto</a:t>
-            </a:r>
-            <a:r>
-              <a:rPr lang="en-US" dirty="0" smtClean="0"/>
-              <a:t> 3 uses an average auxiliaries load (determined by the AAUX module depending on the settings)</a:t>
-            </a:r>
-            <a:r>
-              <a:rPr lang="en-US" dirty="0"/>
-              <a:t> for the </a:t>
-            </a:r>
-            <a:r>
-              <a:rPr lang="en-US" dirty="0" smtClean="0"/>
-              <a:t>simulation. The AAUX module computes the fuel consumption in parallel to </a:t>
+              <a:t>AdvancedAuxiliaries</a:t>
+            </a:r>
+            <a:r>
+              <a:rPr lang="en-US" dirty="0" smtClean="0"/>
+              <a:t> module requires the number of activations for pneumatic consumers (brakes, doors, kneeling) and the (estimated) total cycle time. This can be configured in the .APAC-file (actuations file). For standard bus/coach cycles (i.e., the cycle file contains “bus” </a:t>
+            </a:r>
+            <a:r>
+              <a:rPr lang="en-US" b="1" dirty="0" smtClean="0"/>
+              <a:t>and</a:t>
+            </a:r>
+            <a:r>
+              <a:rPr lang="en-US" dirty="0" smtClean="0"/>
+              <a:t> “</a:t>
             </a:r>
             <a:r>
               <a:rPr lang="en-US" dirty="0" err="1" smtClean="0"/>
-              <a:t>VectoCore</a:t>
-            </a:r>
-            <a:r>
-              <a:rPr lang="en-US" dirty="0" smtClean="0"/>
-              <a:t> and accounts for smart consumers (e.g., alternator, pneumatics, …).</a:t>
-            </a:r>
-          </a:p>
-          <a:p>
-            <a:r>
-              <a:rPr lang="en-US" dirty="0" smtClean="0"/>
-              <a:t>Output</a:t>
-            </a:r>
-          </a:p>
-          <a:p>
-            <a:pPr lvl="1"/>
-            <a:r>
-              <a:rPr lang="en-US" dirty="0" smtClean="0"/>
-              <a:t>The .</a:t>
-            </a:r>
-            <a:r>
-              <a:rPr lang="en-US" dirty="0" err="1" smtClean="0"/>
-              <a:t>vmod</a:t>
-            </a:r>
-            <a:r>
-              <a:rPr lang="en-US" dirty="0" smtClean="0"/>
-              <a:t> file contains both, the fuel consumption calculated by </a:t>
-            </a:r>
-            <a:r>
-              <a:rPr lang="en-US" dirty="0" err="1" smtClean="0"/>
-              <a:t>VectoCore</a:t>
-            </a:r>
-            <a:r>
-              <a:rPr lang="en-US" dirty="0" smtClean="0"/>
-              <a:t> (per simulation interval) and AAUX (accumulated and per simulation interval).</a:t>
-            </a:r>
-            <a:br>
-              <a:rPr lang="en-US" dirty="0" smtClean="0"/>
-            </a:br>
-            <a:r>
-              <a:rPr lang="en-US" dirty="0" smtClean="0"/>
-              <a:t>Columns in .</a:t>
-            </a:r>
-            <a:r>
-              <a:rPr lang="en-US" dirty="0" err="1" smtClean="0"/>
-              <a:t>vmod</a:t>
-            </a:r>
-            <a:r>
-              <a:rPr lang="en-US" dirty="0" smtClean="0"/>
-              <a:t> file:</a:t>
-            </a:r>
-          </a:p>
-          <a:p>
-            <a:pPr lvl="2"/>
-            <a:r>
-              <a:rPr lang="en-US" dirty="0" err="1"/>
-              <a:t>AA_TotalCycleFC_Grams</a:t>
-            </a:r>
-            <a:r>
-              <a:rPr lang="en-US" dirty="0"/>
-              <a:t> [g</a:t>
-            </a:r>
-            <a:r>
-              <a:rPr lang="en-US" dirty="0" smtClean="0"/>
-              <a:t>]: accumulated fuel consumption as computed by the AAUX model, considering smart consumers</a:t>
-            </a:r>
-          </a:p>
-          <a:p>
-            <a:pPr lvl="2"/>
-            <a:r>
-              <a:rPr lang="en-US" dirty="0" smtClean="0"/>
-              <a:t>FC-Map </a:t>
-            </a:r>
-            <a:r>
-              <a:rPr lang="en-US" dirty="0"/>
-              <a:t>[</a:t>
-            </a:r>
-            <a:r>
-              <a:rPr lang="en-US" dirty="0" smtClean="0"/>
-              <a:t>g/h]: fuel consumption as computed by </a:t>
-            </a:r>
-            <a:r>
-              <a:rPr lang="en-US" dirty="0" err="1" smtClean="0"/>
-              <a:t>VectoCore</a:t>
-            </a:r>
-            <a:r>
-              <a:rPr lang="en-US" dirty="0" smtClean="0"/>
-              <a:t> interpolating </a:t>
-            </a:r>
-            <a:r>
-              <a:rPr lang="en-US" dirty="0"/>
-              <a:t>in the FC-Map, </a:t>
-            </a:r>
-            <a:r>
-              <a:rPr lang="en-US" dirty="0" smtClean="0"/>
-              <a:t>using an average base load of auxiliaries</a:t>
-            </a:r>
-          </a:p>
-          <a:p>
-            <a:pPr lvl="2"/>
-            <a:r>
-              <a:rPr lang="en-US" dirty="0" smtClean="0"/>
-              <a:t>FC-</a:t>
-            </a:r>
-            <a:r>
-              <a:rPr lang="en-US" dirty="0" err="1" smtClean="0"/>
-              <a:t>AUXc</a:t>
-            </a:r>
-            <a:r>
-              <a:rPr lang="en-US" dirty="0" smtClean="0"/>
-              <a:t> </a:t>
-            </a:r>
-            <a:r>
-              <a:rPr lang="en-US" dirty="0"/>
-              <a:t>[g/h</a:t>
-            </a:r>
-            <a:r>
-              <a:rPr lang="en-US" dirty="0" smtClean="0"/>
-              <a:t>]: fuel consumption corrected due to engine stop/start (currently not applicable)</a:t>
-            </a:r>
-          </a:p>
-          <a:p>
-            <a:pPr lvl="2"/>
-            <a:r>
-              <a:rPr lang="en-US" dirty="0" smtClean="0"/>
-              <a:t>FC-</a:t>
-            </a:r>
-            <a:r>
-              <a:rPr lang="en-US" dirty="0" err="1" smtClean="0"/>
-              <a:t>WHTCc</a:t>
-            </a:r>
-            <a:r>
-              <a:rPr lang="en-US" dirty="0" smtClean="0"/>
-              <a:t> </a:t>
-            </a:r>
-            <a:r>
-              <a:rPr lang="en-US" dirty="0"/>
-              <a:t>[g/h</a:t>
-            </a:r>
-            <a:r>
-              <a:rPr lang="en-US" dirty="0" smtClean="0"/>
-              <a:t>]: WHTC-corrected fuel consumption (not applicable in engineering mode)</a:t>
-            </a:r>
-          </a:p>
-          <a:p>
-            <a:pPr lvl="2"/>
-            <a:r>
-              <a:rPr lang="en-US" dirty="0" smtClean="0"/>
-              <a:t>FC-AAUX </a:t>
-            </a:r>
-            <a:r>
-              <a:rPr lang="en-US" dirty="0"/>
-              <a:t>[</a:t>
-            </a:r>
-            <a:r>
-              <a:rPr lang="en-US" dirty="0" smtClean="0"/>
-              <a:t>g/h]: fuel consumption per simulation interval, derived from </a:t>
-            </a:r>
-            <a:r>
-              <a:rPr lang="en-US" dirty="0" err="1" smtClean="0"/>
-              <a:t>AA_TotalCycleFC_Grams</a:t>
-            </a:r>
-            <a:endParaRPr lang="en-US" dirty="0" smtClean="0"/>
-          </a:p>
-          <a:p>
-            <a:pPr lvl="2"/>
-            <a:r>
-              <a:rPr lang="en-US" dirty="0" smtClean="0"/>
-              <a:t>FC-Final </a:t>
-            </a:r>
-            <a:r>
-              <a:rPr lang="en-US" dirty="0"/>
-              <a:t>[g/h</a:t>
-            </a:r>
-            <a:r>
-              <a:rPr lang="en-US" dirty="0" smtClean="0"/>
-              <a:t>]: final fuel consumption value with all (applicable) corrections applied (stop/start, WHTC, smart auxiliaries)</a:t>
-            </a:r>
+              <a:t>heavy_urban</a:t>
+            </a:r>
+            <a:r>
+              <a:rPr lang="en-US" dirty="0" smtClean="0"/>
+              <a:t>” or “suburban” or “interurban” or “urban”; </a:t>
+            </a:r>
+            <a:r>
+              <a:rPr lang="en-US" b="1" dirty="0" smtClean="0"/>
+              <a:t>or</a:t>
+            </a:r>
+            <a:r>
+              <a:rPr lang="en-US" dirty="0" smtClean="0"/>
+              <a:t> the cycle contains “coach” (</a:t>
+            </a:r>
+            <a:r>
+              <a:rPr lang="en-US" i="1" dirty="0" smtClean="0"/>
+              <a:t>case insensitive</a:t>
+            </a:r>
+            <a:r>
+              <a:rPr lang="en-US" dirty="0" smtClean="0"/>
+              <a:t>)) the actuations file already contains the number of activations and the cycle time. For other cycles the filename without extension is used to lookup the activations in the .APAC file (</a:t>
+            </a:r>
+            <a:r>
+              <a:rPr lang="en-US" i="1" dirty="0" smtClean="0"/>
+              <a:t>case sensitive</a:t>
+            </a:r>
+            <a:r>
+              <a:rPr lang="en-US" dirty="0" smtClean="0"/>
+              <a:t>)</a:t>
+            </a:r>
+            <a:endParaRPr lang="en-US" dirty="0"/>
           </a:p>
         </p:txBody>
       </p:sp>
     </p:spTree>
     <p:extLst>
       <p:ext uri="{BB962C8B-B14F-4D97-AF65-F5344CB8AC3E}">
-        <p14:creationId xmlns:p14="http://schemas.microsoft.com/office/powerpoint/2010/main" val="1949919211"/>
+        <p14:creationId xmlns:p14="http://schemas.microsoft.com/office/powerpoint/2010/main" val="3750013638"/>
       </p:ext>
     </p:extLst>
   </p:cSld>
@@ -5132,7 +5085,7 @@
             </a:r>
             <a:r>
               <a:rPr lang="en-US" dirty="0" smtClean="0"/>
-              <a:t> 3.x with AAUX (3)</a:t>
+              <a:t> 3.x with AAUX (2)</a:t>
             </a:r>
             <a:endParaRPr lang="en-US" dirty="0"/>
           </a:p>
@@ -5150,8 +5103,8 @@
         </p:nvSpPr>
         <p:spPr>
           <a:xfrm>
-            <a:off x="251521" y="1628800"/>
-            <a:ext cx="8640959" cy="4608512"/>
+            <a:off x="179511" y="1124744"/>
+            <a:ext cx="8856985" cy="5328592"/>
           </a:xfrm>
         </p:spPr>
         <p:txBody>
@@ -5159,35 +5112,20 @@
           <a:lstStyle/>
           <a:p>
             <a:r>
-              <a:rPr lang="en-US" dirty="0" smtClean="0"/>
-              <a:t>Output .</a:t>
-            </a:r>
-            <a:r>
               <a:rPr lang="en-US" dirty="0" err="1" smtClean="0"/>
-              <a:t>vsum</a:t>
-            </a:r>
-            <a:endParaRPr lang="en-US" dirty="0" smtClean="0"/>
-          </a:p>
-          <a:p>
-            <a:pPr lvl="1"/>
-            <a:r>
-              <a:rPr lang="en-US" dirty="0" smtClean="0"/>
-              <a:t>Columns in .</a:t>
-            </a:r>
-            <a:r>
-              <a:rPr lang="en-US" dirty="0" err="1" smtClean="0"/>
-              <a:t>vsum</a:t>
-            </a:r>
-            <a:r>
-              <a:rPr lang="en-US" dirty="0" smtClean="0"/>
-              <a:t> file:</a:t>
-            </a:r>
-          </a:p>
-          <a:p>
-            <a:pPr lvl="2"/>
-            <a:r>
-              <a:rPr lang="en-US" dirty="0" smtClean="0"/>
-              <a:t>FC-Map: total fuel consumption as computed by </a:t>
+              <a:t>Vecto</a:t>
+            </a:r>
+            <a:r>
+              <a:rPr lang="en-US" dirty="0" smtClean="0"/>
+              <a:t> 3 uses an average auxiliaries load (determined by the AAUX module depending on the settings)</a:t>
+            </a:r>
+            <a:r>
+              <a:rPr lang="en-US" dirty="0"/>
+              <a:t> for the </a:t>
+            </a:r>
+            <a:r>
+              <a:rPr lang="en-US" dirty="0" smtClean="0"/>
+              <a:t>simulation. The AAUX module computes the fuel consumption in parallel to </a:t>
             </a:r>
             <a:r>
               <a:rPr lang="en-US" dirty="0" err="1" smtClean="0"/>
@@ -5195,7 +5133,97 @@
             </a:r>
             <a:r>
               <a:rPr lang="en-US" dirty="0" smtClean="0"/>
-              <a:t> interpolating in the FC-Map, using an average base load of auxiliaries</a:t>
+              <a:t> and accounts for smart consumers (e.g., alternator, pneumatics, …).</a:t>
+            </a:r>
+          </a:p>
+          <a:p>
+            <a:r>
+              <a:rPr lang="en-US" dirty="0" smtClean="0"/>
+              <a:t>Output</a:t>
+            </a:r>
+          </a:p>
+          <a:p>
+            <a:pPr lvl="1"/>
+            <a:r>
+              <a:rPr lang="en-US" dirty="0" smtClean="0"/>
+              <a:t>The .</a:t>
+            </a:r>
+            <a:r>
+              <a:rPr lang="en-US" dirty="0" err="1" smtClean="0"/>
+              <a:t>vmod</a:t>
+            </a:r>
+            <a:r>
+              <a:rPr lang="en-US" dirty="0" smtClean="0"/>
+              <a:t> file contains both, the fuel consumption calculated by </a:t>
+            </a:r>
+            <a:r>
+              <a:rPr lang="en-US" dirty="0" err="1" smtClean="0"/>
+              <a:t>VectoCore</a:t>
+            </a:r>
+            <a:r>
+              <a:rPr lang="en-US" dirty="0" smtClean="0"/>
+              <a:t> (per simulation interval) and AAUX (accumulated and per simulation interval).</a:t>
+            </a:r>
+            <a:br>
+              <a:rPr lang="en-US" dirty="0" smtClean="0"/>
+            </a:br>
+            <a:r>
+              <a:rPr lang="en-US" dirty="0" smtClean="0"/>
+              <a:t>Columns in .</a:t>
+            </a:r>
+            <a:r>
+              <a:rPr lang="en-US" dirty="0" err="1" smtClean="0"/>
+              <a:t>vmod</a:t>
+            </a:r>
+            <a:r>
+              <a:rPr lang="en-US" dirty="0" smtClean="0"/>
+              <a:t> file:</a:t>
+            </a:r>
+          </a:p>
+          <a:p>
+            <a:pPr lvl="2"/>
+            <a:r>
+              <a:rPr lang="en-US" dirty="0" err="1"/>
+              <a:t>AA_TotalCycleFC_Grams</a:t>
+            </a:r>
+            <a:r>
+              <a:rPr lang="en-US" dirty="0"/>
+              <a:t> [g</a:t>
+            </a:r>
+            <a:r>
+              <a:rPr lang="en-US" dirty="0" smtClean="0"/>
+              <a:t>]: accumulated fuel consumption as computed by the AAUX model, considering smart consumers</a:t>
+            </a:r>
+          </a:p>
+          <a:p>
+            <a:pPr lvl="2"/>
+            <a:r>
+              <a:rPr lang="en-US" dirty="0" smtClean="0"/>
+              <a:t>FC-Map </a:t>
+            </a:r>
+            <a:r>
+              <a:rPr lang="en-US" dirty="0"/>
+              <a:t>[</a:t>
+            </a:r>
+            <a:r>
+              <a:rPr lang="en-US" dirty="0" smtClean="0"/>
+              <a:t>g/h]: fuel consumption as computed by </a:t>
+            </a:r>
+            <a:r>
+              <a:rPr lang="en-US" dirty="0" err="1" smtClean="0"/>
+              <a:t>VectoCore</a:t>
+            </a:r>
+            <a:r>
+              <a:rPr lang="en-US" dirty="0" smtClean="0"/>
+              <a:t> interpolating </a:t>
+            </a:r>
+            <a:r>
+              <a:rPr lang="en-US" dirty="0"/>
+              <a:t>in the FC-Map, </a:t>
+            </a:r>
+            <a:r>
+              <a:rPr lang="en-US" dirty="0" smtClean="0"/>
+              <a:t>using an average base load of auxiliaries</a:t>
             </a:r>
           </a:p>
           <a:p>
@@ -5210,7 +5238,15 @@
             </a:r>
             <a:r>
               <a:rPr lang="en-US" dirty="0" smtClean="0"/>
-              <a:t>: total fuel consumption corrected due to engine stop/start (currently not applicable)</a:t>
+              <a:t> </a:t>
+            </a:r>
+            <a:r>
+              <a:rPr lang="en-US" dirty="0"/>
+              <a:t>[g/h</a:t>
+            </a:r>
+            <a:r>
+              <a:rPr lang="en-US" dirty="0" smtClean="0"/>
+              <a:t>]: fuel consumption corrected due to engine stop/start (currently not applicable)</a:t>
             </a:r>
           </a:p>
           <a:p>
@@ -5225,14 +5261,30 @@
             </a:r>
             <a:r>
               <a:rPr lang="en-US" dirty="0" smtClean="0"/>
-              <a:t>: WHTC-corrected fuel consumption (not applicable in engineering mode)</a:t>
+              <a:t> </a:t>
+            </a:r>
+            <a:r>
+              <a:rPr lang="en-US" dirty="0"/>
+              <a:t>[g/h</a:t>
+            </a:r>
+            <a:r>
+              <a:rPr lang="en-US" dirty="0" smtClean="0"/>
+              <a:t>]: WHTC-corrected fuel consumption (not applicable in engineering mode)</a:t>
             </a:r>
           </a:p>
           <a:p>
             <a:pPr lvl="2"/>
             <a:r>
               <a:rPr lang="en-US" dirty="0" smtClean="0"/>
-              <a:t>FC-AAUX: fuel consumption per simulation interval, derived from </a:t>
+              <a:t>FC-AAUX </a:t>
+            </a:r>
+            <a:r>
+              <a:rPr lang="en-US" dirty="0"/>
+              <a:t>[</a:t>
+            </a:r>
+            <a:r>
+              <a:rPr lang="en-US" dirty="0" smtClean="0"/>
+              <a:t>g/h]: fuel consumption per simulation interval, derived from </a:t>
             </a:r>
             <a:r>
               <a:rPr lang="en-US" dirty="0" err="1" smtClean="0"/>
@@ -5244,7 +5296,15 @@
             <a:pPr lvl="2"/>
             <a:r>
               <a:rPr lang="en-US" dirty="0" smtClean="0"/>
-              <a:t>FC-Final: final fuel consumption value with all (applicable) corrections applied (stop/start, WHTC, smart auxiliaries)</a:t>
+              <a:t>FC-Final </a:t>
+            </a:r>
+            <a:r>
+              <a:rPr lang="en-US" dirty="0"/>
+              <a:t>[g/h</a:t>
+            </a:r>
+            <a:r>
+              <a:rPr lang="en-US" dirty="0" smtClean="0"/>
+              <a:t>]: final fuel consumption value with all (applicable) corrections applied (stop/start, WHTC, smart auxiliaries)</a:t>
             </a:r>
           </a:p>
         </p:txBody>
@@ -5252,7 +5312,7 @@
     </p:spTree>
     <p:extLst>
       <p:ext uri="{BB962C8B-B14F-4D97-AF65-F5344CB8AC3E}">
-        <p14:creationId xmlns:p14="http://schemas.microsoft.com/office/powerpoint/2010/main" val="120205155"/>
+        <p14:creationId xmlns:p14="http://schemas.microsoft.com/office/powerpoint/2010/main" val="1949919211"/>
       </p:ext>
     </p:extLst>
   </p:cSld>
@@ -5298,8 +5358,8 @@
         </p:nvSpPr>
         <p:spPr>
           <a:xfrm>
-            <a:off x="468315" y="570359"/>
-            <a:ext cx="8218487" cy="482377"/>
+            <a:off x="467544" y="548680"/>
+            <a:ext cx="8218487" cy="504056"/>
           </a:xfrm>
         </p:spPr>
         <p:txBody>
@@ -5307,23 +5367,16 @@
           <a:lstStyle/>
           <a:p>
             <a:r>
+              <a:rPr lang="en-US" dirty="0" smtClean="0"/>
+              <a:t>Notes for using </a:t>
+            </a:r>
+            <a:r>
               <a:rPr lang="en-US" dirty="0" err="1" smtClean="0"/>
               <a:t>Vecto</a:t>
             </a:r>
             <a:r>
               <a:rPr lang="en-US" dirty="0" smtClean="0"/>
-              <a:t> </a:t>
-            </a:r>
-            <a:r>
-              <a:rPr lang="en-US" dirty="0"/>
-              <a:t>3.0.3.537</a:t>
-            </a:r>
-            <a:br>
-              <a:rPr lang="en-US" dirty="0"/>
-            </a:br>
-            <a:r>
-              <a:rPr lang="en-US" sz="1600" dirty="0"/>
-              <a:t>2016-06-21</a:t>
+              <a:t> 3.x with AAUX (3)</a:t>
             </a:r>
             <a:endParaRPr lang="en-US" dirty="0"/>
           </a:p>
@@ -5341,8 +5394,8 @@
         </p:nvSpPr>
         <p:spPr>
           <a:xfrm>
-            <a:off x="179512" y="1124744"/>
-            <a:ext cx="8784975" cy="4857403"/>
+            <a:off x="251521" y="1628800"/>
+            <a:ext cx="8640959" cy="4608512"/>
           </a:xfrm>
         </p:spPr>
         <p:txBody>
@@ -5351,171 +5404,99 @@
           <a:p>
             <a:r>
               <a:rPr lang="en-US" dirty="0" smtClean="0"/>
-              <a:t>Main Updates</a:t>
-            </a:r>
-          </a:p>
-          <a:p>
-            <a:pPr lvl="1"/>
-            <a:r>
-              <a:rPr lang="en-US" dirty="0" smtClean="0"/>
-              <a:t>Plot shift lines as computed according to WB 2016 declaration mode in GUI</a:t>
-            </a:r>
-          </a:p>
-          <a:p>
-            <a:r>
-              <a:rPr lang="en-US" dirty="0" err="1" smtClean="0"/>
-              <a:t>Bugfixes</a:t>
-            </a:r>
-            <a:endParaRPr lang="en-US" dirty="0" smtClean="0"/>
-          </a:p>
-          <a:p>
-            <a:pPr lvl="1"/>
-            <a:r>
-              <a:rPr lang="en-US" dirty="0" smtClean="0"/>
-              <a:t>GUI: Buttons to add/remove auxiliaries are visible again</a:t>
-            </a:r>
-          </a:p>
-          <a:p>
-            <a:pPr lvl="1"/>
-            <a:r>
-              <a:rPr lang="en-US" dirty="0" smtClean="0"/>
-              <a:t>Error in calculation of WHTC correction factor</a:t>
-            </a:r>
-          </a:p>
-          <a:p>
-            <a:pPr lvl="1"/>
-            <a:r>
-              <a:rPr lang="en-US" dirty="0" smtClean="0"/>
-              <a:t>Fix: consider gearbox inertia (engineering mode) for searching operating point</a:t>
-            </a:r>
-          </a:p>
-          <a:p>
-            <a:pPr lvl="1"/>
-            <a:r>
-              <a:rPr lang="en-US" dirty="0" smtClean="0"/>
-              <a:t>Wrong output of road gradient in measured speed mode (correct gradient for simulation)</a:t>
-            </a:r>
-          </a:p>
-          <a:p>
-            <a:pPr lvl="1"/>
-            <a:r>
-              <a:rPr lang="en-US" dirty="0" smtClean="0"/>
-              <a:t>Fuel consumption in .</a:t>
+              <a:t>Output .</a:t>
             </a:r>
             <a:r>
               <a:rPr lang="en-US" dirty="0" err="1" smtClean="0"/>
               <a:t>vsum</a:t>
             </a:r>
-            <a:r>
-              <a:rPr lang="en-US" dirty="0" smtClean="0"/>
-              <a:t> file now accounts for </a:t>
+            <a:endParaRPr lang="en-US" dirty="0" smtClean="0"/>
+          </a:p>
+          <a:p>
+            <a:pPr lvl="1"/>
+            <a:r>
+              <a:rPr lang="en-US" dirty="0" smtClean="0"/>
+              <a:t>Columns in .</a:t>
             </a:r>
             <a:r>
               <a:rPr lang="en-US" dirty="0" err="1" smtClean="0"/>
-              <a:t>AdvancedAuxiliaries</a:t>
-            </a:r>
-            <a:r>
-              <a:rPr lang="en-US" dirty="0" smtClean="0"/>
-              <a:t> model</a:t>
-            </a:r>
-          </a:p>
-          <a:p>
-            <a:pPr lvl="1"/>
+              <a:t>vsum</a:t>
+            </a:r>
+            <a:r>
+              <a:rPr lang="en-US" dirty="0" smtClean="0"/>
+              <a:t> file:</a:t>
+            </a:r>
+          </a:p>
+          <a:p>
+            <a:pPr lvl="2"/>
+            <a:r>
+              <a:rPr lang="en-US" dirty="0" smtClean="0"/>
+              <a:t>FC-Map: total fuel consumption as computed by </a:t>
+            </a:r>
             <a:r>
               <a:rPr lang="en-US" dirty="0" err="1" smtClean="0"/>
-              <a:t>GraphDrawer</a:t>
-            </a:r>
-            <a:r>
-              <a:rPr lang="en-US" dirty="0" smtClean="0"/>
-              <a:t> (</a:t>
+              <a:t>VectoCore</a:t>
+            </a:r>
+            <a:r>
+              <a:rPr lang="en-US" dirty="0" smtClean="0"/>
+              <a:t> interpolating in the FC-Map, using an average base load of auxiliaries</a:t>
+            </a:r>
+          </a:p>
+          <a:p>
+            <a:pPr lvl="2"/>
+            <a:r>
+              <a:rPr lang="en-US" dirty="0" smtClean="0"/>
+              <a:t>FC-</a:t>
             </a:r>
             <a:r>
               <a:rPr lang="en-US" dirty="0" err="1" smtClean="0"/>
-              <a:t>Vecto</a:t>
-            </a:r>
-            <a:r>
-              <a:rPr lang="en-US" dirty="0" smtClean="0"/>
-              <a:t>): handle new .</a:t>
+              <a:t>AUXc</a:t>
+            </a:r>
+            <a:r>
+              <a:rPr lang="en-US" dirty="0" smtClean="0"/>
+              <a:t>: total fuel consumption corrected due to engine stop/start (currently not applicable)</a:t>
+            </a:r>
+          </a:p>
+          <a:p>
+            <a:pPr lvl="2"/>
+            <a:r>
+              <a:rPr lang="en-US" dirty="0" smtClean="0"/>
+              <a:t>FC-</a:t>
             </a:r>
             <a:r>
               <a:rPr lang="en-US" dirty="0" err="1" smtClean="0"/>
-              <a:t>vmod</a:t>
-            </a:r>
-            <a:r>
-              <a:rPr lang="en-US" dirty="0" smtClean="0"/>
-              <a:t> format of </a:t>
+              <a:t>WHTCc</a:t>
+            </a:r>
+            <a:r>
+              <a:rPr lang="en-US" dirty="0" smtClean="0"/>
+              <a:t>: WHTC-corrected fuel consumption (not applicable in engineering mode)</a:t>
+            </a:r>
+          </a:p>
+          <a:p>
+            <a:pPr lvl="2"/>
+            <a:r>
+              <a:rPr lang="en-US" dirty="0" smtClean="0"/>
+              <a:t>FC-AAUX: fuel consumption per simulation interval, derived from </a:t>
             </a:r>
             <a:r>
               <a:rPr lang="en-US" dirty="0" err="1" smtClean="0"/>
-              <a:t>Vecto</a:t>
-            </a:r>
-            <a:r>
-              <a:rPr lang="en-US" dirty="0" smtClean="0"/>
-              <a:t> 3</a:t>
-            </a:r>
-          </a:p>
-          <a:p>
-            <a:pPr lvl="1"/>
-            <a:r>
-              <a:rPr lang="en-US" dirty="0" err="1" smtClean="0"/>
-              <a:t>AdvancedAuxiliaries</a:t>
-            </a:r>
-            <a:r>
-              <a:rPr lang="en-US" dirty="0" smtClean="0"/>
-              <a:t>: language-settings independent input parsing</a:t>
-            </a:r>
-          </a:p>
-          <a:p>
-            <a:pPr lvl="1"/>
-            <a:r>
-              <a:rPr lang="en-US" dirty="0" err="1" smtClean="0"/>
-              <a:t>Paux</a:t>
-            </a:r>
-            <a:r>
-              <a:rPr lang="en-US" dirty="0" smtClean="0"/>
-              <a:t> was ignored when running </a:t>
-            </a:r>
-            <a:r>
-              <a:rPr lang="en-US" dirty="0" err="1" smtClean="0"/>
-              <a:t>Vecto</a:t>
-            </a:r>
-            <a:r>
-              <a:rPr lang="en-US" dirty="0" smtClean="0"/>
-              <a:t> 2.2</a:t>
-            </a:r>
-          </a:p>
-          <a:p>
-            <a:pPr lvl="1"/>
-            <a:r>
-              <a:rPr lang="en-US" dirty="0" smtClean="0"/>
-              <a:t>Error in massive multithreaded execution</a:t>
-            </a:r>
-          </a:p>
-          <a:p>
-            <a:pPr lvl="1"/>
-            <a:r>
-              <a:rPr lang="en-US" dirty="0" smtClean="0"/>
-              <a:t>Fix unhandled response during simulation</a:t>
-            </a:r>
-          </a:p>
-          <a:p>
-            <a:pPr lvl="1"/>
-            <a:r>
-              <a:rPr lang="en-US" dirty="0" smtClean="0"/>
-              <a:t>Fix output columns in .</a:t>
-            </a:r>
-            <a:r>
-              <a:rPr lang="en-US" dirty="0" err="1" smtClean="0"/>
-              <a:t>vmod</a:t>
+              <a:t>AA_TotalCycleFC_Grams</a:t>
             </a:r>
             <a:endParaRPr lang="en-US" dirty="0" smtClean="0"/>
+          </a:p>
+          <a:p>
+            <a:pPr lvl="2"/>
+            <a:r>
+              <a:rPr lang="en-US" dirty="0" smtClean="0"/>
+              <a:t>FC-Final: final fuel consumption value with all (applicable) corrections applied (stop/start, WHTC, smart auxiliaries)</a:t>
+            </a:r>
           </a:p>
         </p:txBody>
       </p:sp>
     </p:spTree>
     <p:extLst>
       <p:ext uri="{BB962C8B-B14F-4D97-AF65-F5344CB8AC3E}">
-        <p14:creationId xmlns:p14="http://schemas.microsoft.com/office/powerpoint/2010/main" val="4096386672"/>
+        <p14:creationId xmlns:p14="http://schemas.microsoft.com/office/powerpoint/2010/main" val="120205155"/>
       </p:ext>
     </p:extLst>
   </p:cSld>
@@ -5559,6 +5540,269 @@
             <p:ph type="title"/>
           </p:nvPr>
         </p:nvSpPr>
+        <p:spPr>
+          <a:xfrm>
+            <a:off x="468315" y="570359"/>
+            <a:ext cx="8218487" cy="482377"/>
+          </a:xfrm>
+        </p:spPr>
+        <p:txBody>
+          <a:bodyPr/>
+          <a:lstStyle/>
+          <a:p>
+            <a:r>
+              <a:rPr lang="en-US" dirty="0" err="1" smtClean="0"/>
+              <a:t>Vecto</a:t>
+            </a:r>
+            <a:r>
+              <a:rPr lang="en-US" dirty="0" smtClean="0"/>
+              <a:t> </a:t>
+            </a:r>
+            <a:r>
+              <a:rPr lang="en-US" dirty="0"/>
+              <a:t>3.0.3.537</a:t>
+            </a:r>
+            <a:br>
+              <a:rPr lang="en-US" dirty="0"/>
+            </a:br>
+            <a:r>
+              <a:rPr lang="en-US" sz="1600" dirty="0"/>
+              <a:t>2016-06-21</a:t>
+            </a:r>
+            <a:endParaRPr lang="en-US" dirty="0"/>
+          </a:p>
+        </p:txBody>
+      </p:sp>
+      <p:sp>
+        <p:nvSpPr>
+          <p:cNvPr id="3" name="Inhaltsplatzhalter 2"/>
+          <p:cNvSpPr>
+            <a:spLocks noGrp="1"/>
+          </p:cNvSpPr>
+          <p:nvPr>
+            <p:ph idx="1"/>
+          </p:nvPr>
+        </p:nvSpPr>
+        <p:spPr>
+          <a:xfrm>
+            <a:off x="179512" y="1124744"/>
+            <a:ext cx="8784975" cy="4857403"/>
+          </a:xfrm>
+        </p:spPr>
+        <p:txBody>
+          <a:bodyPr/>
+          <a:lstStyle/>
+          <a:p>
+            <a:r>
+              <a:rPr lang="en-US" dirty="0" smtClean="0"/>
+              <a:t>Main Updates</a:t>
+            </a:r>
+          </a:p>
+          <a:p>
+            <a:pPr lvl="1"/>
+            <a:r>
+              <a:rPr lang="en-US" dirty="0" smtClean="0"/>
+              <a:t>Plot shift lines as computed according to WB 2016 declaration mode in GUI</a:t>
+            </a:r>
+          </a:p>
+          <a:p>
+            <a:r>
+              <a:rPr lang="en-US" dirty="0" err="1" smtClean="0"/>
+              <a:t>Bugfixes</a:t>
+            </a:r>
+            <a:endParaRPr lang="en-US" dirty="0" smtClean="0"/>
+          </a:p>
+          <a:p>
+            <a:pPr lvl="1"/>
+            <a:r>
+              <a:rPr lang="en-US" dirty="0" smtClean="0"/>
+              <a:t>GUI: Buttons to add/remove auxiliaries are visible again</a:t>
+            </a:r>
+          </a:p>
+          <a:p>
+            <a:pPr lvl="1"/>
+            <a:r>
+              <a:rPr lang="en-US" dirty="0" smtClean="0"/>
+              <a:t>Error in calculation of WHTC correction factor</a:t>
+            </a:r>
+          </a:p>
+          <a:p>
+            <a:pPr lvl="1"/>
+            <a:r>
+              <a:rPr lang="en-US" dirty="0" smtClean="0"/>
+              <a:t>Fix: consider gearbox inertia (engineering mode) for searching operating point</a:t>
+            </a:r>
+          </a:p>
+          <a:p>
+            <a:pPr lvl="1"/>
+            <a:r>
+              <a:rPr lang="en-US" dirty="0" smtClean="0"/>
+              <a:t>Wrong output of road gradient in measured speed mode (correct gradient for simulation)</a:t>
+            </a:r>
+          </a:p>
+          <a:p>
+            <a:pPr lvl="1"/>
+            <a:r>
+              <a:rPr lang="en-US" dirty="0" smtClean="0"/>
+              <a:t>Fuel consumption in .</a:t>
+            </a:r>
+            <a:r>
+              <a:rPr lang="en-US" dirty="0" err="1" smtClean="0"/>
+              <a:t>vsum</a:t>
+            </a:r>
+            <a:r>
+              <a:rPr lang="en-US" dirty="0" smtClean="0"/>
+              <a:t> file now accounts for </a:t>
+            </a:r>
+            <a:r>
+              <a:rPr lang="en-US" dirty="0" err="1" smtClean="0"/>
+              <a:t>AdvancedAuxiliaries</a:t>
+            </a:r>
+            <a:r>
+              <a:rPr lang="en-US" dirty="0" smtClean="0"/>
+              <a:t> model</a:t>
+            </a:r>
+          </a:p>
+          <a:p>
+            <a:pPr lvl="1"/>
+            <a:r>
+              <a:rPr lang="en-US" dirty="0" err="1" smtClean="0"/>
+              <a:t>GraphDrawer</a:t>
+            </a:r>
+            <a:r>
+              <a:rPr lang="en-US" dirty="0" smtClean="0"/>
+              <a:t> (</a:t>
+            </a:r>
+            <a:r>
+              <a:rPr lang="en-US" dirty="0" err="1" smtClean="0"/>
+              <a:t>Vecto</a:t>
+            </a:r>
+            <a:r>
+              <a:rPr lang="en-US" dirty="0" smtClean="0"/>
+              <a:t>): handle new .</a:t>
+            </a:r>
+            <a:r>
+              <a:rPr lang="en-US" dirty="0" err="1" smtClean="0"/>
+              <a:t>vmod</a:t>
+            </a:r>
+            <a:r>
+              <a:rPr lang="en-US" dirty="0" smtClean="0"/>
+              <a:t> format of </a:t>
+            </a:r>
+            <a:r>
+              <a:rPr lang="en-US" dirty="0" err="1" smtClean="0"/>
+              <a:t>Vecto</a:t>
+            </a:r>
+            <a:r>
+              <a:rPr lang="en-US" dirty="0" smtClean="0"/>
+              <a:t> 3</a:t>
+            </a:r>
+          </a:p>
+          <a:p>
+            <a:pPr lvl="1"/>
+            <a:r>
+              <a:rPr lang="en-US" dirty="0" err="1" smtClean="0"/>
+              <a:t>AdvancedAuxiliaries</a:t>
+            </a:r>
+            <a:r>
+              <a:rPr lang="en-US" dirty="0" smtClean="0"/>
+              <a:t>: language-settings independent input parsing</a:t>
+            </a:r>
+          </a:p>
+          <a:p>
+            <a:pPr lvl="1"/>
+            <a:r>
+              <a:rPr lang="en-US" dirty="0" err="1" smtClean="0"/>
+              <a:t>Paux</a:t>
+            </a:r>
+            <a:r>
+              <a:rPr lang="en-US" dirty="0" smtClean="0"/>
+              <a:t> was ignored when running </a:t>
+            </a:r>
+            <a:r>
+              <a:rPr lang="en-US" dirty="0" err="1" smtClean="0"/>
+              <a:t>Vecto</a:t>
+            </a:r>
+            <a:r>
+              <a:rPr lang="en-US" dirty="0" smtClean="0"/>
+              <a:t> 2.2</a:t>
+            </a:r>
+          </a:p>
+          <a:p>
+            <a:pPr lvl="1"/>
+            <a:r>
+              <a:rPr lang="en-US" dirty="0" smtClean="0"/>
+              <a:t>Error in massive multithreaded execution</a:t>
+            </a:r>
+          </a:p>
+          <a:p>
+            <a:pPr lvl="1"/>
+            <a:r>
+              <a:rPr lang="en-US" dirty="0" smtClean="0"/>
+              <a:t>Fix unhandled response during simulation</a:t>
+            </a:r>
+          </a:p>
+          <a:p>
+            <a:pPr lvl="1"/>
+            <a:r>
+              <a:rPr lang="en-US" dirty="0" smtClean="0"/>
+              <a:t>Fix output columns in .</a:t>
+            </a:r>
+            <a:r>
+              <a:rPr lang="en-US" dirty="0" err="1" smtClean="0"/>
+              <a:t>vmod</a:t>
+            </a:r>
+            <a:endParaRPr lang="en-US" dirty="0" smtClean="0"/>
+          </a:p>
+        </p:txBody>
+      </p:sp>
+    </p:spTree>
+    <p:extLst>
+      <p:ext uri="{BB962C8B-B14F-4D97-AF65-F5344CB8AC3E}">
+        <p14:creationId xmlns:p14="http://schemas.microsoft.com/office/powerpoint/2010/main" val="4096386672"/>
+      </p:ext>
+    </p:extLst>
+  </p:cSld>
+  <p:clrMapOvr>
+    <a:masterClrMapping/>
+  </p:clrMapOvr>
+  <p:timing>
+    <p:tnLst>
+      <p:par>
+        <p:cTn id="1" dur="indefinite" restart="never" nodeType="tmRoot"/>
+      </p:par>
+    </p:tnLst>
+  </p:timing>
+</p:sld>
+</file>
+
+<file path=ppt/slides/slide15.xml><?xml version="1.0" encoding="utf-8"?>
+<p:sld xmlns:a="http://schemas.openxmlformats.org/drawingml/2006/main" xmlns:r="http://schemas.openxmlformats.org/officeDocument/2006/relationships" xmlns:p="http://schemas.openxmlformats.org/presentationml/2006/main">
+  <p:cSld>
+    <p:spTree>
+      <p:nvGrpSpPr>
+        <p:cNvPr id="1" name=""/>
+        <p:cNvGrpSpPr/>
+        <p:nvPr/>
+      </p:nvGrpSpPr>
+      <p:grpSpPr>
+        <a:xfrm>
+          <a:off x="0" y="0"/>
+          <a:ext cx="0" cy="0"/>
+          <a:chOff x="0" y="0"/>
+          <a:chExt cx="0" cy="0"/>
+        </a:xfrm>
+      </p:grpSpPr>
+      <p:sp>
+        <p:nvSpPr>
+          <p:cNvPr id="2" name="Titel 1"/>
+          <p:cNvSpPr>
+            <a:spLocks noGrp="1"/>
+          </p:cNvSpPr>
+          <p:nvPr>
+            <p:ph type="title"/>
+          </p:nvPr>
+        </p:nvSpPr>
         <p:spPr/>
         <p:txBody>
           <a:bodyPr/>
@@ -5717,7 +5961,7 @@
 </p:sld>
 </file>
 
-<file path=ppt/slides/slide15.xml><?xml version="1.0" encoding="utf-8"?>
+<file path=ppt/slides/slide16.xml><?xml version="1.0" encoding="utf-8"?>
 <p:sld xmlns:a="http://schemas.openxmlformats.org/drawingml/2006/main" xmlns:r="http://schemas.openxmlformats.org/officeDocument/2006/relationships" xmlns:p="http://schemas.openxmlformats.org/presentationml/2006/main">
   <p:cSld>
     <p:spTree>
@@ -5902,7 +6146,7 @@
 </p:sld>
 </file>
 
-<file path=ppt/slides/slide16.xml><?xml version="1.0" encoding="utf-8"?>
+<file path=ppt/slides/slide17.xml><?xml version="1.0" encoding="utf-8"?>
 <p:sld xmlns:a="http://schemas.openxmlformats.org/drawingml/2006/main" xmlns:r="http://schemas.openxmlformats.org/officeDocument/2006/relationships" xmlns:p="http://schemas.openxmlformats.org/presentationml/2006/main">
   <p:cSld>
     <p:spTree>
@@ -6492,188 +6736,6 @@
 </p:sld>
 </file>
 
-<file path=ppt/slides/slide17.xml><?xml version="1.0" encoding="utf-8"?>
-<p:sld xmlns:a="http://schemas.openxmlformats.org/drawingml/2006/main" xmlns:r="http://schemas.openxmlformats.org/officeDocument/2006/relationships" xmlns:p="http://schemas.openxmlformats.org/presentationml/2006/main">
-  <p:cSld>
-    <p:spTree>
-      <p:nvGrpSpPr>
-        <p:cNvPr id="1" name=""/>
-        <p:cNvGrpSpPr/>
-        <p:nvPr/>
-      </p:nvGrpSpPr>
-      <p:grpSpPr>
-        <a:xfrm>
-          <a:off x="0" y="0"/>
-          <a:ext cx="0" cy="0"/>
-          <a:chOff x="0" y="0"/>
-          <a:chExt cx="0" cy="0"/>
-        </a:xfrm>
-      </p:grpSpPr>
-      <p:sp>
-        <p:nvSpPr>
-          <p:cNvPr id="2" name="Titel 1"/>
-          <p:cNvSpPr>
-            <a:spLocks noGrp="1"/>
-          </p:cNvSpPr>
-          <p:nvPr>
-            <p:ph type="title"/>
-          </p:nvPr>
-        </p:nvSpPr>
-        <p:spPr/>
-        <p:txBody>
-          <a:bodyPr/>
-          <a:lstStyle/>
-          <a:p>
-            <a:r>
-              <a:rPr lang="en-US" dirty="0" err="1" smtClean="0"/>
-              <a:t>Pwheel</a:t>
-            </a:r>
-            <a:r>
-              <a:rPr lang="en-US" dirty="0" smtClean="0"/>
-              <a:t> (</a:t>
-            </a:r>
-            <a:r>
-              <a:rPr lang="en-US" dirty="0" err="1" smtClean="0"/>
-              <a:t>SiCo</a:t>
-            </a:r>
-            <a:r>
-              <a:rPr lang="en-US" dirty="0" smtClean="0"/>
-              <a:t>) Mode</a:t>
-            </a:r>
-            <a:endParaRPr lang="en-US" dirty="0"/>
-          </a:p>
-        </p:txBody>
-      </p:sp>
-      <p:sp>
-        <p:nvSpPr>
-          <p:cNvPr id="3" name="Inhaltsplatzhalter 2"/>
-          <p:cNvSpPr>
-            <a:spLocks noGrp="1"/>
-          </p:cNvSpPr>
-          <p:nvPr>
-            <p:ph idx="1"/>
-          </p:nvPr>
-        </p:nvSpPr>
-        <p:spPr/>
-        <p:txBody>
-          <a:bodyPr/>
-          <a:lstStyle/>
-          <a:p>
-            <a:r>
-              <a:rPr lang="en-US" dirty="0" smtClean="0"/>
-              <a:t>Function as already available in </a:t>
-            </a:r>
-            <a:r>
-              <a:rPr lang="en-US" dirty="0" err="1" smtClean="0"/>
-              <a:t>Vecto</a:t>
-            </a:r>
-            <a:r>
-              <a:rPr lang="en-US" dirty="0" smtClean="0"/>
-              <a:t> 2.2 also added in </a:t>
-            </a:r>
-            <a:r>
-              <a:rPr lang="en-US" dirty="0" err="1" smtClean="0"/>
-              <a:t>Vecto</a:t>
-            </a:r>
-            <a:r>
-              <a:rPr lang="en-US" dirty="0" smtClean="0"/>
-              <a:t> 3.0.2</a:t>
-            </a:r>
-          </a:p>
-          <a:p>
-            <a:pPr lvl="1"/>
-            <a:r>
-              <a:rPr lang="en-US" dirty="0" smtClean="0"/>
-              <a:t>Driving cycle specifies power at wheel, engine speed, gear, and auxiliary power</a:t>
-            </a:r>
-          </a:p>
-          <a:p>
-            <a:pPr lvl="1"/>
-            <a:r>
-              <a:rPr lang="en-US" dirty="0"/>
-              <a:t>No driver model in the simulation.</a:t>
-            </a:r>
-          </a:p>
-          <a:p>
-            <a:pPr lvl="1"/>
-            <a:r>
-              <a:rPr lang="en-US" dirty="0" smtClean="0"/>
-              <a:t>The </a:t>
-            </a:r>
-            <a:r>
-              <a:rPr lang="en-US" dirty="0" err="1"/>
-              <a:t>Vecto</a:t>
-            </a:r>
-            <a:r>
-              <a:rPr lang="en-US" dirty="0"/>
-              <a:t> gear-shift model is overruled.</a:t>
-            </a:r>
-          </a:p>
-          <a:p>
-            <a:pPr lvl="1"/>
-            <a:r>
-              <a:rPr lang="en-US" dirty="0"/>
-              <a:t>Function used for </a:t>
-            </a:r>
-            <a:r>
-              <a:rPr lang="en-US" dirty="0" smtClean="0"/>
-              <a:t>creating reference results for </a:t>
-            </a:r>
-            <a:r>
-              <a:rPr lang="en-US" dirty="0" err="1" smtClean="0"/>
-              <a:t>SiCo</a:t>
-            </a:r>
-            <a:r>
-              <a:rPr lang="en-US" dirty="0" smtClean="0"/>
-              <a:t> tests</a:t>
-            </a:r>
-          </a:p>
-          <a:p>
-            <a:pPr lvl="1"/>
-            <a:r>
-              <a:rPr lang="en-US" dirty="0" smtClean="0"/>
-              <a:t>For details see user manual: Simulation Models / </a:t>
-            </a:r>
-            <a:r>
-              <a:rPr lang="en-US" dirty="0" err="1" smtClean="0"/>
-              <a:t>Pwheel</a:t>
-            </a:r>
-            <a:r>
-              <a:rPr lang="en-US" dirty="0" smtClean="0"/>
-              <a:t> Input (</a:t>
-            </a:r>
-            <a:r>
-              <a:rPr lang="en-US" dirty="0" err="1" smtClean="0"/>
-              <a:t>SiCo</a:t>
-            </a:r>
-            <a:r>
-              <a:rPr lang="en-US" dirty="0" smtClean="0"/>
-              <a:t>)</a:t>
-            </a:r>
-            <a:endParaRPr lang="en-US" dirty="0"/>
-          </a:p>
-          <a:p>
-            <a:pPr lvl="1"/>
-            <a:endParaRPr lang="en-US" dirty="0" smtClean="0"/>
-          </a:p>
-          <a:p>
-            <a:endParaRPr lang="en-US" dirty="0"/>
-          </a:p>
-        </p:txBody>
-      </p:sp>
-    </p:spTree>
-    <p:extLst>
-      <p:ext uri="{BB962C8B-B14F-4D97-AF65-F5344CB8AC3E}">
-        <p14:creationId xmlns:p14="http://schemas.microsoft.com/office/powerpoint/2010/main" val="3176522223"/>
-      </p:ext>
-    </p:extLst>
-  </p:cSld>
-  <p:clrMapOvr>
-    <a:masterClrMapping/>
-  </p:clrMapOvr>
-</p:sld>
-</file>
-
 <file path=ppt/slides/slide18.xml><?xml version="1.0" encoding="utf-8"?>
 <p:sld xmlns:a="http://schemas.openxmlformats.org/drawingml/2006/main" xmlns:r="http://schemas.openxmlformats.org/officeDocument/2006/relationships" xmlns:p="http://schemas.openxmlformats.org/presentationml/2006/main">
   <p:cSld>
@@ -6707,8 +6769,20 @@
           <a:lstStyle/>
           <a:p>
             <a:r>
-              <a:rPr lang="en-US" dirty="0" smtClean="0"/>
-              <a:t>Measured Speed Mode</a:t>
+              <a:rPr lang="en-US" dirty="0" err="1" smtClean="0"/>
+              <a:t>Pwheel</a:t>
+            </a:r>
+            <a:r>
+              <a:rPr lang="en-US" dirty="0" smtClean="0"/>
+              <a:t> (</a:t>
+            </a:r>
+            <a:r>
+              <a:rPr lang="en-US" dirty="0" err="1" smtClean="0"/>
+              <a:t>SiCo</a:t>
+            </a:r>
+            <a:r>
+              <a:rPr lang="en-US" dirty="0" smtClean="0"/>
+              <a:t>) Mode</a:t>
             </a:r>
             <a:endParaRPr lang="en-US" dirty="0"/>
           </a:p>
@@ -6731,7 +6805,7 @@
           <a:p>
             <a:r>
               <a:rPr lang="en-US" dirty="0" smtClean="0"/>
-              <a:t>Functionality already available in </a:t>
+              <a:t>Function as already available in </a:t>
             </a:r>
             <a:r>
               <a:rPr lang="en-US" dirty="0" err="1" smtClean="0"/>
@@ -6739,7 +6813,7 @@
             </a:r>
             <a:r>
               <a:rPr lang="en-US" dirty="0" smtClean="0"/>
-              <a:t> 2.2 added in </a:t>
+              <a:t> 2.2 also added in </a:t>
             </a:r>
             <a:r>
               <a:rPr lang="en-US" dirty="0" err="1" smtClean="0"/>
@@ -6754,37 +6828,79 @@
             <a:pPr lvl="1"/>
             <a:r>
               <a:rPr lang="en-US" dirty="0" smtClean="0"/>
-              <a:t>Driving cycle not defined by target speed but by actual speed. No driver model in the simulation.</a:t>
+              <a:t>Driving cycle specifies power at wheel, engine speed, gear, and auxiliary power</a:t>
             </a:r>
           </a:p>
           <a:p>
             <a:pPr lvl="1"/>
             <a:r>
-              <a:rPr lang="en-US" dirty="0" smtClean="0"/>
-              <a:t>Gear and engine speed can be specified in the driving cycle. In this case the </a:t>
+              <a:rPr lang="en-US" dirty="0"/>
+              <a:t>No driver model in the simulation.</a:t>
+            </a:r>
+          </a:p>
+          <a:p>
+            <a:pPr lvl="1"/>
+            <a:r>
+              <a:rPr lang="en-US" dirty="0" smtClean="0"/>
+              <a:t>The </a:t>
+            </a:r>
+            <a:r>
+              <a:rPr lang="en-US" dirty="0" err="1"/>
+              <a:t>Vecto</a:t>
+            </a:r>
+            <a:r>
+              <a:rPr lang="en-US" dirty="0"/>
+              <a:t> gear-shift model is overruled.</a:t>
+            </a:r>
+          </a:p>
+          <a:p>
+            <a:pPr lvl="1"/>
+            <a:r>
+              <a:rPr lang="en-US" dirty="0"/>
+              <a:t>Function used for </a:t>
+            </a:r>
+            <a:r>
+              <a:rPr lang="en-US" dirty="0" smtClean="0"/>
+              <a:t>creating reference results for </a:t>
             </a:r>
             <a:r>
               <a:rPr lang="en-US" dirty="0" err="1" smtClean="0"/>
-              <a:t>Vecto</a:t>
-            </a:r>
-            <a:r>
-              <a:rPr lang="en-US" dirty="0" smtClean="0"/>
-              <a:t> gear-shift model is overruled.</a:t>
+              <a:t>SiCo</a:t>
+            </a:r>
+            <a:r>
+              <a:rPr lang="en-US" dirty="0" smtClean="0"/>
+              <a:t> tests</a:t>
             </a:r>
           </a:p>
           <a:p>
             <a:pPr lvl="1"/>
             <a:r>
               <a:rPr lang="en-US" dirty="0" smtClean="0"/>
-              <a:t>Function used for “proof of concept” purposes</a:t>
-            </a:r>
+              <a:t>For details see user manual: Simulation Models / </a:t>
+            </a:r>
+            <a:r>
+              <a:rPr lang="en-US" dirty="0" err="1" smtClean="0"/>
+              <a:t>Pwheel</a:t>
+            </a:r>
+            <a:r>
+              <a:rPr lang="en-US" dirty="0" smtClean="0"/>
+              <a:t> Input (</a:t>
+            </a:r>
+            <a:r>
+              <a:rPr lang="en-US" dirty="0" err="1" smtClean="0"/>
+              <a:t>SiCo</a:t>
+            </a:r>
+            <a:r>
+              <a:rPr lang="en-US" dirty="0" smtClean="0"/>
+              <a:t>)</a:t>
+            </a:r>
+            <a:endParaRPr lang="en-US" dirty="0"/>
           </a:p>
           <a:p>
             <a:pPr lvl="1"/>
-            <a:r>
-              <a:rPr lang="en-US" dirty="0" smtClean="0"/>
-              <a:t>For details see user manual: Calculation Modes / Engineering Mode / Measured Speed</a:t>
-            </a:r>
+            <a:endParaRPr lang="en-US" dirty="0" smtClean="0"/>
+          </a:p>
+          <a:p>
             <a:endParaRPr lang="en-US" dirty="0"/>
           </a:p>
         </p:txBody>
@@ -6792,7 +6908,7 @@
     </p:spTree>
     <p:extLst>
       <p:ext uri="{BB962C8B-B14F-4D97-AF65-F5344CB8AC3E}">
-        <p14:creationId xmlns:p14="http://schemas.microsoft.com/office/powerpoint/2010/main" val="3735808897"/>
+        <p14:creationId xmlns:p14="http://schemas.microsoft.com/office/powerpoint/2010/main" val="3176522223"/>
       </p:ext>
     </p:extLst>
   </p:cSld>
@@ -6836,15 +6952,7 @@
           <a:p>
             <a:r>
               <a:rPr lang="en-US" dirty="0" smtClean="0"/>
-              <a:t>.</a:t>
-            </a:r>
-            <a:r>
-              <a:rPr lang="en-US" dirty="0" err="1" smtClean="0"/>
-              <a:t>vmod</a:t>
-            </a:r>
-            <a:r>
-              <a:rPr lang="en-US" dirty="0" smtClean="0"/>
-              <a:t> File Update</a:t>
+              <a:t>Measured Speed Mode</a:t>
             </a:r>
             <a:endParaRPr lang="en-US" dirty="0"/>
           </a:p>
@@ -6866,50 +6974,60 @@
           <a:lstStyle/>
           <a:p>
             <a:r>
-              <a:rPr lang="en-US" dirty="0"/>
-              <a:t>In </a:t>
-            </a:r>
-            <a:r>
-              <a:rPr lang="en-US" dirty="0" err="1"/>
+              <a:rPr lang="en-US" dirty="0" smtClean="0"/>
+              <a:t>Functionality already available in </a:t>
+            </a:r>
+            <a:r>
+              <a:rPr lang="en-US" dirty="0" err="1" smtClean="0"/>
               <a:t>Vecto</a:t>
             </a:r>
             <a:r>
-              <a:rPr lang="en-US" dirty="0"/>
-              <a:t> 3.0.2 the structure of the modal data output has been revised and re-structured. </a:t>
-            </a:r>
-            <a:r>
-              <a:rPr lang="en-US" dirty="0" err="1"/>
-              <a:t>Basicaly</a:t>
-            </a:r>
-            <a:r>
-              <a:rPr lang="en-US" dirty="0"/>
-              <a:t> for every powertrain component the .</a:t>
-            </a:r>
-            <a:r>
-              <a:rPr lang="en-US" dirty="0" err="1"/>
-              <a:t>vmod</a:t>
-            </a:r>
-            <a:r>
-              <a:rPr lang="en-US" dirty="0"/>
-              <a:t> file contains the power at the input shaft and the individual power losses for every component. For the engine the power, torque and engine speed at the output shaft is given along with the internal power and torque used for computing the fuel consumption</a:t>
-            </a:r>
-            <a:r>
-              <a:rPr lang="en-US" dirty="0" smtClean="0"/>
-              <a:t>.</a:t>
-            </a:r>
-          </a:p>
-          <a:p>
-            <a:r>
-              <a:rPr lang="en-US" dirty="0" smtClean="0"/>
-              <a:t>For details see the user manual: Input and Output / Modal Results (.</a:t>
+              <a:rPr lang="en-US" dirty="0" smtClean="0"/>
+              <a:t> 2.2 added in </a:t>
             </a:r>
             <a:r>
               <a:rPr lang="en-US" dirty="0" err="1" smtClean="0"/>
-              <a:t>vmod</a:t>
-            </a:r>
-            <a:r>
-              <a:rPr lang="en-US" dirty="0" smtClean="0"/>
-              <a:t>)</a:t>
+              <a:t>Vecto</a:t>
+            </a:r>
+            <a:r>
+              <a:rPr lang="en-US" dirty="0" smtClean="0"/>
+              <a:t> 3.0.2</a:t>
+            </a:r>
+          </a:p>
+          <a:p>
+            <a:pPr lvl="1"/>
+            <a:r>
+              <a:rPr lang="en-US" dirty="0" smtClean="0"/>
+              <a:t>Driving cycle not defined by target speed but by actual speed. No driver model in the simulation.</a:t>
+            </a:r>
+          </a:p>
+          <a:p>
+            <a:pPr lvl="1"/>
+            <a:r>
+              <a:rPr lang="en-US" dirty="0" smtClean="0"/>
+              <a:t>Gear and engine speed can be specified in the driving cycle. In this case the </a:t>
+            </a:r>
+            <a:r>
+              <a:rPr lang="en-US" dirty="0" err="1" smtClean="0"/>
+              <a:t>Vecto</a:t>
+            </a:r>
+            <a:r>
+              <a:rPr lang="en-US" dirty="0" smtClean="0"/>
+              <a:t> gear-shift model is overruled.</a:t>
+            </a:r>
+          </a:p>
+          <a:p>
+            <a:pPr lvl="1"/>
+            <a:r>
+              <a:rPr lang="en-US" dirty="0" smtClean="0"/>
+              <a:t>Function used for “proof of concept” purposes</a:t>
+            </a:r>
+          </a:p>
+          <a:p>
+            <a:pPr lvl="1"/>
+            <a:r>
+              <a:rPr lang="en-US" dirty="0" smtClean="0"/>
+              <a:t>For details see user manual: Calculation Modes / Engineering Mode / Measured Speed</a:t>
             </a:r>
             <a:endParaRPr lang="en-US" dirty="0"/>
           </a:p>
@@ -6918,7 +7036,7 @@
     </p:spTree>
     <p:extLst>
       <p:ext uri="{BB962C8B-B14F-4D97-AF65-F5344CB8AC3E}">
-        <p14:creationId xmlns:p14="http://schemas.microsoft.com/office/powerpoint/2010/main" val="3869754132"/>
+        <p14:creationId xmlns:p14="http://schemas.microsoft.com/office/powerpoint/2010/main" val="3735808897"/>
       </p:ext>
     </p:extLst>
   </p:cSld>
@@ -6975,7 +7093,7 @@
             </a:r>
             <a:r>
               <a:rPr lang="en-US" dirty="0" smtClean="0"/>
-              <a:t>3.1.0.683</a:t>
+              <a:t>3.1.1.740</a:t>
             </a:r>
             <a:r>
               <a:rPr lang="en-US" dirty="0"/>
@@ -6985,9 +7103,10 @@
               <a:rPr lang="en-US" dirty="0"/>
             </a:br>
             <a:r>
-              <a:rPr lang="en-US" sz="1600" dirty="0"/>
-              <a:t>2016-11-14</a:t>
-            </a:r>
+              <a:rPr lang="en-US" sz="1600" dirty="0" smtClean="0"/>
+              <a:t>2017-01-10</a:t>
+            </a:r>
+            <a:endParaRPr lang="en-US" sz="1600" dirty="0"/>
           </a:p>
         </p:txBody>
       </p:sp>
@@ -7004,7 +7123,7 @@
         <p:spPr>
           <a:xfrm>
             <a:off x="323529" y="1196752"/>
-            <a:ext cx="8640960" cy="5904656"/>
+            <a:ext cx="8640960" cy="5184576"/>
           </a:xfrm>
         </p:spPr>
         <p:txBody>
@@ -7015,211 +7134,156 @@
               <a:buNone/>
             </a:pPr>
             <a:r>
-              <a:rPr lang="en-US" sz="1600" b="1" dirty="0" err="1" smtClean="0"/>
-              <a:t>Bugfixes</a:t>
-            </a:r>
-            <a:r>
-              <a:rPr lang="en-US" sz="1600" b="1" dirty="0" smtClean="0"/>
-              <a:t>:</a:t>
-            </a:r>
-          </a:p>
-          <a:p>
-            <a:r>
-              <a:rPr lang="en-US" sz="1600" dirty="0" smtClean="0"/>
-              <a:t>[</a:t>
-            </a:r>
-            <a:r>
-              <a:rPr lang="en-US" sz="1600" dirty="0"/>
-              <a:t>VECTO-375] Fixed bug when braking during slope change from negative to positive values.</a:t>
-            </a:r>
-          </a:p>
-          <a:p>
-            <a:r>
-              <a:rPr lang="en-US" sz="1600" dirty="0" smtClean="0"/>
-              <a:t>[</a:t>
-            </a:r>
-            <a:r>
-              <a:rPr lang="en-US" sz="1600" dirty="0"/>
-              <a:t>VECTO-372] Added check for unusual acceleration/deceleration data which could lead to error when halting.</a:t>
-            </a:r>
-          </a:p>
-          <a:p>
-            <a:r>
-              <a:rPr lang="en-US" sz="1600" dirty="0" smtClean="0"/>
-              <a:t>[</a:t>
-            </a:r>
-            <a:r>
-              <a:rPr lang="en-US" sz="1600" dirty="0"/>
-              <a:t>VECTO-371] Added additional behavior to overcome such situations</a:t>
-            </a:r>
-          </a:p>
-          <a:p>
-            <a:r>
-              <a:rPr lang="en-US" sz="1600" dirty="0" smtClean="0"/>
-              <a:t>[</a:t>
-            </a:r>
-            <a:r>
-              <a:rPr lang="en-US" sz="1600" dirty="0"/>
-              <a:t>VECTO-370] Added additional behavior to overcome such situations</a:t>
-            </a:r>
-          </a:p>
-          <a:p>
-            <a:r>
-              <a:rPr lang="en-US" sz="1600" dirty="0" smtClean="0"/>
-              <a:t>[</a:t>
-            </a:r>
-            <a:r>
-              <a:rPr lang="en-US" sz="1600" dirty="0"/>
-              <a:t>VECTO-369] </a:t>
-            </a:r>
-            <a:r>
-              <a:rPr lang="en-US" sz="1600" dirty="0" err="1"/>
-              <a:t>CrosswindCorrection</a:t>
-            </a:r>
-            <a:r>
-              <a:rPr lang="en-US" sz="1600" dirty="0"/>
-              <a:t> is now saved and read again from JSON files</a:t>
-            </a:r>
-          </a:p>
-          <a:p>
-            <a:r>
-              <a:rPr lang="en-US" sz="1600" dirty="0" smtClean="0"/>
-              <a:t>[</a:t>
-            </a:r>
-            <a:r>
-              <a:rPr lang="en-US" sz="1600" dirty="0"/>
-              <a:t>VECTO-373] WHTC-Engineering correction factor now correctly read/write in JSON files</a:t>
-            </a:r>
-          </a:p>
-          <a:p>
-            <a:r>
-              <a:rPr lang="en-US" sz="1600" dirty="0" smtClean="0"/>
-              <a:t>[</a:t>
-            </a:r>
-            <a:r>
-              <a:rPr lang="en-US" sz="1600" dirty="0"/>
-              <a:t>VECTO-368] Fixed validation for specific cases when values are intentionally invalid.</a:t>
-            </a:r>
-          </a:p>
-          <a:p>
-            <a:r>
-              <a:rPr lang="en-US" sz="1600" dirty="0" smtClean="0"/>
-              <a:t>[</a:t>
-            </a:r>
-            <a:r>
-              <a:rPr lang="en-US" sz="1600" dirty="0"/>
-              <a:t>VECTO-357] Updated GUI to not show ECO-Roll option to avoid confusion</a:t>
-            </a:r>
-          </a:p>
-          <a:p>
-            <a:r>
-              <a:rPr lang="en-US" sz="1600" dirty="0" smtClean="0"/>
-              <a:t>Fixed </a:t>
-            </a:r>
-            <a:r>
-              <a:rPr lang="en-US" sz="1600" dirty="0"/>
-              <a:t>numerous bugs in AT-</a:t>
-            </a:r>
-            <a:r>
-              <a:rPr lang="en-US" sz="1600" dirty="0" err="1"/>
-              <a:t>ShiftStrategy</a:t>
-            </a:r>
-            <a:r>
-              <a:rPr lang="en-US" sz="1600" dirty="0"/>
-              <a:t> regarding the Torque Converter</a:t>
-            </a:r>
-          </a:p>
-          <a:p>
-            <a:r>
-              <a:rPr lang="en-US" sz="1600" dirty="0" smtClean="0"/>
-              <a:t>Fixed </a:t>
-            </a:r>
-            <a:r>
-              <a:rPr lang="en-US" sz="1600" dirty="0"/>
-              <a:t>numerous bugs in </a:t>
-            </a:r>
-            <a:r>
-              <a:rPr lang="en-US" sz="1600" dirty="0" err="1"/>
-              <a:t>MeasuredSpeed</a:t>
-            </a:r>
-            <a:r>
-              <a:rPr lang="en-US" sz="1600" dirty="0"/>
-              <a:t> Mode (and </a:t>
-            </a:r>
-            <a:r>
-              <a:rPr lang="en-US" sz="1600" dirty="0" err="1"/>
-              <a:t>MeasuredSpeed</a:t>
-            </a:r>
-            <a:r>
-              <a:rPr lang="en-US" sz="1600" dirty="0"/>
-              <a:t> with Gear) in connection with AT-Gearbox and </a:t>
-            </a:r>
-            <a:r>
-              <a:rPr lang="en-US" sz="1600" dirty="0" err="1"/>
-              <a:t>TorqueConverter</a:t>
-            </a:r>
-            <a:endParaRPr lang="en-US" sz="1600" dirty="0"/>
-          </a:p>
-          <a:p>
-            <a:r>
-              <a:rPr lang="en-US" sz="1600" dirty="0" smtClean="0"/>
-              <a:t>Fixed </a:t>
-            </a:r>
-            <a:r>
-              <a:rPr lang="en-US" sz="1600" dirty="0"/>
-              <a:t>a bug when PTO-Cycle was missing</a:t>
-            </a:r>
-          </a:p>
-          <a:p>
-            <a:r>
-              <a:rPr lang="en-US" sz="1600" dirty="0" smtClean="0"/>
-              <a:t>Corrected </a:t>
-            </a:r>
-            <a:r>
-              <a:rPr lang="en-US" sz="1600" dirty="0"/>
-              <a:t>axle loss maps for Generic Vehicles in Declaration Mode to match technical annex</a:t>
-            </a:r>
-          </a:p>
-          <a:p>
-            <a:r>
-              <a:rPr lang="en-US" sz="1600" dirty="0" smtClean="0"/>
-              <a:t>Corrected </a:t>
-            </a:r>
-            <a:r>
-              <a:rPr lang="en-US" sz="1600" dirty="0" err="1"/>
-              <a:t>SumFile</a:t>
-            </a:r>
-            <a:r>
-              <a:rPr lang="en-US" sz="1600" dirty="0"/>
-              <a:t> Cruise Time Share. </a:t>
-            </a:r>
-            <a:r>
-              <a:rPr lang="en-US" sz="1600" dirty="0" smtClean="0"/>
-              <a:t>Added </a:t>
-            </a:r>
-            <a:r>
-              <a:rPr lang="en-US" sz="1600" dirty="0"/>
-              <a:t>that timeshares must add up to 100%</a:t>
+              <a:rPr lang="en-US" sz="1400" b="1" dirty="0" smtClean="0"/>
+              <a:t>Improvements:</a:t>
+            </a:r>
+            <a:endParaRPr lang="en-US" sz="1400" b="1" dirty="0" smtClean="0"/>
+          </a:p>
+          <a:p>
+            <a:r>
+              <a:rPr lang="en-US" sz="1400" dirty="0" smtClean="0"/>
+              <a:t>[VECTO-390, VECTO-400] Adapt engine speed to estimated engine speed after gear shift during traction interruption (double clutching)</a:t>
+            </a:r>
+          </a:p>
+          <a:p>
+            <a:r>
+              <a:rPr lang="en-US" sz="1400" dirty="0"/>
+              <a:t>[VECTO-396, VECTO-388] Add shift losses for AT power shifts</a:t>
+            </a:r>
+          </a:p>
+          <a:p>
+            <a:r>
+              <a:rPr lang="en-US" sz="1400" dirty="0"/>
+              <a:t>[VECTO-389] new gear shift rules for AT gearboxes</a:t>
+            </a:r>
+          </a:p>
+          <a:p>
+            <a:r>
+              <a:rPr lang="en-US" sz="1400" dirty="0"/>
+              <a:t>[VECTO-387] added max input speed for torque converter</a:t>
+            </a:r>
+          </a:p>
+          <a:p>
+            <a:r>
+              <a:rPr lang="en-US" sz="1400" dirty="0"/>
+              <a:t>[VECTO-385] Automatically add generic torque converter data for </a:t>
+            </a:r>
+            <a:r>
+              <a:rPr lang="en-US" sz="1400" dirty="0" smtClean="0"/>
+              <a:t>drag</a:t>
+            </a:r>
+          </a:p>
+          <a:p>
+            <a:r>
+              <a:rPr lang="en-US" sz="1400" dirty="0" smtClean="0"/>
+              <a:t>[VECTO-399] Add missions and loadings for vehicle categories 11, 12, and 16 (declaration mode)</a:t>
+            </a:r>
+          </a:p>
+          <a:p>
+            <a:r>
+              <a:rPr lang="en-US" sz="1400" dirty="0"/>
+              <a:t>[VECTO-384] cleanup memory after simulation run</a:t>
+            </a:r>
+          </a:p>
+          <a:p>
+            <a:r>
+              <a:rPr lang="en-US" sz="1400" dirty="0" smtClean="0"/>
+              <a:t>[VECTO-394] new option for </a:t>
+            </a:r>
+            <a:r>
+              <a:rPr lang="en-US" sz="1400" dirty="0" err="1" smtClean="0"/>
+              <a:t>vectocmd</a:t>
+            </a:r>
+            <a:r>
+              <a:rPr lang="en-US" sz="1400" dirty="0" smtClean="0"/>
+              <a:t> to disable all output</a:t>
+            </a:r>
+          </a:p>
+          <a:p>
+            <a:r>
+              <a:rPr lang="en-US" sz="1400" dirty="0" smtClean="0"/>
+              <a:t>[VECTO-392] make the GUI scale depending on the Windows font size</a:t>
+            </a:r>
+          </a:p>
+          <a:p>
+            <a:r>
+              <a:rPr lang="en-US" sz="1400" dirty="0" smtClean="0"/>
+              <a:t>[VECTO-391] Gearbox output speed and output torque added to .</a:t>
+            </a:r>
+            <a:r>
+              <a:rPr lang="en-US" sz="1400" dirty="0" err="1" smtClean="0"/>
+              <a:t>vmod</a:t>
+            </a:r>
+            <a:r>
+              <a:rPr lang="en-US" sz="1400" dirty="0" smtClean="0"/>
+              <a:t> files</a:t>
+            </a:r>
+          </a:p>
+          <a:p>
+            <a:r>
+              <a:rPr lang="en-US" sz="1400" dirty="0" smtClean="0"/>
+              <a:t>[VECTO-386] Gearbox window: disable input fields not applicable for the selected gearbox type</a:t>
             </a:r>
           </a:p>
           <a:p>
             <a:pPr marL="0" indent="0">
               <a:buNone/>
             </a:pPr>
-            <a:endParaRPr lang="en-US" sz="1600" dirty="0"/>
+            <a:r>
+              <a:rPr lang="en-US" sz="1400" b="1" dirty="0" err="1" smtClean="0"/>
+              <a:t>Bugfixes</a:t>
+            </a:r>
+            <a:r>
+              <a:rPr lang="en-US" sz="1400" b="1" dirty="0"/>
+              <a:t>:</a:t>
+            </a:r>
+          </a:p>
+          <a:p>
+            <a:r>
+              <a:rPr lang="en-US" sz="1400" dirty="0" smtClean="0"/>
+              <a:t>[VECTO-401] Computation of n_95h etc. fails if engine’s max torque is constant 0 </a:t>
+            </a:r>
+          </a:p>
+          <a:p>
+            <a:r>
+              <a:rPr lang="en-US" sz="1400" dirty="0" smtClean="0"/>
+              <a:t>Lookup of </a:t>
+            </a:r>
+            <a:r>
+              <a:rPr lang="en-US" sz="1400" dirty="0" err="1" smtClean="0"/>
+              <a:t>Airdrag</a:t>
+            </a:r>
+            <a:r>
+              <a:rPr lang="en-US" sz="1400" dirty="0" smtClean="0"/>
+              <a:t> parameters in declaration mode</a:t>
+            </a:r>
+          </a:p>
+          <a:p>
+            <a:r>
+              <a:rPr lang="en-US" sz="1400" dirty="0" smtClean="0"/>
+              <a:t>[VECTO-378] Improved file-handling in AAUX module</a:t>
+            </a:r>
+            <a:endParaRPr lang="en-US" sz="1400" dirty="0"/>
           </a:p>
         </p:txBody>
       </p:sp>
     </p:spTree>
     <p:extLst>
       <p:ext uri="{BB962C8B-B14F-4D97-AF65-F5344CB8AC3E}">
-        <p14:creationId xmlns:p14="http://schemas.microsoft.com/office/powerpoint/2010/main" val="2617015194"/>
+        <p14:creationId xmlns:p14="http://schemas.microsoft.com/office/powerpoint/2010/main" val="3490509634"/>
       </p:ext>
     </p:extLst>
   </p:cSld>
   <p:clrMapOvr>
     <a:masterClrMapping/>
   </p:clrMapOvr>
+  <p:timing>
+    <p:tnLst>
+      <p:par>
+        <p:cTn id="1" dur="indefinite" restart="never" nodeType="tmRoot"/>
+      </p:par>
+    </p:tnLst>
+  </p:timing>
 </p:sld>
 </file>
 
@@ -7257,6 +7321,132 @@
           <a:p>
             <a:r>
               <a:rPr lang="en-US" dirty="0" smtClean="0"/>
+              <a:t>.</a:t>
+            </a:r>
+            <a:r>
+              <a:rPr lang="en-US" dirty="0" err="1" smtClean="0"/>
+              <a:t>vmod</a:t>
+            </a:r>
+            <a:r>
+              <a:rPr lang="en-US" dirty="0" smtClean="0"/>
+              <a:t> File Update</a:t>
+            </a:r>
+            <a:endParaRPr lang="en-US" dirty="0"/>
+          </a:p>
+        </p:txBody>
+      </p:sp>
+      <p:sp>
+        <p:nvSpPr>
+          <p:cNvPr id="3" name="Inhaltsplatzhalter 2"/>
+          <p:cNvSpPr>
+            <a:spLocks noGrp="1"/>
+          </p:cNvSpPr>
+          <p:nvPr>
+            <p:ph idx="1"/>
+          </p:nvPr>
+        </p:nvSpPr>
+        <p:spPr/>
+        <p:txBody>
+          <a:bodyPr/>
+          <a:lstStyle/>
+          <a:p>
+            <a:r>
+              <a:rPr lang="en-US" dirty="0"/>
+              <a:t>In </a:t>
+            </a:r>
+            <a:r>
+              <a:rPr lang="en-US" dirty="0" err="1"/>
+              <a:t>Vecto</a:t>
+            </a:r>
+            <a:r>
+              <a:rPr lang="en-US" dirty="0"/>
+              <a:t> 3.0.2 the structure of the modal data output has been revised and re-structured. </a:t>
+            </a:r>
+            <a:r>
+              <a:rPr lang="en-US" dirty="0" err="1"/>
+              <a:t>Basicaly</a:t>
+            </a:r>
+            <a:r>
+              <a:rPr lang="en-US" dirty="0"/>
+              <a:t> for every powertrain component the .</a:t>
+            </a:r>
+            <a:r>
+              <a:rPr lang="en-US" dirty="0" err="1"/>
+              <a:t>vmod</a:t>
+            </a:r>
+            <a:r>
+              <a:rPr lang="en-US" dirty="0"/>
+              <a:t> file contains the power at the input shaft and the individual power losses for every component. For the engine the power, torque and engine speed at the output shaft is given along with the internal power and torque used for computing the fuel consumption</a:t>
+            </a:r>
+            <a:r>
+              <a:rPr lang="en-US" dirty="0" smtClean="0"/>
+              <a:t>.</a:t>
+            </a:r>
+          </a:p>
+          <a:p>
+            <a:r>
+              <a:rPr lang="en-US" dirty="0" smtClean="0"/>
+              <a:t>For details see the user manual: Input and Output / Modal Results (.</a:t>
+            </a:r>
+            <a:r>
+              <a:rPr lang="en-US" dirty="0" err="1" smtClean="0"/>
+              <a:t>vmod</a:t>
+            </a:r>
+            <a:r>
+              <a:rPr lang="en-US" dirty="0" smtClean="0"/>
+              <a:t>)</a:t>
+            </a:r>
+            <a:endParaRPr lang="en-US" dirty="0"/>
+          </a:p>
+        </p:txBody>
+      </p:sp>
+    </p:spTree>
+    <p:extLst>
+      <p:ext uri="{BB962C8B-B14F-4D97-AF65-F5344CB8AC3E}">
+        <p14:creationId xmlns:p14="http://schemas.microsoft.com/office/powerpoint/2010/main" val="3869754132"/>
+      </p:ext>
+    </p:extLst>
+  </p:cSld>
+  <p:clrMapOvr>
+    <a:masterClrMapping/>
+  </p:clrMapOvr>
+</p:sld>
+</file>
+
+<file path=ppt/slides/slide21.xml><?xml version="1.0" encoding="utf-8"?>
+<p:sld xmlns:a="http://schemas.openxmlformats.org/drawingml/2006/main" xmlns:r="http://schemas.openxmlformats.org/officeDocument/2006/relationships" xmlns:p="http://schemas.openxmlformats.org/presentationml/2006/main">
+  <p:cSld>
+    <p:spTree>
+      <p:nvGrpSpPr>
+        <p:cNvPr id="1" name=""/>
+        <p:cNvGrpSpPr/>
+        <p:nvPr/>
+      </p:nvGrpSpPr>
+      <p:grpSpPr>
+        <a:xfrm>
+          <a:off x="0" y="0"/>
+          <a:ext cx="0" cy="0"/>
+          <a:chOff x="0" y="0"/>
+          <a:chExt cx="0" cy="0"/>
+        </a:xfrm>
+      </p:grpSpPr>
+      <p:sp>
+        <p:nvSpPr>
+          <p:cNvPr id="2" name="Titel 1"/>
+          <p:cNvSpPr>
+            <a:spLocks noGrp="1"/>
+          </p:cNvSpPr>
+          <p:nvPr>
+            <p:ph type="title"/>
+          </p:nvPr>
+        </p:nvSpPr>
+        <p:spPr/>
+        <p:txBody>
+          <a:bodyPr/>
+          <a:lstStyle/>
+          <a:p>
+            <a:r>
+              <a:rPr lang="en-US" dirty="0" smtClean="0"/>
               <a:t>Changelog 3.0.2</a:t>
             </a:r>
             <a:endParaRPr lang="en-US" dirty="0"/>
@@ -7682,6 +7872,301 @@
       </p:grpSpPr>
       <p:sp>
         <p:nvSpPr>
+          <p:cNvPr id="2" name="Titel 1"/>
+          <p:cNvSpPr>
+            <a:spLocks noGrp="1"/>
+          </p:cNvSpPr>
+          <p:nvPr>
+            <p:ph type="title"/>
+          </p:nvPr>
+        </p:nvSpPr>
+        <p:spPr>
+          <a:xfrm>
+            <a:off x="468315" y="476672"/>
+            <a:ext cx="8218487" cy="681038"/>
+          </a:xfrm>
+        </p:spPr>
+        <p:txBody>
+          <a:bodyPr/>
+          <a:lstStyle/>
+          <a:p>
+            <a:r>
+              <a:rPr lang="en-US" dirty="0" err="1"/>
+              <a:t>Vecto</a:t>
+            </a:r>
+            <a:r>
+              <a:rPr lang="en-US" dirty="0"/>
+              <a:t> </a:t>
+            </a:r>
+            <a:r>
+              <a:rPr lang="en-US" dirty="0" smtClean="0"/>
+              <a:t>3.1.0.683</a:t>
+            </a:r>
+            <a:r>
+              <a:rPr lang="en-US" dirty="0"/>
+              <a:t/>
+            </a:r>
+            <a:br>
+              <a:rPr lang="en-US" dirty="0"/>
+            </a:br>
+            <a:r>
+              <a:rPr lang="en-US" sz="1600" dirty="0"/>
+              <a:t>2016-11-14</a:t>
+            </a:r>
+          </a:p>
+        </p:txBody>
+      </p:sp>
+      <p:sp>
+        <p:nvSpPr>
+          <p:cNvPr id="3" name="Inhaltsplatzhalter 2"/>
+          <p:cNvSpPr>
+            <a:spLocks noGrp="1"/>
+          </p:cNvSpPr>
+          <p:nvPr>
+            <p:ph idx="1"/>
+          </p:nvPr>
+        </p:nvSpPr>
+        <p:spPr>
+          <a:xfrm>
+            <a:off x="323529" y="1196752"/>
+            <a:ext cx="8640960" cy="5184576"/>
+          </a:xfrm>
+        </p:spPr>
+        <p:txBody>
+          <a:bodyPr/>
+          <a:lstStyle/>
+          <a:p>
+            <a:pPr marL="0" indent="0">
+              <a:buNone/>
+            </a:pPr>
+            <a:r>
+              <a:rPr lang="en-US" sz="1600" b="1" dirty="0" err="1" smtClean="0"/>
+              <a:t>Bugfixes</a:t>
+            </a:r>
+            <a:r>
+              <a:rPr lang="en-US" sz="1600" b="1" dirty="0" smtClean="0"/>
+              <a:t>:</a:t>
+            </a:r>
+          </a:p>
+          <a:p>
+            <a:r>
+              <a:rPr lang="en-US" sz="1600" dirty="0" smtClean="0"/>
+              <a:t>[</a:t>
+            </a:r>
+            <a:r>
+              <a:rPr lang="en-US" sz="1600" dirty="0"/>
+              <a:t>VECTO-375] Fixed bug when braking during slope change from negative to positive values.</a:t>
+            </a:r>
+          </a:p>
+          <a:p>
+            <a:r>
+              <a:rPr lang="en-US" sz="1600" dirty="0" smtClean="0"/>
+              <a:t>[</a:t>
+            </a:r>
+            <a:r>
+              <a:rPr lang="en-US" sz="1600" dirty="0"/>
+              <a:t>VECTO-372] Added check for unusual acceleration/deceleration data which could lead to error when halting.</a:t>
+            </a:r>
+          </a:p>
+          <a:p>
+            <a:r>
+              <a:rPr lang="en-US" sz="1600" dirty="0" smtClean="0"/>
+              <a:t>[</a:t>
+            </a:r>
+            <a:r>
+              <a:rPr lang="en-US" sz="1600" dirty="0"/>
+              <a:t>VECTO-371] Added additional behavior to overcome such situations</a:t>
+            </a:r>
+          </a:p>
+          <a:p>
+            <a:r>
+              <a:rPr lang="en-US" sz="1600" dirty="0" smtClean="0"/>
+              <a:t>[</a:t>
+            </a:r>
+            <a:r>
+              <a:rPr lang="en-US" sz="1600" dirty="0"/>
+              <a:t>VECTO-370] Added additional behavior to overcome such situations</a:t>
+            </a:r>
+          </a:p>
+          <a:p>
+            <a:r>
+              <a:rPr lang="en-US" sz="1600" dirty="0" smtClean="0"/>
+              <a:t>[</a:t>
+            </a:r>
+            <a:r>
+              <a:rPr lang="en-US" sz="1600" dirty="0"/>
+              <a:t>VECTO-369] </a:t>
+            </a:r>
+            <a:r>
+              <a:rPr lang="en-US" sz="1600" dirty="0" err="1"/>
+              <a:t>CrosswindCorrection</a:t>
+            </a:r>
+            <a:r>
+              <a:rPr lang="en-US" sz="1600" dirty="0"/>
+              <a:t> is now saved and read again from JSON files</a:t>
+            </a:r>
+          </a:p>
+          <a:p>
+            <a:r>
+              <a:rPr lang="en-US" sz="1600" dirty="0" smtClean="0"/>
+              <a:t>[</a:t>
+            </a:r>
+            <a:r>
+              <a:rPr lang="en-US" sz="1600" dirty="0"/>
+              <a:t>VECTO-373] WHTC-Engineering correction factor now correctly read/write in JSON files</a:t>
+            </a:r>
+          </a:p>
+          <a:p>
+            <a:r>
+              <a:rPr lang="en-US" sz="1600" dirty="0" smtClean="0"/>
+              <a:t>[</a:t>
+            </a:r>
+            <a:r>
+              <a:rPr lang="en-US" sz="1600" dirty="0"/>
+              <a:t>VECTO-368] Fixed validation for specific cases when values are intentionally invalid.</a:t>
+            </a:r>
+          </a:p>
+          <a:p>
+            <a:r>
+              <a:rPr lang="en-US" sz="1600" dirty="0" smtClean="0"/>
+              <a:t>[</a:t>
+            </a:r>
+            <a:r>
+              <a:rPr lang="en-US" sz="1600" dirty="0"/>
+              <a:t>VECTO-357] Updated GUI to not show ECO-Roll option to avoid confusion</a:t>
+            </a:r>
+          </a:p>
+          <a:p>
+            <a:r>
+              <a:rPr lang="en-US" sz="1600" dirty="0" smtClean="0"/>
+              <a:t>Fixed </a:t>
+            </a:r>
+            <a:r>
+              <a:rPr lang="en-US" sz="1600" dirty="0"/>
+              <a:t>numerous bugs in AT-</a:t>
+            </a:r>
+            <a:r>
+              <a:rPr lang="en-US" sz="1600" dirty="0" err="1"/>
+              <a:t>ShiftStrategy</a:t>
+            </a:r>
+            <a:r>
+              <a:rPr lang="en-US" sz="1600" dirty="0"/>
+              <a:t> regarding the Torque Converter</a:t>
+            </a:r>
+          </a:p>
+          <a:p>
+            <a:r>
+              <a:rPr lang="en-US" sz="1600" dirty="0" smtClean="0"/>
+              <a:t>Fixed </a:t>
+            </a:r>
+            <a:r>
+              <a:rPr lang="en-US" sz="1600" dirty="0"/>
+              <a:t>numerous bugs in </a:t>
+            </a:r>
+            <a:r>
+              <a:rPr lang="en-US" sz="1600" dirty="0" err="1"/>
+              <a:t>MeasuredSpeed</a:t>
+            </a:r>
+            <a:r>
+              <a:rPr lang="en-US" sz="1600" dirty="0"/>
+              <a:t> Mode (and </a:t>
+            </a:r>
+            <a:r>
+              <a:rPr lang="en-US" sz="1600" dirty="0" err="1"/>
+              <a:t>MeasuredSpeed</a:t>
+            </a:r>
+            <a:r>
+              <a:rPr lang="en-US" sz="1600" dirty="0"/>
+              <a:t> with Gear) in connection with AT-Gearbox and </a:t>
+            </a:r>
+            <a:r>
+              <a:rPr lang="en-US" sz="1600" dirty="0" err="1"/>
+              <a:t>TorqueConverter</a:t>
+            </a:r>
+            <a:endParaRPr lang="en-US" sz="1600" dirty="0"/>
+          </a:p>
+          <a:p>
+            <a:r>
+              <a:rPr lang="en-US" sz="1600" dirty="0" smtClean="0"/>
+              <a:t>Fixed </a:t>
+            </a:r>
+            <a:r>
+              <a:rPr lang="en-US" sz="1600" dirty="0"/>
+              <a:t>a bug when PTO-Cycle was missing</a:t>
+            </a:r>
+          </a:p>
+          <a:p>
+            <a:r>
+              <a:rPr lang="en-US" sz="1600" dirty="0" smtClean="0"/>
+              <a:t>Corrected </a:t>
+            </a:r>
+            <a:r>
+              <a:rPr lang="en-US" sz="1600" dirty="0"/>
+              <a:t>axle loss maps for Generic Vehicles in Declaration Mode to match technical annex</a:t>
+            </a:r>
+          </a:p>
+          <a:p>
+            <a:r>
+              <a:rPr lang="en-US" sz="1600" dirty="0" smtClean="0"/>
+              <a:t>Corrected </a:t>
+            </a:r>
+            <a:r>
+              <a:rPr lang="en-US" sz="1600" dirty="0" err="1"/>
+              <a:t>SumFile</a:t>
+            </a:r>
+            <a:r>
+              <a:rPr lang="en-US" sz="1600" dirty="0"/>
+              <a:t> Cruise Time Share. </a:t>
+            </a:r>
+            <a:r>
+              <a:rPr lang="en-US" sz="1600" dirty="0" smtClean="0"/>
+              <a:t>Added </a:t>
+            </a:r>
+            <a:r>
+              <a:rPr lang="en-US" sz="1600" dirty="0"/>
+              <a:t>that timeshares must add up to 100%</a:t>
+            </a:r>
+          </a:p>
+          <a:p>
+            <a:pPr marL="0" indent="0">
+              <a:buNone/>
+            </a:pPr>
+            <a:endParaRPr lang="en-US" sz="1600" dirty="0"/>
+          </a:p>
+        </p:txBody>
+      </p:sp>
+    </p:spTree>
+    <p:extLst>
+      <p:ext uri="{BB962C8B-B14F-4D97-AF65-F5344CB8AC3E}">
+        <p14:creationId xmlns:p14="http://schemas.microsoft.com/office/powerpoint/2010/main" val="2617015194"/>
+      </p:ext>
+    </p:extLst>
+  </p:cSld>
+  <p:clrMapOvr>
+    <a:masterClrMapping/>
+  </p:clrMapOvr>
+</p:sld>
+</file>
+
+<file path=ppt/slides/slide4.xml><?xml version="1.0" encoding="utf-8"?>
+<p:sld xmlns:a="http://schemas.openxmlformats.org/drawingml/2006/main" xmlns:r="http://schemas.openxmlformats.org/officeDocument/2006/relationships" xmlns:p="http://schemas.openxmlformats.org/presentationml/2006/main">
+  <p:cSld>
+    <p:spTree>
+      <p:nvGrpSpPr>
+        <p:cNvPr id="1" name=""/>
+        <p:cNvGrpSpPr/>
+        <p:nvPr/>
+      </p:nvGrpSpPr>
+      <p:grpSpPr>
+        <a:xfrm>
+          <a:off x="0" y="0"/>
+          <a:ext cx="0" cy="0"/>
+          <a:chOff x="0" y="0"/>
+          <a:chExt cx="0" cy="0"/>
+        </a:xfrm>
+      </p:grpSpPr>
+      <p:sp>
+        <p:nvSpPr>
           <p:cNvPr id="3" name="Inhaltsplatzhalter 2"/>
           <p:cNvSpPr>
             <a:spLocks noGrp="1"/>
@@ -7693,7 +8178,7 @@
         <p:spPr>
           <a:xfrm>
             <a:off x="468315" y="1412776"/>
-            <a:ext cx="8496173" cy="5760640"/>
+            <a:ext cx="8496173" cy="4968552"/>
           </a:xfrm>
         </p:spPr>
         <p:txBody>
@@ -8072,281 +8557,6 @@
 </p:sld>
 </file>
 
-<file path=ppt/slides/slide4.xml><?xml version="1.0" encoding="utf-8"?>
-<p:sld xmlns:a="http://schemas.openxmlformats.org/drawingml/2006/main" xmlns:r="http://schemas.openxmlformats.org/officeDocument/2006/relationships" xmlns:p="http://schemas.openxmlformats.org/presentationml/2006/main">
-  <p:cSld>
-    <p:spTree>
-      <p:nvGrpSpPr>
-        <p:cNvPr id="1" name=""/>
-        <p:cNvGrpSpPr/>
-        <p:nvPr/>
-      </p:nvGrpSpPr>
-      <p:grpSpPr>
-        <a:xfrm>
-          <a:off x="0" y="0"/>
-          <a:ext cx="0" cy="0"/>
-          <a:chOff x="0" y="0"/>
-          <a:chExt cx="0" cy="0"/>
-        </a:xfrm>
-      </p:grpSpPr>
-      <p:sp>
-        <p:nvSpPr>
-          <p:cNvPr id="2" name="Titel 1"/>
-          <p:cNvSpPr>
-            <a:spLocks noGrp="1"/>
-          </p:cNvSpPr>
-          <p:nvPr>
-            <p:ph type="title"/>
-          </p:nvPr>
-        </p:nvSpPr>
-        <p:spPr/>
-        <p:txBody>
-          <a:bodyPr/>
-          <a:lstStyle/>
-          <a:p>
-            <a:r>
-              <a:rPr lang="en-US" dirty="0" err="1"/>
-              <a:t>Vecto</a:t>
-            </a:r>
-            <a:r>
-              <a:rPr lang="en-US" dirty="0"/>
-              <a:t> </a:t>
-            </a:r>
-            <a:r>
-              <a:rPr lang="en-US" dirty="0" smtClean="0"/>
-              <a:t>3.1.0.662</a:t>
-            </a:r>
-            <a:br>
-              <a:rPr lang="en-US" dirty="0" smtClean="0"/>
-            </a:br>
-            <a:r>
-              <a:rPr lang="en-US" sz="1600" dirty="0" smtClean="0"/>
-              <a:t>2016-10-24</a:t>
-            </a:r>
-            <a:endParaRPr lang="en-US" sz="1600" dirty="0"/>
-          </a:p>
-        </p:txBody>
-      </p:sp>
-      <p:sp>
-        <p:nvSpPr>
-          <p:cNvPr id="3" name="Inhaltsplatzhalter 2"/>
-          <p:cNvSpPr>
-            <a:spLocks noGrp="1"/>
-          </p:cNvSpPr>
-          <p:nvPr>
-            <p:ph idx="1"/>
-          </p:nvPr>
-        </p:nvSpPr>
-        <p:spPr>
-          <a:xfrm>
-            <a:off x="468315" y="1412776"/>
-            <a:ext cx="8496173" cy="5760640"/>
-          </a:xfrm>
-        </p:spPr>
-        <p:txBody>
-          <a:bodyPr/>
-          <a:lstStyle/>
-          <a:p>
-            <a:r>
-              <a:rPr lang="en-US" sz="1800" b="1" dirty="0" err="1" smtClean="0"/>
-              <a:t>Bugfixes</a:t>
-            </a:r>
-            <a:r>
-              <a:rPr lang="en-US" sz="1800" dirty="0" smtClean="0"/>
-              <a:t>:</a:t>
-            </a:r>
-          </a:p>
-          <a:p>
-            <a:pPr lvl="1"/>
-            <a:r>
-              <a:rPr lang="en-US" sz="1600" dirty="0" smtClean="0"/>
-              <a:t>[</a:t>
-            </a:r>
-            <a:r>
-              <a:rPr lang="en-US" sz="1600" dirty="0"/>
-              <a:t>VECTO-360] Fixed error during startup of VECTO (loading of DLLs</a:t>
-            </a:r>
-            <a:r>
-              <a:rPr lang="en-US" sz="1600" dirty="0" smtClean="0"/>
-              <a:t>).</a:t>
-            </a:r>
-          </a:p>
-          <a:p>
-            <a:pPr lvl="1"/>
-            <a:r>
-              <a:rPr lang="en-US" sz="1600" dirty="0" smtClean="0"/>
-              <a:t>[</a:t>
-            </a:r>
-            <a:r>
-              <a:rPr lang="en-US" sz="1600" dirty="0"/>
-              <a:t>VECTO-358] Fixed errors during simulation where vehicle unintentionally was driving backwards. Fixed 1Hz-Filter for </a:t>
-            </a:r>
-            <a:r>
-              <a:rPr lang="en-US" sz="1600" dirty="0" err="1"/>
-              <a:t>ModFiles</a:t>
-            </a:r>
-            <a:r>
-              <a:rPr lang="en-US" sz="1600" dirty="0"/>
-              <a:t> (distance was wrong under certain circumstances, vehicle seemingly jumping back before halt</a:t>
-            </a:r>
-            <a:r>
-              <a:rPr lang="en-US" sz="1600" dirty="0" smtClean="0"/>
-              <a:t>)</a:t>
-            </a:r>
-          </a:p>
-          <a:p>
-            <a:pPr lvl="1"/>
-            <a:r>
-              <a:rPr lang="en-US" sz="1600" dirty="0" smtClean="0"/>
-              <a:t>[</a:t>
-            </a:r>
-            <a:r>
-              <a:rPr lang="en-US" sz="1600" dirty="0"/>
-              <a:t>VECTO-361] Fixed classification of vehicles with GVM of exactly </a:t>
-            </a:r>
-            <a:r>
-              <a:rPr lang="en-US" sz="1600" dirty="0" smtClean="0"/>
-              <a:t>7500kg</a:t>
-            </a:r>
-          </a:p>
-          <a:p>
-            <a:pPr lvl="1"/>
-            <a:r>
-              <a:rPr lang="en-US" sz="1600" dirty="0" smtClean="0"/>
-              <a:t>[</a:t>
-            </a:r>
-            <a:r>
-              <a:rPr lang="en-US" sz="1600" dirty="0"/>
-              <a:t>VECTO-364] Fixed an error in measured speed mode (run aborts</a:t>
-            </a:r>
-            <a:r>
-              <a:rPr lang="en-US" sz="1600" dirty="0" smtClean="0"/>
-              <a:t>).</a:t>
-            </a:r>
-          </a:p>
-          <a:p>
-            <a:pPr lvl="1"/>
-            <a:r>
-              <a:rPr lang="en-US" sz="1600" dirty="0" smtClean="0"/>
-              <a:t>[</a:t>
-            </a:r>
-            <a:r>
-              <a:rPr lang="en-US" sz="1600" dirty="0"/>
-              <a:t>VECTO-363] Compute shift polygons in declaration mode now uses correct boundary for full load </a:t>
-            </a:r>
-            <a:r>
-              <a:rPr lang="en-US" sz="1600" dirty="0" smtClean="0"/>
-              <a:t>margin.</a:t>
-            </a:r>
-          </a:p>
-          <a:p>
-            <a:pPr lvl="1"/>
-            <a:r>
-              <a:rPr lang="en-US" sz="1600" dirty="0" smtClean="0"/>
-              <a:t>[VECTO-365] Fixed </a:t>
-            </a:r>
-            <a:r>
-              <a:rPr lang="en-US" sz="1600" dirty="0"/>
-              <a:t>editing gears in declaration </a:t>
-            </a:r>
-            <a:r>
-              <a:rPr lang="en-US" sz="1600" dirty="0" smtClean="0"/>
-              <a:t>mode</a:t>
-            </a:r>
-          </a:p>
-          <a:p>
-            <a:r>
-              <a:rPr lang="en-US" sz="1800" b="1" dirty="0" smtClean="0"/>
-              <a:t>Improvements</a:t>
-            </a:r>
-            <a:r>
-              <a:rPr lang="en-US" sz="1800" dirty="0" smtClean="0"/>
-              <a:t>:</a:t>
-            </a:r>
-          </a:p>
-          <a:p>
-            <a:pPr lvl="1"/>
-            <a:r>
-              <a:rPr lang="en-US" sz="1600" dirty="0" smtClean="0"/>
-              <a:t>[</a:t>
-            </a:r>
-            <a:r>
-              <a:rPr lang="en-US" sz="1600" dirty="0"/>
-              <a:t>VECTO-355] User Manual updated (Screenshots, Descriptions, File Formats, </a:t>
-            </a:r>
-            <a:r>
-              <a:rPr lang="en-US" sz="1600" dirty="0" err="1"/>
-              <a:t>Vecto</a:t>
-            </a:r>
-            <a:r>
-              <a:rPr lang="en-US" sz="1600" dirty="0"/>
-              <a:t> V2 Comments removed</a:t>
-            </a:r>
-            <a:r>
-              <a:rPr lang="en-US" sz="1600" dirty="0" smtClean="0"/>
-              <a:t>).</a:t>
-            </a:r>
-          </a:p>
-          <a:p>
-            <a:pPr lvl="1"/>
-            <a:r>
-              <a:rPr lang="en-US" sz="1600" dirty="0" smtClean="0"/>
-              <a:t>[</a:t>
-            </a:r>
-            <a:r>
-              <a:rPr lang="en-US" sz="1600" dirty="0"/>
-              <a:t>VECTO-317] Declaration data for Wheel sizes </a:t>
-            </a:r>
-            <a:r>
-              <a:rPr lang="en-US" sz="1600" dirty="0" smtClean="0"/>
-              <a:t>updated</a:t>
-            </a:r>
-          </a:p>
-          <a:p>
-            <a:pPr lvl="1"/>
-            <a:r>
-              <a:rPr lang="en-US" sz="1600" dirty="0" smtClean="0"/>
-              <a:t>[VECTO-359</a:t>
-            </a:r>
-            <a:r>
-              <a:rPr lang="en-US" sz="1600" dirty="0"/>
-              <a:t>] Simplified code regarding PT1 behavior</a:t>
-            </a:r>
-            <a:r>
-              <a:rPr lang="en-US" sz="1600" dirty="0" smtClean="0"/>
-              <a:t>.</a:t>
-            </a:r>
-          </a:p>
-          <a:p>
-            <a:pPr lvl="1"/>
-            <a:r>
-              <a:rPr lang="en-US" sz="1600" dirty="0" smtClean="0"/>
-              <a:t>[</a:t>
-            </a:r>
-            <a:r>
-              <a:rPr lang="en-US" sz="1600" dirty="0"/>
-              <a:t>VECTO-323] PTO-Cycle may now be left empty when not used in driving </a:t>
-            </a:r>
-            <a:r>
-              <a:rPr lang="en-US" sz="1600" dirty="0" smtClean="0"/>
-              <a:t>cycle.</a:t>
-            </a:r>
-          </a:p>
-        </p:txBody>
-      </p:sp>
-    </p:spTree>
-    <p:extLst>
-      <p:ext uri="{BB962C8B-B14F-4D97-AF65-F5344CB8AC3E}">
-        <p14:creationId xmlns:p14="http://schemas.microsoft.com/office/powerpoint/2010/main" val="3892724049"/>
-      </p:ext>
-    </p:extLst>
-  </p:cSld>
-  <p:clrMapOvr>
-    <a:masterClrMapping/>
-  </p:clrMapOvr>
-</p:sld>
-</file>
-
 <file path=ppt/slides/slide5.xml><?xml version="1.0" encoding="utf-8"?>
 <p:sld xmlns:a="http://schemas.openxmlformats.org/drawingml/2006/main" xmlns:r="http://schemas.openxmlformats.org/officeDocument/2006/relationships" xmlns:p="http://schemas.openxmlformats.org/presentationml/2006/main">
   <p:cSld>
@@ -8389,14 +8599,14 @@
             </a:r>
             <a:r>
               <a:rPr lang="en-US" dirty="0" smtClean="0"/>
-              <a:t>3.1.0.652</a:t>
+              <a:t>3.1.0.662</a:t>
             </a:r>
             <a:br>
               <a:rPr lang="en-US" dirty="0" smtClean="0"/>
             </a:br>
             <a:r>
               <a:rPr lang="en-US" sz="1600" dirty="0" smtClean="0"/>
-              <a:t>2016-10-14</a:t>
+              <a:t>2016-10-24</a:t>
             </a:r>
             <a:endParaRPr lang="en-US" sz="1600" dirty="0"/>
           </a:p>
@@ -8415,7 +8625,7 @@
         <p:spPr>
           <a:xfrm>
             <a:off x="468315" y="1412776"/>
-            <a:ext cx="8496173" cy="4713387"/>
+            <a:ext cx="8496173" cy="4968552"/>
           </a:xfrm>
         </p:spPr>
         <p:txBody>
@@ -8423,125 +8633,196 @@
           <a:lstStyle/>
           <a:p>
             <a:r>
-              <a:rPr lang="en-US" dirty="0" smtClean="0"/>
-              <a:t>Main Updates</a:t>
+              <a:rPr lang="en-US" sz="1800" b="1" dirty="0" err="1" smtClean="0"/>
+              <a:t>Bugfixes</a:t>
+            </a:r>
+            <a:r>
+              <a:rPr lang="en-US" sz="1800" dirty="0" smtClean="0"/>
+              <a:t>:</a:t>
             </a:r>
           </a:p>
           <a:p>
             <a:pPr lvl="1"/>
             <a:r>
-              <a:rPr lang="en-US" dirty="0" smtClean="0"/>
-              <a:t>Removed VECTO Core 2.2</a:t>
+              <a:rPr lang="en-US" sz="1600" dirty="0" smtClean="0"/>
+              <a:t>[</a:t>
+            </a:r>
+            <a:r>
+              <a:rPr lang="en-US" sz="1600" dirty="0"/>
+              <a:t>VECTO-360] Fixed error during startup of VECTO (loading of DLLs</a:t>
+            </a:r>
+            <a:r>
+              <a:rPr lang="en-US" sz="1600" dirty="0" smtClean="0"/>
+              <a:t>).</a:t>
             </a:r>
           </a:p>
           <a:p>
             <a:pPr lvl="1"/>
             <a:r>
-              <a:rPr lang="en-US" dirty="0" smtClean="0"/>
-              <a:t>Refactoring of the User-Interface Backend: loading, saving files and validating user input uses </a:t>
-            </a:r>
-            <a:r>
-              <a:rPr lang="en-US" dirty="0" err="1" smtClean="0"/>
+              <a:rPr lang="en-US" sz="1600" dirty="0" smtClean="0"/>
+              <a:t>[</a:t>
+            </a:r>
+            <a:r>
+              <a:rPr lang="en-US" sz="1600" dirty="0"/>
+              <a:t>VECTO-358] Fixed errors during simulation where vehicle unintentionally was driving backwards. Fixed 1Hz-Filter for </a:t>
+            </a:r>
+            <a:r>
+              <a:rPr lang="en-US" sz="1600" dirty="0" err="1"/>
+              <a:t>ModFiles</a:t>
+            </a:r>
+            <a:r>
+              <a:rPr lang="en-US" sz="1600" dirty="0"/>
+              <a:t> (distance was wrong under certain circumstances, vehicle seemingly jumping back before halt</a:t>
+            </a:r>
+            <a:r>
+              <a:rPr lang="en-US" sz="1600" dirty="0" smtClean="0"/>
+              <a:t>)</a:t>
+            </a:r>
+          </a:p>
+          <a:p>
+            <a:pPr lvl="1"/>
+            <a:r>
+              <a:rPr lang="en-US" sz="1600" dirty="0" smtClean="0"/>
+              <a:t>[</a:t>
+            </a:r>
+            <a:r>
+              <a:rPr lang="en-US" sz="1600" dirty="0"/>
+              <a:t>VECTO-361] Fixed classification of vehicles with GVM of exactly </a:t>
+            </a:r>
+            <a:r>
+              <a:rPr lang="en-US" sz="1600" dirty="0" smtClean="0"/>
+              <a:t>7500kg</a:t>
+            </a:r>
+          </a:p>
+          <a:p>
+            <a:pPr lvl="1"/>
+            <a:r>
+              <a:rPr lang="en-US" sz="1600" dirty="0" smtClean="0"/>
+              <a:t>[</a:t>
+            </a:r>
+            <a:r>
+              <a:rPr lang="en-US" sz="1600" dirty="0"/>
+              <a:t>VECTO-364] Fixed an error in measured speed mode (run aborts</a:t>
+            </a:r>
+            <a:r>
+              <a:rPr lang="en-US" sz="1600" dirty="0" smtClean="0"/>
+              <a:t>).</a:t>
+            </a:r>
+          </a:p>
+          <a:p>
+            <a:pPr lvl="1"/>
+            <a:r>
+              <a:rPr lang="en-US" sz="1600" dirty="0" smtClean="0"/>
+              <a:t>[</a:t>
+            </a:r>
+            <a:r>
+              <a:rPr lang="en-US" sz="1600" dirty="0"/>
+              <a:t>VECTO-363] Compute shift polygons in declaration mode now uses correct boundary for full load </a:t>
+            </a:r>
+            <a:r>
+              <a:rPr lang="en-US" sz="1600" dirty="0" smtClean="0"/>
+              <a:t>margin.</a:t>
+            </a:r>
+          </a:p>
+          <a:p>
+            <a:pPr lvl="1"/>
+            <a:r>
+              <a:rPr lang="en-US" sz="1600" dirty="0" smtClean="0"/>
+              <a:t>[VECTO-365] Fixed </a:t>
+            </a:r>
+            <a:r>
+              <a:rPr lang="en-US" sz="1600" dirty="0"/>
+              <a:t>editing gears in declaration </a:t>
+            </a:r>
+            <a:r>
+              <a:rPr lang="en-US" sz="1600" dirty="0" smtClean="0"/>
+              <a:t>mode</a:t>
+            </a:r>
+          </a:p>
+          <a:p>
+            <a:r>
+              <a:rPr lang="en-US" sz="1800" b="1" dirty="0" smtClean="0"/>
+              <a:t>Improvements</a:t>
+            </a:r>
+            <a:r>
+              <a:rPr lang="en-US" sz="1800" dirty="0" smtClean="0"/>
+              <a:t>:</a:t>
+            </a:r>
+          </a:p>
+          <a:p>
+            <a:pPr lvl="1"/>
+            <a:r>
+              <a:rPr lang="en-US" sz="1600" dirty="0" smtClean="0"/>
+              <a:t>[</a:t>
+            </a:r>
+            <a:r>
+              <a:rPr lang="en-US" sz="1600" dirty="0"/>
+              <a:t>VECTO-355] User Manual updated (Screenshots, Descriptions, File Formats, </a:t>
+            </a:r>
+            <a:r>
+              <a:rPr lang="en-US" sz="1600" dirty="0" err="1"/>
               <a:t>Vecto</a:t>
             </a:r>
             <a:r>
-              <a:rPr lang="en-US" dirty="0" smtClean="0"/>
-              <a:t> 3 models</a:t>
+              <a:rPr lang="en-US" sz="1600" dirty="0"/>
+              <a:t> V2 Comments removed</a:t>
+            </a:r>
+            <a:r>
+              <a:rPr lang="en-US" sz="1600" dirty="0" smtClean="0"/>
+              <a:t>).</a:t>
             </a:r>
           </a:p>
           <a:p>
             <a:pPr lvl="1"/>
             <a:r>
-              <a:rPr lang="en-US" dirty="0" smtClean="0"/>
-              <a:t>AT-Gearbox Model: differentiate between AT gearbox with serial torque converter and AT gearbox using </a:t>
-            </a:r>
-            <a:r>
-              <a:rPr lang="en-US" dirty="0" err="1" smtClean="0"/>
-              <a:t>powersplit</a:t>
-            </a:r>
-            <a:endParaRPr lang="en-US" dirty="0" smtClean="0"/>
+              <a:rPr lang="en-US" sz="1600" dirty="0" smtClean="0"/>
+              <a:t>[</a:t>
+            </a:r>
+            <a:r>
+              <a:rPr lang="en-US" sz="1600" dirty="0"/>
+              <a:t>VECTO-317] Declaration data for Wheel sizes </a:t>
+            </a:r>
+            <a:r>
+              <a:rPr lang="en-US" sz="1600" dirty="0" smtClean="0"/>
+              <a:t>updated</a:t>
+            </a:r>
           </a:p>
           <a:p>
             <a:pPr lvl="1"/>
             <a:r>
-              <a:rPr lang="en-US" dirty="0" smtClean="0"/>
-              <a:t>Numbering of gears with AT gearbox corresponds to mechanical gears, new column </a:t>
-            </a:r>
-            <a:r>
-              <a:rPr lang="en-US" dirty="0" err="1" smtClean="0"/>
-              <a:t>TC_locked</a:t>
-            </a:r>
-            <a:r>
-              <a:rPr lang="en-US" dirty="0" smtClean="0"/>
-              <a:t> in .</a:t>
-            </a:r>
-            <a:r>
-              <a:rPr lang="en-US" dirty="0" err="1" smtClean="0"/>
-              <a:t>vmod</a:t>
-            </a:r>
-            <a:r>
-              <a:rPr lang="en-US" dirty="0" smtClean="0"/>
-              <a:t> file to indicate if torque converter is active</a:t>
+              <a:rPr lang="en-US" sz="1600" dirty="0" smtClean="0"/>
+              <a:t>[VECTO-359</a:t>
+            </a:r>
+            <a:r>
+              <a:rPr lang="en-US" sz="1600" dirty="0"/>
+              <a:t>] Simplified code regarding PT1 behavior</a:t>
+            </a:r>
+            <a:r>
+              <a:rPr lang="en-US" sz="1600" dirty="0" smtClean="0"/>
+              <a:t>.</a:t>
             </a:r>
           </a:p>
           <a:p>
             <a:pPr lvl="1"/>
             <a:r>
-              <a:rPr lang="en-US" dirty="0" smtClean="0"/>
-              <a:t>Torque converter gear no longer allowed in input (added by </a:t>
-            </a:r>
-            <a:r>
-              <a:rPr lang="en-US" dirty="0" err="1" smtClean="0"/>
-              <a:t>Vecto</a:t>
-            </a:r>
-            <a:r>
-              <a:rPr lang="en-US" dirty="0" smtClean="0"/>
-              <a:t> depending on the AT model)</a:t>
-            </a:r>
-          </a:p>
-          <a:p>
-            <a:pPr lvl="1"/>
-            <a:r>
-              <a:rPr lang="en-US" dirty="0" smtClean="0"/>
-              <a:t>New implementation of torque converter model (analytic solutions)</a:t>
-            </a:r>
-          </a:p>
-          <a:p>
-            <a:pPr lvl="1"/>
-            <a:r>
-              <a:rPr lang="en-US" dirty="0" smtClean="0"/>
-              <a:t>Added PTO option for municipal utility vehicles: PTO idle losses, separate PTO cycle during standstill</a:t>
-            </a:r>
-          </a:p>
-          <a:p>
-            <a:pPr lvl="1"/>
-            <a:r>
-              <a:rPr lang="en-US" dirty="0" smtClean="0"/>
-              <a:t>Added </a:t>
-            </a:r>
-            <a:r>
-              <a:rPr lang="en-US" dirty="0" err="1" smtClean="0"/>
-              <a:t>Angledrive</a:t>
-            </a:r>
-            <a:r>
-              <a:rPr lang="en-US" dirty="0" smtClean="0"/>
-              <a:t> Component</a:t>
-            </a:r>
-          </a:p>
-          <a:p>
-            <a:pPr lvl="1"/>
-            <a:r>
-              <a:rPr lang="en-US" dirty="0" smtClean="0"/>
-              <a:t>Option for constant Auxiliary Power Demand in Job-File</a:t>
-            </a:r>
-            <a:endParaRPr lang="en-US" dirty="0"/>
+              <a:rPr lang="en-US" sz="1600" dirty="0" smtClean="0"/>
+              <a:t>[</a:t>
+            </a:r>
+            <a:r>
+              <a:rPr lang="en-US" sz="1600" dirty="0"/>
+              <a:t>VECTO-323] PTO-Cycle may now be left empty when not used in driving </a:t>
+            </a:r>
+            <a:r>
+              <a:rPr lang="en-US" sz="1600" dirty="0" smtClean="0"/>
+              <a:t>cycle.</a:t>
+            </a:r>
           </a:p>
         </p:txBody>
       </p:sp>
     </p:spTree>
     <p:extLst>
       <p:ext uri="{BB962C8B-B14F-4D97-AF65-F5344CB8AC3E}">
-        <p14:creationId xmlns:p14="http://schemas.microsoft.com/office/powerpoint/2010/main" val="3595445446"/>
+        <p14:creationId xmlns:p14="http://schemas.microsoft.com/office/powerpoint/2010/main" val="3892724049"/>
       </p:ext>
     </p:extLst>
   </p:cSld>
@@ -8599,9 +8880,10 @@
               <a:rPr lang="en-US" dirty="0" smtClean="0"/>
             </a:br>
             <a:r>
-              <a:rPr lang="en-US" sz="1600" dirty="0"/>
+              <a:rPr lang="en-US" sz="1600" dirty="0" smtClean="0"/>
               <a:t>2016-10-14</a:t>
             </a:r>
+            <a:endParaRPr lang="en-US" sz="1600" dirty="0"/>
           </a:p>
         </p:txBody>
       </p:sp>
@@ -8617,8 +8899,8 @@
         </p:nvSpPr>
         <p:spPr>
           <a:xfrm>
-            <a:off x="468315" y="1268760"/>
-            <a:ext cx="8496173" cy="4857403"/>
+            <a:off x="468315" y="1412776"/>
+            <a:ext cx="8496173" cy="4713387"/>
           </a:xfrm>
         </p:spPr>
         <p:txBody>
@@ -8627,132 +8909,124 @@
           <a:p>
             <a:r>
               <a:rPr lang="en-US" dirty="0" smtClean="0"/>
-              <a:t>Main Updates (cont.)</a:t>
+              <a:t>Main Updates</a:t>
             </a:r>
           </a:p>
           <a:p>
             <a:pPr lvl="1"/>
             <a:r>
               <a:rPr lang="en-US" dirty="0" smtClean="0"/>
-              <a:t>Normalize x/y values before triangulating Delaunay map (transmission loss-maps, fuel consumption loss map)</a:t>
+              <a:t>Removed VECTO Core 2.2</a:t>
             </a:r>
           </a:p>
           <a:p>
             <a:pPr lvl="1"/>
             <a:r>
               <a:rPr lang="en-US" dirty="0" smtClean="0"/>
-              <a:t>Additional fuel consumption correction factor in declaration mode: cold/hot balancing factor</a:t>
+              <a:t>Refactoring of the User-Interface Backend: loading, saving files and validating user input uses </a:t>
+            </a:r>
+            <a:r>
+              <a:rPr lang="en-US" dirty="0" err="1" smtClean="0"/>
+              <a:t>Vecto</a:t>
+            </a:r>
+            <a:r>
+              <a:rPr lang="en-US" dirty="0" smtClean="0"/>
+              <a:t> 3 models</a:t>
             </a:r>
           </a:p>
           <a:p>
             <a:pPr lvl="1"/>
             <a:r>
               <a:rPr lang="en-US" dirty="0" smtClean="0"/>
-              <a:t>Added fuel consumption correction factor (WHTC, Cold/Hot balancing, …) in engineering mode</a:t>
-            </a:r>
+              <a:t>AT-Gearbox Model: differentiate between AT gearbox with serial torque converter and AT gearbox using </a:t>
+            </a:r>
+            <a:r>
+              <a:rPr lang="en-US" dirty="0" err="1" smtClean="0"/>
+              <a:t>powersplit</a:t>
+            </a:r>
+            <a:endParaRPr lang="en-US" dirty="0" smtClean="0"/>
           </a:p>
           <a:p>
             <a:pPr lvl="1"/>
             <a:r>
               <a:rPr lang="en-US" dirty="0" smtClean="0"/>
-              <a:t>Update </a:t>
-            </a:r>
-            <a:r>
-              <a:rPr lang="en-US" dirty="0"/>
-              <a:t>auxiliaries power demand according to latest </a:t>
+              <a:t>Numbering of gears with AT gearbox corresponds to mechanical gears, new column </a:t>
             </a:r>
             <a:r>
               <a:rPr lang="en-US" dirty="0" err="1" smtClean="0"/>
-              <a:t>whitebook</a:t>
-            </a:r>
-            <a:endParaRPr lang="en-US" dirty="0" smtClean="0"/>
+              <a:t>TC_locked</a:t>
+            </a:r>
+            <a:r>
+              <a:rPr lang="en-US" dirty="0" smtClean="0"/>
+              <a:t> in .</a:t>
+            </a:r>
+            <a:r>
+              <a:rPr lang="en-US" dirty="0" err="1" smtClean="0"/>
+              <a:t>vmod</a:t>
+            </a:r>
+            <a:r>
+              <a:rPr lang="en-US" dirty="0" smtClean="0"/>
+              <a:t> file to indicate if torque converter is active</a:t>
+            </a:r>
           </a:p>
           <a:p>
             <a:pPr lvl="1"/>
             <a:r>
               <a:rPr lang="en-US" dirty="0" smtClean="0"/>
-              <a:t>Allow multiple steered axles</a:t>
+              <a:t>Torque converter gear no longer allowed in input (added by </a:t>
+            </a:r>
+            <a:r>
+              <a:rPr lang="en-US" dirty="0" err="1" smtClean="0"/>
+              <a:t>Vecto</a:t>
+            </a:r>
+            <a:r>
+              <a:rPr lang="en-US" dirty="0" smtClean="0"/>
+              <a:t> depending on the AT model)</a:t>
             </a:r>
           </a:p>
           <a:p>
             <a:pPr lvl="1"/>
             <a:r>
               <a:rPr lang="en-US" dirty="0" smtClean="0"/>
-              <a:t>Adapted engine idle controller (during declutch) – engine speed decreases faster</a:t>
+              <a:t>New implementation of torque converter model (analytic solutions)</a:t>
             </a:r>
           </a:p>
           <a:p>
             <a:pPr lvl="1"/>
             <a:r>
               <a:rPr lang="en-US" dirty="0" smtClean="0"/>
-              <a:t>SUM-File: split </a:t>
+              <a:t>Added PTO option for municipal utility vehicles: PTO idle losses, separate PTO cycle during standstill</a:t>
+            </a:r>
+          </a:p>
+          <a:p>
+            <a:pPr lvl="1"/>
+            <a:r>
+              <a:rPr lang="en-US" dirty="0" smtClean="0"/>
+              <a:t>Added </a:t>
             </a:r>
             <a:r>
               <a:rPr lang="en-US" dirty="0" err="1" smtClean="0"/>
-              <a:t>E_axl_gbx</a:t>
-            </a:r>
-            <a:r>
-              <a:rPr lang="en-US" dirty="0" smtClean="0"/>
-              <a:t> into two columns, </a:t>
-            </a:r>
-            <a:r>
-              <a:rPr lang="en-US" dirty="0" err="1" smtClean="0"/>
-              <a:t>E_axl</a:t>
-            </a:r>
-            <a:r>
-              <a:rPr lang="en-US" dirty="0" smtClean="0"/>
-              <a:t> and </a:t>
-            </a:r>
-            <a:r>
-              <a:rPr lang="en-US" dirty="0" err="1" smtClean="0"/>
-              <a:t>E_gbx</a:t>
-            </a:r>
-            <a:endParaRPr lang="en-US" dirty="0" smtClean="0"/>
+              <a:t>Angledrive</a:t>
+            </a:r>
+            <a:r>
+              <a:rPr lang="en-US" dirty="0" smtClean="0"/>
+              <a:t> Component</a:t>
+            </a:r>
           </a:p>
           <a:p>
             <a:pPr lvl="1"/>
             <a:r>
               <a:rPr lang="en-US" dirty="0" smtClean="0"/>
-              <a:t>New columns in mod-file: PTO, torque converter</a:t>
+              <a:t>Option for constant Auxiliary Power Demand in Job-File</a:t>
             </a:r>
             <a:endParaRPr lang="en-US" dirty="0"/>
-          </a:p>
-          <a:p>
-            <a:pPr lvl="1"/>
-            <a:r>
-              <a:rPr lang="en-US" dirty="0" smtClean="0"/>
-              <a:t>Removed full-load curve per gear, only single value </a:t>
-            </a:r>
-            <a:r>
-              <a:rPr lang="en-US" dirty="0" err="1" smtClean="0"/>
-              <a:t>MaxTorque</a:t>
-            </a:r>
-            <a:endParaRPr lang="en-US" dirty="0" smtClean="0"/>
-          </a:p>
-          <a:p>
-            <a:pPr lvl="1"/>
-            <a:r>
-              <a:rPr lang="en-US" dirty="0" smtClean="0"/>
-              <a:t>Removed rims (dynamic wheel radius depends on wheel type)</a:t>
-            </a:r>
-          </a:p>
-          <a:p>
-            <a:pPr lvl="1"/>
-            <a:r>
-              <a:rPr lang="en-US" dirty="0" smtClean="0"/>
-              <a:t>Fixes in AAUX module: open correct file-browser, save selected files</a:t>
-            </a:r>
-          </a:p>
-          <a:p>
-            <a:pPr lvl="1"/>
-            <a:endParaRPr lang="en-US" dirty="0" smtClean="0"/>
           </a:p>
         </p:txBody>
       </p:sp>
     </p:spTree>
     <p:extLst>
       <p:ext uri="{BB962C8B-B14F-4D97-AF65-F5344CB8AC3E}">
-        <p14:creationId xmlns:p14="http://schemas.microsoft.com/office/powerpoint/2010/main" val="3003112543"/>
+        <p14:creationId xmlns:p14="http://schemas.microsoft.com/office/powerpoint/2010/main" val="3595445446"/>
       </p:ext>
     </p:extLst>
   </p:cSld>
@@ -8789,321 +9063,187 @@
             <p:ph type="title"/>
           </p:nvPr>
         </p:nvSpPr>
+        <p:spPr/>
+        <p:txBody>
+          <a:bodyPr/>
+          <a:lstStyle/>
+          <a:p>
+            <a:r>
+              <a:rPr lang="en-US" dirty="0" err="1"/>
+              <a:t>Vecto</a:t>
+            </a:r>
+            <a:r>
+              <a:rPr lang="en-US" dirty="0"/>
+              <a:t> </a:t>
+            </a:r>
+            <a:r>
+              <a:rPr lang="en-US" dirty="0" smtClean="0"/>
+              <a:t>3.1.0.652</a:t>
+            </a:r>
+            <a:br>
+              <a:rPr lang="en-US" dirty="0" smtClean="0"/>
+            </a:br>
+            <a:r>
+              <a:rPr lang="en-US" sz="1600" dirty="0"/>
+              <a:t>2016-10-14</a:t>
+            </a:r>
+          </a:p>
+        </p:txBody>
+      </p:sp>
+      <p:sp>
+        <p:nvSpPr>
+          <p:cNvPr id="3" name="Inhaltsplatzhalter 2"/>
+          <p:cNvSpPr>
+            <a:spLocks noGrp="1"/>
+          </p:cNvSpPr>
+          <p:nvPr>
+            <p:ph idx="1"/>
+          </p:nvPr>
+        </p:nvSpPr>
         <p:spPr>
           <a:xfrm>
-            <a:off x="296532" y="476672"/>
-            <a:ext cx="8451932" cy="576064"/>
+            <a:off x="468315" y="1268760"/>
+            <a:ext cx="8496173" cy="4857403"/>
           </a:xfrm>
         </p:spPr>
         <p:txBody>
           <a:bodyPr/>
           <a:lstStyle/>
           <a:p>
-            <a:pPr algn="l"/>
-            <a:r>
-              <a:rPr lang="en-US" dirty="0" smtClean="0"/>
-              <a:t>Status quo VECTO software and open issues (Oct. 2016)</a:t>
+            <a:r>
+              <a:rPr lang="en-US" dirty="0" smtClean="0"/>
+              <a:t>Main Updates (cont.)</a:t>
+            </a:r>
+          </a:p>
+          <a:p>
+            <a:pPr lvl="1"/>
+            <a:r>
+              <a:rPr lang="en-US" dirty="0" smtClean="0"/>
+              <a:t>Normalize x/y values before triangulating Delaunay map (transmission loss-maps, fuel consumption loss map)</a:t>
+            </a:r>
+          </a:p>
+          <a:p>
+            <a:pPr lvl="1"/>
+            <a:r>
+              <a:rPr lang="en-US" dirty="0" smtClean="0"/>
+              <a:t>Additional fuel consumption correction factor in declaration mode: cold/hot balancing factor</a:t>
+            </a:r>
+          </a:p>
+          <a:p>
+            <a:pPr lvl="1"/>
+            <a:r>
+              <a:rPr lang="en-US" dirty="0" smtClean="0"/>
+              <a:t>Added fuel consumption correction factor (WHTC, Cold/Hot balancing, …) in engineering mode</a:t>
+            </a:r>
+          </a:p>
+          <a:p>
+            <a:pPr lvl="1"/>
+            <a:r>
+              <a:rPr lang="en-US" dirty="0" smtClean="0"/>
+              <a:t>Update </a:t>
+            </a:r>
+            <a:r>
+              <a:rPr lang="en-US" dirty="0"/>
+              <a:t>auxiliaries power demand according to latest </a:t>
+            </a:r>
+            <a:r>
+              <a:rPr lang="en-US" dirty="0" err="1" smtClean="0"/>
+              <a:t>whitebook</a:t>
+            </a:r>
+            <a:endParaRPr lang="en-US" dirty="0" smtClean="0"/>
+          </a:p>
+          <a:p>
+            <a:pPr lvl="1"/>
+            <a:r>
+              <a:rPr lang="en-US" dirty="0" smtClean="0"/>
+              <a:t>Allow multiple steered axles</a:t>
+            </a:r>
+          </a:p>
+          <a:p>
+            <a:pPr lvl="1"/>
+            <a:r>
+              <a:rPr lang="en-US" dirty="0" smtClean="0"/>
+              <a:t>Adapted engine idle controller (during declutch) – engine speed decreases faster</a:t>
+            </a:r>
+          </a:p>
+          <a:p>
+            <a:pPr lvl="1"/>
+            <a:r>
+              <a:rPr lang="en-US" dirty="0" smtClean="0"/>
+              <a:t>SUM-File: split </a:t>
+            </a:r>
+            <a:r>
+              <a:rPr lang="en-US" dirty="0" err="1" smtClean="0"/>
+              <a:t>E_axl_gbx</a:t>
+            </a:r>
+            <a:r>
+              <a:rPr lang="en-US" dirty="0" smtClean="0"/>
+              <a:t> into two columns, </a:t>
+            </a:r>
+            <a:r>
+              <a:rPr lang="en-US" dirty="0" err="1" smtClean="0"/>
+              <a:t>E_axl</a:t>
+            </a:r>
+            <a:r>
+              <a:rPr lang="en-US" dirty="0" smtClean="0"/>
+              <a:t> and </a:t>
+            </a:r>
+            <a:r>
+              <a:rPr lang="en-US" dirty="0" err="1" smtClean="0"/>
+              <a:t>E_gbx</a:t>
+            </a:r>
+            <a:endParaRPr lang="en-US" dirty="0" smtClean="0"/>
+          </a:p>
+          <a:p>
+            <a:pPr lvl="1"/>
+            <a:r>
+              <a:rPr lang="en-US" dirty="0" smtClean="0"/>
+              <a:t>New columns in mod-file: PTO, torque converter</a:t>
             </a:r>
             <a:endParaRPr lang="en-US" dirty="0"/>
           </a:p>
-        </p:txBody>
-      </p:sp>
-      <p:sp>
-        <p:nvSpPr>
-          <p:cNvPr id="3" name="Textfeld 2"/>
-          <p:cNvSpPr txBox="1"/>
-          <p:nvPr/>
-        </p:nvSpPr>
-        <p:spPr>
-          <a:xfrm>
-            <a:off x="323528" y="908720"/>
-            <a:ext cx="8496944" cy="400110"/>
-          </a:xfrm>
-          <a:prstGeom prst="rect">
-            <a:avLst/>
-          </a:prstGeom>
-          <a:noFill/>
-        </p:spPr>
-        <p:txBody>
-          <a:bodyPr wrap="square" rtlCol="0">
-            <a:spAutoFit/>
-          </a:bodyPr>
-          <a:lstStyle/>
-          <a:p>
-            <a:pPr algn="l"/>
-            <a:r>
-              <a:rPr lang="de-AT" sz="2000" dirty="0" smtClean="0"/>
-              <a:t>Next </a:t>
-            </a:r>
-            <a:r>
-              <a:rPr lang="de-AT" sz="2000" dirty="0" err="1" smtClean="0"/>
-              <a:t>issues</a:t>
-            </a:r>
-            <a:r>
-              <a:rPr lang="de-AT" sz="2000" dirty="0" smtClean="0"/>
-              <a:t> on </a:t>
-            </a:r>
-            <a:r>
-              <a:rPr lang="de-AT" sz="2000" dirty="0" err="1" smtClean="0"/>
-              <a:t>the</a:t>
-            </a:r>
-            <a:r>
-              <a:rPr lang="de-AT" sz="2000" dirty="0" smtClean="0"/>
-              <a:t> </a:t>
-            </a:r>
-            <a:r>
-              <a:rPr lang="de-AT" sz="2000" dirty="0" err="1" smtClean="0"/>
-              <a:t>to</a:t>
-            </a:r>
-            <a:r>
-              <a:rPr lang="de-AT" sz="2000" dirty="0" smtClean="0"/>
-              <a:t> do </a:t>
-            </a:r>
-            <a:r>
-              <a:rPr lang="de-AT" sz="2000" dirty="0" err="1" smtClean="0"/>
-              <a:t>list</a:t>
-            </a:r>
-            <a:endParaRPr lang="de-AT" sz="2000" dirty="0"/>
-          </a:p>
-        </p:txBody>
-      </p:sp>
-      <p:sp>
-        <p:nvSpPr>
-          <p:cNvPr id="7" name="Textfeld 6"/>
-          <p:cNvSpPr txBox="1"/>
-          <p:nvPr/>
-        </p:nvSpPr>
-        <p:spPr>
-          <a:xfrm>
-            <a:off x="539552" y="1484784"/>
-            <a:ext cx="8352928" cy="5093702"/>
-          </a:xfrm>
-          <a:prstGeom prst="rect">
-            <a:avLst/>
-          </a:prstGeom>
-          <a:noFill/>
-        </p:spPr>
-        <p:txBody>
-          <a:bodyPr wrap="square" rtlCol="0">
-            <a:spAutoFit/>
-          </a:bodyPr>
-          <a:lstStyle/>
-          <a:p>
-            <a:pPr marL="285750" indent="-285750" algn="l">
-              <a:buFont typeface="Arial" panose="020B0604020202020204" pitchFamily="34" charset="0"/>
-              <a:buChar char="•"/>
-            </a:pPr>
-            <a:r>
-              <a:rPr lang="en-GB" sz="1400" dirty="0" smtClean="0"/>
-              <a:t>Further development of the AT model</a:t>
-            </a:r>
-            <a:br>
-              <a:rPr lang="en-GB" sz="1400" dirty="0" smtClean="0"/>
-            </a:br>
-            <a:r>
-              <a:rPr lang="en-GB" sz="1400" b="0" dirty="0" smtClean="0"/>
-              <a:t>Consideration of losses during power shifts, update of gear shift logics</a:t>
-            </a:r>
-          </a:p>
-          <a:p>
-            <a:pPr marL="285750" indent="-285750" algn="l">
-              <a:buFont typeface="Arial" panose="020B0604020202020204" pitchFamily="34" charset="0"/>
-              <a:buChar char="•"/>
-            </a:pPr>
-            <a:r>
-              <a:rPr lang="en-GB" sz="1400" dirty="0" smtClean="0"/>
-              <a:t>Reimplementation </a:t>
-            </a:r>
-            <a:r>
-              <a:rPr lang="en-GB" sz="1400" dirty="0"/>
-              <a:t>of engine stop/start</a:t>
-            </a:r>
-          </a:p>
-          <a:p>
-            <a:pPr marL="285750" indent="-285750" algn="l">
-              <a:buFont typeface="Arial" panose="020B0604020202020204" pitchFamily="34" charset="0"/>
-              <a:buChar char="•"/>
-            </a:pPr>
-            <a:r>
-              <a:rPr lang="en-GB" sz="1400" dirty="0" smtClean="0"/>
-              <a:t>Declaration mode: implementation of EMS vehicle configurations</a:t>
-            </a:r>
-          </a:p>
-          <a:p>
-            <a:pPr marL="285750" indent="-285750" algn="l">
-              <a:buFont typeface="Arial" panose="020B0604020202020204" pitchFamily="34" charset="0"/>
-              <a:buChar char="•"/>
-            </a:pPr>
-            <a:endParaRPr lang="en-GB" sz="1400" dirty="0"/>
-          </a:p>
-          <a:p>
-            <a:pPr algn="l"/>
-            <a:r>
-              <a:rPr lang="en-GB" sz="1400" u="sng" dirty="0" smtClean="0"/>
-              <a:t>Items waiting for decision on methods and resources:</a:t>
-            </a:r>
-          </a:p>
-          <a:p>
-            <a:pPr marL="285750" indent="-285750" algn="l">
-              <a:buFont typeface="Arial" panose="020B0604020202020204" pitchFamily="34" charset="0"/>
-              <a:buChar char="•"/>
-            </a:pPr>
-            <a:r>
-              <a:rPr lang="en-GB" sz="1400" dirty="0" smtClean="0"/>
-              <a:t>Update engine data (according to update of Annex II)</a:t>
-            </a:r>
-            <a:br>
-              <a:rPr lang="en-GB" sz="1400" dirty="0" smtClean="0"/>
-            </a:br>
-            <a:r>
-              <a:rPr lang="en-GB" sz="1400" b="0" dirty="0" smtClean="0"/>
-              <a:t>Other fuels than diesel, “top torque” feature, correction factor for periodic </a:t>
-            </a:r>
-            <a:r>
-              <a:rPr lang="en-GB" sz="1400" b="0" dirty="0" err="1" smtClean="0"/>
-              <a:t>regerating</a:t>
-            </a:r>
-            <a:r>
-              <a:rPr lang="en-GB" sz="1400" b="0" dirty="0" smtClean="0"/>
-              <a:t> DPFs</a:t>
-            </a:r>
-          </a:p>
-          <a:p>
-            <a:pPr marL="285750" indent="-285750" algn="l">
-              <a:buFont typeface="Arial" panose="020B0604020202020204" pitchFamily="34" charset="0"/>
-              <a:buChar char="•"/>
-            </a:pPr>
-            <a:r>
-              <a:rPr lang="en-GB" sz="1400" dirty="0" smtClean="0"/>
-              <a:t>Declaration mode: </a:t>
-            </a:r>
-          </a:p>
-          <a:p>
-            <a:pPr marL="742950" lvl="1" indent="-285750" algn="l">
-              <a:spcBef>
-                <a:spcPts val="300"/>
-              </a:spcBef>
-              <a:buFont typeface="Arial" panose="020B0604020202020204" pitchFamily="34" charset="0"/>
-              <a:buChar char="•"/>
-            </a:pPr>
-            <a:r>
-              <a:rPr lang="en-GB" sz="1400" dirty="0"/>
-              <a:t>Revision of calculated vehicle </a:t>
-            </a:r>
-            <a:r>
-              <a:rPr lang="en-GB" sz="1400" dirty="0" smtClean="0"/>
-              <a:t>loads</a:t>
-            </a:r>
-          </a:p>
-          <a:p>
-            <a:pPr marL="742950" lvl="1" indent="-285750" algn="l">
-              <a:spcBef>
-                <a:spcPts val="300"/>
-              </a:spcBef>
-              <a:buFont typeface="Arial" panose="020B0604020202020204" pitchFamily="34" charset="0"/>
-              <a:buChar char="•"/>
-            </a:pPr>
-            <a:r>
-              <a:rPr lang="en-GB" sz="1400" dirty="0" smtClean="0"/>
-              <a:t>implementation of refuse cycle (instead “municipal”)</a:t>
-            </a:r>
-            <a:br>
-              <a:rPr lang="en-GB" sz="1400" dirty="0" smtClean="0"/>
-            </a:br>
-            <a:r>
-              <a:rPr lang="en-GB" sz="1400" b="0" dirty="0" smtClean="0"/>
-              <a:t>Update of driving cycle, consideration of generic PTO loads during collection part,</a:t>
-            </a:r>
-            <a:br>
-              <a:rPr lang="en-GB" sz="1400" b="0" dirty="0" smtClean="0"/>
-            </a:br>
-            <a:r>
-              <a:rPr lang="en-GB" sz="1400" b="0" dirty="0" smtClean="0"/>
-              <a:t>generic body weight and payload</a:t>
-            </a:r>
-          </a:p>
-          <a:p>
-            <a:pPr marL="742950" lvl="1" indent="-285750" algn="l">
-              <a:spcBef>
-                <a:spcPts val="300"/>
-              </a:spcBef>
-              <a:buFont typeface="Arial" panose="020B0604020202020204" pitchFamily="34" charset="0"/>
-              <a:buChar char="•"/>
-            </a:pPr>
-            <a:r>
-              <a:rPr lang="en-GB" sz="1400" dirty="0"/>
-              <a:t>VECTO output (approval </a:t>
-            </a:r>
-            <a:r>
-              <a:rPr lang="en-GB" sz="1400" dirty="0" smtClean="0"/>
-              <a:t>authorities</a:t>
-            </a:r>
-            <a:r>
-              <a:rPr lang="en-GB" sz="1400" dirty="0"/>
-              <a:t>, customer info, monitoring</a:t>
-            </a:r>
-            <a:r>
-              <a:rPr lang="en-GB" sz="1400" dirty="0" smtClean="0"/>
-              <a:t>)</a:t>
-            </a:r>
-          </a:p>
-          <a:p>
-            <a:pPr marL="742950" lvl="1" indent="-285750" algn="l">
-              <a:spcBef>
-                <a:spcPts val="300"/>
-              </a:spcBef>
-              <a:buFont typeface="Arial" panose="020B0604020202020204" pitchFamily="34" charset="0"/>
-              <a:buChar char="•"/>
-            </a:pPr>
-            <a:r>
-              <a:rPr lang="en-GB" sz="1400" dirty="0" smtClean="0"/>
-              <a:t>Buses</a:t>
-            </a:r>
-            <a:endParaRPr lang="en-GB" sz="1400" b="0" dirty="0" smtClean="0"/>
-          </a:p>
-          <a:p>
-            <a:pPr marL="285750" indent="-285750" algn="l">
-              <a:buFont typeface="Arial" panose="020B0604020202020204" pitchFamily="34" charset="0"/>
-              <a:buChar char="•"/>
-            </a:pPr>
-            <a:r>
-              <a:rPr lang="en-GB" sz="1400" dirty="0" smtClean="0"/>
-              <a:t>Predictive ADAS</a:t>
-            </a:r>
-          </a:p>
-          <a:p>
-            <a:pPr marL="285750" indent="-285750" algn="l">
-              <a:buFont typeface="Arial" panose="020B0604020202020204" pitchFamily="34" charset="0"/>
-              <a:buChar char="•"/>
-            </a:pPr>
-            <a:endParaRPr lang="en-GB" sz="1400" dirty="0" smtClean="0"/>
-          </a:p>
-          <a:p>
-            <a:pPr marL="285750" indent="-285750" algn="l">
-              <a:buFont typeface="Arial" panose="020B0604020202020204" pitchFamily="34" charset="0"/>
-              <a:buChar char="•"/>
-            </a:pPr>
-            <a:endParaRPr lang="en-GB" sz="1400" dirty="0"/>
+          <a:p>
+            <a:pPr lvl="1"/>
+            <a:r>
+              <a:rPr lang="en-US" dirty="0" smtClean="0"/>
+              <a:t>Removed full-load curve per gear, only single value </a:t>
+            </a:r>
+            <a:r>
+              <a:rPr lang="en-US" dirty="0" err="1" smtClean="0"/>
+              <a:t>MaxTorque</a:t>
+            </a:r>
+            <a:endParaRPr lang="en-US" dirty="0" smtClean="0"/>
+          </a:p>
+          <a:p>
+            <a:pPr lvl="1"/>
+            <a:r>
+              <a:rPr lang="en-US" dirty="0" smtClean="0"/>
+              <a:t>Removed rims (dynamic wheel radius depends on wheel type)</a:t>
+            </a:r>
+          </a:p>
+          <a:p>
+            <a:pPr lvl="1"/>
+            <a:r>
+              <a:rPr lang="en-US" dirty="0" smtClean="0"/>
+              <a:t>Fixes in AAUX module: open correct file-browser, save selected files</a:t>
+            </a:r>
+          </a:p>
+          <a:p>
+            <a:pPr lvl="1"/>
+            <a:endParaRPr lang="en-US" dirty="0" smtClean="0"/>
           </a:p>
         </p:txBody>
       </p:sp>
     </p:spTree>
     <p:extLst>
       <p:ext uri="{BB962C8B-B14F-4D97-AF65-F5344CB8AC3E}">
-        <p14:creationId xmlns:p14="http://schemas.microsoft.com/office/powerpoint/2010/main" val="4139329725"/>
+        <p14:creationId xmlns:p14="http://schemas.microsoft.com/office/powerpoint/2010/main" val="3003112543"/>
       </p:ext>
     </p:extLst>
   </p:cSld>
   <p:clrMapOvr>
     <a:masterClrMapping/>
   </p:clrMapOvr>
-  <p:timing>
-    <p:tnLst>
-      <p:par>
-        <p:cTn id="1" dur="indefinite" restart="never" nodeType="tmRoot"/>
-      </p:par>
-    </p:tnLst>
-  </p:timing>
 </p:sld>
 </file>
 
@@ -9134,25 +9274,20 @@
             <p:ph type="title"/>
           </p:nvPr>
         </p:nvSpPr>
-        <p:spPr/>
+        <p:spPr>
+          <a:xfrm>
+            <a:off x="296532" y="476672"/>
+            <a:ext cx="8451932" cy="576064"/>
+          </a:xfrm>
+        </p:spPr>
         <p:txBody>
           <a:bodyPr/>
           <a:lstStyle/>
           <a:p>
-            <a:r>
-              <a:rPr lang="en-US" dirty="0" err="1"/>
-              <a:t>Vecto</a:t>
-            </a:r>
-            <a:r>
-              <a:rPr lang="en-US" dirty="0"/>
-              <a:t> 3.0.4.565</a:t>
-            </a:r>
-            <a:br>
-              <a:rPr lang="en-US" dirty="0"/>
-            </a:br>
-            <a:r>
-              <a:rPr lang="en-US" sz="1600" dirty="0"/>
-              <a:t>2016-07-19</a:t>
+            <a:pPr algn="l"/>
+            <a:r>
+              <a:rPr lang="en-US" dirty="0" smtClean="0"/>
+              <a:t>Status quo VECTO software and open issues (Oct. 2016)</a:t>
             </a:r>
             <a:endParaRPr lang="en-US" dirty="0"/>
           </a:p>
@@ -9160,134 +9295,300 @@
       </p:sp>
       <p:sp>
         <p:nvSpPr>
-          <p:cNvPr id="3" name="Inhaltsplatzhalter 2"/>
-          <p:cNvSpPr>
-            <a:spLocks noGrp="1"/>
-          </p:cNvSpPr>
-          <p:nvPr>
-            <p:ph idx="1"/>
-          </p:nvPr>
+          <p:cNvPr id="3" name="Textfeld 2"/>
+          <p:cNvSpPr txBox="1"/>
+          <p:nvPr/>
         </p:nvSpPr>
-        <p:spPr/>
+        <p:spPr>
+          <a:xfrm>
+            <a:off x="323528" y="908720"/>
+            <a:ext cx="8496944" cy="400110"/>
+          </a:xfrm>
+          <a:prstGeom prst="rect">
+            <a:avLst/>
+          </a:prstGeom>
+          <a:noFill/>
+        </p:spPr>
         <p:txBody>
-          <a:bodyPr/>
+          <a:bodyPr wrap="square" rtlCol="0">
+            <a:spAutoFit/>
+          </a:bodyPr>
           <a:lstStyle/>
           <a:p>
-            <a:r>
-              <a:rPr lang="en-US" dirty="0" err="1" smtClean="0"/>
-              <a:t>Bugfixes</a:t>
-            </a:r>
-            <a:endParaRPr lang="en-US" dirty="0"/>
-          </a:p>
-          <a:p>
-            <a:pPr lvl="1"/>
-            <a:r>
-              <a:rPr lang="en-US" dirty="0" smtClean="0"/>
-              <a:t>AAUX </a:t>
-            </a:r>
-            <a:r>
-              <a:rPr lang="en-US" dirty="0"/>
-              <a:t>HVAC Dialog does not store path to </a:t>
-            </a:r>
-            <a:r>
-              <a:rPr lang="en-US" dirty="0" err="1"/>
-              <a:t>ActuationsMap</a:t>
-            </a:r>
-            <a:r>
-              <a:rPr lang="en-US" dirty="0"/>
-              <a:t> and </a:t>
-            </a:r>
-            <a:r>
-              <a:rPr lang="en-US" dirty="0" err="1"/>
-              <a:t>SSMSource</a:t>
-            </a:r>
-            <a:endParaRPr lang="en-US" dirty="0"/>
-          </a:p>
-          <a:p>
-            <a:pPr lvl="1"/>
-            <a:r>
-              <a:rPr lang="en-US" smtClean="0"/>
-              <a:t>GUI</a:t>
-            </a:r>
-            <a:r>
-              <a:rPr lang="en-US" dirty="0"/>
-              <a:t>: check for axle loads in declaration mode renders editing dialog useless </a:t>
-            </a:r>
-          </a:p>
-          <a:p>
-            <a:pPr lvl="1"/>
-            <a:r>
-              <a:rPr lang="en-US" dirty="0" err="1" smtClean="0"/>
-              <a:t>Vecto</a:t>
-            </a:r>
-            <a:r>
-              <a:rPr lang="en-US" dirty="0" smtClean="0"/>
+            <a:pPr algn="l"/>
+            <a:r>
+              <a:rPr lang="de-AT" sz="2000" dirty="0" smtClean="0"/>
+              <a:t>Next </a:t>
+            </a:r>
+            <a:r>
+              <a:rPr lang="de-AT" sz="2000" dirty="0" err="1" smtClean="0"/>
+              <a:t>issues</a:t>
+            </a:r>
+            <a:r>
+              <a:rPr lang="de-AT" sz="2000" dirty="0" smtClean="0"/>
+              <a:t> on </a:t>
+            </a:r>
+            <a:r>
+              <a:rPr lang="de-AT" sz="2000" dirty="0" err="1" smtClean="0"/>
+              <a:t>the</a:t>
+            </a:r>
+            <a:r>
+              <a:rPr lang="de-AT" sz="2000" dirty="0" smtClean="0"/>
               <a:t> </a:t>
             </a:r>
             <a:r>
-              <a:rPr lang="en-US" dirty="0"/>
-              <a:t>2.2: Simulation aborts (</a:t>
-            </a:r>
-            <a:r>
-              <a:rPr lang="en-US" dirty="0" err="1"/>
-              <a:t>Vecto</a:t>
-            </a:r>
-            <a:r>
-              <a:rPr lang="en-US" dirty="0"/>
-              <a:t> terminates) when simulating </a:t>
-            </a:r>
-            <a:r>
-              <a:rPr lang="en-US" dirty="0" err="1"/>
-              <a:t>EngineOnly</a:t>
-            </a:r>
-            <a:r>
-              <a:rPr lang="en-US" dirty="0"/>
-              <a:t> cycles</a:t>
-            </a:r>
-          </a:p>
-          <a:p>
-            <a:pPr lvl="1"/>
-            <a:r>
-              <a:rPr lang="en-US" dirty="0" err="1" smtClean="0"/>
-              <a:t>Vecto</a:t>
-            </a:r>
-            <a:r>
-              <a:rPr lang="en-US" dirty="0" smtClean="0"/>
-              <a:t> </a:t>
-            </a:r>
-            <a:r>
-              <a:rPr lang="en-US" dirty="0"/>
-              <a:t>3: Building </a:t>
-            </a:r>
-            <a:r>
-              <a:rPr lang="en-US" dirty="0" err="1"/>
-              <a:t>SimulationRun</a:t>
-            </a:r>
-            <a:r>
-              <a:rPr lang="en-US" dirty="0"/>
-              <a:t> </a:t>
-            </a:r>
-            <a:r>
-              <a:rPr lang="en-US" dirty="0" err="1"/>
-              <a:t>EngineOnly</a:t>
-            </a:r>
-            <a:r>
-              <a:rPr lang="en-US" dirty="0"/>
-              <a:t> simulation failed</a:t>
-            </a:r>
+              <a:rPr lang="de-AT" sz="2000" dirty="0" err="1" smtClean="0"/>
+              <a:t>to</a:t>
+            </a:r>
+            <a:r>
+              <a:rPr lang="de-AT" sz="2000" dirty="0" smtClean="0"/>
+              <a:t> do </a:t>
+            </a:r>
+            <a:r>
+              <a:rPr lang="de-AT" sz="2000" dirty="0" err="1" smtClean="0"/>
+              <a:t>list</a:t>
+            </a:r>
+            <a:endParaRPr lang="de-AT" sz="2000" dirty="0"/>
+          </a:p>
+        </p:txBody>
+      </p:sp>
+      <p:sp>
+        <p:nvSpPr>
+          <p:cNvPr id="7" name="Textfeld 6"/>
+          <p:cNvSpPr txBox="1"/>
+          <p:nvPr/>
+        </p:nvSpPr>
+        <p:spPr>
+          <a:xfrm>
+            <a:off x="539552" y="1484784"/>
+            <a:ext cx="8352928" cy="5093702"/>
+          </a:xfrm>
+          <a:prstGeom prst="rect">
+            <a:avLst/>
+          </a:prstGeom>
+          <a:noFill/>
+        </p:spPr>
+        <p:txBody>
+          <a:bodyPr wrap="square" rtlCol="0">
+            <a:spAutoFit/>
+          </a:bodyPr>
+          <a:lstStyle/>
+          <a:p>
+            <a:pPr marL="285750" indent="-285750" algn="l">
+              <a:buFont typeface="Arial" panose="020B0604020202020204" pitchFamily="34" charset="0"/>
+              <a:buChar char="•"/>
+            </a:pPr>
+            <a:r>
+              <a:rPr lang="en-GB" sz="1400" dirty="0" smtClean="0"/>
+              <a:t>Further development of the AT model</a:t>
+            </a:r>
+            <a:br>
+              <a:rPr lang="en-GB" sz="1400" dirty="0" smtClean="0"/>
+            </a:br>
+            <a:r>
+              <a:rPr lang="en-GB" sz="1400" b="0" dirty="0" smtClean="0"/>
+              <a:t>Consideration of losses during power shifts, update of gear shift logics</a:t>
+            </a:r>
+          </a:p>
+          <a:p>
+            <a:pPr marL="285750" indent="-285750" algn="l">
+              <a:buFont typeface="Arial" panose="020B0604020202020204" pitchFamily="34" charset="0"/>
+              <a:buChar char="•"/>
+            </a:pPr>
+            <a:r>
+              <a:rPr lang="en-GB" sz="1400" dirty="0" smtClean="0"/>
+              <a:t>Reimplementation </a:t>
+            </a:r>
+            <a:r>
+              <a:rPr lang="en-GB" sz="1400" dirty="0"/>
+              <a:t>of engine stop/start</a:t>
+            </a:r>
+          </a:p>
+          <a:p>
+            <a:pPr marL="285750" indent="-285750" algn="l">
+              <a:buFont typeface="Arial" panose="020B0604020202020204" pitchFamily="34" charset="0"/>
+              <a:buChar char="•"/>
+            </a:pPr>
+            <a:r>
+              <a:rPr lang="en-GB" sz="1400" dirty="0" smtClean="0"/>
+              <a:t>Declaration mode: implementation of EMS vehicle configurations</a:t>
+            </a:r>
+          </a:p>
+          <a:p>
+            <a:pPr marL="285750" indent="-285750" algn="l">
+              <a:buFont typeface="Arial" panose="020B0604020202020204" pitchFamily="34" charset="0"/>
+              <a:buChar char="•"/>
+            </a:pPr>
+            <a:endParaRPr lang="en-GB" sz="1400" dirty="0"/>
+          </a:p>
+          <a:p>
+            <a:pPr algn="l"/>
+            <a:r>
+              <a:rPr lang="en-GB" sz="1400" u="sng" dirty="0" smtClean="0"/>
+              <a:t>Items waiting for decision on methods and resources:</a:t>
+            </a:r>
+          </a:p>
+          <a:p>
+            <a:pPr marL="285750" indent="-285750" algn="l">
+              <a:buFont typeface="Arial" panose="020B0604020202020204" pitchFamily="34" charset="0"/>
+              <a:buChar char="•"/>
+            </a:pPr>
+            <a:r>
+              <a:rPr lang="en-GB" sz="1400" dirty="0" smtClean="0"/>
+              <a:t>Update engine data (according to update of Annex II)</a:t>
+            </a:r>
+            <a:br>
+              <a:rPr lang="en-GB" sz="1400" dirty="0" smtClean="0"/>
+            </a:br>
+            <a:r>
+              <a:rPr lang="en-GB" sz="1400" b="0" dirty="0" smtClean="0"/>
+              <a:t>Other fuels than diesel, “top torque” feature, correction factor for periodic </a:t>
+            </a:r>
+            <a:r>
+              <a:rPr lang="en-GB" sz="1400" b="0" dirty="0" err="1" smtClean="0"/>
+              <a:t>regerating</a:t>
+            </a:r>
+            <a:r>
+              <a:rPr lang="en-GB" sz="1400" b="0" dirty="0" smtClean="0"/>
+              <a:t> DPFs</a:t>
+            </a:r>
+          </a:p>
+          <a:p>
+            <a:pPr marL="285750" indent="-285750" algn="l">
+              <a:buFont typeface="Arial" panose="020B0604020202020204" pitchFamily="34" charset="0"/>
+              <a:buChar char="•"/>
+            </a:pPr>
+            <a:r>
+              <a:rPr lang="en-GB" sz="1400" dirty="0" smtClean="0"/>
+              <a:t>Declaration mode: </a:t>
+            </a:r>
+          </a:p>
+          <a:p>
+            <a:pPr marL="742950" lvl="1" indent="-285750" algn="l">
+              <a:spcBef>
+                <a:spcPts val="300"/>
+              </a:spcBef>
+              <a:buFont typeface="Arial" panose="020B0604020202020204" pitchFamily="34" charset="0"/>
+              <a:buChar char="•"/>
+            </a:pPr>
+            <a:r>
+              <a:rPr lang="en-GB" sz="1400" dirty="0"/>
+              <a:t>Revision of calculated vehicle </a:t>
+            </a:r>
+            <a:r>
+              <a:rPr lang="en-GB" sz="1400" dirty="0" smtClean="0"/>
+              <a:t>loads</a:t>
+            </a:r>
+          </a:p>
+          <a:p>
+            <a:pPr marL="742950" lvl="1" indent="-285750" algn="l">
+              <a:spcBef>
+                <a:spcPts val="300"/>
+              </a:spcBef>
+              <a:buFont typeface="Arial" panose="020B0604020202020204" pitchFamily="34" charset="0"/>
+              <a:buChar char="•"/>
+            </a:pPr>
+            <a:r>
+              <a:rPr lang="en-GB" sz="1400" dirty="0" smtClean="0"/>
+              <a:t>implementation of refuse cycle (instead “municipal”)</a:t>
+            </a:r>
+            <a:br>
+              <a:rPr lang="en-GB" sz="1400" dirty="0" smtClean="0"/>
+            </a:br>
+            <a:r>
+              <a:rPr lang="en-GB" sz="1400" b="0" dirty="0" smtClean="0"/>
+              <a:t>Update of driving cycle, consideration of generic PTO loads during collection part,</a:t>
+            </a:r>
+            <a:br>
+              <a:rPr lang="en-GB" sz="1400" b="0" dirty="0" smtClean="0"/>
+            </a:br>
+            <a:r>
+              <a:rPr lang="en-GB" sz="1400" b="0" dirty="0" smtClean="0"/>
+              <a:t>generic body weight and payload</a:t>
+            </a:r>
+          </a:p>
+          <a:p>
+            <a:pPr marL="742950" lvl="1" indent="-285750" algn="l">
+              <a:spcBef>
+                <a:spcPts val="300"/>
+              </a:spcBef>
+              <a:buFont typeface="Arial" panose="020B0604020202020204" pitchFamily="34" charset="0"/>
+              <a:buChar char="•"/>
+            </a:pPr>
+            <a:r>
+              <a:rPr lang="en-GB" sz="1400" dirty="0"/>
+              <a:t>VECTO output (approval </a:t>
+            </a:r>
+            <a:r>
+              <a:rPr lang="en-GB" sz="1400" dirty="0" smtClean="0"/>
+              <a:t>authorities</a:t>
+            </a:r>
+            <a:r>
+              <a:rPr lang="en-GB" sz="1400" dirty="0"/>
+              <a:t>, customer info, monitoring</a:t>
+            </a:r>
+            <a:r>
+              <a:rPr lang="en-GB" sz="1400" dirty="0" smtClean="0"/>
+              <a:t>)</a:t>
+            </a:r>
+          </a:p>
+          <a:p>
+            <a:pPr marL="742950" lvl="1" indent="-285750" algn="l">
+              <a:spcBef>
+                <a:spcPts val="300"/>
+              </a:spcBef>
+              <a:buFont typeface="Arial" panose="020B0604020202020204" pitchFamily="34" charset="0"/>
+              <a:buChar char="•"/>
+            </a:pPr>
+            <a:r>
+              <a:rPr lang="en-GB" sz="1400" dirty="0" smtClean="0"/>
+              <a:t>Buses</a:t>
+            </a:r>
+            <a:endParaRPr lang="en-GB" sz="1400" b="0" dirty="0" smtClean="0"/>
+          </a:p>
+          <a:p>
+            <a:pPr marL="285750" indent="-285750" algn="l">
+              <a:buFont typeface="Arial" panose="020B0604020202020204" pitchFamily="34" charset="0"/>
+              <a:buChar char="•"/>
+            </a:pPr>
+            <a:r>
+              <a:rPr lang="en-GB" sz="1400" dirty="0" smtClean="0"/>
+              <a:t>Predictive ADAS</a:t>
+            </a:r>
+          </a:p>
+          <a:p>
+            <a:pPr marL="285750" indent="-285750" algn="l">
+              <a:buFont typeface="Arial" panose="020B0604020202020204" pitchFamily="34" charset="0"/>
+              <a:buChar char="•"/>
+            </a:pPr>
+            <a:endParaRPr lang="en-GB" sz="1400" dirty="0" smtClean="0"/>
+          </a:p>
+          <a:p>
+            <a:pPr marL="285750" indent="-285750" algn="l">
+              <a:buFont typeface="Arial" panose="020B0604020202020204" pitchFamily="34" charset="0"/>
+              <a:buChar char="•"/>
+            </a:pPr>
+            <a:endParaRPr lang="en-GB" sz="1400" dirty="0"/>
           </a:p>
         </p:txBody>
       </p:sp>
     </p:spTree>
     <p:extLst>
       <p:ext uri="{BB962C8B-B14F-4D97-AF65-F5344CB8AC3E}">
-        <p14:creationId xmlns:p14="http://schemas.microsoft.com/office/powerpoint/2010/main" val="1421982084"/>
+        <p14:creationId xmlns:p14="http://schemas.microsoft.com/office/powerpoint/2010/main" val="4139329725"/>
       </p:ext>
     </p:extLst>
   </p:cSld>
   <p:clrMapOvr>
     <a:masterClrMapping/>
   </p:clrMapOvr>
+  <p:timing>
+    <p:tnLst>
+      <p:par>
+        <p:cTn id="1" dur="indefinite" restart="never" nodeType="tmRoot"/>
+      </p:par>
+    </p:tnLst>
+  </p:timing>
 </p:sld>
 </file>
 
@@ -9318,34 +9619,25 @@
             <p:ph type="title"/>
           </p:nvPr>
         </p:nvSpPr>
-        <p:spPr>
-          <a:xfrm>
-            <a:off x="468315" y="786383"/>
-            <a:ext cx="8218487" cy="482377"/>
-          </a:xfrm>
-        </p:spPr>
+        <p:spPr/>
         <p:txBody>
           <a:bodyPr/>
           <a:lstStyle/>
           <a:p>
             <a:r>
-              <a:rPr lang="en-US" dirty="0" err="1" smtClean="0"/>
+              <a:rPr lang="en-US" dirty="0" err="1"/>
               <a:t>Vecto</a:t>
             </a:r>
             <a:r>
-              <a:rPr lang="en-US" dirty="0" smtClean="0"/>
-              <a:t> </a:t>
-            </a:r>
-            <a:r>
               <a:rPr lang="en-US" dirty="0"/>
-              <a:t>3.0.4.544</a:t>
+              <a:t> 3.0.4.565</a:t>
             </a:r>
             <a:br>
               <a:rPr lang="en-US" dirty="0"/>
             </a:br>
             <a:r>
               <a:rPr lang="en-US" sz="1600" dirty="0"/>
-              <a:t>2016-06-28</a:t>
+              <a:t>2016-07-19</a:t>
             </a:r>
             <a:endParaRPr lang="en-US" dirty="0"/>
           </a:p>
@@ -9361,97 +9653,12 @@
             <p:ph idx="1"/>
           </p:nvPr>
         </p:nvSpPr>
-        <p:spPr>
-          <a:xfrm>
-            <a:off x="539553" y="1628800"/>
-            <a:ext cx="8064896" cy="4353347"/>
-          </a:xfrm>
-        </p:spPr>
+        <p:spPr/>
         <p:txBody>
           <a:bodyPr/>
           <a:lstStyle/>
           <a:p>
             <a:r>
-              <a:rPr lang="en-US" dirty="0" smtClean="0"/>
-              <a:t>Main </a:t>
-            </a:r>
-            <a:r>
-              <a:rPr lang="en-US" dirty="0"/>
-              <a:t>Updates</a:t>
-            </a:r>
-          </a:p>
-          <a:p>
-            <a:pPr lvl="1"/>
-            <a:r>
-              <a:rPr lang="en-US" dirty="0" smtClean="0"/>
-              <a:t>New </a:t>
-            </a:r>
-            <a:r>
-              <a:rPr lang="en-US" dirty="0"/>
-              <a:t>gear shift strategy according to White Book </a:t>
-            </a:r>
-            <a:r>
-              <a:rPr lang="en-US" dirty="0" smtClean="0"/>
-              <a:t>2016</a:t>
-            </a:r>
-          </a:p>
-          <a:p>
-            <a:pPr lvl="1"/>
-            <a:r>
-              <a:rPr lang="en-US" dirty="0" smtClean="0"/>
-              <a:t>New </a:t>
-            </a:r>
-            <a:r>
-              <a:rPr lang="en-US" dirty="0"/>
-              <a:t>coasting strategy according to White Book 2016</a:t>
-            </a:r>
-          </a:p>
-          <a:p>
-            <a:pPr lvl="1"/>
-            <a:r>
-              <a:rPr lang="en-US" dirty="0" smtClean="0"/>
-              <a:t>New </a:t>
-            </a:r>
-            <a:r>
-              <a:rPr lang="en-US" dirty="0"/>
-              <a:t>input parameters (</a:t>
-            </a:r>
-            <a:r>
-              <a:rPr lang="en-US" dirty="0" err="1"/>
-              <a:t>enineering</a:t>
-            </a:r>
-            <a:r>
-              <a:rPr lang="en-US" dirty="0"/>
-              <a:t> mode) for coasting and gear shift behavior</a:t>
-            </a:r>
-          </a:p>
-          <a:p>
-            <a:pPr lvl="1"/>
-            <a:r>
-              <a:rPr lang="en-US" dirty="0" smtClean="0"/>
-              <a:t>Use </a:t>
-            </a:r>
-            <a:r>
-              <a:rPr lang="en-US" dirty="0"/>
-              <a:t>SI units in Advanced Auxiliaries Module and compile with strict compiler settings (no implicit casts, etc.)</a:t>
-            </a:r>
-          </a:p>
-          <a:p>
-            <a:pPr lvl="1"/>
-            <a:r>
-              <a:rPr lang="en-US" dirty="0" smtClean="0"/>
-              <a:t>Allow </a:t>
-            </a:r>
-            <a:r>
-              <a:rPr lang="en-US" dirty="0"/>
-              <a:t>efficiency for transmission losses (in engineering mode)</a:t>
-            </a:r>
-          </a:p>
-          <a:p>
-            <a:endParaRPr lang="en-US" dirty="0"/>
-          </a:p>
-          <a:p>
-            <a:r>
               <a:rPr lang="en-US" dirty="0" err="1" smtClean="0"/>
               <a:t>Bugfixes</a:t>
             </a:r>
@@ -9461,33 +9668,42 @@
             <a:pPr lvl="1"/>
             <a:r>
               <a:rPr lang="en-US" dirty="0" smtClean="0"/>
-              <a:t>Auxiliary </a:t>
+              <a:t>AAUX </a:t>
+            </a:r>
+            <a:r>
+              <a:rPr lang="en-US" dirty="0"/>
+              <a:t>HVAC Dialog does not store path to </a:t>
             </a:r>
             <a:r>
               <a:rPr lang="en-US" dirty="0" err="1"/>
-              <a:t>TechList</a:t>
+              <a:t>ActuationsMap</a:t>
             </a:r>
             <a:r>
               <a:rPr lang="en-US" dirty="0"/>
-              <a:t> not read from JSON input data</a:t>
-            </a:r>
+              <a:t> and </a:t>
+            </a:r>
+            <a:r>
+              <a:rPr lang="en-US" dirty="0" err="1"/>
+              <a:t>SSMSource</a:t>
+            </a:r>
+            <a:endParaRPr lang="en-US" dirty="0"/>
           </a:p>
           <a:p>
             <a:pPr lvl="1"/>
             <a:r>
-              <a:rPr lang="en-US" dirty="0" smtClean="0"/>
-              <a:t>Improvements </a:t>
+              <a:rPr lang="en-US" smtClean="0"/>
+              <a:t>GUI</a:t>
             </a:r>
             <a:r>
               <a:rPr lang="en-US" dirty="0"/>
-              <a:t>in driver strategy</a:t>
+              <a:t>: check for axle loads in declaration mode renders editing dialog useless </a:t>
             </a:r>
           </a:p>
           <a:p>
             <a:pPr lvl="1"/>
             <a:r>
               <a:rPr lang="en-US" dirty="0" err="1" smtClean="0"/>
-              <a:t>Bugfixes</a:t>
+              <a:t>Vecto</a:t>
             </a:r>
             <a:r>
               <a:rPr lang="en-US" dirty="0" smtClean="0"/>
@@ -9495,37 +9711,68 @@
             </a:r>
             <a:r>
               <a:rPr lang="en-US" dirty="0"/>
-              <a:t>in </a:t>
+              <a:t>2.2: Simulation aborts (</a:t>
             </a:r>
             <a:r>
               <a:rPr lang="en-US" dirty="0" err="1"/>
-              <a:t>MeasuredSpeed</a:t>
+              <a:t>Vecto</a:t>
             </a:r>
             <a:r>
               <a:rPr lang="en-US" dirty="0"/>
-              <a:t> mode</a:t>
-            </a:r>
-            <a:endParaRPr lang="en-US" dirty="0" smtClean="0"/>
+              <a:t> terminates) when simulating </a:t>
+            </a:r>
+            <a:r>
+              <a:rPr lang="en-US" dirty="0" err="1"/>
+              <a:t>EngineOnly</a:t>
+            </a:r>
+            <a:r>
+              <a:rPr lang="en-US" dirty="0"/>
+              <a:t> cycles</a:t>
+            </a:r>
+          </a:p>
+          <a:p>
+            <a:pPr lvl="1"/>
+            <a:r>
+              <a:rPr lang="en-US" dirty="0" err="1" smtClean="0"/>
+              <a:t>Vecto</a:t>
+            </a:r>
+            <a:r>
+              <a:rPr lang="en-US" dirty="0" smtClean="0"/>
+              <a:t> </a:t>
+            </a:r>
+            <a:r>
+              <a:rPr lang="en-US" dirty="0"/>
+              <a:t>3: Building </a:t>
+            </a:r>
+            <a:r>
+              <a:rPr lang="en-US" dirty="0" err="1"/>
+              <a:t>SimulationRun</a:t>
+            </a:r>
+            <a:r>
+              <a:rPr lang="en-US" dirty="0"/>
+              <a:t> </a:t>
+            </a:r>
+            <a:r>
+              <a:rPr lang="en-US" dirty="0" err="1"/>
+              <a:t>EngineOnly</a:t>
+            </a:r>
+            <a:r>
+              <a:rPr lang="en-US" dirty="0"/>
+              <a:t> simulation failed</a:t>
+            </a:r>
           </a:p>
         </p:txBody>
       </p:sp>
     </p:spTree>
     <p:extLst>
       <p:ext uri="{BB962C8B-B14F-4D97-AF65-F5344CB8AC3E}">
-        <p14:creationId xmlns:p14="http://schemas.microsoft.com/office/powerpoint/2010/main" val="3997910218"/>
+        <p14:creationId xmlns:p14="http://schemas.microsoft.com/office/powerpoint/2010/main" val="1421982084"/>
       </p:ext>
     </p:extLst>
   </p:cSld>
   <p:clrMapOvr>
     <a:masterClrMapping/>
   </p:clrMapOvr>
-  <p:timing>
-    <p:tnLst>
-      <p:par>
-        <p:cTn id="1" dur="indefinite" restart="never" nodeType="tmRoot"/>
-      </p:par>
-    </p:tnLst>
-  </p:timing>
 </p:sld>
 </file>
 

</xml_diff>

<commit_message>
update date and version number in changelog
</commit_message>
<xml_diff>
--- a/Documentation/User Manual Source/Release Notes Vecto3.x.pptx
+++ b/Documentation/User Manual Source/Release Notes Vecto3.x.pptx
@@ -4511,7 +4511,7 @@
                   <a:srgbClr val="990000"/>
                 </a:solidFill>
               </a:rPr>
-              <a:t>10.01.2017</a:t>
+              <a:t>12.01.2017</a:t>
             </a:r>
             <a:endParaRPr lang="en-US" sz="2000" dirty="0" smtClean="0">
               <a:solidFill>
@@ -7088,23 +7088,23 @@
               <a:t>Vecto</a:t>
             </a:r>
             <a:r>
-              <a:rPr lang="en-US" dirty="0"/>
+              <a:rPr lang="en-US"/>
               <a:t> </a:t>
             </a:r>
             <a:r>
-              <a:rPr lang="en-US" dirty="0" smtClean="0"/>
-              <a:t>3.1.1.740</a:t>
-            </a:r>
-            <a:r>
-              <a:rPr lang="en-US" dirty="0"/>
+              <a:rPr lang="en-US" smtClean="0"/>
+              <a:t>3.1.1.742</a:t>
+            </a:r>
+            <a:r>
+              <a:rPr lang="en-US"/>
               <a:t/>
             </a:r>
             <a:br>
-              <a:rPr lang="en-US" dirty="0"/>
+              <a:rPr lang="en-US"/>
             </a:br>
             <a:r>
-              <a:rPr lang="en-US" sz="1600" dirty="0" smtClean="0"/>
-              <a:t>2017-01-10</a:t>
+              <a:rPr lang="en-US" sz="1600" smtClean="0"/>
+              <a:t>2017-01-12</a:t>
             </a:r>
             <a:endParaRPr lang="en-US" sz="1600" dirty="0"/>
           </a:p>
@@ -7137,7 +7137,6 @@
               <a:rPr lang="en-US" sz="1400" b="1" dirty="0" smtClean="0"/>
               <a:t>Improvements:</a:t>
             </a:r>
-            <a:endParaRPr lang="en-US" sz="1400" b="1" dirty="0" smtClean="0"/>
           </a:p>
           <a:p>
             <a:r>

</xml_diff>

<commit_message>
adding files for new build
</commit_message>
<xml_diff>
--- a/Documentation/User Manual Source/Release Notes Vecto3.x.pptx
+++ b/Documentation/User Manual Source/Release Notes Vecto3.x.pptx
@@ -5,33 +5,34 @@
     <p:sldMasterId id="2147483648" r:id="rId1"/>
   </p:sldMasterIdLst>
   <p:notesMasterIdLst>
-    <p:notesMasterId r:id="rId23"/>
+    <p:notesMasterId r:id="rId24"/>
   </p:notesMasterIdLst>
   <p:handoutMasterIdLst>
-    <p:handoutMasterId r:id="rId24"/>
+    <p:handoutMasterId r:id="rId25"/>
   </p:handoutMasterIdLst>
   <p:sldIdLst>
     <p:sldId id="575" r:id="rId2"/>
     <p:sldId id="661" r:id="rId3"/>
-    <p:sldId id="657" r:id="rId4"/>
-    <p:sldId id="659" r:id="rId5"/>
-    <p:sldId id="660" r:id="rId6"/>
-    <p:sldId id="656" r:id="rId7"/>
-    <p:sldId id="655" r:id="rId8"/>
-    <p:sldId id="654" r:id="rId9"/>
-    <p:sldId id="653" r:id="rId10"/>
-    <p:sldId id="651" r:id="rId11"/>
-    <p:sldId id="648" r:id="rId12"/>
-    <p:sldId id="649" r:id="rId13"/>
-    <p:sldId id="650" r:id="rId14"/>
-    <p:sldId id="645" r:id="rId15"/>
-    <p:sldId id="647" r:id="rId16"/>
-    <p:sldId id="646" r:id="rId17"/>
-    <p:sldId id="640" r:id="rId18"/>
-    <p:sldId id="641" r:id="rId19"/>
-    <p:sldId id="642" r:id="rId20"/>
-    <p:sldId id="643" r:id="rId21"/>
-    <p:sldId id="644" r:id="rId22"/>
+    <p:sldId id="662" r:id="rId4"/>
+    <p:sldId id="657" r:id="rId5"/>
+    <p:sldId id="659" r:id="rId6"/>
+    <p:sldId id="660" r:id="rId7"/>
+    <p:sldId id="656" r:id="rId8"/>
+    <p:sldId id="655" r:id="rId9"/>
+    <p:sldId id="654" r:id="rId10"/>
+    <p:sldId id="653" r:id="rId11"/>
+    <p:sldId id="651" r:id="rId12"/>
+    <p:sldId id="648" r:id="rId13"/>
+    <p:sldId id="649" r:id="rId14"/>
+    <p:sldId id="650" r:id="rId15"/>
+    <p:sldId id="645" r:id="rId16"/>
+    <p:sldId id="647" r:id="rId17"/>
+    <p:sldId id="646" r:id="rId18"/>
+    <p:sldId id="640" r:id="rId19"/>
+    <p:sldId id="641" r:id="rId20"/>
+    <p:sldId id="642" r:id="rId21"/>
+    <p:sldId id="643" r:id="rId22"/>
+    <p:sldId id="644" r:id="rId23"/>
   </p:sldIdLst>
   <p:sldSz cx="9144000" cy="6858000" type="screen4x3"/>
   <p:notesSz cx="6805613" cy="9944100"/>
@@ -162,7 +163,7 @@
   </p:defaultTextStyle>
   <p:extLst>
     <p:ext uri="{EFAFB233-063F-42B5-8137-9DF3F51BA10A}">
-      <p15:sldGuideLst xmlns:p15="http://schemas.microsoft.com/office/powerpoint/2012/main" xmlns="">
+      <p15:sldGuideLst xmlns:p15="http://schemas.microsoft.com/office/powerpoint/2012/main">
         <p15:guide id="1" orient="horz" pos="2160">
           <p15:clr>
             <a:srgbClr val="A4A3A4"/>
@@ -176,7 +177,7 @@
       </p15:sldGuideLst>
     </p:ext>
     <p:ext uri="{2D200454-40CA-4A62-9FC3-DE9A4176ACB9}">
-      <p15:notesGuideLst xmlns:p15="http://schemas.microsoft.com/office/powerpoint/2012/main" xmlns="">
+      <p15:notesGuideLst xmlns:p15="http://schemas.microsoft.com/office/powerpoint/2012/main">
         <p15:guide id="1" orient="horz" pos="3132">
           <p15:clr>
             <a:srgbClr val="A4A3A4"/>
@@ -4506,12 +4507,12 @@
           <a:p>
             <a:pPr eaLnBrk="1" hangingPunct="1"/>
             <a:r>
-              <a:rPr lang="en-US" sz="2000" dirty="0" smtClean="0">
+              <a:rPr lang="en-US" sz="2000" smtClean="0">
                 <a:solidFill>
                   <a:srgbClr val="990000"/>
                 </a:solidFill>
               </a:rPr>
-              <a:t>12.01.2017</a:t>
+              <a:t>18.01.2017</a:t>
             </a:r>
             <a:endParaRPr lang="en-US" sz="2000" dirty="0" smtClean="0">
               <a:solidFill>
@@ -4688,34 +4689,25 @@
             <p:ph type="title"/>
           </p:nvPr>
         </p:nvSpPr>
-        <p:spPr>
-          <a:xfrm>
-            <a:off x="468315" y="786383"/>
-            <a:ext cx="8218487" cy="482377"/>
-          </a:xfrm>
-        </p:spPr>
+        <p:spPr/>
         <p:txBody>
           <a:bodyPr/>
           <a:lstStyle/>
           <a:p>
             <a:r>
-              <a:rPr lang="en-US" dirty="0" err="1" smtClean="0"/>
+              <a:rPr lang="en-US" dirty="0" err="1"/>
               <a:t>Vecto</a:t>
             </a:r>
             <a:r>
-              <a:rPr lang="en-US" dirty="0" smtClean="0"/>
-              <a:t> </a:t>
-            </a:r>
-            <a:r>
               <a:rPr lang="en-US" dirty="0"/>
-              <a:t>3.0.4.544</a:t>
+              <a:t> 3.0.4.565</a:t>
             </a:r>
             <a:br>
               <a:rPr lang="en-US" dirty="0"/>
             </a:br>
             <a:r>
               <a:rPr lang="en-US" sz="1600" dirty="0"/>
-              <a:t>2016-06-28</a:t>
+              <a:t>2016-07-19</a:t>
             </a:r>
             <a:endParaRPr lang="en-US" dirty="0"/>
           </a:p>
@@ -4731,97 +4723,12 @@
             <p:ph idx="1"/>
           </p:nvPr>
         </p:nvSpPr>
-        <p:spPr>
-          <a:xfrm>
-            <a:off x="539553" y="1628800"/>
-            <a:ext cx="8064896" cy="4353347"/>
-          </a:xfrm>
-        </p:spPr>
+        <p:spPr/>
         <p:txBody>
           <a:bodyPr/>
           <a:lstStyle/>
           <a:p>
             <a:r>
-              <a:rPr lang="en-US" dirty="0" smtClean="0"/>
-              <a:t>Main </a:t>
-            </a:r>
-            <a:r>
-              <a:rPr lang="en-US" dirty="0"/>
-              <a:t>Updates</a:t>
-            </a:r>
-          </a:p>
-          <a:p>
-            <a:pPr lvl="1"/>
-            <a:r>
-              <a:rPr lang="en-US" dirty="0" smtClean="0"/>
-              <a:t>New </a:t>
-            </a:r>
-            <a:r>
-              <a:rPr lang="en-US" dirty="0"/>
-              <a:t>gear shift strategy according to White Book </a:t>
-            </a:r>
-            <a:r>
-              <a:rPr lang="en-US" dirty="0" smtClean="0"/>
-              <a:t>2016</a:t>
-            </a:r>
-          </a:p>
-          <a:p>
-            <a:pPr lvl="1"/>
-            <a:r>
-              <a:rPr lang="en-US" dirty="0" smtClean="0"/>
-              <a:t>New </a:t>
-            </a:r>
-            <a:r>
-              <a:rPr lang="en-US" dirty="0"/>
-              <a:t>coasting strategy according to White Book 2016</a:t>
-            </a:r>
-          </a:p>
-          <a:p>
-            <a:pPr lvl="1"/>
-            <a:r>
-              <a:rPr lang="en-US" dirty="0" smtClean="0"/>
-              <a:t>New </a:t>
-            </a:r>
-            <a:r>
-              <a:rPr lang="en-US" dirty="0"/>
-              <a:t>input parameters (</a:t>
-            </a:r>
-            <a:r>
-              <a:rPr lang="en-US" dirty="0" err="1"/>
-              <a:t>enineering</a:t>
-            </a:r>
-            <a:r>
-              <a:rPr lang="en-US" dirty="0"/>
-              <a:t> mode) for coasting and gear shift behavior</a:t>
-            </a:r>
-          </a:p>
-          <a:p>
-            <a:pPr lvl="1"/>
-            <a:r>
-              <a:rPr lang="en-US" dirty="0" smtClean="0"/>
-              <a:t>Use </a:t>
-            </a:r>
-            <a:r>
-              <a:rPr lang="en-US" dirty="0"/>
-              <a:t>SI units in Advanced Auxiliaries Module and compile with strict compiler settings (no implicit casts, etc.)</a:t>
-            </a:r>
-          </a:p>
-          <a:p>
-            <a:pPr lvl="1"/>
-            <a:r>
-              <a:rPr lang="en-US" dirty="0" smtClean="0"/>
-              <a:t>Allow </a:t>
-            </a:r>
-            <a:r>
-              <a:rPr lang="en-US" dirty="0"/>
-              <a:t>efficiency for transmission losses (in engineering mode)</a:t>
-            </a:r>
-          </a:p>
-          <a:p>
-            <a:endParaRPr lang="en-US" dirty="0"/>
-          </a:p>
-          <a:p>
-            <a:r>
               <a:rPr lang="en-US" dirty="0" err="1" smtClean="0"/>
               <a:t>Bugfixes</a:t>
             </a:r>
@@ -4831,33 +4738,42 @@
             <a:pPr lvl="1"/>
             <a:r>
               <a:rPr lang="en-US" dirty="0" smtClean="0"/>
-              <a:t>Auxiliary </a:t>
+              <a:t>AAUX </a:t>
+            </a:r>
+            <a:r>
+              <a:rPr lang="en-US" dirty="0"/>
+              <a:t>HVAC Dialog does not store path to </a:t>
             </a:r>
             <a:r>
               <a:rPr lang="en-US" dirty="0" err="1"/>
-              <a:t>TechList</a:t>
+              <a:t>ActuationsMap</a:t>
             </a:r>
             <a:r>
               <a:rPr lang="en-US" dirty="0"/>
-              <a:t> not read from JSON input data</a:t>
-            </a:r>
+              <a:t> and </a:t>
+            </a:r>
+            <a:r>
+              <a:rPr lang="en-US" dirty="0" err="1"/>
+              <a:t>SSMSource</a:t>
+            </a:r>
+            <a:endParaRPr lang="en-US" dirty="0"/>
           </a:p>
           <a:p>
             <a:pPr lvl="1"/>
             <a:r>
-              <a:rPr lang="en-US" dirty="0" smtClean="0"/>
-              <a:t>Improvements </a:t>
+              <a:rPr lang="en-US" smtClean="0"/>
+              <a:t>GUI</a:t>
             </a:r>
             <a:r>
               <a:rPr lang="en-US" dirty="0"/>
-              <a:t>in driver strategy</a:t>
+              <a:t>: check for axle loads in declaration mode renders editing dialog useless </a:t>
             </a:r>
           </a:p>
           <a:p>
             <a:pPr lvl="1"/>
             <a:r>
               <a:rPr lang="en-US" dirty="0" err="1" smtClean="0"/>
-              <a:t>Bugfixes</a:t>
+              <a:t>Vecto</a:t>
             </a:r>
             <a:r>
               <a:rPr lang="en-US" dirty="0" smtClean="0"/>
@@ -4865,37 +4781,68 @@
             </a:r>
             <a:r>
               <a:rPr lang="en-US" dirty="0"/>
-              <a:t>in </a:t>
+              <a:t>2.2: Simulation aborts (</a:t>
             </a:r>
             <a:r>
               <a:rPr lang="en-US" dirty="0" err="1"/>
-              <a:t>MeasuredSpeed</a:t>
+              <a:t>Vecto</a:t>
             </a:r>
             <a:r>
               <a:rPr lang="en-US" dirty="0"/>
-              <a:t> mode</a:t>
-            </a:r>
-            <a:endParaRPr lang="en-US" dirty="0" smtClean="0"/>
+              <a:t> terminates) when simulating </a:t>
+            </a:r>
+            <a:r>
+              <a:rPr lang="en-US" dirty="0" err="1"/>
+              <a:t>EngineOnly</a:t>
+            </a:r>
+            <a:r>
+              <a:rPr lang="en-US" dirty="0"/>
+              <a:t> cycles</a:t>
+            </a:r>
+          </a:p>
+          <a:p>
+            <a:pPr lvl="1"/>
+            <a:r>
+              <a:rPr lang="en-US" dirty="0" err="1" smtClean="0"/>
+              <a:t>Vecto</a:t>
+            </a:r>
+            <a:r>
+              <a:rPr lang="en-US" dirty="0" smtClean="0"/>
+              <a:t> </a:t>
+            </a:r>
+            <a:r>
+              <a:rPr lang="en-US" dirty="0"/>
+              <a:t>3: Building </a:t>
+            </a:r>
+            <a:r>
+              <a:rPr lang="en-US" dirty="0" err="1"/>
+              <a:t>SimulationRun</a:t>
+            </a:r>
+            <a:r>
+              <a:rPr lang="en-US" dirty="0"/>
+              <a:t> </a:t>
+            </a:r>
+            <a:r>
+              <a:rPr lang="en-US" dirty="0" err="1"/>
+              <a:t>EngineOnly</a:t>
+            </a:r>
+            <a:r>
+              <a:rPr lang="en-US" dirty="0"/>
+              <a:t> simulation failed</a:t>
+            </a:r>
           </a:p>
         </p:txBody>
       </p:sp>
     </p:spTree>
     <p:extLst>
       <p:ext uri="{BB962C8B-B14F-4D97-AF65-F5344CB8AC3E}">
-        <p14:creationId xmlns:p14="http://schemas.microsoft.com/office/powerpoint/2010/main" val="3997910218"/>
+        <p14:creationId xmlns:p14="http://schemas.microsoft.com/office/powerpoint/2010/main" val="1421982084"/>
       </p:ext>
     </p:extLst>
   </p:cSld>
   <p:clrMapOvr>
     <a:masterClrMapping/>
   </p:clrMapOvr>
-  <p:timing>
-    <p:tnLst>
-      <p:par>
-        <p:cTn id="1" dur="indefinite" restart="never" nodeType="tmRoot"/>
-      </p:par>
-    </p:tnLst>
-  </p:timing>
 </p:sld>
 </file>
 
@@ -4926,22 +4873,34 @@
             <p:ph type="title"/>
           </p:nvPr>
         </p:nvSpPr>
-        <p:spPr/>
+        <p:spPr>
+          <a:xfrm>
+            <a:off x="468315" y="786383"/>
+            <a:ext cx="8218487" cy="482377"/>
+          </a:xfrm>
+        </p:spPr>
         <p:txBody>
           <a:bodyPr/>
           <a:lstStyle/>
           <a:p>
             <a:r>
-              <a:rPr lang="en-US" dirty="0" smtClean="0"/>
-              <a:t>Notes for using </a:t>
-            </a:r>
-            <a:r>
               <a:rPr lang="en-US" dirty="0" err="1" smtClean="0"/>
               <a:t>Vecto</a:t>
             </a:r>
             <a:r>
               <a:rPr lang="en-US" dirty="0" smtClean="0"/>
-              <a:t> 3.x with AAUX (1)</a:t>
+              <a:t> </a:t>
+            </a:r>
+            <a:r>
+              <a:rPr lang="en-US" dirty="0"/>
+              <a:t>3.0.4.544</a:t>
+            </a:r>
+            <a:br>
+              <a:rPr lang="en-US" dirty="0"/>
+            </a:br>
+            <a:r>
+              <a:rPr lang="en-US" sz="1600" dirty="0"/>
+              <a:t>2016-06-28</a:t>
             </a:r>
             <a:endParaRPr lang="en-US" dirty="0"/>
           </a:p>
@@ -4957,71 +4916,158 @@
             <p:ph idx="1"/>
           </p:nvPr>
         </p:nvSpPr>
-        <p:spPr/>
+        <p:spPr>
+          <a:xfrm>
+            <a:off x="539553" y="1628800"/>
+            <a:ext cx="8064896" cy="4353347"/>
+          </a:xfrm>
+        </p:spPr>
         <p:txBody>
           <a:bodyPr/>
           <a:lstStyle/>
           <a:p>
             <a:r>
               <a:rPr lang="en-US" dirty="0" smtClean="0"/>
-              <a:t>The </a:t>
-            </a:r>
+              <a:t>Main </a:t>
+            </a:r>
+            <a:r>
+              <a:rPr lang="en-US" dirty="0"/>
+              <a:t>Updates</a:t>
+            </a:r>
+          </a:p>
+          <a:p>
+            <a:pPr lvl="1"/>
+            <a:r>
+              <a:rPr lang="en-US" dirty="0" smtClean="0"/>
+              <a:t>New </a:t>
+            </a:r>
+            <a:r>
+              <a:rPr lang="en-US" dirty="0"/>
+              <a:t>gear shift strategy according to White Book </a:t>
+            </a:r>
+            <a:r>
+              <a:rPr lang="en-US" dirty="0" smtClean="0"/>
+              <a:t>2016</a:t>
+            </a:r>
+          </a:p>
+          <a:p>
+            <a:pPr lvl="1"/>
+            <a:r>
+              <a:rPr lang="en-US" dirty="0" smtClean="0"/>
+              <a:t>New </a:t>
+            </a:r>
+            <a:r>
+              <a:rPr lang="en-US" dirty="0"/>
+              <a:t>coasting strategy according to White Book 2016</a:t>
+            </a:r>
+          </a:p>
+          <a:p>
+            <a:pPr lvl="1"/>
+            <a:r>
+              <a:rPr lang="en-US" dirty="0" smtClean="0"/>
+              <a:t>New </a:t>
+            </a:r>
+            <a:r>
+              <a:rPr lang="en-US" dirty="0"/>
+              <a:t>input parameters (</a:t>
+            </a:r>
+            <a:r>
+              <a:rPr lang="en-US" dirty="0" err="1"/>
+              <a:t>enineering</a:t>
+            </a:r>
+            <a:r>
+              <a:rPr lang="en-US" dirty="0"/>
+              <a:t> mode) for coasting and gear shift behavior</a:t>
+            </a:r>
+          </a:p>
+          <a:p>
+            <a:pPr lvl="1"/>
+            <a:r>
+              <a:rPr lang="en-US" dirty="0" smtClean="0"/>
+              <a:t>Use </a:t>
+            </a:r>
+            <a:r>
+              <a:rPr lang="en-US" dirty="0"/>
+              <a:t>SI units in Advanced Auxiliaries Module and compile with strict compiler settings (no implicit casts, etc.)</a:t>
+            </a:r>
+          </a:p>
+          <a:p>
+            <a:pPr lvl="1"/>
+            <a:r>
+              <a:rPr lang="en-US" dirty="0" smtClean="0"/>
+              <a:t>Allow </a:t>
+            </a:r>
+            <a:r>
+              <a:rPr lang="en-US" dirty="0"/>
+              <a:t>efficiency for transmission losses (in engineering mode)</a:t>
+            </a:r>
+          </a:p>
+          <a:p>
+            <a:endParaRPr lang="en-US" dirty="0"/>
+          </a:p>
+          <a:p>
             <a:r>
               <a:rPr lang="en-US" dirty="0" err="1" smtClean="0"/>
-              <a:t>AdvancedAuxiliaries</a:t>
-            </a:r>
-            <a:r>
-              <a:rPr lang="en-US" dirty="0" smtClean="0"/>
-              <a:t> module requires the number of activations for pneumatic consumers (brakes, doors, kneeling) and the (estimated) total cycle time. This can be configured in the .APAC-file (actuations file). For standard bus/coach cycles (i.e., the cycle file contains “bus” </a:t>
-            </a:r>
-            <a:r>
-              <a:rPr lang="en-US" b="1" dirty="0" smtClean="0"/>
-              <a:t>and</a:t>
-            </a:r>
-            <a:r>
-              <a:rPr lang="en-US" dirty="0" smtClean="0"/>
-              <a:t> “</a:t>
-            </a:r>
+              <a:t>Bugfixes</a:t>
+            </a:r>
+            <a:endParaRPr lang="en-US" dirty="0"/>
+          </a:p>
+          <a:p>
+            <a:pPr lvl="1"/>
+            <a:r>
+              <a:rPr lang="en-US" dirty="0" smtClean="0"/>
+              <a:t>Auxiliary </a:t>
+            </a:r>
+            <a:r>
+              <a:rPr lang="en-US" dirty="0" err="1"/>
+              <a:t>TechList</a:t>
+            </a:r>
+            <a:r>
+              <a:rPr lang="en-US" dirty="0"/>
+              <a:t> not read from JSON input data</a:t>
+            </a:r>
+          </a:p>
+          <a:p>
+            <a:pPr lvl="1"/>
+            <a:r>
+              <a:rPr lang="en-US" dirty="0" smtClean="0"/>
+              <a:t>Improvements </a:t>
+            </a:r>
+            <a:r>
+              <a:rPr lang="en-US" dirty="0"/>
+              <a:t>in driver strategy</a:t>
+            </a:r>
+          </a:p>
+          <a:p>
+            <a:pPr lvl="1"/>
             <a:r>
               <a:rPr lang="en-US" dirty="0" err="1" smtClean="0"/>
-              <a:t>heavy_urban</a:t>
-            </a:r>
-            <a:r>
-              <a:rPr lang="en-US" dirty="0" smtClean="0"/>
-              <a:t>” or “suburban” or “interurban” or “urban”; </a:t>
-            </a:r>
-            <a:r>
-              <a:rPr lang="en-US" b="1" dirty="0" smtClean="0"/>
-              <a:t>or</a:t>
-            </a:r>
-            <a:r>
-              <a:rPr lang="en-US" dirty="0" smtClean="0"/>
-              <a:t> the cycle contains “coach” (</a:t>
-            </a:r>
-            <a:r>
-              <a:rPr lang="en-US" i="1" dirty="0" smtClean="0"/>
-              <a:t>case insensitive</a:t>
-            </a:r>
-            <a:r>
-              <a:rPr lang="en-US" dirty="0" smtClean="0"/>
-              <a:t>)) the actuations file already contains the number of activations and the cycle time. For other cycles the filename without extension is used to lookup the activations in the .APAC file (</a:t>
-            </a:r>
-            <a:r>
-              <a:rPr lang="en-US" i="1" dirty="0" smtClean="0"/>
-              <a:t>case sensitive</a:t>
-            </a:r>
-            <a:r>
-              <a:rPr lang="en-US" dirty="0" smtClean="0"/>
-              <a:t>)</a:t>
-            </a:r>
-            <a:endParaRPr lang="en-US" dirty="0"/>
+              <a:t>Bugfixes</a:t>
+            </a:r>
+            <a:r>
+              <a:rPr lang="en-US" dirty="0" smtClean="0"/>
+              <a:t> </a:t>
+            </a:r>
+            <a:r>
+              <a:rPr lang="en-US" dirty="0"/>
+              <a:t>in </a:t>
+            </a:r>
+            <a:r>
+              <a:rPr lang="en-US" dirty="0" err="1"/>
+              <a:t>MeasuredSpeed</a:t>
+            </a:r>
+            <a:r>
+              <a:rPr lang="en-US" dirty="0"/>
+              <a:t> mode</a:t>
+            </a:r>
+            <a:endParaRPr lang="en-US" dirty="0" smtClean="0"/>
           </a:p>
         </p:txBody>
       </p:sp>
     </p:spTree>
     <p:extLst>
       <p:ext uri="{BB962C8B-B14F-4D97-AF65-F5344CB8AC3E}">
-        <p14:creationId xmlns:p14="http://schemas.microsoft.com/office/powerpoint/2010/main" val="3750013638"/>
+        <p14:creationId xmlns:p14="http://schemas.microsoft.com/office/powerpoint/2010/main" val="3997910218"/>
       </p:ext>
     </p:extLst>
   </p:cSld>
@@ -5065,12 +5111,7 @@
             <p:ph type="title"/>
           </p:nvPr>
         </p:nvSpPr>
-        <p:spPr>
-          <a:xfrm>
-            <a:off x="467544" y="548680"/>
-            <a:ext cx="8218487" cy="504056"/>
-          </a:xfrm>
-        </p:spPr>
+        <p:spPr/>
         <p:txBody>
           <a:bodyPr/>
           <a:lstStyle/>
@@ -5085,7 +5126,7 @@
             </a:r>
             <a:r>
               <a:rPr lang="en-US" dirty="0" smtClean="0"/>
-              <a:t> 3.x with AAUX (2)</a:t>
+              <a:t> 3.x with AAUX (1)</a:t>
             </a:r>
             <a:endParaRPr lang="en-US" dirty="0"/>
           </a:p>
@@ -5101,218 +5142,71 @@
             <p:ph idx="1"/>
           </p:nvPr>
         </p:nvSpPr>
-        <p:spPr>
-          <a:xfrm>
-            <a:off x="179511" y="1124744"/>
-            <a:ext cx="8856985" cy="5328592"/>
-          </a:xfrm>
-        </p:spPr>
+        <p:spPr/>
         <p:txBody>
           <a:bodyPr/>
           <a:lstStyle/>
           <a:p>
             <a:r>
+              <a:rPr lang="en-US" dirty="0" smtClean="0"/>
+              <a:t>The </a:t>
+            </a:r>
+            <a:r>
               <a:rPr lang="en-US" dirty="0" err="1" smtClean="0"/>
-              <a:t>Vecto</a:t>
-            </a:r>
-            <a:r>
-              <a:rPr lang="en-US" dirty="0" smtClean="0"/>
-              <a:t> 3 uses an average auxiliaries load (determined by the AAUX module depending on the settings)</a:t>
-            </a:r>
-            <a:r>
-              <a:rPr lang="en-US" dirty="0"/>
-              <a:t> for the </a:t>
-            </a:r>
-            <a:r>
-              <a:rPr lang="en-US" dirty="0" smtClean="0"/>
-              <a:t>simulation. The AAUX module computes the fuel consumption in parallel to </a:t>
+              <a:t>AdvancedAuxiliaries</a:t>
+            </a:r>
+            <a:r>
+              <a:rPr lang="en-US" dirty="0" smtClean="0"/>
+              <a:t> module requires the number of activations for pneumatic consumers (brakes, doors, kneeling) and the (estimated) total cycle time. This can be configured in the .APAC-file (actuations file). For standard bus/coach cycles (i.e., the cycle file contains “bus” </a:t>
+            </a:r>
+            <a:r>
+              <a:rPr lang="en-US" b="1" dirty="0" smtClean="0"/>
+              <a:t>and</a:t>
+            </a:r>
+            <a:r>
+              <a:rPr lang="en-US" dirty="0" smtClean="0"/>
+              <a:t> “</a:t>
             </a:r>
             <a:r>
               <a:rPr lang="en-US" dirty="0" err="1" smtClean="0"/>
-              <a:t>VectoCore</a:t>
-            </a:r>
-            <a:r>
-              <a:rPr lang="en-US" dirty="0" smtClean="0"/>
-              <a:t> and accounts for smart consumers (e.g., alternator, pneumatics, …).</a:t>
-            </a:r>
-          </a:p>
-          <a:p>
-            <a:r>
-              <a:rPr lang="en-US" dirty="0" smtClean="0"/>
-              <a:t>Output</a:t>
-            </a:r>
-          </a:p>
-          <a:p>
-            <a:pPr lvl="1"/>
-            <a:r>
-              <a:rPr lang="en-US" dirty="0" smtClean="0"/>
-              <a:t>The .</a:t>
-            </a:r>
-            <a:r>
-              <a:rPr lang="en-US" dirty="0" err="1" smtClean="0"/>
-              <a:t>vmod</a:t>
-            </a:r>
-            <a:r>
-              <a:rPr lang="en-US" dirty="0" smtClean="0"/>
-              <a:t> file contains both, the fuel consumption calculated by </a:t>
-            </a:r>
-            <a:r>
-              <a:rPr lang="en-US" dirty="0" err="1" smtClean="0"/>
-              <a:t>VectoCore</a:t>
-            </a:r>
-            <a:r>
-              <a:rPr lang="en-US" dirty="0" smtClean="0"/>
-              <a:t> (per simulation interval) and AAUX (accumulated and per simulation interval).</a:t>
-            </a:r>
-            <a:br>
-              <a:rPr lang="en-US" dirty="0" smtClean="0"/>
-            </a:br>
-            <a:r>
-              <a:rPr lang="en-US" dirty="0" smtClean="0"/>
-              <a:t>Columns in .</a:t>
-            </a:r>
-            <a:r>
-              <a:rPr lang="en-US" dirty="0" err="1" smtClean="0"/>
-              <a:t>vmod</a:t>
-            </a:r>
-            <a:r>
-              <a:rPr lang="en-US" dirty="0" smtClean="0"/>
-              <a:t> file:</a:t>
-            </a:r>
-          </a:p>
-          <a:p>
-            <a:pPr lvl="2"/>
-            <a:r>
-              <a:rPr lang="en-US" dirty="0" err="1"/>
-              <a:t>AA_TotalCycleFC_Grams</a:t>
-            </a:r>
-            <a:r>
-              <a:rPr lang="en-US" dirty="0"/>
-              <a:t> [g</a:t>
-            </a:r>
-            <a:r>
-              <a:rPr lang="en-US" dirty="0" smtClean="0"/>
-              <a:t>]: accumulated fuel consumption as computed by the AAUX model, considering smart consumers</a:t>
-            </a:r>
-          </a:p>
-          <a:p>
-            <a:pPr lvl="2"/>
-            <a:r>
-              <a:rPr lang="en-US" dirty="0" smtClean="0"/>
-              <a:t>FC-Map </a:t>
-            </a:r>
-            <a:r>
-              <a:rPr lang="en-US" dirty="0"/>
-              <a:t>[</a:t>
-            </a:r>
-            <a:r>
-              <a:rPr lang="en-US" dirty="0" smtClean="0"/>
-              <a:t>g/h]: fuel consumption as computed by </a:t>
-            </a:r>
-            <a:r>
-              <a:rPr lang="en-US" dirty="0" err="1" smtClean="0"/>
-              <a:t>VectoCore</a:t>
-            </a:r>
-            <a:r>
-              <a:rPr lang="en-US" dirty="0" smtClean="0"/>
-              <a:t> interpolating </a:t>
-            </a:r>
-            <a:r>
-              <a:rPr lang="en-US" dirty="0"/>
-              <a:t>in the FC-Map, </a:t>
-            </a:r>
-            <a:r>
-              <a:rPr lang="en-US" dirty="0" smtClean="0"/>
-              <a:t>using an average base load of auxiliaries</a:t>
-            </a:r>
-          </a:p>
-          <a:p>
-            <a:pPr lvl="2"/>
-            <a:r>
-              <a:rPr lang="en-US" dirty="0" smtClean="0"/>
-              <a:t>FC-</a:t>
-            </a:r>
-            <a:r>
-              <a:rPr lang="en-US" dirty="0" err="1" smtClean="0"/>
-              <a:t>AUXc</a:t>
-            </a:r>
-            <a:r>
-              <a:rPr lang="en-US" dirty="0" smtClean="0"/>
-              <a:t> </a:t>
-            </a:r>
-            <a:r>
-              <a:rPr lang="en-US" dirty="0"/>
-              <a:t>[g/h</a:t>
-            </a:r>
-            <a:r>
-              <a:rPr lang="en-US" dirty="0" smtClean="0"/>
-              <a:t>]: fuel consumption corrected due to engine stop/start (currently not applicable)</a:t>
-            </a:r>
-          </a:p>
-          <a:p>
-            <a:pPr lvl="2"/>
-            <a:r>
-              <a:rPr lang="en-US" dirty="0" smtClean="0"/>
-              <a:t>FC-</a:t>
-            </a:r>
-            <a:r>
-              <a:rPr lang="en-US" dirty="0" err="1" smtClean="0"/>
-              <a:t>WHTCc</a:t>
-            </a:r>
-            <a:r>
-              <a:rPr lang="en-US" dirty="0" smtClean="0"/>
-              <a:t> </a:t>
-            </a:r>
-            <a:r>
-              <a:rPr lang="en-US" dirty="0"/>
-              <a:t>[g/h</a:t>
-            </a:r>
-            <a:r>
-              <a:rPr lang="en-US" dirty="0" smtClean="0"/>
-              <a:t>]: WHTC-corrected fuel consumption (not applicable in engineering mode)</a:t>
-            </a:r>
-          </a:p>
-          <a:p>
-            <a:pPr lvl="2"/>
-            <a:r>
-              <a:rPr lang="en-US" dirty="0" smtClean="0"/>
-              <a:t>FC-AAUX </a:t>
-            </a:r>
-            <a:r>
-              <a:rPr lang="en-US" dirty="0"/>
-              <a:t>[</a:t>
-            </a:r>
-            <a:r>
-              <a:rPr lang="en-US" dirty="0" smtClean="0"/>
-              <a:t>g/h]: fuel consumption per simulation interval, derived from </a:t>
-            </a:r>
-            <a:r>
-              <a:rPr lang="en-US" dirty="0" err="1" smtClean="0"/>
-              <a:t>AA_TotalCycleFC_Grams</a:t>
-            </a:r>
-            <a:endParaRPr lang="en-US" dirty="0" smtClean="0"/>
-          </a:p>
-          <a:p>
-            <a:pPr lvl="2"/>
-            <a:r>
-              <a:rPr lang="en-US" dirty="0" smtClean="0"/>
-              <a:t>FC-Final </a:t>
-            </a:r>
-            <a:r>
-              <a:rPr lang="en-US" dirty="0"/>
-              <a:t>[g/h</a:t>
-            </a:r>
-            <a:r>
-              <a:rPr lang="en-US" dirty="0" smtClean="0"/>
-              <a:t>]: final fuel consumption value with all (applicable) corrections applied (stop/start, WHTC, smart auxiliaries)</a:t>
-            </a:r>
+              <a:t>heavy_urban</a:t>
+            </a:r>
+            <a:r>
+              <a:rPr lang="en-US" dirty="0" smtClean="0"/>
+              <a:t>” or “suburban” or “interurban” or “urban”; </a:t>
+            </a:r>
+            <a:r>
+              <a:rPr lang="en-US" b="1" dirty="0" smtClean="0"/>
+              <a:t>or</a:t>
+            </a:r>
+            <a:r>
+              <a:rPr lang="en-US" dirty="0" smtClean="0"/>
+              <a:t> the cycle contains “coach” (</a:t>
+            </a:r>
+            <a:r>
+              <a:rPr lang="en-US" i="1" dirty="0" smtClean="0"/>
+              <a:t>case insensitive</a:t>
+            </a:r>
+            <a:r>
+              <a:rPr lang="en-US" dirty="0" smtClean="0"/>
+              <a:t>)) the actuations file already contains the number of activations and the cycle time. For other cycles the filename without extension is used to lookup the activations in the .APAC file (</a:t>
+            </a:r>
+            <a:r>
+              <a:rPr lang="en-US" i="1" dirty="0" smtClean="0"/>
+              <a:t>case sensitive</a:t>
+            </a:r>
+            <a:r>
+              <a:rPr lang="en-US" dirty="0" smtClean="0"/>
+              <a:t>)</a:t>
+            </a:r>
+            <a:endParaRPr lang="en-US" dirty="0"/>
           </a:p>
         </p:txBody>
       </p:sp>
     </p:spTree>
     <p:extLst>
       <p:ext uri="{BB962C8B-B14F-4D97-AF65-F5344CB8AC3E}">
-        <p14:creationId xmlns:p14="http://schemas.microsoft.com/office/powerpoint/2010/main" val="1949919211"/>
+        <p14:creationId xmlns:p14="http://schemas.microsoft.com/office/powerpoint/2010/main" val="3750013638"/>
       </p:ext>
     </p:extLst>
   </p:cSld>
@@ -5376,7 +5270,7 @@
             </a:r>
             <a:r>
               <a:rPr lang="en-US" dirty="0" smtClean="0"/>
-              <a:t> 3.x with AAUX (3)</a:t>
+              <a:t> 3.x with AAUX (2)</a:t>
             </a:r>
             <a:endParaRPr lang="en-US" dirty="0"/>
           </a:p>
@@ -5394,8 +5288,8 @@
         </p:nvSpPr>
         <p:spPr>
           <a:xfrm>
-            <a:off x="251521" y="1628800"/>
-            <a:ext cx="8640959" cy="4608512"/>
+            <a:off x="179511" y="1124744"/>
+            <a:ext cx="8856985" cy="5328592"/>
           </a:xfrm>
         </p:spPr>
         <p:txBody>
@@ -5403,35 +5297,20 @@
           <a:lstStyle/>
           <a:p>
             <a:r>
-              <a:rPr lang="en-US" dirty="0" smtClean="0"/>
-              <a:t>Output .</a:t>
-            </a:r>
-            <a:r>
               <a:rPr lang="en-US" dirty="0" err="1" smtClean="0"/>
-              <a:t>vsum</a:t>
-            </a:r>
-            <a:endParaRPr lang="en-US" dirty="0" smtClean="0"/>
-          </a:p>
-          <a:p>
-            <a:pPr lvl="1"/>
-            <a:r>
-              <a:rPr lang="en-US" dirty="0" smtClean="0"/>
-              <a:t>Columns in .</a:t>
-            </a:r>
-            <a:r>
-              <a:rPr lang="en-US" dirty="0" err="1" smtClean="0"/>
-              <a:t>vsum</a:t>
-            </a:r>
-            <a:r>
-              <a:rPr lang="en-US" dirty="0" smtClean="0"/>
-              <a:t> file:</a:t>
-            </a:r>
-          </a:p>
-          <a:p>
-            <a:pPr lvl="2"/>
-            <a:r>
-              <a:rPr lang="en-US" dirty="0" smtClean="0"/>
-              <a:t>FC-Map: total fuel consumption as computed by </a:t>
+              <a:t>Vecto</a:t>
+            </a:r>
+            <a:r>
+              <a:rPr lang="en-US" dirty="0" smtClean="0"/>
+              <a:t> 3 uses an average auxiliaries load (determined by the AAUX module depending on the settings)</a:t>
+            </a:r>
+            <a:r>
+              <a:rPr lang="en-US" dirty="0"/>
+              <a:t> for the </a:t>
+            </a:r>
+            <a:r>
+              <a:rPr lang="en-US" dirty="0" smtClean="0"/>
+              <a:t>simulation. The AAUX module computes the fuel consumption in parallel to </a:t>
             </a:r>
             <a:r>
               <a:rPr lang="en-US" dirty="0" err="1" smtClean="0"/>
@@ -5439,7 +5318,97 @@
             </a:r>
             <a:r>
               <a:rPr lang="en-US" dirty="0" smtClean="0"/>
-              <a:t> interpolating in the FC-Map, using an average base load of auxiliaries</a:t>
+              <a:t> and accounts for smart consumers (e.g., alternator, pneumatics, …).</a:t>
+            </a:r>
+          </a:p>
+          <a:p>
+            <a:r>
+              <a:rPr lang="en-US" dirty="0" smtClean="0"/>
+              <a:t>Output</a:t>
+            </a:r>
+          </a:p>
+          <a:p>
+            <a:pPr lvl="1"/>
+            <a:r>
+              <a:rPr lang="en-US" dirty="0" smtClean="0"/>
+              <a:t>The .</a:t>
+            </a:r>
+            <a:r>
+              <a:rPr lang="en-US" dirty="0" err="1" smtClean="0"/>
+              <a:t>vmod</a:t>
+            </a:r>
+            <a:r>
+              <a:rPr lang="en-US" dirty="0" smtClean="0"/>
+              <a:t> file contains both, the fuel consumption calculated by </a:t>
+            </a:r>
+            <a:r>
+              <a:rPr lang="en-US" dirty="0" err="1" smtClean="0"/>
+              <a:t>VectoCore</a:t>
+            </a:r>
+            <a:r>
+              <a:rPr lang="en-US" dirty="0" smtClean="0"/>
+              <a:t> (per simulation interval) and AAUX (accumulated and per simulation interval).</a:t>
+            </a:r>
+            <a:br>
+              <a:rPr lang="en-US" dirty="0" smtClean="0"/>
+            </a:br>
+            <a:r>
+              <a:rPr lang="en-US" dirty="0" smtClean="0"/>
+              <a:t>Columns in .</a:t>
+            </a:r>
+            <a:r>
+              <a:rPr lang="en-US" dirty="0" err="1" smtClean="0"/>
+              <a:t>vmod</a:t>
+            </a:r>
+            <a:r>
+              <a:rPr lang="en-US" dirty="0" smtClean="0"/>
+              <a:t> file:</a:t>
+            </a:r>
+          </a:p>
+          <a:p>
+            <a:pPr lvl="2"/>
+            <a:r>
+              <a:rPr lang="en-US" dirty="0" err="1"/>
+              <a:t>AA_TotalCycleFC_Grams</a:t>
+            </a:r>
+            <a:r>
+              <a:rPr lang="en-US" dirty="0"/>
+              <a:t> [g</a:t>
+            </a:r>
+            <a:r>
+              <a:rPr lang="en-US" dirty="0" smtClean="0"/>
+              <a:t>]: accumulated fuel consumption as computed by the AAUX model, considering smart consumers</a:t>
+            </a:r>
+          </a:p>
+          <a:p>
+            <a:pPr lvl="2"/>
+            <a:r>
+              <a:rPr lang="en-US" dirty="0" smtClean="0"/>
+              <a:t>FC-Map </a:t>
+            </a:r>
+            <a:r>
+              <a:rPr lang="en-US" dirty="0"/>
+              <a:t>[</a:t>
+            </a:r>
+            <a:r>
+              <a:rPr lang="en-US" dirty="0" smtClean="0"/>
+              <a:t>g/h]: fuel consumption as computed by </a:t>
+            </a:r>
+            <a:r>
+              <a:rPr lang="en-US" dirty="0" err="1" smtClean="0"/>
+              <a:t>VectoCore</a:t>
+            </a:r>
+            <a:r>
+              <a:rPr lang="en-US" dirty="0" smtClean="0"/>
+              <a:t> interpolating </a:t>
+            </a:r>
+            <a:r>
+              <a:rPr lang="en-US" dirty="0"/>
+              <a:t>in the FC-Map, </a:t>
+            </a:r>
+            <a:r>
+              <a:rPr lang="en-US" dirty="0" smtClean="0"/>
+              <a:t>using an average base load of auxiliaries</a:t>
             </a:r>
           </a:p>
           <a:p>
@@ -5454,7 +5423,15 @@
             </a:r>
             <a:r>
               <a:rPr lang="en-US" dirty="0" smtClean="0"/>
-              <a:t>: total fuel consumption corrected due to engine stop/start (currently not applicable)</a:t>
+              <a:t> </a:t>
+            </a:r>
+            <a:r>
+              <a:rPr lang="en-US" dirty="0"/>
+              <a:t>[g/h</a:t>
+            </a:r>
+            <a:r>
+              <a:rPr lang="en-US" dirty="0" smtClean="0"/>
+              <a:t>]: fuel consumption corrected due to engine stop/start (currently not applicable)</a:t>
             </a:r>
           </a:p>
           <a:p>
@@ -5469,14 +5446,30 @@
             </a:r>
             <a:r>
               <a:rPr lang="en-US" dirty="0" smtClean="0"/>
-              <a:t>: WHTC-corrected fuel consumption (not applicable in engineering mode)</a:t>
+              <a:t> </a:t>
+            </a:r>
+            <a:r>
+              <a:rPr lang="en-US" dirty="0"/>
+              <a:t>[g/h</a:t>
+            </a:r>
+            <a:r>
+              <a:rPr lang="en-US" dirty="0" smtClean="0"/>
+              <a:t>]: WHTC-corrected fuel consumption (not applicable in engineering mode)</a:t>
             </a:r>
           </a:p>
           <a:p>
             <a:pPr lvl="2"/>
             <a:r>
               <a:rPr lang="en-US" dirty="0" smtClean="0"/>
-              <a:t>FC-AAUX: fuel consumption per simulation interval, derived from </a:t>
+              <a:t>FC-AAUX </a:t>
+            </a:r>
+            <a:r>
+              <a:rPr lang="en-US" dirty="0"/>
+              <a:t>[</a:t>
+            </a:r>
+            <a:r>
+              <a:rPr lang="en-US" dirty="0" smtClean="0"/>
+              <a:t>g/h]: fuel consumption per simulation interval, derived from </a:t>
             </a:r>
             <a:r>
               <a:rPr lang="en-US" dirty="0" err="1" smtClean="0"/>
@@ -5488,7 +5481,15 @@
             <a:pPr lvl="2"/>
             <a:r>
               <a:rPr lang="en-US" dirty="0" smtClean="0"/>
-              <a:t>FC-Final: final fuel consumption value with all (applicable) corrections applied (stop/start, WHTC, smart auxiliaries)</a:t>
+              <a:t>FC-Final </a:t>
+            </a:r>
+            <a:r>
+              <a:rPr lang="en-US" dirty="0"/>
+              <a:t>[g/h</a:t>
+            </a:r>
+            <a:r>
+              <a:rPr lang="en-US" dirty="0" smtClean="0"/>
+              <a:t>]: final fuel consumption value with all (applicable) corrections applied (stop/start, WHTC, smart auxiliaries)</a:t>
             </a:r>
           </a:p>
         </p:txBody>
@@ -5496,7 +5497,7 @@
     </p:spTree>
     <p:extLst>
       <p:ext uri="{BB962C8B-B14F-4D97-AF65-F5344CB8AC3E}">
-        <p14:creationId xmlns:p14="http://schemas.microsoft.com/office/powerpoint/2010/main" val="120205155"/>
+        <p14:creationId xmlns:p14="http://schemas.microsoft.com/office/powerpoint/2010/main" val="1949919211"/>
       </p:ext>
     </p:extLst>
   </p:cSld>
@@ -5542,8 +5543,8 @@
         </p:nvSpPr>
         <p:spPr>
           <a:xfrm>
-            <a:off x="468315" y="570359"/>
-            <a:ext cx="8218487" cy="482377"/>
+            <a:off x="467544" y="548680"/>
+            <a:ext cx="8218487" cy="504056"/>
           </a:xfrm>
         </p:spPr>
         <p:txBody>
@@ -5551,23 +5552,16 @@
           <a:lstStyle/>
           <a:p>
             <a:r>
+              <a:rPr lang="en-US" dirty="0" smtClean="0"/>
+              <a:t>Notes for using </a:t>
+            </a:r>
+            <a:r>
               <a:rPr lang="en-US" dirty="0" err="1" smtClean="0"/>
               <a:t>Vecto</a:t>
             </a:r>
             <a:r>
               <a:rPr lang="en-US" dirty="0" smtClean="0"/>
-              <a:t> </a:t>
-            </a:r>
-            <a:r>
-              <a:rPr lang="en-US" dirty="0"/>
-              <a:t>3.0.3.537</a:t>
-            </a:r>
-            <a:br>
-              <a:rPr lang="en-US" dirty="0"/>
-            </a:br>
-            <a:r>
-              <a:rPr lang="en-US" sz="1600" dirty="0"/>
-              <a:t>2016-06-21</a:t>
+              <a:t> 3.x with AAUX (3)</a:t>
             </a:r>
             <a:endParaRPr lang="en-US" dirty="0"/>
           </a:p>
@@ -5585,8 +5579,8 @@
         </p:nvSpPr>
         <p:spPr>
           <a:xfrm>
-            <a:off x="179512" y="1124744"/>
-            <a:ext cx="8784975" cy="4857403"/>
+            <a:off x="251521" y="1628800"/>
+            <a:ext cx="8640959" cy="4608512"/>
           </a:xfrm>
         </p:spPr>
         <p:txBody>
@@ -5595,171 +5589,99 @@
           <a:p>
             <a:r>
               <a:rPr lang="en-US" dirty="0" smtClean="0"/>
-              <a:t>Main Updates</a:t>
-            </a:r>
-          </a:p>
-          <a:p>
-            <a:pPr lvl="1"/>
-            <a:r>
-              <a:rPr lang="en-US" dirty="0" smtClean="0"/>
-              <a:t>Plot shift lines as computed according to WB 2016 declaration mode in GUI</a:t>
-            </a:r>
-          </a:p>
-          <a:p>
-            <a:r>
-              <a:rPr lang="en-US" dirty="0" err="1" smtClean="0"/>
-              <a:t>Bugfixes</a:t>
-            </a:r>
-            <a:endParaRPr lang="en-US" dirty="0" smtClean="0"/>
-          </a:p>
-          <a:p>
-            <a:pPr lvl="1"/>
-            <a:r>
-              <a:rPr lang="en-US" dirty="0" smtClean="0"/>
-              <a:t>GUI: Buttons to add/remove auxiliaries are visible again</a:t>
-            </a:r>
-          </a:p>
-          <a:p>
-            <a:pPr lvl="1"/>
-            <a:r>
-              <a:rPr lang="en-US" dirty="0" smtClean="0"/>
-              <a:t>Error in calculation of WHTC correction factor</a:t>
-            </a:r>
-          </a:p>
-          <a:p>
-            <a:pPr lvl="1"/>
-            <a:r>
-              <a:rPr lang="en-US" dirty="0" smtClean="0"/>
-              <a:t>Fix: consider gearbox inertia (engineering mode) for searching operating point</a:t>
-            </a:r>
-          </a:p>
-          <a:p>
-            <a:pPr lvl="1"/>
-            <a:r>
-              <a:rPr lang="en-US" dirty="0" smtClean="0"/>
-              <a:t>Wrong output of road gradient in measured speed mode (correct gradient for simulation)</a:t>
-            </a:r>
-          </a:p>
-          <a:p>
-            <a:pPr lvl="1"/>
-            <a:r>
-              <a:rPr lang="en-US" dirty="0" smtClean="0"/>
-              <a:t>Fuel consumption in .</a:t>
+              <a:t>Output .</a:t>
             </a:r>
             <a:r>
               <a:rPr lang="en-US" dirty="0" err="1" smtClean="0"/>
               <a:t>vsum</a:t>
             </a:r>
-            <a:r>
-              <a:rPr lang="en-US" dirty="0" smtClean="0"/>
-              <a:t> file now accounts for </a:t>
+            <a:endParaRPr lang="en-US" dirty="0" smtClean="0"/>
+          </a:p>
+          <a:p>
+            <a:pPr lvl="1"/>
+            <a:r>
+              <a:rPr lang="en-US" dirty="0" smtClean="0"/>
+              <a:t>Columns in .</a:t>
             </a:r>
             <a:r>
               <a:rPr lang="en-US" dirty="0" err="1" smtClean="0"/>
-              <a:t>AdvancedAuxiliaries</a:t>
-            </a:r>
-            <a:r>
-              <a:rPr lang="en-US" dirty="0" smtClean="0"/>
-              <a:t> model</a:t>
-            </a:r>
-          </a:p>
-          <a:p>
-            <a:pPr lvl="1"/>
+              <a:t>vsum</a:t>
+            </a:r>
+            <a:r>
+              <a:rPr lang="en-US" dirty="0" smtClean="0"/>
+              <a:t> file:</a:t>
+            </a:r>
+          </a:p>
+          <a:p>
+            <a:pPr lvl="2"/>
+            <a:r>
+              <a:rPr lang="en-US" dirty="0" smtClean="0"/>
+              <a:t>FC-Map: total fuel consumption as computed by </a:t>
+            </a:r>
             <a:r>
               <a:rPr lang="en-US" dirty="0" err="1" smtClean="0"/>
-              <a:t>GraphDrawer</a:t>
-            </a:r>
-            <a:r>
-              <a:rPr lang="en-US" dirty="0" smtClean="0"/>
-              <a:t> (</a:t>
+              <a:t>VectoCore</a:t>
+            </a:r>
+            <a:r>
+              <a:rPr lang="en-US" dirty="0" smtClean="0"/>
+              <a:t> interpolating in the FC-Map, using an average base load of auxiliaries</a:t>
+            </a:r>
+          </a:p>
+          <a:p>
+            <a:pPr lvl="2"/>
+            <a:r>
+              <a:rPr lang="en-US" dirty="0" smtClean="0"/>
+              <a:t>FC-</a:t>
             </a:r>
             <a:r>
               <a:rPr lang="en-US" dirty="0" err="1" smtClean="0"/>
-              <a:t>Vecto</a:t>
-            </a:r>
-            <a:r>
-              <a:rPr lang="en-US" dirty="0" smtClean="0"/>
-              <a:t>): handle new .</a:t>
+              <a:t>AUXc</a:t>
+            </a:r>
+            <a:r>
+              <a:rPr lang="en-US" dirty="0" smtClean="0"/>
+              <a:t>: total fuel consumption corrected due to engine stop/start (currently not applicable)</a:t>
+            </a:r>
+          </a:p>
+          <a:p>
+            <a:pPr lvl="2"/>
+            <a:r>
+              <a:rPr lang="en-US" dirty="0" smtClean="0"/>
+              <a:t>FC-</a:t>
             </a:r>
             <a:r>
               <a:rPr lang="en-US" dirty="0" err="1" smtClean="0"/>
-              <a:t>vmod</a:t>
-            </a:r>
-            <a:r>
-              <a:rPr lang="en-US" dirty="0" smtClean="0"/>
-              <a:t> format of </a:t>
+              <a:t>WHTCc</a:t>
+            </a:r>
+            <a:r>
+              <a:rPr lang="en-US" dirty="0" smtClean="0"/>
+              <a:t>: WHTC-corrected fuel consumption (not applicable in engineering mode)</a:t>
+            </a:r>
+          </a:p>
+          <a:p>
+            <a:pPr lvl="2"/>
+            <a:r>
+              <a:rPr lang="en-US" dirty="0" smtClean="0"/>
+              <a:t>FC-AAUX: fuel consumption per simulation interval, derived from </a:t>
             </a:r>
             <a:r>
               <a:rPr lang="en-US" dirty="0" err="1" smtClean="0"/>
-              <a:t>Vecto</a:t>
-            </a:r>
-            <a:r>
-              <a:rPr lang="en-US" dirty="0" smtClean="0"/>
-              <a:t> 3</a:t>
-            </a:r>
-          </a:p>
-          <a:p>
-            <a:pPr lvl="1"/>
-            <a:r>
-              <a:rPr lang="en-US" dirty="0" err="1" smtClean="0"/>
-              <a:t>AdvancedAuxiliaries</a:t>
-            </a:r>
-            <a:r>
-              <a:rPr lang="en-US" dirty="0" smtClean="0"/>
-              <a:t>: language-settings independent input parsing</a:t>
-            </a:r>
-          </a:p>
-          <a:p>
-            <a:pPr lvl="1"/>
-            <a:r>
-              <a:rPr lang="en-US" dirty="0" err="1" smtClean="0"/>
-              <a:t>Paux</a:t>
-            </a:r>
-            <a:r>
-              <a:rPr lang="en-US" dirty="0" smtClean="0"/>
-              <a:t> was ignored when running </a:t>
-            </a:r>
-            <a:r>
-              <a:rPr lang="en-US" dirty="0" err="1" smtClean="0"/>
-              <a:t>Vecto</a:t>
-            </a:r>
-            <a:r>
-              <a:rPr lang="en-US" dirty="0" smtClean="0"/>
-              <a:t> 2.2</a:t>
-            </a:r>
-          </a:p>
-          <a:p>
-            <a:pPr lvl="1"/>
-            <a:r>
-              <a:rPr lang="en-US" dirty="0" smtClean="0"/>
-              <a:t>Error in massive multithreaded execution</a:t>
-            </a:r>
-          </a:p>
-          <a:p>
-            <a:pPr lvl="1"/>
-            <a:r>
-              <a:rPr lang="en-US" dirty="0" smtClean="0"/>
-              <a:t>Fix unhandled response during simulation</a:t>
-            </a:r>
-          </a:p>
-          <a:p>
-            <a:pPr lvl="1"/>
-            <a:r>
-              <a:rPr lang="en-US" dirty="0" smtClean="0"/>
-              <a:t>Fix output columns in .</a:t>
-            </a:r>
-            <a:r>
-              <a:rPr lang="en-US" dirty="0" err="1" smtClean="0"/>
-              <a:t>vmod</a:t>
+              <a:t>AA_TotalCycleFC_Grams</a:t>
             </a:r>
             <a:endParaRPr lang="en-US" dirty="0" smtClean="0"/>
+          </a:p>
+          <a:p>
+            <a:pPr lvl="2"/>
+            <a:r>
+              <a:rPr lang="en-US" dirty="0" smtClean="0"/>
+              <a:t>FC-Final: final fuel consumption value with all (applicable) corrections applied (stop/start, WHTC, smart auxiliaries)</a:t>
+            </a:r>
           </a:p>
         </p:txBody>
       </p:sp>
     </p:spTree>
     <p:extLst>
       <p:ext uri="{BB962C8B-B14F-4D97-AF65-F5344CB8AC3E}">
-        <p14:creationId xmlns:p14="http://schemas.microsoft.com/office/powerpoint/2010/main" val="4096386672"/>
+        <p14:creationId xmlns:p14="http://schemas.microsoft.com/office/powerpoint/2010/main" val="120205155"/>
       </p:ext>
     </p:extLst>
   </p:cSld>
@@ -5803,6 +5725,269 @@
             <p:ph type="title"/>
           </p:nvPr>
         </p:nvSpPr>
+        <p:spPr>
+          <a:xfrm>
+            <a:off x="468315" y="570359"/>
+            <a:ext cx="8218487" cy="482377"/>
+          </a:xfrm>
+        </p:spPr>
+        <p:txBody>
+          <a:bodyPr/>
+          <a:lstStyle/>
+          <a:p>
+            <a:r>
+              <a:rPr lang="en-US" dirty="0" err="1" smtClean="0"/>
+              <a:t>Vecto</a:t>
+            </a:r>
+            <a:r>
+              <a:rPr lang="en-US" dirty="0" smtClean="0"/>
+              <a:t> </a:t>
+            </a:r>
+            <a:r>
+              <a:rPr lang="en-US" dirty="0"/>
+              <a:t>3.0.3.537</a:t>
+            </a:r>
+            <a:br>
+              <a:rPr lang="en-US" dirty="0"/>
+            </a:br>
+            <a:r>
+              <a:rPr lang="en-US" sz="1600" dirty="0"/>
+              <a:t>2016-06-21</a:t>
+            </a:r>
+            <a:endParaRPr lang="en-US" dirty="0"/>
+          </a:p>
+        </p:txBody>
+      </p:sp>
+      <p:sp>
+        <p:nvSpPr>
+          <p:cNvPr id="3" name="Inhaltsplatzhalter 2"/>
+          <p:cNvSpPr>
+            <a:spLocks noGrp="1"/>
+          </p:cNvSpPr>
+          <p:nvPr>
+            <p:ph idx="1"/>
+          </p:nvPr>
+        </p:nvSpPr>
+        <p:spPr>
+          <a:xfrm>
+            <a:off x="179512" y="1124744"/>
+            <a:ext cx="8784975" cy="4857403"/>
+          </a:xfrm>
+        </p:spPr>
+        <p:txBody>
+          <a:bodyPr/>
+          <a:lstStyle/>
+          <a:p>
+            <a:r>
+              <a:rPr lang="en-US" dirty="0" smtClean="0"/>
+              <a:t>Main Updates</a:t>
+            </a:r>
+          </a:p>
+          <a:p>
+            <a:pPr lvl="1"/>
+            <a:r>
+              <a:rPr lang="en-US" dirty="0" smtClean="0"/>
+              <a:t>Plot shift lines as computed according to WB 2016 declaration mode in GUI</a:t>
+            </a:r>
+          </a:p>
+          <a:p>
+            <a:r>
+              <a:rPr lang="en-US" dirty="0" err="1" smtClean="0"/>
+              <a:t>Bugfixes</a:t>
+            </a:r>
+            <a:endParaRPr lang="en-US" dirty="0" smtClean="0"/>
+          </a:p>
+          <a:p>
+            <a:pPr lvl="1"/>
+            <a:r>
+              <a:rPr lang="en-US" dirty="0" smtClean="0"/>
+              <a:t>GUI: Buttons to add/remove auxiliaries are visible again</a:t>
+            </a:r>
+          </a:p>
+          <a:p>
+            <a:pPr lvl="1"/>
+            <a:r>
+              <a:rPr lang="en-US" dirty="0" smtClean="0"/>
+              <a:t>Error in calculation of WHTC correction factor</a:t>
+            </a:r>
+          </a:p>
+          <a:p>
+            <a:pPr lvl="1"/>
+            <a:r>
+              <a:rPr lang="en-US" dirty="0" smtClean="0"/>
+              <a:t>Fix: consider gearbox inertia (engineering mode) for searching operating point</a:t>
+            </a:r>
+          </a:p>
+          <a:p>
+            <a:pPr lvl="1"/>
+            <a:r>
+              <a:rPr lang="en-US" dirty="0" smtClean="0"/>
+              <a:t>Wrong output of road gradient in measured speed mode (correct gradient for simulation)</a:t>
+            </a:r>
+          </a:p>
+          <a:p>
+            <a:pPr lvl="1"/>
+            <a:r>
+              <a:rPr lang="en-US" dirty="0" smtClean="0"/>
+              <a:t>Fuel consumption in .</a:t>
+            </a:r>
+            <a:r>
+              <a:rPr lang="en-US" dirty="0" err="1" smtClean="0"/>
+              <a:t>vsum</a:t>
+            </a:r>
+            <a:r>
+              <a:rPr lang="en-US" dirty="0" smtClean="0"/>
+              <a:t> file now accounts for </a:t>
+            </a:r>
+            <a:r>
+              <a:rPr lang="en-US" dirty="0" err="1" smtClean="0"/>
+              <a:t>AdvancedAuxiliaries</a:t>
+            </a:r>
+            <a:r>
+              <a:rPr lang="en-US" dirty="0" smtClean="0"/>
+              <a:t> model</a:t>
+            </a:r>
+          </a:p>
+          <a:p>
+            <a:pPr lvl="1"/>
+            <a:r>
+              <a:rPr lang="en-US" dirty="0" err="1" smtClean="0"/>
+              <a:t>GraphDrawer</a:t>
+            </a:r>
+            <a:r>
+              <a:rPr lang="en-US" dirty="0" smtClean="0"/>
+              <a:t> (</a:t>
+            </a:r>
+            <a:r>
+              <a:rPr lang="en-US" dirty="0" err="1" smtClean="0"/>
+              <a:t>Vecto</a:t>
+            </a:r>
+            <a:r>
+              <a:rPr lang="en-US" dirty="0" smtClean="0"/>
+              <a:t>): handle new .</a:t>
+            </a:r>
+            <a:r>
+              <a:rPr lang="en-US" dirty="0" err="1" smtClean="0"/>
+              <a:t>vmod</a:t>
+            </a:r>
+            <a:r>
+              <a:rPr lang="en-US" dirty="0" smtClean="0"/>
+              <a:t> format of </a:t>
+            </a:r>
+            <a:r>
+              <a:rPr lang="en-US" dirty="0" err="1" smtClean="0"/>
+              <a:t>Vecto</a:t>
+            </a:r>
+            <a:r>
+              <a:rPr lang="en-US" dirty="0" smtClean="0"/>
+              <a:t> 3</a:t>
+            </a:r>
+          </a:p>
+          <a:p>
+            <a:pPr lvl="1"/>
+            <a:r>
+              <a:rPr lang="en-US" dirty="0" err="1" smtClean="0"/>
+              <a:t>AdvancedAuxiliaries</a:t>
+            </a:r>
+            <a:r>
+              <a:rPr lang="en-US" dirty="0" smtClean="0"/>
+              <a:t>: language-settings independent input parsing</a:t>
+            </a:r>
+          </a:p>
+          <a:p>
+            <a:pPr lvl="1"/>
+            <a:r>
+              <a:rPr lang="en-US" dirty="0" err="1" smtClean="0"/>
+              <a:t>Paux</a:t>
+            </a:r>
+            <a:r>
+              <a:rPr lang="en-US" dirty="0" smtClean="0"/>
+              <a:t> was ignored when running </a:t>
+            </a:r>
+            <a:r>
+              <a:rPr lang="en-US" dirty="0" err="1" smtClean="0"/>
+              <a:t>Vecto</a:t>
+            </a:r>
+            <a:r>
+              <a:rPr lang="en-US" dirty="0" smtClean="0"/>
+              <a:t> 2.2</a:t>
+            </a:r>
+          </a:p>
+          <a:p>
+            <a:pPr lvl="1"/>
+            <a:r>
+              <a:rPr lang="en-US" dirty="0" smtClean="0"/>
+              <a:t>Error in massive multithreaded execution</a:t>
+            </a:r>
+          </a:p>
+          <a:p>
+            <a:pPr lvl="1"/>
+            <a:r>
+              <a:rPr lang="en-US" dirty="0" smtClean="0"/>
+              <a:t>Fix unhandled response during simulation</a:t>
+            </a:r>
+          </a:p>
+          <a:p>
+            <a:pPr lvl="1"/>
+            <a:r>
+              <a:rPr lang="en-US" dirty="0" smtClean="0"/>
+              <a:t>Fix output columns in .</a:t>
+            </a:r>
+            <a:r>
+              <a:rPr lang="en-US" dirty="0" err="1" smtClean="0"/>
+              <a:t>vmod</a:t>
+            </a:r>
+            <a:endParaRPr lang="en-US" dirty="0" smtClean="0"/>
+          </a:p>
+        </p:txBody>
+      </p:sp>
+    </p:spTree>
+    <p:extLst>
+      <p:ext uri="{BB962C8B-B14F-4D97-AF65-F5344CB8AC3E}">
+        <p14:creationId xmlns:p14="http://schemas.microsoft.com/office/powerpoint/2010/main" val="4096386672"/>
+      </p:ext>
+    </p:extLst>
+  </p:cSld>
+  <p:clrMapOvr>
+    <a:masterClrMapping/>
+  </p:clrMapOvr>
+  <p:timing>
+    <p:tnLst>
+      <p:par>
+        <p:cTn id="1" dur="indefinite" restart="never" nodeType="tmRoot"/>
+      </p:par>
+    </p:tnLst>
+  </p:timing>
+</p:sld>
+</file>
+
+<file path=ppt/slides/slide16.xml><?xml version="1.0" encoding="utf-8"?>
+<p:sld xmlns:a="http://schemas.openxmlformats.org/drawingml/2006/main" xmlns:r="http://schemas.openxmlformats.org/officeDocument/2006/relationships" xmlns:p="http://schemas.openxmlformats.org/presentationml/2006/main">
+  <p:cSld>
+    <p:spTree>
+      <p:nvGrpSpPr>
+        <p:cNvPr id="1" name=""/>
+        <p:cNvGrpSpPr/>
+        <p:nvPr/>
+      </p:nvGrpSpPr>
+      <p:grpSpPr>
+        <a:xfrm>
+          <a:off x="0" y="0"/>
+          <a:ext cx="0" cy="0"/>
+          <a:chOff x="0" y="0"/>
+          <a:chExt cx="0" cy="0"/>
+        </a:xfrm>
+      </p:grpSpPr>
+      <p:sp>
+        <p:nvSpPr>
+          <p:cNvPr id="2" name="Titel 1"/>
+          <p:cNvSpPr>
+            <a:spLocks noGrp="1"/>
+          </p:cNvSpPr>
+          <p:nvPr>
+            <p:ph type="title"/>
+          </p:nvPr>
+        </p:nvSpPr>
         <p:spPr/>
         <p:txBody>
           <a:bodyPr/>
@@ -5961,7 +6146,7 @@
 </p:sld>
 </file>
 
-<file path=ppt/slides/slide16.xml><?xml version="1.0" encoding="utf-8"?>
+<file path=ppt/slides/slide17.xml><?xml version="1.0" encoding="utf-8"?>
 <p:sld xmlns:a="http://schemas.openxmlformats.org/drawingml/2006/main" xmlns:r="http://schemas.openxmlformats.org/officeDocument/2006/relationships" xmlns:p="http://schemas.openxmlformats.org/presentationml/2006/main">
   <p:cSld>
     <p:spTree>
@@ -6146,7 +6331,7 @@
 </p:sld>
 </file>
 
-<file path=ppt/slides/slide17.xml><?xml version="1.0" encoding="utf-8"?>
+<file path=ppt/slides/slide18.xml><?xml version="1.0" encoding="utf-8"?>
 <p:sld xmlns:a="http://schemas.openxmlformats.org/drawingml/2006/main" xmlns:r="http://schemas.openxmlformats.org/officeDocument/2006/relationships" xmlns:p="http://schemas.openxmlformats.org/presentationml/2006/main">
   <p:cSld>
     <p:spTree>
@@ -6736,188 +6921,6 @@
 </p:sld>
 </file>
 
-<file path=ppt/slides/slide18.xml><?xml version="1.0" encoding="utf-8"?>
-<p:sld xmlns:a="http://schemas.openxmlformats.org/drawingml/2006/main" xmlns:r="http://schemas.openxmlformats.org/officeDocument/2006/relationships" xmlns:p="http://schemas.openxmlformats.org/presentationml/2006/main">
-  <p:cSld>
-    <p:spTree>
-      <p:nvGrpSpPr>
-        <p:cNvPr id="1" name=""/>
-        <p:cNvGrpSpPr/>
-        <p:nvPr/>
-      </p:nvGrpSpPr>
-      <p:grpSpPr>
-        <a:xfrm>
-          <a:off x="0" y="0"/>
-          <a:ext cx="0" cy="0"/>
-          <a:chOff x="0" y="0"/>
-          <a:chExt cx="0" cy="0"/>
-        </a:xfrm>
-      </p:grpSpPr>
-      <p:sp>
-        <p:nvSpPr>
-          <p:cNvPr id="2" name="Titel 1"/>
-          <p:cNvSpPr>
-            <a:spLocks noGrp="1"/>
-          </p:cNvSpPr>
-          <p:nvPr>
-            <p:ph type="title"/>
-          </p:nvPr>
-        </p:nvSpPr>
-        <p:spPr/>
-        <p:txBody>
-          <a:bodyPr/>
-          <a:lstStyle/>
-          <a:p>
-            <a:r>
-              <a:rPr lang="en-US" dirty="0" err="1" smtClean="0"/>
-              <a:t>Pwheel</a:t>
-            </a:r>
-            <a:r>
-              <a:rPr lang="en-US" dirty="0" smtClean="0"/>
-              <a:t> (</a:t>
-            </a:r>
-            <a:r>
-              <a:rPr lang="en-US" dirty="0" err="1" smtClean="0"/>
-              <a:t>SiCo</a:t>
-            </a:r>
-            <a:r>
-              <a:rPr lang="en-US" dirty="0" smtClean="0"/>
-              <a:t>) Mode</a:t>
-            </a:r>
-            <a:endParaRPr lang="en-US" dirty="0"/>
-          </a:p>
-        </p:txBody>
-      </p:sp>
-      <p:sp>
-        <p:nvSpPr>
-          <p:cNvPr id="3" name="Inhaltsplatzhalter 2"/>
-          <p:cNvSpPr>
-            <a:spLocks noGrp="1"/>
-          </p:cNvSpPr>
-          <p:nvPr>
-            <p:ph idx="1"/>
-          </p:nvPr>
-        </p:nvSpPr>
-        <p:spPr/>
-        <p:txBody>
-          <a:bodyPr/>
-          <a:lstStyle/>
-          <a:p>
-            <a:r>
-              <a:rPr lang="en-US" dirty="0" smtClean="0"/>
-              <a:t>Function as already available in </a:t>
-            </a:r>
-            <a:r>
-              <a:rPr lang="en-US" dirty="0" err="1" smtClean="0"/>
-              <a:t>Vecto</a:t>
-            </a:r>
-            <a:r>
-              <a:rPr lang="en-US" dirty="0" smtClean="0"/>
-              <a:t> 2.2 also added in </a:t>
-            </a:r>
-            <a:r>
-              <a:rPr lang="en-US" dirty="0" err="1" smtClean="0"/>
-              <a:t>Vecto</a:t>
-            </a:r>
-            <a:r>
-              <a:rPr lang="en-US" dirty="0" smtClean="0"/>
-              <a:t> 3.0.2</a:t>
-            </a:r>
-          </a:p>
-          <a:p>
-            <a:pPr lvl="1"/>
-            <a:r>
-              <a:rPr lang="en-US" dirty="0" smtClean="0"/>
-              <a:t>Driving cycle specifies power at wheel, engine speed, gear, and auxiliary power</a:t>
-            </a:r>
-          </a:p>
-          <a:p>
-            <a:pPr lvl="1"/>
-            <a:r>
-              <a:rPr lang="en-US" dirty="0"/>
-              <a:t>No driver model in the simulation.</a:t>
-            </a:r>
-          </a:p>
-          <a:p>
-            <a:pPr lvl="1"/>
-            <a:r>
-              <a:rPr lang="en-US" dirty="0" smtClean="0"/>
-              <a:t>The </a:t>
-            </a:r>
-            <a:r>
-              <a:rPr lang="en-US" dirty="0" err="1"/>
-              <a:t>Vecto</a:t>
-            </a:r>
-            <a:r>
-              <a:rPr lang="en-US" dirty="0"/>
-              <a:t> gear-shift model is overruled.</a:t>
-            </a:r>
-          </a:p>
-          <a:p>
-            <a:pPr lvl="1"/>
-            <a:r>
-              <a:rPr lang="en-US" dirty="0"/>
-              <a:t>Function used for </a:t>
-            </a:r>
-            <a:r>
-              <a:rPr lang="en-US" dirty="0" smtClean="0"/>
-              <a:t>creating reference results for </a:t>
-            </a:r>
-            <a:r>
-              <a:rPr lang="en-US" dirty="0" err="1" smtClean="0"/>
-              <a:t>SiCo</a:t>
-            </a:r>
-            <a:r>
-              <a:rPr lang="en-US" dirty="0" smtClean="0"/>
-              <a:t> tests</a:t>
-            </a:r>
-          </a:p>
-          <a:p>
-            <a:pPr lvl="1"/>
-            <a:r>
-              <a:rPr lang="en-US" dirty="0" smtClean="0"/>
-              <a:t>For details see user manual: Simulation Models / </a:t>
-            </a:r>
-            <a:r>
-              <a:rPr lang="en-US" dirty="0" err="1" smtClean="0"/>
-              <a:t>Pwheel</a:t>
-            </a:r>
-            <a:r>
-              <a:rPr lang="en-US" dirty="0" smtClean="0"/>
-              <a:t> Input (</a:t>
-            </a:r>
-            <a:r>
-              <a:rPr lang="en-US" dirty="0" err="1" smtClean="0"/>
-              <a:t>SiCo</a:t>
-            </a:r>
-            <a:r>
-              <a:rPr lang="en-US" dirty="0" smtClean="0"/>
-              <a:t>)</a:t>
-            </a:r>
-            <a:endParaRPr lang="en-US" dirty="0"/>
-          </a:p>
-          <a:p>
-            <a:pPr lvl="1"/>
-            <a:endParaRPr lang="en-US" dirty="0" smtClean="0"/>
-          </a:p>
-          <a:p>
-            <a:endParaRPr lang="en-US" dirty="0"/>
-          </a:p>
-        </p:txBody>
-      </p:sp>
-    </p:spTree>
-    <p:extLst>
-      <p:ext uri="{BB962C8B-B14F-4D97-AF65-F5344CB8AC3E}">
-        <p14:creationId xmlns:p14="http://schemas.microsoft.com/office/powerpoint/2010/main" val="3176522223"/>
-      </p:ext>
-    </p:extLst>
-  </p:cSld>
-  <p:clrMapOvr>
-    <a:masterClrMapping/>
-  </p:clrMapOvr>
-</p:sld>
-</file>
-
 <file path=ppt/slides/slide19.xml><?xml version="1.0" encoding="utf-8"?>
 <p:sld xmlns:a="http://schemas.openxmlformats.org/drawingml/2006/main" xmlns:r="http://schemas.openxmlformats.org/officeDocument/2006/relationships" xmlns:p="http://schemas.openxmlformats.org/presentationml/2006/main">
   <p:cSld>
@@ -6951,8 +6954,20 @@
           <a:lstStyle/>
           <a:p>
             <a:r>
-              <a:rPr lang="en-US" dirty="0" smtClean="0"/>
-              <a:t>Measured Speed Mode</a:t>
+              <a:rPr lang="en-US" dirty="0" err="1" smtClean="0"/>
+              <a:t>Pwheel</a:t>
+            </a:r>
+            <a:r>
+              <a:rPr lang="en-US" dirty="0" smtClean="0"/>
+              <a:t> (</a:t>
+            </a:r>
+            <a:r>
+              <a:rPr lang="en-US" dirty="0" err="1" smtClean="0"/>
+              <a:t>SiCo</a:t>
+            </a:r>
+            <a:r>
+              <a:rPr lang="en-US" dirty="0" smtClean="0"/>
+              <a:t>) Mode</a:t>
             </a:r>
             <a:endParaRPr lang="en-US" dirty="0"/>
           </a:p>
@@ -6975,7 +6990,7 @@
           <a:p>
             <a:r>
               <a:rPr lang="en-US" dirty="0" smtClean="0"/>
-              <a:t>Functionality already available in </a:t>
+              <a:t>Function as already available in </a:t>
             </a:r>
             <a:r>
               <a:rPr lang="en-US" dirty="0" err="1" smtClean="0"/>
@@ -6983,7 +6998,7 @@
             </a:r>
             <a:r>
               <a:rPr lang="en-US" dirty="0" smtClean="0"/>
-              <a:t> 2.2 added in </a:t>
+              <a:t> 2.2 also added in </a:t>
             </a:r>
             <a:r>
               <a:rPr lang="en-US" dirty="0" err="1" smtClean="0"/>
@@ -6998,37 +7013,79 @@
             <a:pPr lvl="1"/>
             <a:r>
               <a:rPr lang="en-US" dirty="0" smtClean="0"/>
-              <a:t>Driving cycle not defined by target speed but by actual speed. No driver model in the simulation.</a:t>
+              <a:t>Driving cycle specifies power at wheel, engine speed, gear, and auxiliary power</a:t>
             </a:r>
           </a:p>
           <a:p>
             <a:pPr lvl="1"/>
             <a:r>
-              <a:rPr lang="en-US" dirty="0" smtClean="0"/>
-              <a:t>Gear and engine speed can be specified in the driving cycle. In this case the </a:t>
+              <a:rPr lang="en-US" dirty="0"/>
+              <a:t>No driver model in the simulation.</a:t>
+            </a:r>
+          </a:p>
+          <a:p>
+            <a:pPr lvl="1"/>
+            <a:r>
+              <a:rPr lang="en-US" dirty="0" smtClean="0"/>
+              <a:t>The </a:t>
+            </a:r>
+            <a:r>
+              <a:rPr lang="en-US" dirty="0" err="1"/>
+              <a:t>Vecto</a:t>
+            </a:r>
+            <a:r>
+              <a:rPr lang="en-US" dirty="0"/>
+              <a:t> gear-shift model is overruled.</a:t>
+            </a:r>
+          </a:p>
+          <a:p>
+            <a:pPr lvl="1"/>
+            <a:r>
+              <a:rPr lang="en-US" dirty="0"/>
+              <a:t>Function used for </a:t>
+            </a:r>
+            <a:r>
+              <a:rPr lang="en-US" dirty="0" smtClean="0"/>
+              <a:t>creating reference results for </a:t>
             </a:r>
             <a:r>
               <a:rPr lang="en-US" dirty="0" err="1" smtClean="0"/>
-              <a:t>Vecto</a:t>
-            </a:r>
-            <a:r>
-              <a:rPr lang="en-US" dirty="0" smtClean="0"/>
-              <a:t> gear-shift model is overruled.</a:t>
+              <a:t>SiCo</a:t>
+            </a:r>
+            <a:r>
+              <a:rPr lang="en-US" dirty="0" smtClean="0"/>
+              <a:t> tests</a:t>
             </a:r>
           </a:p>
           <a:p>
             <a:pPr lvl="1"/>
             <a:r>
               <a:rPr lang="en-US" dirty="0" smtClean="0"/>
-              <a:t>Function used for “proof of concept” purposes</a:t>
-            </a:r>
+              <a:t>For details see user manual: Simulation Models / </a:t>
+            </a:r>
+            <a:r>
+              <a:rPr lang="en-US" dirty="0" err="1" smtClean="0"/>
+              <a:t>Pwheel</a:t>
+            </a:r>
+            <a:r>
+              <a:rPr lang="en-US" dirty="0" smtClean="0"/>
+              <a:t> Input (</a:t>
+            </a:r>
+            <a:r>
+              <a:rPr lang="en-US" dirty="0" err="1" smtClean="0"/>
+              <a:t>SiCo</a:t>
+            </a:r>
+            <a:r>
+              <a:rPr lang="en-US" dirty="0" smtClean="0"/>
+              <a:t>)</a:t>
+            </a:r>
+            <a:endParaRPr lang="en-US" dirty="0"/>
           </a:p>
           <a:p>
             <a:pPr lvl="1"/>
-            <a:r>
-              <a:rPr lang="en-US" dirty="0" smtClean="0"/>
-              <a:t>For details see user manual: Calculation Modes / Engineering Mode / Measured Speed</a:t>
-            </a:r>
+            <a:endParaRPr lang="en-US" dirty="0" smtClean="0"/>
+          </a:p>
+          <a:p>
             <a:endParaRPr lang="en-US" dirty="0"/>
           </a:p>
         </p:txBody>
@@ -7036,7 +7093,7 @@
     </p:spTree>
     <p:extLst>
       <p:ext uri="{BB962C8B-B14F-4D97-AF65-F5344CB8AC3E}">
-        <p14:creationId xmlns:p14="http://schemas.microsoft.com/office/powerpoint/2010/main" val="3735808897"/>
+        <p14:creationId xmlns:p14="http://schemas.microsoft.com/office/powerpoint/2010/main" val="3176522223"/>
       </p:ext>
     </p:extLst>
   </p:cSld>
@@ -7088,23 +7145,23 @@
               <a:t>Vecto</a:t>
             </a:r>
             <a:r>
-              <a:rPr lang="en-US"/>
+              <a:rPr lang="en-US" dirty="0"/>
               <a:t> </a:t>
             </a:r>
             <a:r>
-              <a:rPr lang="en-US" smtClean="0"/>
-              <a:t>3.1.1.742</a:t>
-            </a:r>
-            <a:r>
-              <a:rPr lang="en-US"/>
+              <a:rPr lang="en-US" dirty="0" smtClean="0"/>
+              <a:t>3.1.1.748</a:t>
+            </a:r>
+            <a:r>
+              <a:rPr lang="en-US" dirty="0"/>
               <a:t/>
             </a:r>
             <a:br>
-              <a:rPr lang="en-US"/>
+              <a:rPr lang="en-US" dirty="0"/>
             </a:br>
             <a:r>
-              <a:rPr lang="en-US" sz="1600" smtClean="0"/>
-              <a:t>2017-01-12</a:t>
+              <a:rPr lang="en-US" sz="1600" dirty="0" smtClean="0"/>
+              <a:t>2017-01-18</a:t>
             </a:r>
             <a:endParaRPr lang="en-US" sz="1600" dirty="0"/>
           </a:p>
@@ -7122,8 +7179,8 @@
         </p:nvSpPr>
         <p:spPr>
           <a:xfrm>
-            <a:off x="323529" y="1196752"/>
-            <a:ext cx="8640960" cy="5184576"/>
+            <a:off x="323529" y="1628800"/>
+            <a:ext cx="8640960" cy="4752528"/>
           </a:xfrm>
         </p:spPr>
         <p:txBody>
@@ -7134,101 +7191,6 @@
               <a:buNone/>
             </a:pPr>
             <a:r>
-              <a:rPr lang="en-US" sz="1400" b="1" dirty="0" smtClean="0"/>
-              <a:t>Improvements:</a:t>
-            </a:r>
-          </a:p>
-          <a:p>
-            <a:r>
-              <a:rPr lang="en-US" sz="1400" dirty="0" smtClean="0"/>
-              <a:t>[VECTO-390, VECTO-400] Adapt engine speed to estimated engine speed after gear shift during traction interruption (double clutching)</a:t>
-            </a:r>
-          </a:p>
-          <a:p>
-            <a:r>
-              <a:rPr lang="en-US" sz="1400" dirty="0"/>
-              <a:t>[VECTO-396, VECTO-388] Add shift losses for AT power shifts</a:t>
-            </a:r>
-          </a:p>
-          <a:p>
-            <a:r>
-              <a:rPr lang="en-US" sz="1400" dirty="0"/>
-              <a:t>[VECTO-389] new gear shift rules for AT gearboxes</a:t>
-            </a:r>
-          </a:p>
-          <a:p>
-            <a:r>
-              <a:rPr lang="en-US" sz="1400" dirty="0"/>
-              <a:t>[VECTO-387] added max input speed for torque converter</a:t>
-            </a:r>
-          </a:p>
-          <a:p>
-            <a:r>
-              <a:rPr lang="en-US" sz="1400" dirty="0"/>
-              <a:t>[VECTO-385] Automatically add generic torque converter data for </a:t>
-            </a:r>
-            <a:r>
-              <a:rPr lang="en-US" sz="1400" dirty="0" smtClean="0"/>
-              <a:t>drag</a:t>
-            </a:r>
-          </a:p>
-          <a:p>
-            <a:r>
-              <a:rPr lang="en-US" sz="1400" dirty="0" smtClean="0"/>
-              <a:t>[VECTO-399] Add missions and loadings for vehicle categories 11, 12, and 16 (declaration mode)</a:t>
-            </a:r>
-          </a:p>
-          <a:p>
-            <a:r>
-              <a:rPr lang="en-US" sz="1400" dirty="0"/>
-              <a:t>[VECTO-384] cleanup memory after simulation run</a:t>
-            </a:r>
-          </a:p>
-          <a:p>
-            <a:r>
-              <a:rPr lang="en-US" sz="1400" dirty="0" smtClean="0"/>
-              <a:t>[VECTO-394] new option for </a:t>
-            </a:r>
-            <a:r>
-              <a:rPr lang="en-US" sz="1400" dirty="0" err="1" smtClean="0"/>
-              <a:t>vectocmd</a:t>
-            </a:r>
-            <a:r>
-              <a:rPr lang="en-US" sz="1400" dirty="0" smtClean="0"/>
-              <a:t> to disable all output</a:t>
-            </a:r>
-          </a:p>
-          <a:p>
-            <a:r>
-              <a:rPr lang="en-US" sz="1400" dirty="0" smtClean="0"/>
-              <a:t>[VECTO-392] make the GUI scale depending on the Windows font size</a:t>
-            </a:r>
-          </a:p>
-          <a:p>
-            <a:r>
-              <a:rPr lang="en-US" sz="1400" dirty="0" smtClean="0"/>
-              <a:t>[VECTO-391] Gearbox output speed and output torque added to .</a:t>
-            </a:r>
-            <a:r>
-              <a:rPr lang="en-US" sz="1400" dirty="0" err="1" smtClean="0"/>
-              <a:t>vmod</a:t>
-            </a:r>
-            <a:r>
-              <a:rPr lang="en-US" sz="1400" dirty="0" smtClean="0"/>
-              <a:t> files</a:t>
-            </a:r>
-          </a:p>
-          <a:p>
-            <a:r>
-              <a:rPr lang="en-US" sz="1400" dirty="0" smtClean="0"/>
-              <a:t>[VECTO-386] Gearbox window: disable input fields not applicable for the selected gearbox type</a:t>
-            </a:r>
-          </a:p>
-          <a:p>
-            <a:pPr marL="0" indent="0">
-              <a:buNone/>
-            </a:pPr>
-            <a:r>
               <a:rPr lang="en-US" sz="1400" b="1" dirty="0" err="1" smtClean="0"/>
               <a:t>Bugfixes</a:t>
             </a:r>
@@ -7240,27 +7202,19 @@
           <a:p>
             <a:r>
               <a:rPr lang="en-US" sz="1400" dirty="0" smtClean="0"/>
-              <a:t>[VECTO-401] Computation of n_95h etc. fails if engine’s max torque is constant 0 </a:t>
-            </a:r>
-          </a:p>
-          <a:p>
+              <a:t>[</a:t>
+            </a:r>
+            <a:r>
+              <a:rPr lang="en-US" sz="1400" dirty="0"/>
+              <a:t>VECTO-404] Driving Cycle with PTO </a:t>
+            </a:r>
             <a:r>
               <a:rPr lang="en-US" sz="1400" dirty="0" smtClean="0"/>
-              <a:t>Lookup of </a:t>
-            </a:r>
-            <a:r>
-              <a:rPr lang="en-US" sz="1400" dirty="0" err="1" smtClean="0"/>
-              <a:t>Airdrag</a:t>
-            </a:r>
-            <a:r>
-              <a:rPr lang="en-US" sz="1400" dirty="0" smtClean="0"/>
-              <a:t> parameters in declaration mode</a:t>
-            </a:r>
-          </a:p>
-          <a:p>
-            <a:r>
-              <a:rPr lang="en-US" sz="1400" dirty="0" smtClean="0"/>
-              <a:t>[VECTO-378] Improved file-handling in AAUX module</a:t>
+              <a:t>stopped simulation </a:t>
+            </a:r>
+            <a:r>
+              <a:rPr lang="en-US" sz="1400" dirty="0"/>
+              <a:t>after first PTO activation</a:t>
             </a:r>
             <a:endParaRPr lang="en-US" sz="1400" dirty="0"/>
           </a:p>
@@ -7320,15 +7274,7 @@
           <a:p>
             <a:r>
               <a:rPr lang="en-US" dirty="0" smtClean="0"/>
-              <a:t>.</a:t>
-            </a:r>
-            <a:r>
-              <a:rPr lang="en-US" dirty="0" err="1" smtClean="0"/>
-              <a:t>vmod</a:t>
-            </a:r>
-            <a:r>
-              <a:rPr lang="en-US" dirty="0" smtClean="0"/>
-              <a:t> File Update</a:t>
+              <a:t>Measured Speed Mode</a:t>
             </a:r>
             <a:endParaRPr lang="en-US" dirty="0"/>
           </a:p>
@@ -7350,6 +7296,142 @@
           <a:lstStyle/>
           <a:p>
             <a:r>
+              <a:rPr lang="en-US" dirty="0" smtClean="0"/>
+              <a:t>Functionality already available in </a:t>
+            </a:r>
+            <a:r>
+              <a:rPr lang="en-US" dirty="0" err="1" smtClean="0"/>
+              <a:t>Vecto</a:t>
+            </a:r>
+            <a:r>
+              <a:rPr lang="en-US" dirty="0" smtClean="0"/>
+              <a:t> 2.2 added in </a:t>
+            </a:r>
+            <a:r>
+              <a:rPr lang="en-US" dirty="0" err="1" smtClean="0"/>
+              <a:t>Vecto</a:t>
+            </a:r>
+            <a:r>
+              <a:rPr lang="en-US" dirty="0" smtClean="0"/>
+              <a:t> 3.0.2</a:t>
+            </a:r>
+          </a:p>
+          <a:p>
+            <a:pPr lvl="1"/>
+            <a:r>
+              <a:rPr lang="en-US" dirty="0" smtClean="0"/>
+              <a:t>Driving cycle not defined by target speed but by actual speed. No driver model in the simulation.</a:t>
+            </a:r>
+          </a:p>
+          <a:p>
+            <a:pPr lvl="1"/>
+            <a:r>
+              <a:rPr lang="en-US" dirty="0" smtClean="0"/>
+              <a:t>Gear and engine speed can be specified in the driving cycle. In this case the </a:t>
+            </a:r>
+            <a:r>
+              <a:rPr lang="en-US" dirty="0" err="1" smtClean="0"/>
+              <a:t>Vecto</a:t>
+            </a:r>
+            <a:r>
+              <a:rPr lang="en-US" dirty="0" smtClean="0"/>
+              <a:t> gear-shift model is overruled.</a:t>
+            </a:r>
+          </a:p>
+          <a:p>
+            <a:pPr lvl="1"/>
+            <a:r>
+              <a:rPr lang="en-US" dirty="0" smtClean="0"/>
+              <a:t>Function used for “proof of concept” purposes</a:t>
+            </a:r>
+          </a:p>
+          <a:p>
+            <a:pPr lvl="1"/>
+            <a:r>
+              <a:rPr lang="en-US" dirty="0" smtClean="0"/>
+              <a:t>For details see user manual: Calculation Modes / Engineering Mode / Measured Speed</a:t>
+            </a:r>
+            <a:endParaRPr lang="en-US" dirty="0"/>
+          </a:p>
+        </p:txBody>
+      </p:sp>
+    </p:spTree>
+    <p:extLst>
+      <p:ext uri="{BB962C8B-B14F-4D97-AF65-F5344CB8AC3E}">
+        <p14:creationId xmlns:p14="http://schemas.microsoft.com/office/powerpoint/2010/main" val="3735808897"/>
+      </p:ext>
+    </p:extLst>
+  </p:cSld>
+  <p:clrMapOvr>
+    <a:masterClrMapping/>
+  </p:clrMapOvr>
+</p:sld>
+</file>
+
+<file path=ppt/slides/slide21.xml><?xml version="1.0" encoding="utf-8"?>
+<p:sld xmlns:a="http://schemas.openxmlformats.org/drawingml/2006/main" xmlns:r="http://schemas.openxmlformats.org/officeDocument/2006/relationships" xmlns:p="http://schemas.openxmlformats.org/presentationml/2006/main">
+  <p:cSld>
+    <p:spTree>
+      <p:nvGrpSpPr>
+        <p:cNvPr id="1" name=""/>
+        <p:cNvGrpSpPr/>
+        <p:nvPr/>
+      </p:nvGrpSpPr>
+      <p:grpSpPr>
+        <a:xfrm>
+          <a:off x="0" y="0"/>
+          <a:ext cx="0" cy="0"/>
+          <a:chOff x="0" y="0"/>
+          <a:chExt cx="0" cy="0"/>
+        </a:xfrm>
+      </p:grpSpPr>
+      <p:sp>
+        <p:nvSpPr>
+          <p:cNvPr id="2" name="Titel 1"/>
+          <p:cNvSpPr>
+            <a:spLocks noGrp="1"/>
+          </p:cNvSpPr>
+          <p:nvPr>
+            <p:ph type="title"/>
+          </p:nvPr>
+        </p:nvSpPr>
+        <p:spPr/>
+        <p:txBody>
+          <a:bodyPr/>
+          <a:lstStyle/>
+          <a:p>
+            <a:r>
+              <a:rPr lang="en-US" dirty="0" smtClean="0"/>
+              <a:t>.</a:t>
+            </a:r>
+            <a:r>
+              <a:rPr lang="en-US" dirty="0" err="1" smtClean="0"/>
+              <a:t>vmod</a:t>
+            </a:r>
+            <a:r>
+              <a:rPr lang="en-US" dirty="0" smtClean="0"/>
+              <a:t> File Update</a:t>
+            </a:r>
+            <a:endParaRPr lang="en-US" dirty="0"/>
+          </a:p>
+        </p:txBody>
+      </p:sp>
+      <p:sp>
+        <p:nvSpPr>
+          <p:cNvPr id="3" name="Inhaltsplatzhalter 2"/>
+          <p:cNvSpPr>
+            <a:spLocks noGrp="1"/>
+          </p:cNvSpPr>
+          <p:nvPr>
+            <p:ph idx="1"/>
+          </p:nvPr>
+        </p:nvSpPr>
+        <p:spPr/>
+        <p:txBody>
+          <a:bodyPr/>
+          <a:lstStyle/>
+          <a:p>
+            <a:r>
               <a:rPr lang="en-US" dirty="0"/>
               <a:t>In </a:t>
             </a:r>
@@ -7412,7 +7494,7 @@
 </p:sld>
 </file>
 
-<file path=ppt/slides/slide21.xml><?xml version="1.0" encoding="utf-8"?>
+<file path=ppt/slides/slide22.xml><?xml version="1.0" encoding="utf-8"?>
 <p:sld xmlns:a="http://schemas.openxmlformats.org/drawingml/2006/main" xmlns:r="http://schemas.openxmlformats.org/officeDocument/2006/relationships" xmlns:p="http://schemas.openxmlformats.org/presentationml/2006/main">
   <p:cSld>
     <p:spTree>
@@ -7894,24 +7976,25 @@
               <a:t>Vecto</a:t>
             </a:r>
             <a:r>
-              <a:rPr lang="en-US" dirty="0"/>
+              <a:rPr lang="en-US"/>
               <a:t> </a:t>
             </a:r>
             <a:r>
-              <a:rPr lang="en-US" dirty="0" smtClean="0"/>
-              <a:t>3.1.0.683</a:t>
-            </a:r>
-            <a:r>
-              <a:rPr lang="en-US" dirty="0"/>
+              <a:rPr lang="en-US" smtClean="0"/>
+              <a:t>3.1.1.742</a:t>
+            </a:r>
+            <a:r>
+              <a:rPr lang="en-US"/>
               <a:t/>
             </a:r>
             <a:br>
-              <a:rPr lang="en-US" dirty="0"/>
+              <a:rPr lang="en-US"/>
             </a:br>
             <a:r>
-              <a:rPr lang="en-US" sz="1600" dirty="0"/>
-              <a:t>2016-11-14</a:t>
-            </a:r>
+              <a:rPr lang="en-US" sz="1600" smtClean="0"/>
+              <a:t>2017-01-12</a:t>
+            </a:r>
+            <a:endParaRPr lang="en-US" sz="1600" dirty="0"/>
           </a:p>
         </p:txBody>
       </p:sp>
@@ -7939,6 +8022,245 @@
               <a:buNone/>
             </a:pPr>
             <a:r>
+              <a:rPr lang="en-US" sz="1400" b="1" dirty="0" smtClean="0"/>
+              <a:t>Improvements:</a:t>
+            </a:r>
+          </a:p>
+          <a:p>
+            <a:r>
+              <a:rPr lang="en-US" sz="1400" dirty="0" smtClean="0"/>
+              <a:t>[VECTO-390, VECTO-400] Adapt engine speed to estimated engine speed after gear shift during traction interruption (double clutching)</a:t>
+            </a:r>
+          </a:p>
+          <a:p>
+            <a:r>
+              <a:rPr lang="en-US" sz="1400" dirty="0"/>
+              <a:t>[VECTO-396, VECTO-388] Add shift losses for AT power shifts</a:t>
+            </a:r>
+          </a:p>
+          <a:p>
+            <a:r>
+              <a:rPr lang="en-US" sz="1400" dirty="0"/>
+              <a:t>[VECTO-389] new gear shift rules for AT gearboxes</a:t>
+            </a:r>
+          </a:p>
+          <a:p>
+            <a:r>
+              <a:rPr lang="en-US" sz="1400" dirty="0"/>
+              <a:t>[VECTO-387] added max input speed for torque converter</a:t>
+            </a:r>
+          </a:p>
+          <a:p>
+            <a:r>
+              <a:rPr lang="en-US" sz="1400" dirty="0"/>
+              <a:t>[VECTO-385] Automatically add generic torque converter data for </a:t>
+            </a:r>
+            <a:r>
+              <a:rPr lang="en-US" sz="1400" dirty="0" smtClean="0"/>
+              <a:t>drag</a:t>
+            </a:r>
+          </a:p>
+          <a:p>
+            <a:r>
+              <a:rPr lang="en-US" sz="1400" dirty="0" smtClean="0"/>
+              <a:t>[VECTO-399] Add missions and loadings for vehicle categories 11, 12, and 16 (declaration mode)</a:t>
+            </a:r>
+          </a:p>
+          <a:p>
+            <a:r>
+              <a:rPr lang="en-US" sz="1400" dirty="0"/>
+              <a:t>[VECTO-384] cleanup memory after simulation run</a:t>
+            </a:r>
+          </a:p>
+          <a:p>
+            <a:r>
+              <a:rPr lang="en-US" sz="1400" dirty="0" smtClean="0"/>
+              <a:t>[VECTO-394] new option for </a:t>
+            </a:r>
+            <a:r>
+              <a:rPr lang="en-US" sz="1400" dirty="0" err="1" smtClean="0"/>
+              <a:t>vectocmd</a:t>
+            </a:r>
+            <a:r>
+              <a:rPr lang="en-US" sz="1400" dirty="0" smtClean="0"/>
+              <a:t> to disable all output</a:t>
+            </a:r>
+          </a:p>
+          <a:p>
+            <a:r>
+              <a:rPr lang="en-US" sz="1400" dirty="0" smtClean="0"/>
+              <a:t>[VECTO-392] make the GUI scale depending on the Windows font size</a:t>
+            </a:r>
+          </a:p>
+          <a:p>
+            <a:r>
+              <a:rPr lang="en-US" sz="1400" dirty="0" smtClean="0"/>
+              <a:t>[VECTO-391] Gearbox output speed and output torque added to .</a:t>
+            </a:r>
+            <a:r>
+              <a:rPr lang="en-US" sz="1400" dirty="0" err="1" smtClean="0"/>
+              <a:t>vmod</a:t>
+            </a:r>
+            <a:r>
+              <a:rPr lang="en-US" sz="1400" dirty="0" smtClean="0"/>
+              <a:t> files</a:t>
+            </a:r>
+          </a:p>
+          <a:p>
+            <a:r>
+              <a:rPr lang="en-US" sz="1400" dirty="0" smtClean="0"/>
+              <a:t>[VECTO-386] Gearbox window: disable input fields not applicable for the selected gearbox type</a:t>
+            </a:r>
+          </a:p>
+          <a:p>
+            <a:pPr marL="0" indent="0">
+              <a:buNone/>
+            </a:pPr>
+            <a:r>
+              <a:rPr lang="en-US" sz="1400" b="1" dirty="0" err="1" smtClean="0"/>
+              <a:t>Bugfixes</a:t>
+            </a:r>
+            <a:r>
+              <a:rPr lang="en-US" sz="1400" b="1" dirty="0"/>
+              <a:t>:</a:t>
+            </a:r>
+          </a:p>
+          <a:p>
+            <a:r>
+              <a:rPr lang="en-US" sz="1400" dirty="0" smtClean="0"/>
+              <a:t>[VECTO-401] Computation of n_95h etc. fails if engine’s max torque is constant 0 </a:t>
+            </a:r>
+          </a:p>
+          <a:p>
+            <a:r>
+              <a:rPr lang="en-US" sz="1400" dirty="0" smtClean="0"/>
+              <a:t>Lookup of </a:t>
+            </a:r>
+            <a:r>
+              <a:rPr lang="en-US" sz="1400" dirty="0" err="1" smtClean="0"/>
+              <a:t>Airdrag</a:t>
+            </a:r>
+            <a:r>
+              <a:rPr lang="en-US" sz="1400" dirty="0" smtClean="0"/>
+              <a:t> parameters in declaration mode</a:t>
+            </a:r>
+          </a:p>
+          <a:p>
+            <a:r>
+              <a:rPr lang="en-US" sz="1400" dirty="0" smtClean="0"/>
+              <a:t>[VECTO-378] Improved file-handling in AAUX module</a:t>
+            </a:r>
+            <a:endParaRPr lang="en-US" sz="1400" dirty="0"/>
+          </a:p>
+        </p:txBody>
+      </p:sp>
+    </p:spTree>
+    <p:extLst>
+      <p:ext uri="{BB962C8B-B14F-4D97-AF65-F5344CB8AC3E}">
+        <p14:creationId xmlns:p14="http://schemas.microsoft.com/office/powerpoint/2010/main" val="2520835531"/>
+      </p:ext>
+    </p:extLst>
+  </p:cSld>
+  <p:clrMapOvr>
+    <a:masterClrMapping/>
+  </p:clrMapOvr>
+  <p:timing>
+    <p:tnLst>
+      <p:par>
+        <p:cTn id="1" dur="indefinite" restart="never" nodeType="tmRoot"/>
+      </p:par>
+    </p:tnLst>
+  </p:timing>
+</p:sld>
+</file>
+
+<file path=ppt/slides/slide4.xml><?xml version="1.0" encoding="utf-8"?>
+<p:sld xmlns:a="http://schemas.openxmlformats.org/drawingml/2006/main" xmlns:r="http://schemas.openxmlformats.org/officeDocument/2006/relationships" xmlns:p="http://schemas.openxmlformats.org/presentationml/2006/main">
+  <p:cSld>
+    <p:spTree>
+      <p:nvGrpSpPr>
+        <p:cNvPr id="1" name=""/>
+        <p:cNvGrpSpPr/>
+        <p:nvPr/>
+      </p:nvGrpSpPr>
+      <p:grpSpPr>
+        <a:xfrm>
+          <a:off x="0" y="0"/>
+          <a:ext cx="0" cy="0"/>
+          <a:chOff x="0" y="0"/>
+          <a:chExt cx="0" cy="0"/>
+        </a:xfrm>
+      </p:grpSpPr>
+      <p:sp>
+        <p:nvSpPr>
+          <p:cNvPr id="2" name="Titel 1"/>
+          <p:cNvSpPr>
+            <a:spLocks noGrp="1"/>
+          </p:cNvSpPr>
+          <p:nvPr>
+            <p:ph type="title"/>
+          </p:nvPr>
+        </p:nvSpPr>
+        <p:spPr>
+          <a:xfrm>
+            <a:off x="468315" y="476672"/>
+            <a:ext cx="8218487" cy="681038"/>
+          </a:xfrm>
+        </p:spPr>
+        <p:txBody>
+          <a:bodyPr/>
+          <a:lstStyle/>
+          <a:p>
+            <a:r>
+              <a:rPr lang="en-US" dirty="0" err="1"/>
+              <a:t>Vecto</a:t>
+            </a:r>
+            <a:r>
+              <a:rPr lang="en-US" dirty="0"/>
+              <a:t> </a:t>
+            </a:r>
+            <a:r>
+              <a:rPr lang="en-US" dirty="0" smtClean="0"/>
+              <a:t>3.1.0.683</a:t>
+            </a:r>
+            <a:r>
+              <a:rPr lang="en-US" dirty="0"/>
+              <a:t/>
+            </a:r>
+            <a:br>
+              <a:rPr lang="en-US" dirty="0"/>
+            </a:br>
+            <a:r>
+              <a:rPr lang="en-US" sz="1600" dirty="0"/>
+              <a:t>2016-11-14</a:t>
+            </a:r>
+          </a:p>
+        </p:txBody>
+      </p:sp>
+      <p:sp>
+        <p:nvSpPr>
+          <p:cNvPr id="3" name="Inhaltsplatzhalter 2"/>
+          <p:cNvSpPr>
+            <a:spLocks noGrp="1"/>
+          </p:cNvSpPr>
+          <p:nvPr>
+            <p:ph idx="1"/>
+          </p:nvPr>
+        </p:nvSpPr>
+        <p:spPr>
+          <a:xfrm>
+            <a:off x="323529" y="1196752"/>
+            <a:ext cx="8640960" cy="5184576"/>
+          </a:xfrm>
+        </p:spPr>
+        <p:txBody>
+          <a:bodyPr/>
+          <a:lstStyle/>
+          <a:p>
+            <a:pPr marL="0" indent="0">
+              <a:buNone/>
+            </a:pPr>
+            <a:r>
               <a:rPr lang="en-US" sz="1600" b="1" dirty="0" err="1" smtClean="0"/>
               <a:t>Bugfixes</a:t>
             </a:r>
@@ -8147,7 +8469,7 @@
 </p:sld>
 </file>
 
-<file path=ppt/slides/slide4.xml><?xml version="1.0" encoding="utf-8"?>
+<file path=ppt/slides/slide5.xml><?xml version="1.0" encoding="utf-8"?>
 <p:sld xmlns:a="http://schemas.openxmlformats.org/drawingml/2006/main" xmlns:r="http://schemas.openxmlformats.org/officeDocument/2006/relationships" xmlns:p="http://schemas.openxmlformats.org/presentationml/2006/main">
   <p:cSld>
     <p:spTree>
@@ -8556,281 +8878,6 @@
 </p:sld>
 </file>
 
-<file path=ppt/slides/slide5.xml><?xml version="1.0" encoding="utf-8"?>
-<p:sld xmlns:a="http://schemas.openxmlformats.org/drawingml/2006/main" xmlns:r="http://schemas.openxmlformats.org/officeDocument/2006/relationships" xmlns:p="http://schemas.openxmlformats.org/presentationml/2006/main">
-  <p:cSld>
-    <p:spTree>
-      <p:nvGrpSpPr>
-        <p:cNvPr id="1" name=""/>
-        <p:cNvGrpSpPr/>
-        <p:nvPr/>
-      </p:nvGrpSpPr>
-      <p:grpSpPr>
-        <a:xfrm>
-          <a:off x="0" y="0"/>
-          <a:ext cx="0" cy="0"/>
-          <a:chOff x="0" y="0"/>
-          <a:chExt cx="0" cy="0"/>
-        </a:xfrm>
-      </p:grpSpPr>
-      <p:sp>
-        <p:nvSpPr>
-          <p:cNvPr id="2" name="Titel 1"/>
-          <p:cNvSpPr>
-            <a:spLocks noGrp="1"/>
-          </p:cNvSpPr>
-          <p:nvPr>
-            <p:ph type="title"/>
-          </p:nvPr>
-        </p:nvSpPr>
-        <p:spPr/>
-        <p:txBody>
-          <a:bodyPr/>
-          <a:lstStyle/>
-          <a:p>
-            <a:r>
-              <a:rPr lang="en-US" dirty="0" err="1"/>
-              <a:t>Vecto</a:t>
-            </a:r>
-            <a:r>
-              <a:rPr lang="en-US" dirty="0"/>
-              <a:t> </a:t>
-            </a:r>
-            <a:r>
-              <a:rPr lang="en-US" dirty="0" smtClean="0"/>
-              <a:t>3.1.0.662</a:t>
-            </a:r>
-            <a:br>
-              <a:rPr lang="en-US" dirty="0" smtClean="0"/>
-            </a:br>
-            <a:r>
-              <a:rPr lang="en-US" sz="1600" dirty="0" smtClean="0"/>
-              <a:t>2016-10-24</a:t>
-            </a:r>
-            <a:endParaRPr lang="en-US" sz="1600" dirty="0"/>
-          </a:p>
-        </p:txBody>
-      </p:sp>
-      <p:sp>
-        <p:nvSpPr>
-          <p:cNvPr id="3" name="Inhaltsplatzhalter 2"/>
-          <p:cNvSpPr>
-            <a:spLocks noGrp="1"/>
-          </p:cNvSpPr>
-          <p:nvPr>
-            <p:ph idx="1"/>
-          </p:nvPr>
-        </p:nvSpPr>
-        <p:spPr>
-          <a:xfrm>
-            <a:off x="468315" y="1412776"/>
-            <a:ext cx="8496173" cy="4968552"/>
-          </a:xfrm>
-        </p:spPr>
-        <p:txBody>
-          <a:bodyPr/>
-          <a:lstStyle/>
-          <a:p>
-            <a:r>
-              <a:rPr lang="en-US" sz="1800" b="1" dirty="0" err="1" smtClean="0"/>
-              <a:t>Bugfixes</a:t>
-            </a:r>
-            <a:r>
-              <a:rPr lang="en-US" sz="1800" dirty="0" smtClean="0"/>
-              <a:t>:</a:t>
-            </a:r>
-          </a:p>
-          <a:p>
-            <a:pPr lvl="1"/>
-            <a:r>
-              <a:rPr lang="en-US" sz="1600" dirty="0" smtClean="0"/>
-              <a:t>[</a:t>
-            </a:r>
-            <a:r>
-              <a:rPr lang="en-US" sz="1600" dirty="0"/>
-              <a:t>VECTO-360] Fixed error during startup of VECTO (loading of DLLs</a:t>
-            </a:r>
-            <a:r>
-              <a:rPr lang="en-US" sz="1600" dirty="0" smtClean="0"/>
-              <a:t>).</a:t>
-            </a:r>
-          </a:p>
-          <a:p>
-            <a:pPr lvl="1"/>
-            <a:r>
-              <a:rPr lang="en-US" sz="1600" dirty="0" smtClean="0"/>
-              <a:t>[</a:t>
-            </a:r>
-            <a:r>
-              <a:rPr lang="en-US" sz="1600" dirty="0"/>
-              <a:t>VECTO-358] Fixed errors during simulation where vehicle unintentionally was driving backwards. Fixed 1Hz-Filter for </a:t>
-            </a:r>
-            <a:r>
-              <a:rPr lang="en-US" sz="1600" dirty="0" err="1"/>
-              <a:t>ModFiles</a:t>
-            </a:r>
-            <a:r>
-              <a:rPr lang="en-US" sz="1600" dirty="0"/>
-              <a:t> (distance was wrong under certain circumstances, vehicle seemingly jumping back before halt</a:t>
-            </a:r>
-            <a:r>
-              <a:rPr lang="en-US" sz="1600" dirty="0" smtClean="0"/>
-              <a:t>)</a:t>
-            </a:r>
-          </a:p>
-          <a:p>
-            <a:pPr lvl="1"/>
-            <a:r>
-              <a:rPr lang="en-US" sz="1600" dirty="0" smtClean="0"/>
-              <a:t>[</a:t>
-            </a:r>
-            <a:r>
-              <a:rPr lang="en-US" sz="1600" dirty="0"/>
-              <a:t>VECTO-361] Fixed classification of vehicles with GVM of exactly </a:t>
-            </a:r>
-            <a:r>
-              <a:rPr lang="en-US" sz="1600" dirty="0" smtClean="0"/>
-              <a:t>7500kg</a:t>
-            </a:r>
-          </a:p>
-          <a:p>
-            <a:pPr lvl="1"/>
-            <a:r>
-              <a:rPr lang="en-US" sz="1600" dirty="0" smtClean="0"/>
-              <a:t>[</a:t>
-            </a:r>
-            <a:r>
-              <a:rPr lang="en-US" sz="1600" dirty="0"/>
-              <a:t>VECTO-364] Fixed an error in measured speed mode (run aborts</a:t>
-            </a:r>
-            <a:r>
-              <a:rPr lang="en-US" sz="1600" dirty="0" smtClean="0"/>
-              <a:t>).</a:t>
-            </a:r>
-          </a:p>
-          <a:p>
-            <a:pPr lvl="1"/>
-            <a:r>
-              <a:rPr lang="en-US" sz="1600" dirty="0" smtClean="0"/>
-              <a:t>[</a:t>
-            </a:r>
-            <a:r>
-              <a:rPr lang="en-US" sz="1600" dirty="0"/>
-              <a:t>VECTO-363] Compute shift polygons in declaration mode now uses correct boundary for full load </a:t>
-            </a:r>
-            <a:r>
-              <a:rPr lang="en-US" sz="1600" dirty="0" smtClean="0"/>
-              <a:t>margin.</a:t>
-            </a:r>
-          </a:p>
-          <a:p>
-            <a:pPr lvl="1"/>
-            <a:r>
-              <a:rPr lang="en-US" sz="1600" dirty="0" smtClean="0"/>
-              <a:t>[VECTO-365] Fixed </a:t>
-            </a:r>
-            <a:r>
-              <a:rPr lang="en-US" sz="1600" dirty="0"/>
-              <a:t>editing gears in declaration </a:t>
-            </a:r>
-            <a:r>
-              <a:rPr lang="en-US" sz="1600" dirty="0" smtClean="0"/>
-              <a:t>mode</a:t>
-            </a:r>
-          </a:p>
-          <a:p>
-            <a:r>
-              <a:rPr lang="en-US" sz="1800" b="1" dirty="0" smtClean="0"/>
-              <a:t>Improvements</a:t>
-            </a:r>
-            <a:r>
-              <a:rPr lang="en-US" sz="1800" dirty="0" smtClean="0"/>
-              <a:t>:</a:t>
-            </a:r>
-          </a:p>
-          <a:p>
-            <a:pPr lvl="1"/>
-            <a:r>
-              <a:rPr lang="en-US" sz="1600" dirty="0" smtClean="0"/>
-              <a:t>[</a:t>
-            </a:r>
-            <a:r>
-              <a:rPr lang="en-US" sz="1600" dirty="0"/>
-              <a:t>VECTO-355] User Manual updated (Screenshots, Descriptions, File Formats, </a:t>
-            </a:r>
-            <a:r>
-              <a:rPr lang="en-US" sz="1600" dirty="0" err="1"/>
-              <a:t>Vecto</a:t>
-            </a:r>
-            <a:r>
-              <a:rPr lang="en-US" sz="1600" dirty="0"/>
-              <a:t> V2 Comments removed</a:t>
-            </a:r>
-            <a:r>
-              <a:rPr lang="en-US" sz="1600" dirty="0" smtClean="0"/>
-              <a:t>).</a:t>
-            </a:r>
-          </a:p>
-          <a:p>
-            <a:pPr lvl="1"/>
-            <a:r>
-              <a:rPr lang="en-US" sz="1600" dirty="0" smtClean="0"/>
-              <a:t>[</a:t>
-            </a:r>
-            <a:r>
-              <a:rPr lang="en-US" sz="1600" dirty="0"/>
-              <a:t>VECTO-317] Declaration data for Wheel sizes </a:t>
-            </a:r>
-            <a:r>
-              <a:rPr lang="en-US" sz="1600" dirty="0" smtClean="0"/>
-              <a:t>updated</a:t>
-            </a:r>
-          </a:p>
-          <a:p>
-            <a:pPr lvl="1"/>
-            <a:r>
-              <a:rPr lang="en-US" sz="1600" dirty="0" smtClean="0"/>
-              <a:t>[VECTO-359</a:t>
-            </a:r>
-            <a:r>
-              <a:rPr lang="en-US" sz="1600" dirty="0"/>
-              <a:t>] Simplified code regarding PT1 behavior</a:t>
-            </a:r>
-            <a:r>
-              <a:rPr lang="en-US" sz="1600" dirty="0" smtClean="0"/>
-              <a:t>.</a:t>
-            </a:r>
-          </a:p>
-          <a:p>
-            <a:pPr lvl="1"/>
-            <a:r>
-              <a:rPr lang="en-US" sz="1600" dirty="0" smtClean="0"/>
-              <a:t>[</a:t>
-            </a:r>
-            <a:r>
-              <a:rPr lang="en-US" sz="1600" dirty="0"/>
-              <a:t>VECTO-323] PTO-Cycle may now be left empty when not used in driving </a:t>
-            </a:r>
-            <a:r>
-              <a:rPr lang="en-US" sz="1600" dirty="0" smtClean="0"/>
-              <a:t>cycle.</a:t>
-            </a:r>
-          </a:p>
-        </p:txBody>
-      </p:sp>
-    </p:spTree>
-    <p:extLst>
-      <p:ext uri="{BB962C8B-B14F-4D97-AF65-F5344CB8AC3E}">
-        <p14:creationId xmlns:p14="http://schemas.microsoft.com/office/powerpoint/2010/main" val="3892724049"/>
-      </p:ext>
-    </p:extLst>
-  </p:cSld>
-  <p:clrMapOvr>
-    <a:masterClrMapping/>
-  </p:clrMapOvr>
-</p:sld>
-</file>
-
 <file path=ppt/slides/slide6.xml><?xml version="1.0" encoding="utf-8"?>
 <p:sld xmlns:a="http://schemas.openxmlformats.org/drawingml/2006/main" xmlns:r="http://schemas.openxmlformats.org/officeDocument/2006/relationships" xmlns:p="http://schemas.openxmlformats.org/presentationml/2006/main">
   <p:cSld>
@@ -8873,14 +8920,14 @@
             </a:r>
             <a:r>
               <a:rPr lang="en-US" dirty="0" smtClean="0"/>
-              <a:t>3.1.0.652</a:t>
+              <a:t>3.1.0.662</a:t>
             </a:r>
             <a:br>
               <a:rPr lang="en-US" dirty="0" smtClean="0"/>
             </a:br>
             <a:r>
               <a:rPr lang="en-US" sz="1600" dirty="0" smtClean="0"/>
-              <a:t>2016-10-14</a:t>
+              <a:t>2016-10-24</a:t>
             </a:r>
             <a:endParaRPr lang="en-US" sz="1600" dirty="0"/>
           </a:p>
@@ -8899,7 +8946,7 @@
         <p:spPr>
           <a:xfrm>
             <a:off x="468315" y="1412776"/>
-            <a:ext cx="8496173" cy="4713387"/>
+            <a:ext cx="8496173" cy="4968552"/>
           </a:xfrm>
         </p:spPr>
         <p:txBody>
@@ -8907,125 +8954,196 @@
           <a:lstStyle/>
           <a:p>
             <a:r>
-              <a:rPr lang="en-US" dirty="0" smtClean="0"/>
-              <a:t>Main Updates</a:t>
+              <a:rPr lang="en-US" sz="1800" b="1" dirty="0" err="1" smtClean="0"/>
+              <a:t>Bugfixes</a:t>
+            </a:r>
+            <a:r>
+              <a:rPr lang="en-US" sz="1800" dirty="0" smtClean="0"/>
+              <a:t>:</a:t>
             </a:r>
           </a:p>
           <a:p>
             <a:pPr lvl="1"/>
             <a:r>
-              <a:rPr lang="en-US" dirty="0" smtClean="0"/>
-              <a:t>Removed VECTO Core 2.2</a:t>
+              <a:rPr lang="en-US" sz="1600" dirty="0" smtClean="0"/>
+              <a:t>[</a:t>
+            </a:r>
+            <a:r>
+              <a:rPr lang="en-US" sz="1600" dirty="0"/>
+              <a:t>VECTO-360] Fixed error during startup of VECTO (loading of DLLs</a:t>
+            </a:r>
+            <a:r>
+              <a:rPr lang="en-US" sz="1600" dirty="0" smtClean="0"/>
+              <a:t>).</a:t>
             </a:r>
           </a:p>
           <a:p>
             <a:pPr lvl="1"/>
             <a:r>
-              <a:rPr lang="en-US" dirty="0" smtClean="0"/>
-              <a:t>Refactoring of the User-Interface Backend: loading, saving files and validating user input uses </a:t>
-            </a:r>
-            <a:r>
-              <a:rPr lang="en-US" dirty="0" err="1" smtClean="0"/>
+              <a:rPr lang="en-US" sz="1600" dirty="0" smtClean="0"/>
+              <a:t>[</a:t>
+            </a:r>
+            <a:r>
+              <a:rPr lang="en-US" sz="1600" dirty="0"/>
+              <a:t>VECTO-358] Fixed errors during simulation where vehicle unintentionally was driving backwards. Fixed 1Hz-Filter for </a:t>
+            </a:r>
+            <a:r>
+              <a:rPr lang="en-US" sz="1600" dirty="0" err="1"/>
+              <a:t>ModFiles</a:t>
+            </a:r>
+            <a:r>
+              <a:rPr lang="en-US" sz="1600" dirty="0"/>
+              <a:t> (distance was wrong under certain circumstances, vehicle seemingly jumping back before halt</a:t>
+            </a:r>
+            <a:r>
+              <a:rPr lang="en-US" sz="1600" dirty="0" smtClean="0"/>
+              <a:t>)</a:t>
+            </a:r>
+          </a:p>
+          <a:p>
+            <a:pPr lvl="1"/>
+            <a:r>
+              <a:rPr lang="en-US" sz="1600" dirty="0" smtClean="0"/>
+              <a:t>[</a:t>
+            </a:r>
+            <a:r>
+              <a:rPr lang="en-US" sz="1600" dirty="0"/>
+              <a:t>VECTO-361] Fixed classification of vehicles with GVM of exactly </a:t>
+            </a:r>
+            <a:r>
+              <a:rPr lang="en-US" sz="1600" dirty="0" smtClean="0"/>
+              <a:t>7500kg</a:t>
+            </a:r>
+          </a:p>
+          <a:p>
+            <a:pPr lvl="1"/>
+            <a:r>
+              <a:rPr lang="en-US" sz="1600" dirty="0" smtClean="0"/>
+              <a:t>[</a:t>
+            </a:r>
+            <a:r>
+              <a:rPr lang="en-US" sz="1600" dirty="0"/>
+              <a:t>VECTO-364] Fixed an error in measured speed mode (run aborts</a:t>
+            </a:r>
+            <a:r>
+              <a:rPr lang="en-US" sz="1600" dirty="0" smtClean="0"/>
+              <a:t>).</a:t>
+            </a:r>
+          </a:p>
+          <a:p>
+            <a:pPr lvl="1"/>
+            <a:r>
+              <a:rPr lang="en-US" sz="1600" dirty="0" smtClean="0"/>
+              <a:t>[</a:t>
+            </a:r>
+            <a:r>
+              <a:rPr lang="en-US" sz="1600" dirty="0"/>
+              <a:t>VECTO-363] Compute shift polygons in declaration mode now uses correct boundary for full load </a:t>
+            </a:r>
+            <a:r>
+              <a:rPr lang="en-US" sz="1600" dirty="0" smtClean="0"/>
+              <a:t>margin.</a:t>
+            </a:r>
+          </a:p>
+          <a:p>
+            <a:pPr lvl="1"/>
+            <a:r>
+              <a:rPr lang="en-US" sz="1600" dirty="0" smtClean="0"/>
+              <a:t>[VECTO-365] Fixed </a:t>
+            </a:r>
+            <a:r>
+              <a:rPr lang="en-US" sz="1600" dirty="0"/>
+              <a:t>editing gears in declaration </a:t>
+            </a:r>
+            <a:r>
+              <a:rPr lang="en-US" sz="1600" dirty="0" smtClean="0"/>
+              <a:t>mode</a:t>
+            </a:r>
+          </a:p>
+          <a:p>
+            <a:r>
+              <a:rPr lang="en-US" sz="1800" b="1" dirty="0" smtClean="0"/>
+              <a:t>Improvements</a:t>
+            </a:r>
+            <a:r>
+              <a:rPr lang="en-US" sz="1800" dirty="0" smtClean="0"/>
+              <a:t>:</a:t>
+            </a:r>
+          </a:p>
+          <a:p>
+            <a:pPr lvl="1"/>
+            <a:r>
+              <a:rPr lang="en-US" sz="1600" dirty="0" smtClean="0"/>
+              <a:t>[</a:t>
+            </a:r>
+            <a:r>
+              <a:rPr lang="en-US" sz="1600" dirty="0"/>
+              <a:t>VECTO-355] User Manual updated (Screenshots, Descriptions, File Formats, </a:t>
+            </a:r>
+            <a:r>
+              <a:rPr lang="en-US" sz="1600" dirty="0" err="1"/>
               <a:t>Vecto</a:t>
             </a:r>
             <a:r>
-              <a:rPr lang="en-US" dirty="0" smtClean="0"/>
-              <a:t> 3 models</a:t>
+              <a:rPr lang="en-US" sz="1600" dirty="0"/>
+              <a:t> V2 Comments removed</a:t>
+            </a:r>
+            <a:r>
+              <a:rPr lang="en-US" sz="1600" dirty="0" smtClean="0"/>
+              <a:t>).</a:t>
             </a:r>
           </a:p>
           <a:p>
             <a:pPr lvl="1"/>
             <a:r>
-              <a:rPr lang="en-US" dirty="0" smtClean="0"/>
-              <a:t>AT-Gearbox Model: differentiate between AT gearbox with serial torque converter and AT gearbox using </a:t>
-            </a:r>
-            <a:r>
-              <a:rPr lang="en-US" dirty="0" err="1" smtClean="0"/>
-              <a:t>powersplit</a:t>
-            </a:r>
-            <a:endParaRPr lang="en-US" dirty="0" smtClean="0"/>
+              <a:rPr lang="en-US" sz="1600" dirty="0" smtClean="0"/>
+              <a:t>[</a:t>
+            </a:r>
+            <a:r>
+              <a:rPr lang="en-US" sz="1600" dirty="0"/>
+              <a:t>VECTO-317] Declaration data for Wheel sizes </a:t>
+            </a:r>
+            <a:r>
+              <a:rPr lang="en-US" sz="1600" dirty="0" smtClean="0"/>
+              <a:t>updated</a:t>
+            </a:r>
           </a:p>
           <a:p>
             <a:pPr lvl="1"/>
             <a:r>
-              <a:rPr lang="en-US" dirty="0" smtClean="0"/>
-              <a:t>Numbering of gears with AT gearbox corresponds to mechanical gears, new column </a:t>
-            </a:r>
-            <a:r>
-              <a:rPr lang="en-US" dirty="0" err="1" smtClean="0"/>
-              <a:t>TC_locked</a:t>
-            </a:r>
-            <a:r>
-              <a:rPr lang="en-US" dirty="0" smtClean="0"/>
-              <a:t> in .</a:t>
-            </a:r>
-            <a:r>
-              <a:rPr lang="en-US" dirty="0" err="1" smtClean="0"/>
-              <a:t>vmod</a:t>
-            </a:r>
-            <a:r>
-              <a:rPr lang="en-US" dirty="0" smtClean="0"/>
-              <a:t> file to indicate if torque converter is active</a:t>
+              <a:rPr lang="en-US" sz="1600" dirty="0" smtClean="0"/>
+              <a:t>[VECTO-359</a:t>
+            </a:r>
+            <a:r>
+              <a:rPr lang="en-US" sz="1600" dirty="0"/>
+              <a:t>] Simplified code regarding PT1 behavior</a:t>
+            </a:r>
+            <a:r>
+              <a:rPr lang="en-US" sz="1600" dirty="0" smtClean="0"/>
+              <a:t>.</a:t>
             </a:r>
           </a:p>
           <a:p>
             <a:pPr lvl="1"/>
             <a:r>
-              <a:rPr lang="en-US" dirty="0" smtClean="0"/>
-              <a:t>Torque converter gear no longer allowed in input (added by </a:t>
-            </a:r>
-            <a:r>
-              <a:rPr lang="en-US" dirty="0" err="1" smtClean="0"/>
-              <a:t>Vecto</a:t>
-            </a:r>
-            <a:r>
-              <a:rPr lang="en-US" dirty="0" smtClean="0"/>
-              <a:t> depending on the AT model)</a:t>
-            </a:r>
-          </a:p>
-          <a:p>
-            <a:pPr lvl="1"/>
-            <a:r>
-              <a:rPr lang="en-US" dirty="0" smtClean="0"/>
-              <a:t>New implementation of torque converter model (analytic solutions)</a:t>
-            </a:r>
-          </a:p>
-          <a:p>
-            <a:pPr lvl="1"/>
-            <a:r>
-              <a:rPr lang="en-US" dirty="0" smtClean="0"/>
-              <a:t>Added PTO option for municipal utility vehicles: PTO idle losses, separate PTO cycle during standstill</a:t>
-            </a:r>
-          </a:p>
-          <a:p>
-            <a:pPr lvl="1"/>
-            <a:r>
-              <a:rPr lang="en-US" dirty="0" smtClean="0"/>
-              <a:t>Added </a:t>
-            </a:r>
-            <a:r>
-              <a:rPr lang="en-US" dirty="0" err="1" smtClean="0"/>
-              <a:t>Angledrive</a:t>
-            </a:r>
-            <a:r>
-              <a:rPr lang="en-US" dirty="0" smtClean="0"/>
-              <a:t> Component</a:t>
-            </a:r>
-          </a:p>
-          <a:p>
-            <a:pPr lvl="1"/>
-            <a:r>
-              <a:rPr lang="en-US" dirty="0" smtClean="0"/>
-              <a:t>Option for constant Auxiliary Power Demand in Job-File</a:t>
-            </a:r>
-            <a:endParaRPr lang="en-US" dirty="0"/>
+              <a:rPr lang="en-US" sz="1600" dirty="0" smtClean="0"/>
+              <a:t>[</a:t>
+            </a:r>
+            <a:r>
+              <a:rPr lang="en-US" sz="1600" dirty="0"/>
+              <a:t>VECTO-323] PTO-Cycle may now be left empty when not used in driving </a:t>
+            </a:r>
+            <a:r>
+              <a:rPr lang="en-US" sz="1600" dirty="0" smtClean="0"/>
+              <a:t>cycle.</a:t>
+            </a:r>
           </a:p>
         </p:txBody>
       </p:sp>
     </p:spTree>
     <p:extLst>
       <p:ext uri="{BB962C8B-B14F-4D97-AF65-F5344CB8AC3E}">
-        <p14:creationId xmlns:p14="http://schemas.microsoft.com/office/powerpoint/2010/main" val="3595445446"/>
+        <p14:creationId xmlns:p14="http://schemas.microsoft.com/office/powerpoint/2010/main" val="3892724049"/>
       </p:ext>
     </p:extLst>
   </p:cSld>
@@ -9083,9 +9201,10 @@
               <a:rPr lang="en-US" dirty="0" smtClean="0"/>
             </a:br>
             <a:r>
-              <a:rPr lang="en-US" sz="1600" dirty="0"/>
+              <a:rPr lang="en-US" sz="1600" dirty="0" smtClean="0"/>
               <a:t>2016-10-14</a:t>
             </a:r>
+            <a:endParaRPr lang="en-US" sz="1600" dirty="0"/>
           </a:p>
         </p:txBody>
       </p:sp>
@@ -9101,8 +9220,8 @@
         </p:nvSpPr>
         <p:spPr>
           <a:xfrm>
-            <a:off x="468315" y="1268760"/>
-            <a:ext cx="8496173" cy="4857403"/>
+            <a:off x="468315" y="1412776"/>
+            <a:ext cx="8496173" cy="4713387"/>
           </a:xfrm>
         </p:spPr>
         <p:txBody>
@@ -9111,132 +9230,124 @@
           <a:p>
             <a:r>
               <a:rPr lang="en-US" dirty="0" smtClean="0"/>
-              <a:t>Main Updates (cont.)</a:t>
+              <a:t>Main Updates</a:t>
             </a:r>
           </a:p>
           <a:p>
             <a:pPr lvl="1"/>
             <a:r>
               <a:rPr lang="en-US" dirty="0" smtClean="0"/>
-              <a:t>Normalize x/y values before triangulating Delaunay map (transmission loss-maps, fuel consumption loss map)</a:t>
+              <a:t>Removed VECTO Core 2.2</a:t>
             </a:r>
           </a:p>
           <a:p>
             <a:pPr lvl="1"/>
             <a:r>
               <a:rPr lang="en-US" dirty="0" smtClean="0"/>
-              <a:t>Additional fuel consumption correction factor in declaration mode: cold/hot balancing factor</a:t>
+              <a:t>Refactoring of the User-Interface Backend: loading, saving files and validating user input uses </a:t>
+            </a:r>
+            <a:r>
+              <a:rPr lang="en-US" dirty="0" err="1" smtClean="0"/>
+              <a:t>Vecto</a:t>
+            </a:r>
+            <a:r>
+              <a:rPr lang="en-US" dirty="0" smtClean="0"/>
+              <a:t> 3 models</a:t>
             </a:r>
           </a:p>
           <a:p>
             <a:pPr lvl="1"/>
             <a:r>
               <a:rPr lang="en-US" dirty="0" smtClean="0"/>
-              <a:t>Added fuel consumption correction factor (WHTC, Cold/Hot balancing, …) in engineering mode</a:t>
-            </a:r>
+              <a:t>AT-Gearbox Model: differentiate between AT gearbox with serial torque converter and AT gearbox using </a:t>
+            </a:r>
+            <a:r>
+              <a:rPr lang="en-US" dirty="0" err="1" smtClean="0"/>
+              <a:t>powersplit</a:t>
+            </a:r>
+            <a:endParaRPr lang="en-US" dirty="0" smtClean="0"/>
           </a:p>
           <a:p>
             <a:pPr lvl="1"/>
             <a:r>
               <a:rPr lang="en-US" dirty="0" smtClean="0"/>
-              <a:t>Update </a:t>
-            </a:r>
-            <a:r>
-              <a:rPr lang="en-US" dirty="0"/>
-              <a:t>auxiliaries power demand according to latest </a:t>
+              <a:t>Numbering of gears with AT gearbox corresponds to mechanical gears, new column </a:t>
             </a:r>
             <a:r>
               <a:rPr lang="en-US" dirty="0" err="1" smtClean="0"/>
-              <a:t>whitebook</a:t>
-            </a:r>
-            <a:endParaRPr lang="en-US" dirty="0" smtClean="0"/>
+              <a:t>TC_locked</a:t>
+            </a:r>
+            <a:r>
+              <a:rPr lang="en-US" dirty="0" smtClean="0"/>
+              <a:t> in .</a:t>
+            </a:r>
+            <a:r>
+              <a:rPr lang="en-US" dirty="0" err="1" smtClean="0"/>
+              <a:t>vmod</a:t>
+            </a:r>
+            <a:r>
+              <a:rPr lang="en-US" dirty="0" smtClean="0"/>
+              <a:t> file to indicate if torque converter is active</a:t>
+            </a:r>
           </a:p>
           <a:p>
             <a:pPr lvl="1"/>
             <a:r>
               <a:rPr lang="en-US" dirty="0" smtClean="0"/>
-              <a:t>Allow multiple steered axles</a:t>
+              <a:t>Torque converter gear no longer allowed in input (added by </a:t>
+            </a:r>
+            <a:r>
+              <a:rPr lang="en-US" dirty="0" err="1" smtClean="0"/>
+              <a:t>Vecto</a:t>
+            </a:r>
+            <a:r>
+              <a:rPr lang="en-US" dirty="0" smtClean="0"/>
+              <a:t> depending on the AT model)</a:t>
             </a:r>
           </a:p>
           <a:p>
             <a:pPr lvl="1"/>
             <a:r>
               <a:rPr lang="en-US" dirty="0" smtClean="0"/>
-              <a:t>Adapted engine idle controller (during declutch) – engine speed decreases faster</a:t>
+              <a:t>New implementation of torque converter model (analytic solutions)</a:t>
             </a:r>
           </a:p>
           <a:p>
             <a:pPr lvl="1"/>
             <a:r>
               <a:rPr lang="en-US" dirty="0" smtClean="0"/>
-              <a:t>SUM-File: split </a:t>
+              <a:t>Added PTO option for municipal utility vehicles: PTO idle losses, separate PTO cycle during standstill</a:t>
+            </a:r>
+          </a:p>
+          <a:p>
+            <a:pPr lvl="1"/>
+            <a:r>
+              <a:rPr lang="en-US" dirty="0" smtClean="0"/>
+              <a:t>Added </a:t>
             </a:r>
             <a:r>
               <a:rPr lang="en-US" dirty="0" err="1" smtClean="0"/>
-              <a:t>E_axl_gbx</a:t>
-            </a:r>
-            <a:r>
-              <a:rPr lang="en-US" dirty="0" smtClean="0"/>
-              <a:t> into two columns, </a:t>
-            </a:r>
-            <a:r>
-              <a:rPr lang="en-US" dirty="0" err="1" smtClean="0"/>
-              <a:t>E_axl</a:t>
-            </a:r>
-            <a:r>
-              <a:rPr lang="en-US" dirty="0" smtClean="0"/>
-              <a:t> and </a:t>
-            </a:r>
-            <a:r>
-              <a:rPr lang="en-US" dirty="0" err="1" smtClean="0"/>
-              <a:t>E_gbx</a:t>
-            </a:r>
-            <a:endParaRPr lang="en-US" dirty="0" smtClean="0"/>
+              <a:t>Angledrive</a:t>
+            </a:r>
+            <a:r>
+              <a:rPr lang="en-US" dirty="0" smtClean="0"/>
+              <a:t> Component</a:t>
+            </a:r>
           </a:p>
           <a:p>
             <a:pPr lvl="1"/>
             <a:r>
               <a:rPr lang="en-US" dirty="0" smtClean="0"/>
-              <a:t>New columns in mod-file: PTO, torque converter</a:t>
+              <a:t>Option for constant Auxiliary Power Demand in Job-File</a:t>
             </a:r>
             <a:endParaRPr lang="en-US" dirty="0"/>
-          </a:p>
-          <a:p>
-            <a:pPr lvl="1"/>
-            <a:r>
-              <a:rPr lang="en-US" dirty="0" smtClean="0"/>
-              <a:t>Removed full-load curve per gear, only single value </a:t>
-            </a:r>
-            <a:r>
-              <a:rPr lang="en-US" dirty="0" err="1" smtClean="0"/>
-              <a:t>MaxTorque</a:t>
-            </a:r>
-            <a:endParaRPr lang="en-US" dirty="0" smtClean="0"/>
-          </a:p>
-          <a:p>
-            <a:pPr lvl="1"/>
-            <a:r>
-              <a:rPr lang="en-US" dirty="0" smtClean="0"/>
-              <a:t>Removed rims (dynamic wheel radius depends on wheel type)</a:t>
-            </a:r>
-          </a:p>
-          <a:p>
-            <a:pPr lvl="1"/>
-            <a:r>
-              <a:rPr lang="en-US" dirty="0" smtClean="0"/>
-              <a:t>Fixes in AAUX module: open correct file-browser, save selected files</a:t>
-            </a:r>
-          </a:p>
-          <a:p>
-            <a:pPr lvl="1"/>
-            <a:endParaRPr lang="en-US" dirty="0" smtClean="0"/>
           </a:p>
         </p:txBody>
       </p:sp>
     </p:spTree>
     <p:extLst>
       <p:ext uri="{BB962C8B-B14F-4D97-AF65-F5344CB8AC3E}">
-        <p14:creationId xmlns:p14="http://schemas.microsoft.com/office/powerpoint/2010/main" val="3003112543"/>
+        <p14:creationId xmlns:p14="http://schemas.microsoft.com/office/powerpoint/2010/main" val="3595445446"/>
       </p:ext>
     </p:extLst>
   </p:cSld>
@@ -9273,321 +9384,187 @@
             <p:ph type="title"/>
           </p:nvPr>
         </p:nvSpPr>
+        <p:spPr/>
+        <p:txBody>
+          <a:bodyPr/>
+          <a:lstStyle/>
+          <a:p>
+            <a:r>
+              <a:rPr lang="en-US" dirty="0" err="1"/>
+              <a:t>Vecto</a:t>
+            </a:r>
+            <a:r>
+              <a:rPr lang="en-US" dirty="0"/>
+              <a:t> </a:t>
+            </a:r>
+            <a:r>
+              <a:rPr lang="en-US" dirty="0" smtClean="0"/>
+              <a:t>3.1.0.652</a:t>
+            </a:r>
+            <a:br>
+              <a:rPr lang="en-US" dirty="0" smtClean="0"/>
+            </a:br>
+            <a:r>
+              <a:rPr lang="en-US" sz="1600" dirty="0"/>
+              <a:t>2016-10-14</a:t>
+            </a:r>
+          </a:p>
+        </p:txBody>
+      </p:sp>
+      <p:sp>
+        <p:nvSpPr>
+          <p:cNvPr id="3" name="Inhaltsplatzhalter 2"/>
+          <p:cNvSpPr>
+            <a:spLocks noGrp="1"/>
+          </p:cNvSpPr>
+          <p:nvPr>
+            <p:ph idx="1"/>
+          </p:nvPr>
+        </p:nvSpPr>
         <p:spPr>
           <a:xfrm>
-            <a:off x="296532" y="476672"/>
-            <a:ext cx="8451932" cy="576064"/>
+            <a:off x="468315" y="1268760"/>
+            <a:ext cx="8496173" cy="4857403"/>
           </a:xfrm>
         </p:spPr>
         <p:txBody>
           <a:bodyPr/>
           <a:lstStyle/>
           <a:p>
-            <a:pPr algn="l"/>
-            <a:r>
-              <a:rPr lang="en-US" dirty="0" smtClean="0"/>
-              <a:t>Status quo VECTO software and open issues (Oct. 2016)</a:t>
+            <a:r>
+              <a:rPr lang="en-US" dirty="0" smtClean="0"/>
+              <a:t>Main Updates (cont.)</a:t>
+            </a:r>
+          </a:p>
+          <a:p>
+            <a:pPr lvl="1"/>
+            <a:r>
+              <a:rPr lang="en-US" dirty="0" smtClean="0"/>
+              <a:t>Normalize x/y values before triangulating Delaunay map (transmission loss-maps, fuel consumption loss map)</a:t>
+            </a:r>
+          </a:p>
+          <a:p>
+            <a:pPr lvl="1"/>
+            <a:r>
+              <a:rPr lang="en-US" dirty="0" smtClean="0"/>
+              <a:t>Additional fuel consumption correction factor in declaration mode: cold/hot balancing factor</a:t>
+            </a:r>
+          </a:p>
+          <a:p>
+            <a:pPr lvl="1"/>
+            <a:r>
+              <a:rPr lang="en-US" dirty="0" smtClean="0"/>
+              <a:t>Added fuel consumption correction factor (WHTC, Cold/Hot balancing, …) in engineering mode</a:t>
+            </a:r>
+          </a:p>
+          <a:p>
+            <a:pPr lvl="1"/>
+            <a:r>
+              <a:rPr lang="en-US" dirty="0" smtClean="0"/>
+              <a:t>Update </a:t>
+            </a:r>
+            <a:r>
+              <a:rPr lang="en-US" dirty="0"/>
+              <a:t>auxiliaries power demand according to latest </a:t>
+            </a:r>
+            <a:r>
+              <a:rPr lang="en-US" dirty="0" err="1" smtClean="0"/>
+              <a:t>whitebook</a:t>
+            </a:r>
+            <a:endParaRPr lang="en-US" dirty="0" smtClean="0"/>
+          </a:p>
+          <a:p>
+            <a:pPr lvl="1"/>
+            <a:r>
+              <a:rPr lang="en-US" dirty="0" smtClean="0"/>
+              <a:t>Allow multiple steered axles</a:t>
+            </a:r>
+          </a:p>
+          <a:p>
+            <a:pPr lvl="1"/>
+            <a:r>
+              <a:rPr lang="en-US" dirty="0" smtClean="0"/>
+              <a:t>Adapted engine idle controller (during declutch) – engine speed decreases faster</a:t>
+            </a:r>
+          </a:p>
+          <a:p>
+            <a:pPr lvl="1"/>
+            <a:r>
+              <a:rPr lang="en-US" dirty="0" smtClean="0"/>
+              <a:t>SUM-File: split </a:t>
+            </a:r>
+            <a:r>
+              <a:rPr lang="en-US" dirty="0" err="1" smtClean="0"/>
+              <a:t>E_axl_gbx</a:t>
+            </a:r>
+            <a:r>
+              <a:rPr lang="en-US" dirty="0" smtClean="0"/>
+              <a:t> into two columns, </a:t>
+            </a:r>
+            <a:r>
+              <a:rPr lang="en-US" dirty="0" err="1" smtClean="0"/>
+              <a:t>E_axl</a:t>
+            </a:r>
+            <a:r>
+              <a:rPr lang="en-US" dirty="0" smtClean="0"/>
+              <a:t> and </a:t>
+            </a:r>
+            <a:r>
+              <a:rPr lang="en-US" dirty="0" err="1" smtClean="0"/>
+              <a:t>E_gbx</a:t>
+            </a:r>
+            <a:endParaRPr lang="en-US" dirty="0" smtClean="0"/>
+          </a:p>
+          <a:p>
+            <a:pPr lvl="1"/>
+            <a:r>
+              <a:rPr lang="en-US" dirty="0" smtClean="0"/>
+              <a:t>New columns in mod-file: PTO, torque converter</a:t>
             </a:r>
             <a:endParaRPr lang="en-US" dirty="0"/>
           </a:p>
-        </p:txBody>
-      </p:sp>
-      <p:sp>
-        <p:nvSpPr>
-          <p:cNvPr id="3" name="Textfeld 2"/>
-          <p:cNvSpPr txBox="1"/>
-          <p:nvPr/>
-        </p:nvSpPr>
-        <p:spPr>
-          <a:xfrm>
-            <a:off x="323528" y="908720"/>
-            <a:ext cx="8496944" cy="400110"/>
-          </a:xfrm>
-          <a:prstGeom prst="rect">
-            <a:avLst/>
-          </a:prstGeom>
-          <a:noFill/>
-        </p:spPr>
-        <p:txBody>
-          <a:bodyPr wrap="square" rtlCol="0">
-            <a:spAutoFit/>
-          </a:bodyPr>
-          <a:lstStyle/>
-          <a:p>
-            <a:pPr algn="l"/>
-            <a:r>
-              <a:rPr lang="de-AT" sz="2000" dirty="0" smtClean="0"/>
-              <a:t>Next </a:t>
-            </a:r>
-            <a:r>
-              <a:rPr lang="de-AT" sz="2000" dirty="0" err="1" smtClean="0"/>
-              <a:t>issues</a:t>
-            </a:r>
-            <a:r>
-              <a:rPr lang="de-AT" sz="2000" dirty="0" smtClean="0"/>
-              <a:t> on </a:t>
-            </a:r>
-            <a:r>
-              <a:rPr lang="de-AT" sz="2000" dirty="0" err="1" smtClean="0"/>
-              <a:t>the</a:t>
-            </a:r>
-            <a:r>
-              <a:rPr lang="de-AT" sz="2000" dirty="0" smtClean="0"/>
-              <a:t> </a:t>
-            </a:r>
-            <a:r>
-              <a:rPr lang="de-AT" sz="2000" dirty="0" err="1" smtClean="0"/>
-              <a:t>to</a:t>
-            </a:r>
-            <a:r>
-              <a:rPr lang="de-AT" sz="2000" dirty="0" smtClean="0"/>
-              <a:t> do </a:t>
-            </a:r>
-            <a:r>
-              <a:rPr lang="de-AT" sz="2000" dirty="0" err="1" smtClean="0"/>
-              <a:t>list</a:t>
-            </a:r>
-            <a:endParaRPr lang="de-AT" sz="2000" dirty="0"/>
-          </a:p>
-        </p:txBody>
-      </p:sp>
-      <p:sp>
-        <p:nvSpPr>
-          <p:cNvPr id="7" name="Textfeld 6"/>
-          <p:cNvSpPr txBox="1"/>
-          <p:nvPr/>
-        </p:nvSpPr>
-        <p:spPr>
-          <a:xfrm>
-            <a:off x="539552" y="1484784"/>
-            <a:ext cx="8352928" cy="5093702"/>
-          </a:xfrm>
-          <a:prstGeom prst="rect">
-            <a:avLst/>
-          </a:prstGeom>
-          <a:noFill/>
-        </p:spPr>
-        <p:txBody>
-          <a:bodyPr wrap="square" rtlCol="0">
-            <a:spAutoFit/>
-          </a:bodyPr>
-          <a:lstStyle/>
-          <a:p>
-            <a:pPr marL="285750" indent="-285750" algn="l">
-              <a:buFont typeface="Arial" panose="020B0604020202020204" pitchFamily="34" charset="0"/>
-              <a:buChar char="•"/>
-            </a:pPr>
-            <a:r>
-              <a:rPr lang="en-GB" sz="1400" dirty="0" smtClean="0"/>
-              <a:t>Further development of the AT model</a:t>
-            </a:r>
-            <a:br>
-              <a:rPr lang="en-GB" sz="1400" dirty="0" smtClean="0"/>
-            </a:br>
-            <a:r>
-              <a:rPr lang="en-GB" sz="1400" b="0" dirty="0" smtClean="0"/>
-              <a:t>Consideration of losses during power shifts, update of gear shift logics</a:t>
-            </a:r>
-          </a:p>
-          <a:p>
-            <a:pPr marL="285750" indent="-285750" algn="l">
-              <a:buFont typeface="Arial" panose="020B0604020202020204" pitchFamily="34" charset="0"/>
-              <a:buChar char="•"/>
-            </a:pPr>
-            <a:r>
-              <a:rPr lang="en-GB" sz="1400" dirty="0" smtClean="0"/>
-              <a:t>Reimplementation </a:t>
-            </a:r>
-            <a:r>
-              <a:rPr lang="en-GB" sz="1400" dirty="0"/>
-              <a:t>of engine stop/start</a:t>
-            </a:r>
-          </a:p>
-          <a:p>
-            <a:pPr marL="285750" indent="-285750" algn="l">
-              <a:buFont typeface="Arial" panose="020B0604020202020204" pitchFamily="34" charset="0"/>
-              <a:buChar char="•"/>
-            </a:pPr>
-            <a:r>
-              <a:rPr lang="en-GB" sz="1400" dirty="0" smtClean="0"/>
-              <a:t>Declaration mode: implementation of EMS vehicle configurations</a:t>
-            </a:r>
-          </a:p>
-          <a:p>
-            <a:pPr marL="285750" indent="-285750" algn="l">
-              <a:buFont typeface="Arial" panose="020B0604020202020204" pitchFamily="34" charset="0"/>
-              <a:buChar char="•"/>
-            </a:pPr>
-            <a:endParaRPr lang="en-GB" sz="1400" dirty="0"/>
-          </a:p>
-          <a:p>
-            <a:pPr algn="l"/>
-            <a:r>
-              <a:rPr lang="en-GB" sz="1400" u="sng" dirty="0" smtClean="0"/>
-              <a:t>Items waiting for decision on methods and resources:</a:t>
-            </a:r>
-          </a:p>
-          <a:p>
-            <a:pPr marL="285750" indent="-285750" algn="l">
-              <a:buFont typeface="Arial" panose="020B0604020202020204" pitchFamily="34" charset="0"/>
-              <a:buChar char="•"/>
-            </a:pPr>
-            <a:r>
-              <a:rPr lang="en-GB" sz="1400" dirty="0" smtClean="0"/>
-              <a:t>Update engine data (according to update of Annex II)</a:t>
-            </a:r>
-            <a:br>
-              <a:rPr lang="en-GB" sz="1400" dirty="0" smtClean="0"/>
-            </a:br>
-            <a:r>
-              <a:rPr lang="en-GB" sz="1400" b="0" dirty="0" smtClean="0"/>
-              <a:t>Other fuels than diesel, “top torque” feature, correction factor for periodic </a:t>
-            </a:r>
-            <a:r>
-              <a:rPr lang="en-GB" sz="1400" b="0" dirty="0" err="1" smtClean="0"/>
-              <a:t>regerating</a:t>
-            </a:r>
-            <a:r>
-              <a:rPr lang="en-GB" sz="1400" b="0" dirty="0" smtClean="0"/>
-              <a:t> DPFs</a:t>
-            </a:r>
-          </a:p>
-          <a:p>
-            <a:pPr marL="285750" indent="-285750" algn="l">
-              <a:buFont typeface="Arial" panose="020B0604020202020204" pitchFamily="34" charset="0"/>
-              <a:buChar char="•"/>
-            </a:pPr>
-            <a:r>
-              <a:rPr lang="en-GB" sz="1400" dirty="0" smtClean="0"/>
-              <a:t>Declaration mode: </a:t>
-            </a:r>
-          </a:p>
-          <a:p>
-            <a:pPr marL="742950" lvl="1" indent="-285750" algn="l">
-              <a:spcBef>
-                <a:spcPts val="300"/>
-              </a:spcBef>
-              <a:buFont typeface="Arial" panose="020B0604020202020204" pitchFamily="34" charset="0"/>
-              <a:buChar char="•"/>
-            </a:pPr>
-            <a:r>
-              <a:rPr lang="en-GB" sz="1400" dirty="0"/>
-              <a:t>Revision of calculated vehicle </a:t>
-            </a:r>
-            <a:r>
-              <a:rPr lang="en-GB" sz="1400" dirty="0" smtClean="0"/>
-              <a:t>loads</a:t>
-            </a:r>
-          </a:p>
-          <a:p>
-            <a:pPr marL="742950" lvl="1" indent="-285750" algn="l">
-              <a:spcBef>
-                <a:spcPts val="300"/>
-              </a:spcBef>
-              <a:buFont typeface="Arial" panose="020B0604020202020204" pitchFamily="34" charset="0"/>
-              <a:buChar char="•"/>
-            </a:pPr>
-            <a:r>
-              <a:rPr lang="en-GB" sz="1400" dirty="0" smtClean="0"/>
-              <a:t>implementation of refuse cycle (instead “municipal”)</a:t>
-            </a:r>
-            <a:br>
-              <a:rPr lang="en-GB" sz="1400" dirty="0" smtClean="0"/>
-            </a:br>
-            <a:r>
-              <a:rPr lang="en-GB" sz="1400" b="0" dirty="0" smtClean="0"/>
-              <a:t>Update of driving cycle, consideration of generic PTO loads during collection part,</a:t>
-            </a:r>
-            <a:br>
-              <a:rPr lang="en-GB" sz="1400" b="0" dirty="0" smtClean="0"/>
-            </a:br>
-            <a:r>
-              <a:rPr lang="en-GB" sz="1400" b="0" dirty="0" smtClean="0"/>
-              <a:t>generic body weight and payload</a:t>
-            </a:r>
-          </a:p>
-          <a:p>
-            <a:pPr marL="742950" lvl="1" indent="-285750" algn="l">
-              <a:spcBef>
-                <a:spcPts val="300"/>
-              </a:spcBef>
-              <a:buFont typeface="Arial" panose="020B0604020202020204" pitchFamily="34" charset="0"/>
-              <a:buChar char="•"/>
-            </a:pPr>
-            <a:r>
-              <a:rPr lang="en-GB" sz="1400" dirty="0"/>
-              <a:t>VECTO output (approval </a:t>
-            </a:r>
-            <a:r>
-              <a:rPr lang="en-GB" sz="1400" dirty="0" smtClean="0"/>
-              <a:t>authorities</a:t>
-            </a:r>
-            <a:r>
-              <a:rPr lang="en-GB" sz="1400" dirty="0"/>
-              <a:t>, customer info, monitoring</a:t>
-            </a:r>
-            <a:r>
-              <a:rPr lang="en-GB" sz="1400" dirty="0" smtClean="0"/>
-              <a:t>)</a:t>
-            </a:r>
-          </a:p>
-          <a:p>
-            <a:pPr marL="742950" lvl="1" indent="-285750" algn="l">
-              <a:spcBef>
-                <a:spcPts val="300"/>
-              </a:spcBef>
-              <a:buFont typeface="Arial" panose="020B0604020202020204" pitchFamily="34" charset="0"/>
-              <a:buChar char="•"/>
-            </a:pPr>
-            <a:r>
-              <a:rPr lang="en-GB" sz="1400" dirty="0" smtClean="0"/>
-              <a:t>Buses</a:t>
-            </a:r>
-            <a:endParaRPr lang="en-GB" sz="1400" b="0" dirty="0" smtClean="0"/>
-          </a:p>
-          <a:p>
-            <a:pPr marL="285750" indent="-285750" algn="l">
-              <a:buFont typeface="Arial" panose="020B0604020202020204" pitchFamily="34" charset="0"/>
-              <a:buChar char="•"/>
-            </a:pPr>
-            <a:r>
-              <a:rPr lang="en-GB" sz="1400" dirty="0" smtClean="0"/>
-              <a:t>Predictive ADAS</a:t>
-            </a:r>
-          </a:p>
-          <a:p>
-            <a:pPr marL="285750" indent="-285750" algn="l">
-              <a:buFont typeface="Arial" panose="020B0604020202020204" pitchFamily="34" charset="0"/>
-              <a:buChar char="•"/>
-            </a:pPr>
-            <a:endParaRPr lang="en-GB" sz="1400" dirty="0" smtClean="0"/>
-          </a:p>
-          <a:p>
-            <a:pPr marL="285750" indent="-285750" algn="l">
-              <a:buFont typeface="Arial" panose="020B0604020202020204" pitchFamily="34" charset="0"/>
-              <a:buChar char="•"/>
-            </a:pPr>
-            <a:endParaRPr lang="en-GB" sz="1400" dirty="0"/>
+          <a:p>
+            <a:pPr lvl="1"/>
+            <a:r>
+              <a:rPr lang="en-US" dirty="0" smtClean="0"/>
+              <a:t>Removed full-load curve per gear, only single value </a:t>
+            </a:r>
+            <a:r>
+              <a:rPr lang="en-US" dirty="0" err="1" smtClean="0"/>
+              <a:t>MaxTorque</a:t>
+            </a:r>
+            <a:endParaRPr lang="en-US" dirty="0" smtClean="0"/>
+          </a:p>
+          <a:p>
+            <a:pPr lvl="1"/>
+            <a:r>
+              <a:rPr lang="en-US" dirty="0" smtClean="0"/>
+              <a:t>Removed rims (dynamic wheel radius depends on wheel type)</a:t>
+            </a:r>
+          </a:p>
+          <a:p>
+            <a:pPr lvl="1"/>
+            <a:r>
+              <a:rPr lang="en-US" dirty="0" smtClean="0"/>
+              <a:t>Fixes in AAUX module: open correct file-browser, save selected files</a:t>
+            </a:r>
+          </a:p>
+          <a:p>
+            <a:pPr lvl="1"/>
+            <a:endParaRPr lang="en-US" dirty="0" smtClean="0"/>
           </a:p>
         </p:txBody>
       </p:sp>
     </p:spTree>
     <p:extLst>
       <p:ext uri="{BB962C8B-B14F-4D97-AF65-F5344CB8AC3E}">
-        <p14:creationId xmlns:p14="http://schemas.microsoft.com/office/powerpoint/2010/main" val="4139329725"/>
+        <p14:creationId xmlns:p14="http://schemas.microsoft.com/office/powerpoint/2010/main" val="3003112543"/>
       </p:ext>
     </p:extLst>
   </p:cSld>
   <p:clrMapOvr>
     <a:masterClrMapping/>
   </p:clrMapOvr>
-  <p:timing>
-    <p:tnLst>
-      <p:par>
-        <p:cTn id="1" dur="indefinite" restart="never" nodeType="tmRoot"/>
-      </p:par>
-    </p:tnLst>
-  </p:timing>
 </p:sld>
 </file>
 
@@ -9618,25 +9595,20 @@
             <p:ph type="title"/>
           </p:nvPr>
         </p:nvSpPr>
-        <p:spPr/>
+        <p:spPr>
+          <a:xfrm>
+            <a:off x="296532" y="476672"/>
+            <a:ext cx="8451932" cy="576064"/>
+          </a:xfrm>
+        </p:spPr>
         <p:txBody>
           <a:bodyPr/>
           <a:lstStyle/>
           <a:p>
-            <a:r>
-              <a:rPr lang="en-US" dirty="0" err="1"/>
-              <a:t>Vecto</a:t>
-            </a:r>
-            <a:r>
-              <a:rPr lang="en-US" dirty="0"/>
-              <a:t> 3.0.4.565</a:t>
-            </a:r>
-            <a:br>
-              <a:rPr lang="en-US" dirty="0"/>
-            </a:br>
-            <a:r>
-              <a:rPr lang="en-US" sz="1600" dirty="0"/>
-              <a:t>2016-07-19</a:t>
+            <a:pPr algn="l"/>
+            <a:r>
+              <a:rPr lang="en-US" dirty="0" smtClean="0"/>
+              <a:t>Status quo VECTO software and open issues (Oct. 2016)</a:t>
             </a:r>
             <a:endParaRPr lang="en-US" dirty="0"/>
           </a:p>
@@ -9644,134 +9616,300 @@
       </p:sp>
       <p:sp>
         <p:nvSpPr>
-          <p:cNvPr id="3" name="Inhaltsplatzhalter 2"/>
-          <p:cNvSpPr>
-            <a:spLocks noGrp="1"/>
-          </p:cNvSpPr>
-          <p:nvPr>
-            <p:ph idx="1"/>
-          </p:nvPr>
+          <p:cNvPr id="3" name="Textfeld 2"/>
+          <p:cNvSpPr txBox="1"/>
+          <p:nvPr/>
         </p:nvSpPr>
-        <p:spPr/>
+        <p:spPr>
+          <a:xfrm>
+            <a:off x="323528" y="908720"/>
+            <a:ext cx="8496944" cy="400110"/>
+          </a:xfrm>
+          <a:prstGeom prst="rect">
+            <a:avLst/>
+          </a:prstGeom>
+          <a:noFill/>
+        </p:spPr>
         <p:txBody>
-          <a:bodyPr/>
+          <a:bodyPr wrap="square" rtlCol="0">
+            <a:spAutoFit/>
+          </a:bodyPr>
           <a:lstStyle/>
           <a:p>
-            <a:r>
-              <a:rPr lang="en-US" dirty="0" err="1" smtClean="0"/>
-              <a:t>Bugfixes</a:t>
-            </a:r>
-            <a:endParaRPr lang="en-US" dirty="0"/>
-          </a:p>
-          <a:p>
-            <a:pPr lvl="1"/>
-            <a:r>
-              <a:rPr lang="en-US" dirty="0" smtClean="0"/>
-              <a:t>AAUX </a:t>
-            </a:r>
-            <a:r>
-              <a:rPr lang="en-US" dirty="0"/>
-              <a:t>HVAC Dialog does not store path to </a:t>
-            </a:r>
-            <a:r>
-              <a:rPr lang="en-US" dirty="0" err="1"/>
-              <a:t>ActuationsMap</a:t>
-            </a:r>
-            <a:r>
-              <a:rPr lang="en-US" dirty="0"/>
-              <a:t> and </a:t>
-            </a:r>
-            <a:r>
-              <a:rPr lang="en-US" dirty="0" err="1"/>
-              <a:t>SSMSource</a:t>
-            </a:r>
-            <a:endParaRPr lang="en-US" dirty="0"/>
-          </a:p>
-          <a:p>
-            <a:pPr lvl="1"/>
-            <a:r>
-              <a:rPr lang="en-US" smtClean="0"/>
-              <a:t>GUI</a:t>
-            </a:r>
-            <a:r>
-              <a:rPr lang="en-US" dirty="0"/>
-              <a:t>: check for axle loads in declaration mode renders editing dialog useless </a:t>
-            </a:r>
-          </a:p>
-          <a:p>
-            <a:pPr lvl="1"/>
-            <a:r>
-              <a:rPr lang="en-US" dirty="0" err="1" smtClean="0"/>
-              <a:t>Vecto</a:t>
-            </a:r>
-            <a:r>
-              <a:rPr lang="en-US" dirty="0" smtClean="0"/>
+            <a:pPr algn="l"/>
+            <a:r>
+              <a:rPr lang="de-AT" sz="2000" dirty="0" smtClean="0"/>
+              <a:t>Next </a:t>
+            </a:r>
+            <a:r>
+              <a:rPr lang="de-AT" sz="2000" dirty="0" err="1" smtClean="0"/>
+              <a:t>issues</a:t>
+            </a:r>
+            <a:r>
+              <a:rPr lang="de-AT" sz="2000" dirty="0" smtClean="0"/>
+              <a:t> on </a:t>
+            </a:r>
+            <a:r>
+              <a:rPr lang="de-AT" sz="2000" dirty="0" err="1" smtClean="0"/>
+              <a:t>the</a:t>
+            </a:r>
+            <a:r>
+              <a:rPr lang="de-AT" sz="2000" dirty="0" smtClean="0"/>
               <a:t> </a:t>
             </a:r>
             <a:r>
-              <a:rPr lang="en-US" dirty="0"/>
-              <a:t>2.2: Simulation aborts (</a:t>
-            </a:r>
-            <a:r>
-              <a:rPr lang="en-US" dirty="0" err="1"/>
-              <a:t>Vecto</a:t>
-            </a:r>
-            <a:r>
-              <a:rPr lang="en-US" dirty="0"/>
-              <a:t> terminates) when simulating </a:t>
-            </a:r>
-            <a:r>
-              <a:rPr lang="en-US" dirty="0" err="1"/>
-              <a:t>EngineOnly</a:t>
-            </a:r>
-            <a:r>
-              <a:rPr lang="en-US" dirty="0"/>
-              <a:t> cycles</a:t>
-            </a:r>
-          </a:p>
-          <a:p>
-            <a:pPr lvl="1"/>
-            <a:r>
-              <a:rPr lang="en-US" dirty="0" err="1" smtClean="0"/>
-              <a:t>Vecto</a:t>
-            </a:r>
-            <a:r>
-              <a:rPr lang="en-US" dirty="0" smtClean="0"/>
-              <a:t> </a:t>
-            </a:r>
-            <a:r>
-              <a:rPr lang="en-US" dirty="0"/>
-              <a:t>3: Building </a:t>
-            </a:r>
-            <a:r>
-              <a:rPr lang="en-US" dirty="0" err="1"/>
-              <a:t>SimulationRun</a:t>
-            </a:r>
-            <a:r>
-              <a:rPr lang="en-US" dirty="0"/>
-              <a:t> </a:t>
-            </a:r>
-            <a:r>
-              <a:rPr lang="en-US" dirty="0" err="1"/>
-              <a:t>EngineOnly</a:t>
-            </a:r>
-            <a:r>
-              <a:rPr lang="en-US" dirty="0"/>
-              <a:t> simulation failed</a:t>
-            </a:r>
+              <a:rPr lang="de-AT" sz="2000" dirty="0" err="1" smtClean="0"/>
+              <a:t>to</a:t>
+            </a:r>
+            <a:r>
+              <a:rPr lang="de-AT" sz="2000" dirty="0" smtClean="0"/>
+              <a:t> do </a:t>
+            </a:r>
+            <a:r>
+              <a:rPr lang="de-AT" sz="2000" dirty="0" err="1" smtClean="0"/>
+              <a:t>list</a:t>
+            </a:r>
+            <a:endParaRPr lang="de-AT" sz="2000" dirty="0"/>
+          </a:p>
+        </p:txBody>
+      </p:sp>
+      <p:sp>
+        <p:nvSpPr>
+          <p:cNvPr id="7" name="Textfeld 6"/>
+          <p:cNvSpPr txBox="1"/>
+          <p:nvPr/>
+        </p:nvSpPr>
+        <p:spPr>
+          <a:xfrm>
+            <a:off x="539552" y="1484784"/>
+            <a:ext cx="8352928" cy="5093702"/>
+          </a:xfrm>
+          <a:prstGeom prst="rect">
+            <a:avLst/>
+          </a:prstGeom>
+          <a:noFill/>
+        </p:spPr>
+        <p:txBody>
+          <a:bodyPr wrap="square" rtlCol="0">
+            <a:spAutoFit/>
+          </a:bodyPr>
+          <a:lstStyle/>
+          <a:p>
+            <a:pPr marL="285750" indent="-285750" algn="l">
+              <a:buFont typeface="Arial" panose="020B0604020202020204" pitchFamily="34" charset="0"/>
+              <a:buChar char="•"/>
+            </a:pPr>
+            <a:r>
+              <a:rPr lang="en-GB" sz="1400" dirty="0" smtClean="0"/>
+              <a:t>Further development of the AT model</a:t>
+            </a:r>
+            <a:br>
+              <a:rPr lang="en-GB" sz="1400" dirty="0" smtClean="0"/>
+            </a:br>
+            <a:r>
+              <a:rPr lang="en-GB" sz="1400" b="0" dirty="0" smtClean="0"/>
+              <a:t>Consideration of losses during power shifts, update of gear shift logics</a:t>
+            </a:r>
+          </a:p>
+          <a:p>
+            <a:pPr marL="285750" indent="-285750" algn="l">
+              <a:buFont typeface="Arial" panose="020B0604020202020204" pitchFamily="34" charset="0"/>
+              <a:buChar char="•"/>
+            </a:pPr>
+            <a:r>
+              <a:rPr lang="en-GB" sz="1400" dirty="0" smtClean="0"/>
+              <a:t>Reimplementation </a:t>
+            </a:r>
+            <a:r>
+              <a:rPr lang="en-GB" sz="1400" dirty="0"/>
+              <a:t>of engine stop/start</a:t>
+            </a:r>
+          </a:p>
+          <a:p>
+            <a:pPr marL="285750" indent="-285750" algn="l">
+              <a:buFont typeface="Arial" panose="020B0604020202020204" pitchFamily="34" charset="0"/>
+              <a:buChar char="•"/>
+            </a:pPr>
+            <a:r>
+              <a:rPr lang="en-GB" sz="1400" dirty="0" smtClean="0"/>
+              <a:t>Declaration mode: implementation of EMS vehicle configurations</a:t>
+            </a:r>
+          </a:p>
+          <a:p>
+            <a:pPr marL="285750" indent="-285750" algn="l">
+              <a:buFont typeface="Arial" panose="020B0604020202020204" pitchFamily="34" charset="0"/>
+              <a:buChar char="•"/>
+            </a:pPr>
+            <a:endParaRPr lang="en-GB" sz="1400" dirty="0"/>
+          </a:p>
+          <a:p>
+            <a:pPr algn="l"/>
+            <a:r>
+              <a:rPr lang="en-GB" sz="1400" u="sng" dirty="0" smtClean="0"/>
+              <a:t>Items waiting for decision on methods and resources:</a:t>
+            </a:r>
+          </a:p>
+          <a:p>
+            <a:pPr marL="285750" indent="-285750" algn="l">
+              <a:buFont typeface="Arial" panose="020B0604020202020204" pitchFamily="34" charset="0"/>
+              <a:buChar char="•"/>
+            </a:pPr>
+            <a:r>
+              <a:rPr lang="en-GB" sz="1400" dirty="0" smtClean="0"/>
+              <a:t>Update engine data (according to update of Annex II)</a:t>
+            </a:r>
+            <a:br>
+              <a:rPr lang="en-GB" sz="1400" dirty="0" smtClean="0"/>
+            </a:br>
+            <a:r>
+              <a:rPr lang="en-GB" sz="1400" b="0" dirty="0" smtClean="0"/>
+              <a:t>Other fuels than diesel, “top torque” feature, correction factor for periodic </a:t>
+            </a:r>
+            <a:r>
+              <a:rPr lang="en-GB" sz="1400" b="0" dirty="0" err="1" smtClean="0"/>
+              <a:t>regerating</a:t>
+            </a:r>
+            <a:r>
+              <a:rPr lang="en-GB" sz="1400" b="0" dirty="0" smtClean="0"/>
+              <a:t> DPFs</a:t>
+            </a:r>
+          </a:p>
+          <a:p>
+            <a:pPr marL="285750" indent="-285750" algn="l">
+              <a:buFont typeface="Arial" panose="020B0604020202020204" pitchFamily="34" charset="0"/>
+              <a:buChar char="•"/>
+            </a:pPr>
+            <a:r>
+              <a:rPr lang="en-GB" sz="1400" dirty="0" smtClean="0"/>
+              <a:t>Declaration mode: </a:t>
+            </a:r>
+          </a:p>
+          <a:p>
+            <a:pPr marL="742950" lvl="1" indent="-285750" algn="l">
+              <a:spcBef>
+                <a:spcPts val="300"/>
+              </a:spcBef>
+              <a:buFont typeface="Arial" panose="020B0604020202020204" pitchFamily="34" charset="0"/>
+              <a:buChar char="•"/>
+            </a:pPr>
+            <a:r>
+              <a:rPr lang="en-GB" sz="1400" dirty="0"/>
+              <a:t>Revision of calculated vehicle </a:t>
+            </a:r>
+            <a:r>
+              <a:rPr lang="en-GB" sz="1400" dirty="0" smtClean="0"/>
+              <a:t>loads</a:t>
+            </a:r>
+          </a:p>
+          <a:p>
+            <a:pPr marL="742950" lvl="1" indent="-285750" algn="l">
+              <a:spcBef>
+                <a:spcPts val="300"/>
+              </a:spcBef>
+              <a:buFont typeface="Arial" panose="020B0604020202020204" pitchFamily="34" charset="0"/>
+              <a:buChar char="•"/>
+            </a:pPr>
+            <a:r>
+              <a:rPr lang="en-GB" sz="1400" dirty="0" smtClean="0"/>
+              <a:t>implementation of refuse cycle (instead “municipal”)</a:t>
+            </a:r>
+            <a:br>
+              <a:rPr lang="en-GB" sz="1400" dirty="0" smtClean="0"/>
+            </a:br>
+            <a:r>
+              <a:rPr lang="en-GB" sz="1400" b="0" dirty="0" smtClean="0"/>
+              <a:t>Update of driving cycle, consideration of generic PTO loads during collection part,</a:t>
+            </a:r>
+            <a:br>
+              <a:rPr lang="en-GB" sz="1400" b="0" dirty="0" smtClean="0"/>
+            </a:br>
+            <a:r>
+              <a:rPr lang="en-GB" sz="1400" b="0" dirty="0" smtClean="0"/>
+              <a:t>generic body weight and payload</a:t>
+            </a:r>
+          </a:p>
+          <a:p>
+            <a:pPr marL="742950" lvl="1" indent="-285750" algn="l">
+              <a:spcBef>
+                <a:spcPts val="300"/>
+              </a:spcBef>
+              <a:buFont typeface="Arial" panose="020B0604020202020204" pitchFamily="34" charset="0"/>
+              <a:buChar char="•"/>
+            </a:pPr>
+            <a:r>
+              <a:rPr lang="en-GB" sz="1400" dirty="0"/>
+              <a:t>VECTO output (approval </a:t>
+            </a:r>
+            <a:r>
+              <a:rPr lang="en-GB" sz="1400" dirty="0" smtClean="0"/>
+              <a:t>authorities</a:t>
+            </a:r>
+            <a:r>
+              <a:rPr lang="en-GB" sz="1400" dirty="0"/>
+              <a:t>, customer info, monitoring</a:t>
+            </a:r>
+            <a:r>
+              <a:rPr lang="en-GB" sz="1400" dirty="0" smtClean="0"/>
+              <a:t>)</a:t>
+            </a:r>
+          </a:p>
+          <a:p>
+            <a:pPr marL="742950" lvl="1" indent="-285750" algn="l">
+              <a:spcBef>
+                <a:spcPts val="300"/>
+              </a:spcBef>
+              <a:buFont typeface="Arial" panose="020B0604020202020204" pitchFamily="34" charset="0"/>
+              <a:buChar char="•"/>
+            </a:pPr>
+            <a:r>
+              <a:rPr lang="en-GB" sz="1400" dirty="0" smtClean="0"/>
+              <a:t>Buses</a:t>
+            </a:r>
+            <a:endParaRPr lang="en-GB" sz="1400" b="0" dirty="0" smtClean="0"/>
+          </a:p>
+          <a:p>
+            <a:pPr marL="285750" indent="-285750" algn="l">
+              <a:buFont typeface="Arial" panose="020B0604020202020204" pitchFamily="34" charset="0"/>
+              <a:buChar char="•"/>
+            </a:pPr>
+            <a:r>
+              <a:rPr lang="en-GB" sz="1400" dirty="0" smtClean="0"/>
+              <a:t>Predictive ADAS</a:t>
+            </a:r>
+          </a:p>
+          <a:p>
+            <a:pPr marL="285750" indent="-285750" algn="l">
+              <a:buFont typeface="Arial" panose="020B0604020202020204" pitchFamily="34" charset="0"/>
+              <a:buChar char="•"/>
+            </a:pPr>
+            <a:endParaRPr lang="en-GB" sz="1400" dirty="0" smtClean="0"/>
+          </a:p>
+          <a:p>
+            <a:pPr marL="285750" indent="-285750" algn="l">
+              <a:buFont typeface="Arial" panose="020B0604020202020204" pitchFamily="34" charset="0"/>
+              <a:buChar char="•"/>
+            </a:pPr>
+            <a:endParaRPr lang="en-GB" sz="1400" dirty="0"/>
           </a:p>
         </p:txBody>
       </p:sp>
     </p:spTree>
     <p:extLst>
       <p:ext uri="{BB962C8B-B14F-4D97-AF65-F5344CB8AC3E}">
-        <p14:creationId xmlns:p14="http://schemas.microsoft.com/office/powerpoint/2010/main" val="1421982084"/>
+        <p14:creationId xmlns:p14="http://schemas.microsoft.com/office/powerpoint/2010/main" val="4139329725"/>
       </p:ext>
     </p:extLst>
   </p:cSld>
   <p:clrMapOvr>
     <a:masterClrMapping/>
   </p:clrMapOvr>
+  <p:timing>
+    <p:tnLst>
+      <p:par>
+        <p:cTn id="1" dur="indefinite" restart="never" nodeType="tmRoot"/>
+      </p:par>
+    </p:tnLst>
+  </p:timing>
 </p:sld>
 </file>
 

</xml_diff>

<commit_message>
updating documentation: xml schema of output
</commit_message>
<xml_diff>
--- a/Documentation/User Manual Source/Release Notes Vecto3.x.pptx
+++ b/Documentation/User Manual Source/Release Notes Vecto3.x.pptx
@@ -4518,21 +4518,8 @@
                   <a:srgbClr val="990000"/>
                 </a:solidFill>
               </a:rPr>
-              <a:t>14</a:t>
-            </a:r>
-            <a:r>
-              <a:rPr lang="en-US" sz="2000" dirty="0" smtClean="0">
-                <a:solidFill>
-                  <a:srgbClr val="990000"/>
-                </a:solidFill>
-              </a:rPr>
-              <a:t>.07.2017</a:t>
-            </a:r>
-            <a:endParaRPr lang="en-US" sz="2000" dirty="0" smtClean="0">
-              <a:solidFill>
-                <a:srgbClr val="990000"/>
-              </a:solidFill>
-            </a:endParaRPr>
+              <a:t>14.07.2017</a:t>
+            </a:r>
           </a:p>
           <a:p>
             <a:pPr eaLnBrk="1" hangingPunct="1"/>
@@ -9962,12 +9949,17 @@
             </a:r>
             <a:r>
               <a:rPr lang="en-US" sz="1400" dirty="0"/>
-              <a:t> supplement for additional EMS </a:t>
-            </a:r>
-            <a:r>
-              <a:rPr lang="en-US" sz="1400" dirty="0" smtClean="0"/>
+              <a:t> supplement for </a:t>
+            </a:r>
+            <a:r>
+              <a:rPr lang="en-US" sz="1400"/>
+              <a:t>additional </a:t>
+            </a:r>
+            <a:r>
+              <a:rPr lang="en-US" sz="1400" smtClean="0"/>
               <a:t>trailers</a:t>
             </a:r>
+            <a:endParaRPr lang="en-US" sz="1400" dirty="0" smtClean="0"/>
           </a:p>
           <a:p>
             <a:r>
@@ -10360,6 +10352,25 @@
               <a:t>)</a:t>
             </a:r>
           </a:p>
+          <a:p>
+            <a:r>
+              <a:rPr lang="en-US" sz="1400" dirty="0" smtClean="0"/>
+              <a:t>[VECTO-542] </a:t>
+            </a:r>
+            <a:r>
+              <a:rPr lang="en-US" sz="1400" dirty="0"/>
+              <a:t>reduce </a:t>
+            </a:r>
+            <a:r>
+              <a:rPr lang="en-US" sz="1400" dirty="0" err="1"/>
+              <a:t>overspeed</a:t>
+            </a:r>
+            <a:r>
+              <a:rPr lang="en-US" sz="1400" dirty="0"/>
+              <a:t> in declaration mode to 2.5km/h</a:t>
+            </a:r>
+            <a:endParaRPr lang="en-US" sz="1400" dirty="0" smtClean="0"/>
+          </a:p>
         </p:txBody>
       </p:sp>
     </p:spTree>
@@ -10600,7 +10611,6 @@
               <a:rPr lang="en-US" sz="1400" dirty="0"/>
               <a:t> is 0</a:t>
             </a:r>
-            <a:endParaRPr lang="en-US" sz="1400" dirty="0"/>
           </a:p>
         </p:txBody>
       </p:sp>

</xml_diff>

<commit_message>
remove TUG/IVT logo from release notes PPTs
</commit_message>
<xml_diff>
--- a/Documentation/User Manual Source/Release Notes Vecto3.x.pptx
+++ b/Documentation/User Manual Source/Release Notes Vecto3.x.pptx
@@ -3451,227 +3451,6 @@
       </p:sp>
       <p:sp>
         <p:nvSpPr>
-          <p:cNvPr id="1031" name="Rectangle 25"/>
-          <p:cNvSpPr>
-            <a:spLocks noChangeArrowheads="1"/>
-          </p:cNvSpPr>
-          <p:nvPr userDrawn="1"/>
-        </p:nvSpPr>
-        <p:spPr bwMode="auto">
-          <a:xfrm>
-            <a:off x="0" y="6373813"/>
-            <a:ext cx="9144000" cy="215900"/>
-          </a:xfrm>
-          <a:prstGeom prst="rect">
-            <a:avLst/>
-          </a:prstGeom>
-          <a:solidFill>
-            <a:srgbClr val="DDDDDD"/>
-          </a:solidFill>
-          <a:ln w="6350">
-            <a:solidFill>
-              <a:schemeClr val="tx1"/>
-            </a:solidFill>
-            <a:miter lim="800000"/>
-            <a:headEnd/>
-            <a:tailEnd/>
-          </a:ln>
-          <a:effectLst/>
-          <a:extLst>
-            <a:ext uri="{AF507438-7753-43E0-B8FC-AC1667EBCBE1}">
-              <a14:hiddenEffects xmlns:a14="http://schemas.microsoft.com/office/drawing/2010/main">
-                <a:effectLst>
-                  <a:outerShdw dist="35921" dir="2700000" algn="ctr" rotWithShape="0">
-                    <a:schemeClr val="bg2"/>
-                  </a:outerShdw>
-                </a:effectLst>
-              </a14:hiddenEffects>
-            </a:ext>
-          </a:extLst>
-        </p:spPr>
-        <p:txBody>
-          <a:bodyPr wrap="none" tIns="39600" anchor="ctr"/>
-          <a:lstStyle/>
-          <a:p>
-            <a:pPr algn="l">
-              <a:spcBef>
-                <a:spcPct val="0"/>
-              </a:spcBef>
-            </a:pPr>
-            <a:endParaRPr lang="en-GB" sz="1200">
-              <a:latin typeface="Verdana" pitchFamily="34" charset="0"/>
-            </a:endParaRPr>
-          </a:p>
-        </p:txBody>
-      </p:sp>
-      <p:pic>
-        <p:nvPicPr>
-          <p:cNvPr id="1032" name="Picture 26" descr="logo"/>
-          <p:cNvPicPr>
-            <a:picLocks noChangeAspect="1" noChangeArrowheads="1"/>
-          </p:cNvPicPr>
-          <p:nvPr userDrawn="1"/>
-        </p:nvPicPr>
-        <p:blipFill>
-          <a:blip r:embed="rId15" cstate="print">
-            <a:extLst>
-              <a:ext uri="{28A0092B-C50C-407E-A947-70E740481C1C}">
-                <a14:useLocalDpi xmlns:a14="http://schemas.microsoft.com/office/drawing/2010/main" val="0"/>
-              </a:ext>
-            </a:extLst>
-          </a:blip>
-          <a:srcRect/>
-          <a:stretch>
-            <a:fillRect/>
-          </a:stretch>
-        </p:blipFill>
-        <p:spPr bwMode="auto">
-          <a:xfrm>
-            <a:off x="8532442" y="152075"/>
-            <a:ext cx="504056" cy="185220"/>
-          </a:xfrm>
-          <a:prstGeom prst="rect">
-            <a:avLst/>
-          </a:prstGeom>
-          <a:noFill/>
-          <a:ln>
-            <a:noFill/>
-          </a:ln>
-          <a:extLst>
-            <a:ext uri="{909E8E84-426E-40DD-AFC4-6F175D3DCCD1}">
-              <a14:hiddenFill xmlns:a14="http://schemas.microsoft.com/office/drawing/2010/main">
-                <a:solidFill>
-                  <a:srgbClr val="FFFFFF"/>
-                </a:solidFill>
-              </a14:hiddenFill>
-            </a:ext>
-            <a:ext uri="{91240B29-F687-4F45-9708-019B960494DF}">
-              <a14:hiddenLine xmlns:a14="http://schemas.microsoft.com/office/drawing/2010/main" w="9525">
-                <a:solidFill>
-                  <a:srgbClr val="000000"/>
-                </a:solidFill>
-                <a:miter lim="800000"/>
-                <a:headEnd/>
-                <a:tailEnd/>
-              </a14:hiddenLine>
-            </a:ext>
-          </a:extLst>
-        </p:spPr>
-      </p:pic>
-      <p:pic>
-        <p:nvPicPr>
-          <p:cNvPr id="1033" name="Picture 27" descr="IVT_Logo_klein"/>
-          <p:cNvPicPr>
-            <a:picLocks noChangeAspect="1" noChangeArrowheads="1"/>
-          </p:cNvPicPr>
-          <p:nvPr userDrawn="1"/>
-        </p:nvPicPr>
-        <p:blipFill>
-          <a:blip r:embed="rId16" cstate="print">
-            <a:extLst>
-              <a:ext uri="{28A0092B-C50C-407E-A947-70E740481C1C}">
-                <a14:useLocalDpi xmlns:a14="http://schemas.microsoft.com/office/drawing/2010/main" val="0"/>
-              </a:ext>
-            </a:extLst>
-          </a:blip>
-          <a:srcRect/>
-          <a:stretch>
-            <a:fillRect/>
-          </a:stretch>
-        </p:blipFill>
-        <p:spPr bwMode="auto">
-          <a:xfrm>
-            <a:off x="8100392" y="188640"/>
-            <a:ext cx="310830" cy="149374"/>
-          </a:xfrm>
-          <a:prstGeom prst="rect">
-            <a:avLst/>
-          </a:prstGeom>
-          <a:noFill/>
-          <a:ln>
-            <a:noFill/>
-          </a:ln>
-          <a:extLst>
-            <a:ext uri="{909E8E84-426E-40DD-AFC4-6F175D3DCCD1}">
-              <a14:hiddenFill xmlns:a14="http://schemas.microsoft.com/office/drawing/2010/main">
-                <a:solidFill>
-                  <a:srgbClr val="FFFFFF"/>
-                </a:solidFill>
-              </a14:hiddenFill>
-            </a:ext>
-            <a:ext uri="{91240B29-F687-4F45-9708-019B960494DF}">
-              <a14:hiddenLine xmlns:a14="http://schemas.microsoft.com/office/drawing/2010/main" w="9525">
-                <a:solidFill>
-                  <a:srgbClr val="000000"/>
-                </a:solidFill>
-                <a:miter lim="800000"/>
-                <a:headEnd/>
-                <a:tailEnd/>
-              </a14:hiddenLine>
-            </a:ext>
-          </a:extLst>
-        </p:spPr>
-      </p:pic>
-      <p:sp>
-        <p:nvSpPr>
-          <p:cNvPr id="1035" name="Rectangle 29"/>
-          <p:cNvSpPr>
-            <a:spLocks noChangeAspect="1" noChangeArrowheads="1"/>
-          </p:cNvSpPr>
-          <p:nvPr userDrawn="1"/>
-        </p:nvSpPr>
-        <p:spPr bwMode="auto">
-          <a:xfrm>
-            <a:off x="0" y="6373813"/>
-            <a:ext cx="215900" cy="214312"/>
-          </a:xfrm>
-          <a:prstGeom prst="rect">
-            <a:avLst/>
-          </a:prstGeom>
-          <a:solidFill>
-            <a:srgbClr val="F70146"/>
-          </a:solidFill>
-          <a:ln>
-            <a:noFill/>
-          </a:ln>
-          <a:effectLst/>
-          <a:extLst>
-            <a:ext uri="{91240B29-F687-4F45-9708-019B960494DF}">
-              <a14:hiddenLine xmlns:a14="http://schemas.microsoft.com/office/drawing/2010/main" w="9525">
-                <a:solidFill>
-                  <a:schemeClr val="tx1"/>
-                </a:solidFill>
-                <a:miter lim="800000"/>
-                <a:headEnd/>
-                <a:tailEnd/>
-              </a14:hiddenLine>
-            </a:ext>
-            <a:ext uri="{AF507438-7753-43E0-B8FC-AC1667EBCBE1}">
-              <a14:hiddenEffects xmlns:a14="http://schemas.microsoft.com/office/drawing/2010/main">
-                <a:effectLst>
-                  <a:outerShdw dist="35921" dir="2700000" algn="ctr" rotWithShape="0">
-                    <a:schemeClr val="bg2"/>
-                  </a:outerShdw>
-                </a:effectLst>
-              </a14:hiddenEffects>
-            </a:ext>
-          </a:extLst>
-        </p:spPr>
-        <p:txBody>
-          <a:bodyPr wrap="none" anchor="ctr"/>
-          <a:lstStyle/>
-          <a:p>
-            <a:pPr>
-              <a:spcBef>
-                <a:spcPct val="30000"/>
-              </a:spcBef>
-            </a:pPr>
-            <a:endParaRPr lang="en-GB" sz="2000"/>
-          </a:p>
-        </p:txBody>
-      </p:sp>
-      <p:sp>
-        <p:nvSpPr>
           <p:cNvPr id="13" name="Text Box 30"/>
           <p:cNvSpPr txBox="1">
             <a:spLocks noChangeArrowheads="1"/>
@@ -3680,7 +3459,7 @@
         </p:nvSpPr>
         <p:spPr bwMode="auto">
           <a:xfrm>
-            <a:off x="215900" y="6381328"/>
+            <a:off x="102213" y="6613529"/>
             <a:ext cx="1882924" cy="215900"/>
           </a:xfrm>
           <a:prstGeom prst="rect">
@@ -3862,29 +3641,28 @@
       </p:sp>
       <p:pic>
         <p:nvPicPr>
-          <p:cNvPr id="2" name="Picture 2" descr="I:\raphaelluz\VECTO\source\VECTO\User Manual\pics\JRC.png"/>
+          <p:cNvPr id="2" name="Picture 2"/>
           <p:cNvPicPr>
             <a:picLocks noChangeAspect="1" noChangeArrowheads="1"/>
           </p:cNvPicPr>
           <p:nvPr userDrawn="1"/>
         </p:nvPicPr>
         <p:blipFill>
-          <a:blip r:embed="rId17">
+          <a:blip r:embed="rId15" cstate="print">
             <a:extLst>
               <a:ext uri="{28A0092B-C50C-407E-A947-70E740481C1C}">
                 <a14:useLocalDpi xmlns:a14="http://schemas.microsoft.com/office/drawing/2010/main" val="0"/>
               </a:ext>
             </a:extLst>
           </a:blip>
-          <a:srcRect/>
           <a:stretch>
             <a:fillRect/>
           </a:stretch>
         </p:blipFill>
         <p:spPr bwMode="auto">
           <a:xfrm>
-            <a:off x="6588224" y="44624"/>
-            <a:ext cx="1367520" cy="284378"/>
+            <a:off x="7668344" y="62835"/>
+            <a:ext cx="1400973" cy="347914"/>
           </a:xfrm>
           <a:prstGeom prst="rect">
             <a:avLst/>
@@ -3910,7 +3688,7 @@
           <p:nvPr userDrawn="1"/>
         </p:nvPicPr>
         <p:blipFill>
-          <a:blip r:embed="rId18">
+          <a:blip r:embed="rId16">
             <a:extLst>
               <a:ext uri="{28A0092B-C50C-407E-A947-70E740481C1C}">
                 <a14:useLocalDpi xmlns:a14="http://schemas.microsoft.com/office/drawing/2010/main" val="0"/>
@@ -3942,6 +3720,57 @@
           </a:extLst>
         </p:spPr>
       </p:pic>
+      <p:sp>
+        <p:nvSpPr>
+          <p:cNvPr id="14" name="Line 20"/>
+          <p:cNvSpPr>
+            <a:spLocks noChangeShapeType="1"/>
+          </p:cNvSpPr>
+          <p:nvPr userDrawn="1"/>
+        </p:nvSpPr>
+        <p:spPr bwMode="auto">
+          <a:xfrm>
+            <a:off x="0" y="6596862"/>
+            <a:ext cx="9144000" cy="0"/>
+          </a:xfrm>
+          <a:prstGeom prst="line">
+            <a:avLst/>
+          </a:prstGeom>
+          <a:noFill/>
+          <a:ln w="9525">
+            <a:solidFill>
+              <a:schemeClr val="tx1"/>
+            </a:solidFill>
+            <a:round/>
+            <a:headEnd/>
+            <a:tailEnd/>
+          </a:ln>
+          <a:effectLst/>
+          <a:extLst>
+            <a:ext uri="{909E8E84-426E-40DD-AFC4-6F175D3DCCD1}">
+              <a14:hiddenFill xmlns:a14="http://schemas.microsoft.com/office/drawing/2010/main">
+                <a:noFill/>
+              </a14:hiddenFill>
+            </a:ext>
+            <a:ext uri="{AF507438-7753-43E0-B8FC-AC1667EBCBE1}">
+              <a14:hiddenEffects xmlns:a14="http://schemas.microsoft.com/office/drawing/2010/main">
+                <a:effectLst>
+                  <a:outerShdw dist="35921" dir="2700000" algn="ctr" rotWithShape="0">
+                    <a:schemeClr val="bg2"/>
+                  </a:outerShdw>
+                </a:effectLst>
+              </a14:hiddenEffects>
+            </a:ext>
+          </a:extLst>
+        </p:spPr>
+        <p:txBody>
+          <a:bodyPr/>
+          <a:lstStyle/>
+          <a:p>
+            <a:endParaRPr lang="de-AT"/>
+          </a:p>
+        </p:txBody>
+      </p:sp>
     </p:spTree>
   </p:cSld>
   <p:clrMap bg1="lt1" tx1="dk1" bg2="lt2" tx2="dk2" accent1="accent1" accent2="accent2" accent3="accent3" accent4="accent4" accent5="accent5" accent6="accent6" hlink="hlink" folHlink="folHlink"/>
@@ -4531,11 +4360,6 @@
               </a:rPr>
               <a:t>03.12.2018</a:t>
             </a:r>
-            <a:endParaRPr lang="en-US" sz="2000" dirty="0" smtClean="0">
-              <a:solidFill>
-                <a:srgbClr val="990000"/>
-              </a:solidFill>
-            </a:endParaRPr>
           </a:p>
           <a:p>
             <a:pPr eaLnBrk="1" hangingPunct="1"/>
@@ -7284,7 +7108,6 @@
               <a:rPr lang="en-US" sz="1600" dirty="0" smtClean="0"/>
               <a:t>[VECTO-795] – VECTO Hashing Tool crashes</a:t>
             </a:r>
-            <a:endParaRPr lang="en-US" sz="1600" dirty="0" smtClean="0"/>
           </a:p>
           <a:p>
             <a:pPr>

</xml_diff>

<commit_message>
remove TUG/IVT logos from release notes ppt
</commit_message>
<xml_diff>
--- a/Documentation/User Manual Source/Release Notes Vecto3.x.pptx
+++ b/Documentation/User Manual Source/Release Notes Vecto3.x.pptx
@@ -3451,227 +3451,6 @@
       </p:sp>
       <p:sp>
         <p:nvSpPr>
-          <p:cNvPr id="1031" name="Rectangle 25"/>
-          <p:cNvSpPr>
-            <a:spLocks noChangeArrowheads="1"/>
-          </p:cNvSpPr>
-          <p:nvPr userDrawn="1"/>
-        </p:nvSpPr>
-        <p:spPr bwMode="auto">
-          <a:xfrm>
-            <a:off x="0" y="6373813"/>
-            <a:ext cx="9144000" cy="215900"/>
-          </a:xfrm>
-          <a:prstGeom prst="rect">
-            <a:avLst/>
-          </a:prstGeom>
-          <a:solidFill>
-            <a:srgbClr val="DDDDDD"/>
-          </a:solidFill>
-          <a:ln w="6350">
-            <a:solidFill>
-              <a:schemeClr val="tx1"/>
-            </a:solidFill>
-            <a:miter lim="800000"/>
-            <a:headEnd/>
-            <a:tailEnd/>
-          </a:ln>
-          <a:effectLst/>
-          <a:extLst>
-            <a:ext uri="{AF507438-7753-43E0-B8FC-AC1667EBCBE1}">
-              <a14:hiddenEffects xmlns:a14="http://schemas.microsoft.com/office/drawing/2010/main">
-                <a:effectLst>
-                  <a:outerShdw dist="35921" dir="2700000" algn="ctr" rotWithShape="0">
-                    <a:schemeClr val="bg2"/>
-                  </a:outerShdw>
-                </a:effectLst>
-              </a14:hiddenEffects>
-            </a:ext>
-          </a:extLst>
-        </p:spPr>
-        <p:txBody>
-          <a:bodyPr wrap="none" tIns="39600" anchor="ctr"/>
-          <a:lstStyle/>
-          <a:p>
-            <a:pPr algn="l">
-              <a:spcBef>
-                <a:spcPct val="0"/>
-              </a:spcBef>
-            </a:pPr>
-            <a:endParaRPr lang="en-GB" sz="1200">
-              <a:latin typeface="Verdana" pitchFamily="34" charset="0"/>
-            </a:endParaRPr>
-          </a:p>
-        </p:txBody>
-      </p:sp>
-      <p:pic>
-        <p:nvPicPr>
-          <p:cNvPr id="1032" name="Picture 26" descr="logo"/>
-          <p:cNvPicPr>
-            <a:picLocks noChangeAspect="1" noChangeArrowheads="1"/>
-          </p:cNvPicPr>
-          <p:nvPr userDrawn="1"/>
-        </p:nvPicPr>
-        <p:blipFill>
-          <a:blip r:embed="rId15" cstate="print">
-            <a:extLst>
-              <a:ext uri="{28A0092B-C50C-407E-A947-70E740481C1C}">
-                <a14:useLocalDpi xmlns:a14="http://schemas.microsoft.com/office/drawing/2010/main" val="0"/>
-              </a:ext>
-            </a:extLst>
-          </a:blip>
-          <a:srcRect/>
-          <a:stretch>
-            <a:fillRect/>
-          </a:stretch>
-        </p:blipFill>
-        <p:spPr bwMode="auto">
-          <a:xfrm>
-            <a:off x="8532442" y="152075"/>
-            <a:ext cx="504056" cy="185220"/>
-          </a:xfrm>
-          <a:prstGeom prst="rect">
-            <a:avLst/>
-          </a:prstGeom>
-          <a:noFill/>
-          <a:ln>
-            <a:noFill/>
-          </a:ln>
-          <a:extLst>
-            <a:ext uri="{909E8E84-426E-40DD-AFC4-6F175D3DCCD1}">
-              <a14:hiddenFill xmlns:a14="http://schemas.microsoft.com/office/drawing/2010/main">
-                <a:solidFill>
-                  <a:srgbClr val="FFFFFF"/>
-                </a:solidFill>
-              </a14:hiddenFill>
-            </a:ext>
-            <a:ext uri="{91240B29-F687-4F45-9708-019B960494DF}">
-              <a14:hiddenLine xmlns:a14="http://schemas.microsoft.com/office/drawing/2010/main" w="9525">
-                <a:solidFill>
-                  <a:srgbClr val="000000"/>
-                </a:solidFill>
-                <a:miter lim="800000"/>
-                <a:headEnd/>
-                <a:tailEnd/>
-              </a14:hiddenLine>
-            </a:ext>
-          </a:extLst>
-        </p:spPr>
-      </p:pic>
-      <p:pic>
-        <p:nvPicPr>
-          <p:cNvPr id="1033" name="Picture 27" descr="IVT_Logo_klein"/>
-          <p:cNvPicPr>
-            <a:picLocks noChangeAspect="1" noChangeArrowheads="1"/>
-          </p:cNvPicPr>
-          <p:nvPr userDrawn="1"/>
-        </p:nvPicPr>
-        <p:blipFill>
-          <a:blip r:embed="rId16" cstate="print">
-            <a:extLst>
-              <a:ext uri="{28A0092B-C50C-407E-A947-70E740481C1C}">
-                <a14:useLocalDpi xmlns:a14="http://schemas.microsoft.com/office/drawing/2010/main" val="0"/>
-              </a:ext>
-            </a:extLst>
-          </a:blip>
-          <a:srcRect/>
-          <a:stretch>
-            <a:fillRect/>
-          </a:stretch>
-        </p:blipFill>
-        <p:spPr bwMode="auto">
-          <a:xfrm>
-            <a:off x="8100392" y="188640"/>
-            <a:ext cx="310830" cy="149374"/>
-          </a:xfrm>
-          <a:prstGeom prst="rect">
-            <a:avLst/>
-          </a:prstGeom>
-          <a:noFill/>
-          <a:ln>
-            <a:noFill/>
-          </a:ln>
-          <a:extLst>
-            <a:ext uri="{909E8E84-426E-40DD-AFC4-6F175D3DCCD1}">
-              <a14:hiddenFill xmlns:a14="http://schemas.microsoft.com/office/drawing/2010/main">
-                <a:solidFill>
-                  <a:srgbClr val="FFFFFF"/>
-                </a:solidFill>
-              </a14:hiddenFill>
-            </a:ext>
-            <a:ext uri="{91240B29-F687-4F45-9708-019B960494DF}">
-              <a14:hiddenLine xmlns:a14="http://schemas.microsoft.com/office/drawing/2010/main" w="9525">
-                <a:solidFill>
-                  <a:srgbClr val="000000"/>
-                </a:solidFill>
-                <a:miter lim="800000"/>
-                <a:headEnd/>
-                <a:tailEnd/>
-              </a14:hiddenLine>
-            </a:ext>
-          </a:extLst>
-        </p:spPr>
-      </p:pic>
-      <p:sp>
-        <p:nvSpPr>
-          <p:cNvPr id="1035" name="Rectangle 29"/>
-          <p:cNvSpPr>
-            <a:spLocks noChangeAspect="1" noChangeArrowheads="1"/>
-          </p:cNvSpPr>
-          <p:nvPr userDrawn="1"/>
-        </p:nvSpPr>
-        <p:spPr bwMode="auto">
-          <a:xfrm>
-            <a:off x="0" y="6373813"/>
-            <a:ext cx="215900" cy="214312"/>
-          </a:xfrm>
-          <a:prstGeom prst="rect">
-            <a:avLst/>
-          </a:prstGeom>
-          <a:solidFill>
-            <a:srgbClr val="F70146"/>
-          </a:solidFill>
-          <a:ln>
-            <a:noFill/>
-          </a:ln>
-          <a:effectLst/>
-          <a:extLst>
-            <a:ext uri="{91240B29-F687-4F45-9708-019B960494DF}">
-              <a14:hiddenLine xmlns:a14="http://schemas.microsoft.com/office/drawing/2010/main" w="9525">
-                <a:solidFill>
-                  <a:schemeClr val="tx1"/>
-                </a:solidFill>
-                <a:miter lim="800000"/>
-                <a:headEnd/>
-                <a:tailEnd/>
-              </a14:hiddenLine>
-            </a:ext>
-            <a:ext uri="{AF507438-7753-43E0-B8FC-AC1667EBCBE1}">
-              <a14:hiddenEffects xmlns:a14="http://schemas.microsoft.com/office/drawing/2010/main">
-                <a:effectLst>
-                  <a:outerShdw dist="35921" dir="2700000" algn="ctr" rotWithShape="0">
-                    <a:schemeClr val="bg2"/>
-                  </a:outerShdw>
-                </a:effectLst>
-              </a14:hiddenEffects>
-            </a:ext>
-          </a:extLst>
-        </p:spPr>
-        <p:txBody>
-          <a:bodyPr wrap="none" anchor="ctr"/>
-          <a:lstStyle/>
-          <a:p>
-            <a:pPr>
-              <a:spcBef>
-                <a:spcPct val="30000"/>
-              </a:spcBef>
-            </a:pPr>
-            <a:endParaRPr lang="en-GB" sz="2000"/>
-          </a:p>
-        </p:txBody>
-      </p:sp>
-      <p:sp>
-        <p:nvSpPr>
           <p:cNvPr id="13" name="Text Box 30"/>
           <p:cNvSpPr txBox="1">
             <a:spLocks noChangeArrowheads="1"/>
@@ -3680,7 +3459,7 @@
         </p:nvSpPr>
         <p:spPr bwMode="auto">
           <a:xfrm>
-            <a:off x="215900" y="6381328"/>
+            <a:off x="144393" y="6627817"/>
             <a:ext cx="1882924" cy="215900"/>
           </a:xfrm>
           <a:prstGeom prst="rect">
@@ -3862,29 +3641,28 @@
       </p:sp>
       <p:pic>
         <p:nvPicPr>
-          <p:cNvPr id="2" name="Picture 2" descr="I:\raphaelluz\VECTO\source\VECTO\User Manual\pics\JRC.png"/>
+          <p:cNvPr id="2" name="Picture 2"/>
           <p:cNvPicPr>
             <a:picLocks noChangeAspect="1" noChangeArrowheads="1"/>
           </p:cNvPicPr>
           <p:nvPr userDrawn="1"/>
         </p:nvPicPr>
         <p:blipFill>
-          <a:blip r:embed="rId17">
+          <a:blip r:embed="rId15" cstate="print">
             <a:extLst>
               <a:ext uri="{28A0092B-C50C-407E-A947-70E740481C1C}">
                 <a14:useLocalDpi xmlns:a14="http://schemas.microsoft.com/office/drawing/2010/main" val="0"/>
               </a:ext>
             </a:extLst>
           </a:blip>
-          <a:srcRect/>
           <a:stretch>
             <a:fillRect/>
           </a:stretch>
         </p:blipFill>
         <p:spPr bwMode="auto">
           <a:xfrm>
-            <a:off x="6588224" y="44624"/>
-            <a:ext cx="1367520" cy="284378"/>
+            <a:off x="7389209" y="37884"/>
+            <a:ext cx="1421346" cy="352973"/>
           </a:xfrm>
           <a:prstGeom prst="rect">
             <a:avLst/>
@@ -3910,7 +3688,7 @@
           <p:nvPr userDrawn="1"/>
         </p:nvPicPr>
         <p:blipFill>
-          <a:blip r:embed="rId18">
+          <a:blip r:embed="rId16">
             <a:extLst>
               <a:ext uri="{28A0092B-C50C-407E-A947-70E740481C1C}">
                 <a14:useLocalDpi xmlns:a14="http://schemas.microsoft.com/office/drawing/2010/main" val="0"/>
@@ -3942,6 +3720,57 @@
           </a:extLst>
         </p:spPr>
       </p:pic>
+      <p:sp>
+        <p:nvSpPr>
+          <p:cNvPr id="14" name="Line 20"/>
+          <p:cNvSpPr>
+            <a:spLocks noChangeShapeType="1"/>
+          </p:cNvSpPr>
+          <p:nvPr userDrawn="1"/>
+        </p:nvSpPr>
+        <p:spPr bwMode="auto">
+          <a:xfrm>
+            <a:off x="0" y="6599242"/>
+            <a:ext cx="9144000" cy="0"/>
+          </a:xfrm>
+          <a:prstGeom prst="line">
+            <a:avLst/>
+          </a:prstGeom>
+          <a:noFill/>
+          <a:ln w="9525">
+            <a:solidFill>
+              <a:schemeClr val="tx1"/>
+            </a:solidFill>
+            <a:round/>
+            <a:headEnd/>
+            <a:tailEnd/>
+          </a:ln>
+          <a:effectLst/>
+          <a:extLst>
+            <a:ext uri="{909E8E84-426E-40DD-AFC4-6F175D3DCCD1}">
+              <a14:hiddenFill xmlns:a14="http://schemas.microsoft.com/office/drawing/2010/main">
+                <a:noFill/>
+              </a14:hiddenFill>
+            </a:ext>
+            <a:ext uri="{AF507438-7753-43E0-B8FC-AC1667EBCBE1}">
+              <a14:hiddenEffects xmlns:a14="http://schemas.microsoft.com/office/drawing/2010/main">
+                <a:effectLst>
+                  <a:outerShdw dist="35921" dir="2700000" algn="ctr" rotWithShape="0">
+                    <a:schemeClr val="bg2"/>
+                  </a:outerShdw>
+                </a:effectLst>
+              </a14:hiddenEffects>
+            </a:ext>
+          </a:extLst>
+        </p:spPr>
+        <p:txBody>
+          <a:bodyPr/>
+          <a:lstStyle/>
+          <a:p>
+            <a:endParaRPr lang="de-AT"/>
+          </a:p>
+        </p:txBody>
+      </p:sp>
     </p:spTree>
   </p:cSld>
   <p:clrMap bg1="lt1" tx1="dk1" bg2="lt2" tx2="dk2" accent1="accent1" accent2="accent2" accent3="accent3" accent4="accent4" accent5="accent5" accent6="accent6" hlink="hlink" folHlink="folHlink"/>
@@ -4531,11 +4360,6 @@
               </a:rPr>
               <a:t>04.12.2018</a:t>
             </a:r>
-            <a:endParaRPr lang="en-US" sz="2000" dirty="0" smtClean="0">
-              <a:solidFill>
-                <a:srgbClr val="990000"/>
-              </a:solidFill>
-            </a:endParaRPr>
           </a:p>
           <a:p>
             <a:pPr eaLnBrk="1" hangingPunct="1"/>
@@ -7223,11 +7047,7 @@
             </a:r>
             <a:r>
               <a:rPr lang="en-US" dirty="0" smtClean="0"/>
-              <a:t>3.3.0.1433 </a:t>
-            </a:r>
-            <a:r>
-              <a:rPr lang="en-US" dirty="0" smtClean="0"/>
-              <a:t>Official Release</a:t>
+              <a:t>3.3.0.1433 Official Release</a:t>
             </a:r>
             <a:r>
               <a:rPr lang="en-US" dirty="0"/>
@@ -7286,11 +7106,7 @@
             </a:pPr>
             <a:r>
               <a:rPr lang="en-US" sz="1600" dirty="0" smtClean="0"/>
-              <a:t>[VECTO-795] – VECTO Hashing Tool </a:t>
-            </a:r>
-            <a:r>
-              <a:rPr lang="en-US" sz="1600" dirty="0" smtClean="0"/>
-              <a:t>crashes</a:t>
+              <a:t>[VECTO-795] – VECTO Hashing Tool crashes</a:t>
             </a:r>
           </a:p>
           <a:p>
@@ -7315,7 +7131,6 @@
               <a:rPr lang="en-US" sz="1600" dirty="0" smtClean="0"/>
               <a:t>file</a:t>
             </a:r>
-            <a:endParaRPr lang="en-US" sz="1600" dirty="0" smtClean="0"/>
           </a:p>
           <a:p>
             <a:pPr>

</xml_diff>

<commit_message>
update user manual and release notes with more details on the input parameters for CNG/LNG vehicles.
</commit_message>
<xml_diff>
--- a/Documentation/User Manual Source/Release Notes Vecto3.x.pptx
+++ b/Documentation/User Manual Source/Release Notes Vecto3.x.pptx
@@ -7588,11 +7588,7 @@
             </a:r>
             <a:r>
               <a:rPr lang="en-US" sz="1400" dirty="0" smtClean="0"/>
-              <a:t>power demand </a:t>
-            </a:r>
-            <a:r>
-              <a:rPr lang="en-US" sz="1400" dirty="0" smtClean="0"/>
-              <a:t>auxiliaries (for extended segmentation table)</a:t>
+              <a:t>power demand auxiliaries (for extended segmentation table)</a:t>
             </a:r>
             <a:endParaRPr lang="en-US" sz="1400" dirty="0"/>
           </a:p>
@@ -7734,7 +7730,6 @@
               <a:rPr lang="en-US" sz="1400" dirty="0" smtClean="0"/>
               <a:t>missing</a:t>
             </a:r>
-            <a:endParaRPr lang="en-US" sz="1400" dirty="0" smtClean="0"/>
           </a:p>
         </p:txBody>
       </p:sp>
@@ -10480,7 +10475,7 @@
         </p:nvSpPr>
         <p:spPr>
           <a:xfrm>
-            <a:off x="323529" y="1628800"/>
+            <a:off x="323529" y="1196752"/>
             <a:ext cx="8640960" cy="1584176"/>
           </a:xfrm>
         </p:spPr>
@@ -10495,7 +10490,11 @@
             </a:pPr>
             <a:r>
               <a:rPr lang="en-US" sz="1800" b="1" dirty="0" smtClean="0"/>
-              <a:t>New input parameters</a:t>
+              <a:t>New input </a:t>
+            </a:r>
+            <a:r>
+              <a:rPr lang="en-US" sz="1800" b="1" dirty="0" smtClean="0"/>
+              <a:t>parameters</a:t>
             </a:r>
             <a:endParaRPr lang="en-US" sz="1800" b="1" dirty="0"/>
           </a:p>
@@ -10507,15 +10506,7 @@
             </a:pPr>
             <a:r>
               <a:rPr lang="en-US" sz="1400" dirty="0" smtClean="0"/>
-              <a:t>The new input fields (see table below) are optional in this version. When this release candidate will be an official </a:t>
-            </a:r>
-            <a:r>
-              <a:rPr lang="en-US" sz="1400" dirty="0" smtClean="0"/>
-              <a:t>version </a:t>
-            </a:r>
-            <a:r>
-              <a:rPr lang="en-US" sz="1400" dirty="0" smtClean="0"/>
-              <a:t>manufacturers MAY certify their new vehicles using the new input parameters. As from 1</a:t>
+              <a:t>The new input fields (see table below) are optional in this version. When this release candidate will be an official version manufacturers MAY certify their new vehicles using the new input parameters. As from 1</a:t>
             </a:r>
             <a:r>
               <a:rPr lang="en-US" sz="1400" baseline="30000" dirty="0" smtClean="0"/>
@@ -10523,13 +10514,8 @@
             </a:r>
             <a:r>
               <a:rPr lang="en-US" sz="1400" dirty="0" smtClean="0"/>
-              <a:t> July 2019 the new input fields will become </a:t>
-            </a:r>
-            <a:r>
-              <a:rPr lang="en-US" sz="1400" dirty="0" smtClean="0"/>
-              <a:t>mandatory. Further details are provided in the timetable on the next page.</a:t>
-            </a:r>
-            <a:endParaRPr lang="en-US" sz="1400" dirty="0" smtClean="0"/>
+              <a:t> July 2019 the new input fields will become mandatory. Further details are provided in the timetable on the next page.</a:t>
+            </a:r>
           </a:p>
           <a:p>
             <a:pPr lvl="1">
@@ -10591,13 +10577,13 @@
           <p:nvPr>
             <p:extLst>
               <p:ext uri="{D42A27DB-BD31-4B8C-83A1-F6EECF244321}">
-                <p14:modId xmlns:p14="http://schemas.microsoft.com/office/powerpoint/2010/main" val="3024880213"/>
+                <p14:modId xmlns:p14="http://schemas.microsoft.com/office/powerpoint/2010/main" val="1239747512"/>
               </p:ext>
             </p:extLst>
           </p:nvPr>
         </p:nvGraphicFramePr>
         <p:xfrm>
-          <a:off x="1475656" y="3200714"/>
+          <a:off x="1475656" y="2768666"/>
           <a:ext cx="6022519" cy="2892582"/>
         </p:xfrm>
         <a:graphic>
@@ -11380,6 +11366,279 @@
           </a:graphicData>
         </a:graphic>
       </p:graphicFrame>
+      <p:sp>
+        <p:nvSpPr>
+          <p:cNvPr id="6" name="Inhaltsplatzhalter 2"/>
+          <p:cNvSpPr txBox="1">
+            <a:spLocks/>
+          </p:cNvSpPr>
+          <p:nvPr/>
+        </p:nvSpPr>
+        <p:spPr bwMode="auto">
+          <a:xfrm>
+            <a:off x="166435" y="5661248"/>
+            <a:ext cx="8640960" cy="936104"/>
+          </a:xfrm>
+          <a:prstGeom prst="rect">
+            <a:avLst/>
+          </a:prstGeom>
+          <a:noFill/>
+          <a:ln>
+            <a:noFill/>
+          </a:ln>
+          <a:effectLst/>
+          <a:extLst>
+            <a:ext uri="{909E8E84-426E-40DD-AFC4-6F175D3DCCD1}">
+              <a14:hiddenFill xmlns:a14="http://schemas.microsoft.com/office/drawing/2010/main">
+                <a:solidFill>
+                  <a:srgbClr val="DDDDDD"/>
+                </a:solidFill>
+              </a14:hiddenFill>
+            </a:ext>
+            <a:ext uri="{91240B29-F687-4F45-9708-019B960494DF}">
+              <a14:hiddenLine xmlns:a14="http://schemas.microsoft.com/office/drawing/2010/main" w="9525">
+                <a:solidFill>
+                  <a:srgbClr val="DDDDDD"/>
+                </a:solidFill>
+                <a:miter lim="800000"/>
+                <a:headEnd/>
+                <a:tailEnd/>
+              </a14:hiddenLine>
+            </a:ext>
+            <a:ext uri="{AF507438-7753-43E0-B8FC-AC1667EBCBE1}">
+              <a14:hiddenEffects xmlns:a14="http://schemas.microsoft.com/office/drawing/2010/main">
+                <a:effectLst>
+                  <a:outerShdw dist="35921" dir="2700000" algn="ctr" rotWithShape="0">
+                    <a:schemeClr val="bg2"/>
+                  </a:outerShdw>
+                </a:effectLst>
+              </a14:hiddenEffects>
+            </a:ext>
+          </a:extLst>
+        </p:spPr>
+        <p:txBody>
+          <a:bodyPr vert="horz" wrap="square" lIns="91440" tIns="45720" rIns="91440" bIns="45720" numCol="1" anchor="t" anchorCtr="0" compatLnSpc="1">
+            <a:prstTxWarp prst="textNoShape">
+              <a:avLst/>
+            </a:prstTxWarp>
+          </a:bodyPr>
+          <a:lstStyle>
+            <a:lvl1pPr marL="342900" indent="-342900" algn="l" rtl="0" eaLnBrk="0" fontAlgn="base" hangingPunct="0">
+              <a:spcBef>
+                <a:spcPct val="20000"/>
+              </a:spcBef>
+              <a:spcAft>
+                <a:spcPct val="0"/>
+              </a:spcAft>
+              <a:buChar char="•"/>
+              <a:defRPr sz="2000">
+                <a:solidFill>
+                  <a:schemeClr val="tx1"/>
+                </a:solidFill>
+                <a:latin typeface="+mn-lt"/>
+                <a:ea typeface="+mn-ea"/>
+                <a:cs typeface="+mn-cs"/>
+              </a:defRPr>
+            </a:lvl1pPr>
+            <a:lvl2pPr marL="742950" indent="-285750" algn="l" rtl="0" eaLnBrk="0" fontAlgn="base" hangingPunct="0">
+              <a:spcBef>
+                <a:spcPct val="20000"/>
+              </a:spcBef>
+              <a:spcAft>
+                <a:spcPct val="0"/>
+              </a:spcAft>
+              <a:buChar char="–"/>
+              <a:defRPr>
+                <a:solidFill>
+                  <a:schemeClr val="tx1"/>
+                </a:solidFill>
+                <a:latin typeface="+mn-lt"/>
+              </a:defRPr>
+            </a:lvl2pPr>
+            <a:lvl3pPr marL="1143000" indent="-228600" algn="l" rtl="0" eaLnBrk="0" fontAlgn="base" hangingPunct="0">
+              <a:spcBef>
+                <a:spcPct val="20000"/>
+              </a:spcBef>
+              <a:spcAft>
+                <a:spcPct val="0"/>
+              </a:spcAft>
+              <a:buChar char="•"/>
+              <a:defRPr sz="1400">
+                <a:solidFill>
+                  <a:schemeClr val="tx1"/>
+                </a:solidFill>
+                <a:latin typeface="+mn-lt"/>
+              </a:defRPr>
+            </a:lvl3pPr>
+            <a:lvl4pPr marL="1600200" indent="-228600" algn="l" rtl="0" eaLnBrk="0" fontAlgn="base" hangingPunct="0">
+              <a:spcBef>
+                <a:spcPct val="20000"/>
+              </a:spcBef>
+              <a:spcAft>
+                <a:spcPct val="0"/>
+              </a:spcAft>
+              <a:buChar char="–"/>
+              <a:defRPr sz="1200">
+                <a:solidFill>
+                  <a:schemeClr val="tx1"/>
+                </a:solidFill>
+                <a:latin typeface="+mn-lt"/>
+              </a:defRPr>
+            </a:lvl4pPr>
+            <a:lvl5pPr marL="2057400" indent="-228600" algn="l" rtl="0" eaLnBrk="0" fontAlgn="base" hangingPunct="0">
+              <a:spcBef>
+                <a:spcPct val="20000"/>
+              </a:spcBef>
+              <a:spcAft>
+                <a:spcPct val="0"/>
+              </a:spcAft>
+              <a:buChar char="»"/>
+              <a:defRPr sz="2000">
+                <a:solidFill>
+                  <a:schemeClr val="tx1"/>
+                </a:solidFill>
+                <a:latin typeface="+mn-lt"/>
+              </a:defRPr>
+            </a:lvl5pPr>
+            <a:lvl6pPr marL="2514600" indent="-228600" algn="l" rtl="0" fontAlgn="base">
+              <a:spcBef>
+                <a:spcPct val="20000"/>
+              </a:spcBef>
+              <a:spcAft>
+                <a:spcPct val="0"/>
+              </a:spcAft>
+              <a:buChar char="»"/>
+              <a:defRPr sz="2000">
+                <a:solidFill>
+                  <a:schemeClr val="tx1"/>
+                </a:solidFill>
+                <a:latin typeface="+mn-lt"/>
+              </a:defRPr>
+            </a:lvl6pPr>
+            <a:lvl7pPr marL="2971800" indent="-228600" algn="l" rtl="0" fontAlgn="base">
+              <a:spcBef>
+                <a:spcPct val="20000"/>
+              </a:spcBef>
+              <a:spcAft>
+                <a:spcPct val="0"/>
+              </a:spcAft>
+              <a:buChar char="»"/>
+              <a:defRPr sz="2000">
+                <a:solidFill>
+                  <a:schemeClr val="tx1"/>
+                </a:solidFill>
+                <a:latin typeface="+mn-lt"/>
+              </a:defRPr>
+            </a:lvl7pPr>
+            <a:lvl8pPr marL="3429000" indent="-228600" algn="l" rtl="0" fontAlgn="base">
+              <a:spcBef>
+                <a:spcPct val="20000"/>
+              </a:spcBef>
+              <a:spcAft>
+                <a:spcPct val="0"/>
+              </a:spcAft>
+              <a:buChar char="»"/>
+              <a:defRPr sz="2000">
+                <a:solidFill>
+                  <a:schemeClr val="tx1"/>
+                </a:solidFill>
+                <a:latin typeface="+mn-lt"/>
+              </a:defRPr>
+            </a:lvl8pPr>
+            <a:lvl9pPr marL="3886200" indent="-228600" algn="l" rtl="0" fontAlgn="base">
+              <a:spcBef>
+                <a:spcPct val="20000"/>
+              </a:spcBef>
+              <a:spcAft>
+                <a:spcPct val="0"/>
+              </a:spcAft>
+              <a:buChar char="»"/>
+              <a:defRPr sz="2000">
+                <a:solidFill>
+                  <a:schemeClr val="tx1"/>
+                </a:solidFill>
+                <a:latin typeface="+mn-lt"/>
+              </a:defRPr>
+            </a:lvl9pPr>
+          </a:lstStyle>
+          <a:p>
+            <a:pPr lvl="1">
+              <a:tabLst>
+                <a:tab pos="1885950" algn="l"/>
+              </a:tabLst>
+            </a:pPr>
+            <a:r>
+              <a:rPr lang="en-US" sz="1400" b="0" kern="0" dirty="0" smtClean="0"/>
+              <a:t>Currently </a:t>
+            </a:r>
+            <a:r>
+              <a:rPr lang="en-US" sz="1400" kern="0" dirty="0" smtClean="0"/>
+              <a:t>only</a:t>
+            </a:r>
+            <a:r>
+              <a:rPr lang="en-US" sz="1400" b="0" kern="0" dirty="0" smtClean="0"/>
+              <a:t> the fuel type ‘</a:t>
+            </a:r>
+            <a:r>
+              <a:rPr lang="en-US" sz="1400" kern="0" dirty="0" smtClean="0"/>
+              <a:t>NG PI</a:t>
+            </a:r>
+            <a:r>
+              <a:rPr lang="en-US" sz="1400" b="0" kern="0" dirty="0" smtClean="0"/>
+              <a:t>’ for the </a:t>
+            </a:r>
+            <a:r>
+              <a:rPr lang="en-US" sz="1400" kern="0" dirty="0" smtClean="0"/>
+              <a:t>engine certification </a:t>
+            </a:r>
+            <a:r>
+              <a:rPr lang="en-US" sz="1400" b="0" kern="0" dirty="0" smtClean="0"/>
+              <a:t>is allowed by 2017/2400. For LNG vehicles, therefore, the engine fuel type has to be set to ‘</a:t>
+            </a:r>
+            <a:r>
+              <a:rPr lang="en-US" sz="1400" kern="0" dirty="0" smtClean="0"/>
+              <a:t>NG PI</a:t>
+            </a:r>
+            <a:r>
+              <a:rPr lang="en-US" sz="1400" b="0" kern="0" dirty="0" smtClean="0"/>
+              <a:t>’ and at the vehicle level </a:t>
+            </a:r>
+            <a:r>
+              <a:rPr lang="en-US" sz="1400" b="0" kern="0" dirty="0" err="1" smtClean="0"/>
+              <a:t>NgTankSystem</a:t>
+            </a:r>
+            <a:r>
+              <a:rPr lang="en-US" sz="1400" b="0" kern="0" dirty="0" smtClean="0"/>
+              <a:t> has to be set to </a:t>
+            </a:r>
+            <a:r>
+              <a:rPr lang="en-US" sz="1400" kern="0" dirty="0" smtClean="0"/>
+              <a:t>liquefied</a:t>
+            </a:r>
+            <a:r>
+              <a:rPr lang="en-US" sz="1400" b="0" kern="0" dirty="0" smtClean="0"/>
+              <a:t>. For CNG the same engine fuel type is used but </a:t>
+            </a:r>
+            <a:r>
+              <a:rPr lang="en-US" sz="1400" b="0" kern="0" dirty="0" err="1" smtClean="0"/>
+              <a:t>NgTankSystem</a:t>
+            </a:r>
+            <a:r>
+              <a:rPr lang="en-US" sz="1400" b="0" kern="0" dirty="0" smtClean="0"/>
+              <a:t> has to be set to </a:t>
+            </a:r>
+            <a:r>
+              <a:rPr lang="en-US" sz="1400" kern="0" dirty="0" smtClean="0"/>
+              <a:t>compressed</a:t>
+            </a:r>
+            <a:r>
+              <a:rPr lang="en-US" sz="1400" b="0" kern="0" dirty="0" smtClean="0"/>
+              <a:t>.</a:t>
+            </a:r>
+            <a:endParaRPr lang="en-US" sz="1400" b="0" kern="0" dirty="0" smtClean="0"/>
+          </a:p>
+        </p:txBody>
+      </p:sp>
     </p:spTree>
     <p:extLst>
       <p:ext uri="{BB962C8B-B14F-4D97-AF65-F5344CB8AC3E}">
@@ -16305,11 +16564,7 @@
             </a:pPr>
             <a:r>
               <a:rPr lang="en-US" sz="1800" b="1" dirty="0" smtClean="0"/>
-              <a:t>Update of Fuel Properties [</a:t>
-            </a:r>
-            <a:r>
-              <a:rPr lang="en-US" sz="1800" b="1" dirty="0" smtClean="0"/>
-              <a:t>VECTO-796]</a:t>
+              <a:t>Update of Fuel Properties [VECTO-796]</a:t>
             </a:r>
             <a:endParaRPr lang="en-US" sz="1800" b="1" dirty="0"/>
           </a:p>

</xml_diff>

<commit_message>
new development release 0.6.1.1957
</commit_message>
<xml_diff>
--- a/Documentation/User Manual Source/Release Notes Vecto3.x.pptx
+++ b/Documentation/User Manual Source/Release Notes Vecto3.x.pptx
@@ -4378,11 +4378,6 @@
               </a:rPr>
               <a:t>05/2020</a:t>
             </a:r>
-            <a:endParaRPr lang="en-US" sz="2000" dirty="0" smtClean="0">
-              <a:solidFill>
-                <a:srgbClr val="990000"/>
-              </a:solidFill>
-            </a:endParaRPr>
           </a:p>
           <a:p>
             <a:pPr eaLnBrk="1" hangingPunct="1"/>
@@ -10563,11 +10558,7 @@
             </a:r>
             <a:r>
               <a:rPr lang="en-US" dirty="0" smtClean="0"/>
-              <a:t>0.6.1.1957 </a:t>
-            </a:r>
-            <a:r>
-              <a:rPr lang="en-US" dirty="0" smtClean="0"/>
-              <a:t>Development Version</a:t>
+              <a:t>0.6.1.1957 Development Version</a:t>
             </a:r>
             <a:r>
               <a:rPr lang="en-US" dirty="0"/>
@@ -10578,11 +10569,7 @@
             </a:br>
             <a:r>
               <a:rPr lang="en-US" sz="1600" dirty="0" smtClean="0"/>
-              <a:t>May </a:t>
-            </a:r>
-            <a:r>
-              <a:rPr lang="en-US" sz="1600" dirty="0" smtClean="0"/>
-              <a:t>2020</a:t>
+              <a:t>May 2020</a:t>
             </a:r>
             <a:endParaRPr lang="en-US" sz="1600" dirty="0"/>
           </a:p>
@@ -10660,8 +10647,21 @@
             </a:pPr>
             <a:r>
               <a:rPr lang="en-US" sz="1600" dirty="0" smtClean="0"/>
-              <a:t>“Single bus” mode with data from segmentation table completed vehicle</a:t>
-            </a:r>
+              <a:t>“Single bus” mode with </a:t>
+            </a:r>
+            <a:r>
+              <a:rPr lang="en-US" sz="1600" dirty="0" smtClean="0"/>
+              <a:t>generic data </a:t>
+            </a:r>
+            <a:r>
+              <a:rPr lang="en-US" sz="1600" dirty="0" smtClean="0"/>
+              <a:t>from segmentation table completed </a:t>
+            </a:r>
+            <a:r>
+              <a:rPr lang="en-US" sz="1600" dirty="0" smtClean="0"/>
+              <a:t>vehicle (previous version used generic data from primary vehicle)</a:t>
+            </a:r>
+            <a:endParaRPr lang="en-US" sz="1600" dirty="0" smtClean="0"/>
           </a:p>
           <a:p>
             <a:pPr lvl="1">
@@ -10726,7 +10726,15 @@
             </a:pPr>
             <a:r>
               <a:rPr lang="en-US" sz="1200" dirty="0" smtClean="0"/>
-              <a:t>Creating complete(d) bus job file (PIF + completed XML)</a:t>
+              <a:t>Creating </a:t>
+            </a:r>
+            <a:r>
+              <a:rPr lang="en-US" sz="1200" dirty="0"/>
+              <a:t>&amp; editing complete(d</a:t>
+            </a:r>
+            <a:r>
+              <a:rPr lang="en-US" sz="1200" dirty="0" smtClean="0"/>
+              <a:t>) bus job file (PIF + completed XML)</a:t>
             </a:r>
           </a:p>
           <a:p>
@@ -10737,7 +10745,15 @@
             </a:pPr>
             <a:r>
               <a:rPr lang="en-US" sz="1200" dirty="0" smtClean="0"/>
-              <a:t>Creating single bus job file (primary XML + completed XML)</a:t>
+              <a:t>Creating </a:t>
+            </a:r>
+            <a:r>
+              <a:rPr lang="en-US" sz="1200" dirty="0"/>
+              <a:t>&amp; editing single </a:t>
+            </a:r>
+            <a:r>
+              <a:rPr lang="en-US" sz="1200" dirty="0" smtClean="0"/>
+              <a:t>bus job file (primary XML + completed XML)</a:t>
             </a:r>
           </a:p>
           <a:p>
@@ -10759,7 +10775,15 @@
             </a:pPr>
             <a:r>
               <a:rPr lang="en-US" sz="1200" dirty="0" smtClean="0"/>
-              <a:t>Currently, existing job files can not be edited in the new GUI – planned to be extended in future</a:t>
+              <a:t>Currently, </a:t>
+            </a:r>
+            <a:r>
+              <a:rPr lang="en-US" sz="1200" dirty="0" smtClean="0"/>
+              <a:t>other existing </a:t>
+            </a:r>
+            <a:r>
+              <a:rPr lang="en-US" sz="1200" dirty="0" smtClean="0"/>
+              <a:t>job files can not be edited in the new GUI – planned to be extended in future</a:t>
             </a:r>
           </a:p>
           <a:p>
@@ -10770,8 +10794,24 @@
             </a:pPr>
             <a:r>
               <a:rPr lang="en-US" sz="1200" dirty="0" smtClean="0"/>
-              <a:t>Functionality similar to currently official VECTO version, for further information see separate user manual on new GUI</a:t>
-            </a:r>
+              <a:t>Functionality similar to currently official VECTO version, for further information see separate user manual on new </a:t>
+            </a:r>
+            <a:r>
+              <a:rPr lang="en-US" sz="1200" dirty="0" smtClean="0"/>
+              <a:t>GUI</a:t>
+            </a:r>
+          </a:p>
+          <a:p>
+            <a:pPr lvl="1">
+              <a:tabLst>
+                <a:tab pos="1885950" algn="l"/>
+              </a:tabLst>
+            </a:pPr>
+            <a:r>
+              <a:rPr lang="en-US" sz="1600" dirty="0" smtClean="0"/>
+              <a:t>XML reports (MRF, CIF, PIF) according to draft Annex IV</a:t>
+            </a:r>
+            <a:endParaRPr lang="en-US" sz="1600" dirty="0" smtClean="0"/>
           </a:p>
           <a:p>
             <a:pPr lvl="1">
@@ -13869,11 +13909,7 @@
             </a:r>
             <a:r>
               <a:rPr lang="en-US" dirty="0" smtClean="0"/>
-              <a:t>0.6.1.1957 </a:t>
-            </a:r>
-            <a:r>
-              <a:rPr lang="en-US" dirty="0" smtClean="0"/>
-              <a:t>Development Version</a:t>
+              <a:t>0.6.1.1957 Development Version</a:t>
             </a:r>
             <a:r>
               <a:rPr lang="en-US" dirty="0"/>
@@ -13884,11 +13920,7 @@
             </a:br>
             <a:r>
               <a:rPr lang="en-US" sz="1600" dirty="0" smtClean="0"/>
-              <a:t>May </a:t>
-            </a:r>
-            <a:r>
-              <a:rPr lang="en-US" sz="1600" dirty="0" smtClean="0"/>
-              <a:t>2020</a:t>
+              <a:t>May 2020</a:t>
             </a:r>
             <a:endParaRPr lang="en-US" sz="1600" dirty="0"/>
           </a:p>
@@ -13925,8 +13957,9 @@
             </a:r>
             <a:r>
               <a:rPr lang="en-US" sz="1800" b="1" dirty="0" smtClean="0"/>
-              <a:t> </a:t>
-            </a:r>
+              <a:t> heavy buses </a:t>
+            </a:r>
+            <a:endParaRPr lang="en-US" sz="1800" b="1" dirty="0" smtClean="0"/>
           </a:p>
           <a:p>
             <a:pPr lvl="1">
@@ -13990,12 +14023,87 @@
               </a:tabLst>
             </a:pPr>
             <a:r>
+              <a:rPr lang="en-US" sz="1600" dirty="0" smtClean="0"/>
+              <a:t>Correcting passenger count depending on HVAC </a:t>
+            </a:r>
+            <a:r>
+              <a:rPr lang="en-US" sz="1600" dirty="0" smtClean="0"/>
+              <a:t>configuration</a:t>
+            </a:r>
+          </a:p>
+          <a:p>
+            <a:pPr>
+              <a:tabLst>
+                <a:tab pos="1885950" algn="l"/>
+              </a:tabLst>
+            </a:pPr>
+            <a:r>
+              <a:rPr lang="en-US" sz="1800" dirty="0" err="1" smtClean="0"/>
+              <a:t>Bugfixes</a:t>
+            </a:r>
+            <a:r>
+              <a:rPr lang="en-US" sz="1800" dirty="0" smtClean="0"/>
+              <a:t> medium lorries</a:t>
+            </a:r>
+          </a:p>
+          <a:p>
+            <a:pPr lvl="1">
+              <a:tabLst>
+                <a:tab pos="1885950" algn="l"/>
+              </a:tabLst>
+            </a:pPr>
+            <a:r>
+              <a:rPr lang="en-US" sz="1600" dirty="0" smtClean="0"/>
+              <a:t>New technologies for electric steering pump</a:t>
+            </a:r>
+          </a:p>
+          <a:p>
+            <a:pPr lvl="1">
+              <a:tabLst>
+                <a:tab pos="1885950" algn="l"/>
+              </a:tabLst>
+            </a:pPr>
+            <a:r>
+              <a:rPr lang="en-US" sz="1600" dirty="0" smtClean="0"/>
+              <a:t>New </a:t>
+            </a:r>
+            <a:r>
+              <a:rPr lang="en-US" sz="1600" dirty="0" err="1" smtClean="0"/>
+              <a:t>tyre</a:t>
+            </a:r>
+            <a:r>
+              <a:rPr lang="en-US" sz="1600" dirty="0" smtClean="0"/>
+              <a:t> xml supported</a:t>
+            </a:r>
+          </a:p>
+          <a:p>
+            <a:pPr lvl="1">
+              <a:tabLst>
+                <a:tab pos="1885950" algn="l"/>
+              </a:tabLst>
+            </a:pPr>
+            <a:r>
+              <a:rPr lang="en-US" sz="1600" dirty="0" err="1" smtClean="0"/>
+              <a:t>Bugfixes</a:t>
+            </a:r>
+            <a:r>
+              <a:rPr lang="en-US" sz="1600" dirty="0" smtClean="0"/>
+              <a:t> graphical user interface</a:t>
+            </a:r>
+          </a:p>
+          <a:p>
+            <a:pPr lvl="1">
+              <a:tabLst>
+                <a:tab pos="1885950" algn="l"/>
+              </a:tabLst>
+            </a:pPr>
+            <a:r>
+              <a:rPr lang="en-US" sz="1600" dirty="0" smtClean="0"/>
+              <a:t>New sample </a:t>
+            </a:r>
+            <a:r>
               <a:rPr lang="en-US" sz="1600" smtClean="0"/>
-              <a:t>Correcting </a:t>
-            </a:r>
-            <a:r>
-              <a:rPr lang="en-US" sz="1600" dirty="0" smtClean="0"/>
-              <a:t>passenger count depending on HVAC configuration</a:t>
+              <a:t>data VTP</a:t>
             </a:r>
             <a:endParaRPr lang="en-US" sz="1600" dirty="0" smtClean="0"/>
           </a:p>

</xml_diff>

<commit_message>
updating version number, release notes, changelog for release
</commit_message>
<xml_diff>
--- a/Documentation/User Manual Source/Release Notes Vecto3.x.pptx
+++ b/Documentation/User Manual Source/Release Notes Vecto3.x.pptx
@@ -4302,7 +4302,7 @@
                   <a:srgbClr val="990000"/>
                 </a:solidFill>
               </a:rPr>
-              <a:t>17.11.2020</a:t>
+              <a:t>1.7.2020</a:t>
             </a:r>
           </a:p>
           <a:p>
@@ -6759,8 +6759,12 @@
           <a:lstStyle/>
           <a:p>
             <a:r>
-              <a:rPr lang="en-US" dirty="0"/>
-              <a:t>Vecto 3.3.10.XXXX Release Candidate</a:t>
+              <a:rPr lang="en-US"/>
+              <a:t>Vecto 3.3.10.2373 </a:t>
+            </a:r>
+            <a:r>
+              <a:rPr lang="en-US" dirty="0"/>
+              <a:t>Release Candidate</a:t>
             </a:r>
             <a:br>
               <a:rPr lang="en-US" dirty="0"/>
@@ -12319,7 +12323,7 @@
           <a:p>
             <a:r>
               <a:rPr lang="en-US" dirty="0"/>
-              <a:t>Vecto 3.3.10.XXXX Release Candidate</a:t>
+              <a:t>Vecto 3.3.10.2373 Release Candidate</a:t>
             </a:r>
             <a:br>
               <a:rPr lang="en-US" dirty="0"/>

</xml_diff>

<commit_message>
Updated Version Number to 0.7.8 for xEV Release
</commit_message>
<xml_diff>
--- a/Documentation/User Manual Source/Release Notes Vecto3.x.pptx
+++ b/Documentation/User Manual Source/Release Notes Vecto3.x.pptx
@@ -8235,8 +8235,12 @@
           <a:lstStyle/>
           <a:p>
             <a:r>
-              <a:rPr lang="en-US" dirty="0"/>
-              <a:t>Vecto 0.7.8.xxx Development Version</a:t>
+              <a:rPr lang="en-US" dirty="0" err="1"/>
+              <a:t>Vecto</a:t>
+            </a:r>
+            <a:r>
+              <a:rPr lang="en-US" dirty="0"/>
+              <a:t> 0.7.8.2679 Development Version</a:t>
             </a:r>
             <a:br>
               <a:rPr lang="en-US" dirty="0"/>

</xml_diff>

<commit_message>
Release Notes: Added GUI changes for VECTO xEV Release 0.7.8.2579
</commit_message>
<xml_diff>
--- a/Documentation/User Manual Source/Release Notes Vecto3.x.pptx
+++ b/Documentation/User Manual Source/Release Notes Vecto3.x.pptx
@@ -8456,6 +8456,17 @@
             <a:r>
               <a:rPr lang="en-US" sz="1400" dirty="0"/>
               <a:t>Update LH cycle</a:t>
+            </a:r>
+          </a:p>
+          <a:p>
+            <a:pPr lvl="1">
+              <a:tabLst>
+                <a:tab pos="1885950" algn="l"/>
+              </a:tabLst>
+            </a:pPr>
+            <a:r>
+              <a:rPr lang="en-US" sz="1400" dirty="0"/>
+              <a:t>GUI improvements: enable/disable some fields in Job Form, Vehicle Form, and Hybrid Strategy Parameters to simplify user interface and avoid erratic entries.</a:t>
             </a:r>
           </a:p>
           <a:p>

</xml_diff>